<commit_message>
Polish mini2 validation docs and python node
</commit_message>
<xml_diff>
--- a/mini2-poster.pptx
+++ b/mini2-poster.pptx
@@ -3283,8 +3283,8 @@
         </p:nvSpPr>
         <p:spPr>
           <a:xfrm>
-            <a:off x="411480" y="228600"/>
-            <a:ext cx="7406640" cy="640080"/>
+            <a:off x="411480" y="201168"/>
+            <a:ext cx="8778240" cy="713232"/>
           </a:xfrm>
           <a:prstGeom prst="rect">
             <a:avLst/>
@@ -3305,7 +3305,7 @@
               </a:defRPr>
             </a:pPr>
             <a:r>
-              <a:t>Chunk Size Controls Distributed Query Cost</a:t>
+              <a:t>The Fastest Curve Was Not Trustworthy Until We Broke It</a:t>
             </a:r>
           </a:p>
         </p:txBody>
@@ -3340,7 +3340,7 @@
               </a:defRPr>
             </a:pPr>
             <a:r>
-              <a:t>NYC 311 scatter-gather over C++/Python gRPC nodes</a:t>
+              <a:t>NYC 311 scatter-gather: chunk-size result plus the failures that validated it</a:t>
             </a:r>
           </a:p>
         </p:txBody>
@@ -3487,7 +3487,7 @@
         <p:spPr>
           <a:xfrm>
             <a:off x="7360920" y="2743200"/>
-            <a:ext cx="4389120" cy="1234440"/>
+            <a:ext cx="4389120" cy="1417320"/>
           </a:xfrm>
           <a:prstGeom prst="roundRect">
             <a:avLst/>
@@ -3531,8 +3531,8 @@
         </p:nvSpPr>
         <p:spPr>
           <a:xfrm>
-            <a:off x="7635240" y="2907792"/>
-            <a:ext cx="3886200" cy="868680"/>
+            <a:off x="7635240" y="2889504"/>
+            <a:ext cx="3886200" cy="1060704"/>
           </a:xfrm>
           <a:prstGeom prst="rect">
             <a:avLst/>
@@ -3546,14 +3546,26 @@
           <a:lstStyle/>
           <a:p>
             <a:pPr>
-              <a:defRPr sz="1600" b="1">
+              <a:defRPr sz="1400" b="1">
                 <a:solidFill>
                   <a:srgbClr val="F5F8FF"/>
                 </a:solidFill>
               </a:defRPr>
             </a:pPr>
             <a:r>
-              <a:t>Tradeoff: fewer round trips, but larger buffers and higher per-RPC latency.</a:t>
+              <a:t>Validation failures caught:</a:t>
+            </a:r>
+          </a:p>
+          <a:p>
+            <a:pPr>
+              <a:defRPr sz="1400" b="1">
+                <a:solidFill>
+                  <a:srgbClr val="F5F8FF"/>
+                </a:solidFill>
+              </a:defRPr>
+            </a:pPr>
+            <a:r>
+              <a:t>port collision | partial tree | cached partial result</a:t>
             </a:r>
           </a:p>
         </p:txBody>
@@ -3566,8 +3578,8 @@
         </p:nvSpPr>
         <p:spPr>
           <a:xfrm>
-            <a:off x="7360920" y="4251960"/>
-            <a:ext cx="4389120" cy="1051560"/>
+            <a:off x="7360920" y="4434840"/>
+            <a:ext cx="4389120" cy="960120"/>
           </a:xfrm>
           <a:prstGeom prst="roundRect">
             <a:avLst/>
@@ -3611,8 +3623,8 @@
         </p:nvSpPr>
         <p:spPr>
           <a:xfrm>
-            <a:off x="7635240" y="4407408"/>
-            <a:ext cx="3886200" cy="685800"/>
+            <a:off x="7635240" y="4572000"/>
+            <a:ext cx="3886200" cy="640080"/>
           </a:xfrm>
           <a:prstGeom prst="rect">
             <a:avLst/>
@@ -3680,7 +3692,7 @@
               </a:defRPr>
             </a:pPr>
             <a:r>
-              <a:t>Local debug: 3 runs. Final two-computer run: 15-30 runs per chunk size.</a:t>
+              <a:t>Tradeoff: fewer round trips, larger buffers. Local debug: 3 runs; final two-computer run: 15-30 runs.</a:t>
             </a:r>
           </a:p>
         </p:txBody>

</xml_diff>

<commit_message>
Add final two-host benchmark results
</commit_message>
<xml_diff>
--- a/mini2-poster.pptx
+++ b/mini2-poster.pptx
@@ -180,19 +180,19 @@
                 <c:formatCode>General</c:formatCode>
                 <c:ptCount val="5"/>
                 <c:pt idx="0">
-                  <c:v>423093</c:v>
+                  <c:v>337844</c:v>
                 </c:pt>
                 <c:pt idx="1">
-                  <c:v>100274</c:v>
+                  <c:v>91303</c:v>
                 </c:pt>
                 <c:pt idx="2">
-                  <c:v>31579</c:v>
+                  <c:v>45748</c:v>
                 </c:pt>
                 <c:pt idx="3">
-                  <c:v>19446</c:v>
+                  <c:v>47482</c:v>
                 </c:pt>
                 <c:pt idx="4">
-                  <c:v>9073</c:v>
+                  <c:v>44046</c:v>
                 </c:pt>
               </c:numCache>
             </c:numRef>
@@ -3438,7 +3438,7 @@
               </a:defRPr>
             </a:pPr>
             <a:r>
-              <a:t>46.6x faster</a:t>
+              <a:t>7.7x faster</a:t>
             </a:r>
           </a:p>
         </p:txBody>
@@ -3473,7 +3473,7 @@
               </a:defRPr>
             </a:pPr>
             <a:r>
-              <a:t>512 KB chunks vs. 2 KB chunks, same 80,000 records</a:t>
+              <a:t>512 KB chunks vs. 2 KB chunks, two laptops, 80,000 records</a:t>
             </a:r>
           </a:p>
         </p:txBody>
@@ -3565,7 +3565,7 @@
               </a:defRPr>
             </a:pPr>
             <a:r>
-              <a:t>port collision | partial tree | cached partial result</a:t>
+              <a:t>port collision | partial tree | cached partial result | Python env | missing shards</a:t>
             </a:r>
           </a:p>
         </p:txBody>
@@ -3692,7 +3692,7 @@
               </a:defRPr>
             </a:pPr>
             <a:r>
-              <a:t>Tradeoff: fewer round trips, larger buffers. Local debug: 3 runs; final two-computer run: 15-30 runs.</a:t>
+              <a:t>Tradeoff: fewer round trips, larger buffers. Final two-computer run: 30 runs per chunk size.</a:t>
             </a:r>
           </a:p>
         </p:txBody>

</xml_diff>

<commit_message>
Focus mini2 report on findings and validation
</commit_message>
<xml_diff>
--- a/mini2-poster.pptx
+++ b/mini2-poster.pptx
@@ -3340,7 +3340,7 @@
               </a:defRPr>
             </a:pPr>
             <a:r>
-              <a:t>NYC 311 scatter-gather: chunk-size result plus the failures that validated it</a:t>
+              <a:t>The result: chunk size mattered, but validation made the speedup believable</a:t>
             </a:r>
           </a:p>
         </p:txBody>
@@ -3565,7 +3565,7 @@
               </a:defRPr>
             </a:pPr>
             <a:r>
-              <a:t>port collision | partial tree | cached partial result | Python env | missing shards</a:t>
+              <a:t>port collision | partial tree | cached partial result | binary layout | missing shards</a:t>
             </a:r>
           </a:p>
         </p:txBody>
@@ -3645,7 +3645,7 @@
               </a:defRPr>
             </a:pPr>
             <a:r>
-              <a:t>client -&gt; A -&gt; B,H,G,I</a:t>
+              <a:t>Fairness: 4 clients each got 50 chunks</a:t>
             </a:r>
           </a:p>
           <a:p>
@@ -3657,7 +3657,7 @@
               </a:defRPr>
             </a:pPr>
             <a:r>
-              <a:t>B -&gt; C,D,E    E -&gt; F</a:t>
+              <a:t>Failure: H down before gather failed fast</a:t>
             </a:r>
           </a:p>
         </p:txBody>
@@ -3692,7 +3692,7 @@
               </a:defRPr>
             </a:pPr>
             <a:r>
-              <a:t>Tradeoff: fewer round trips, larger buffers. Final two-computer run: 30 runs per chunk size.</a:t>
+              <a:t>Not a project summary: one finding, one tradeoff, and the failures that made the finding credible.</a:t>
             </a:r>
           </a:p>
         </p:txBody>

</xml_diff>

<commit_message>
Redesign mini2 poster slide
</commit_message>
<xml_diff>
--- a/mini2-poster.pptx
+++ b/mini2-poster.pptx
@@ -105,185 +105,6 @@
     </a:lvl9pPr>
   </p:defaultTextStyle>
 </p:presentation>
-</file>
-
-<file path=ppt/charts/chart1.xml><?xml version="1.0" encoding="utf-8"?>
-<c:chartSpace xmlns:c="http://schemas.openxmlformats.org/drawingml/2006/chart" xmlns:a="http://schemas.openxmlformats.org/drawingml/2006/main" xmlns:r="http://schemas.openxmlformats.org/officeDocument/2006/relationships">
-  <c:date1904 val="0"/>
-  <c:chart>
-    <c:title>
-      <c:tx>
-        <c:rich>
-          <a:bodyPr/>
-          <a:lstStyle/>
-          <a:p>
-            <a:r>
-              <a:t>Total Request Time vs. Chunk Size</a:t>
-            </a:r>
-          </a:p>
-        </c:rich>
-      </c:tx>
-      <c:layout/>
-      <c:overlay val="0"/>
-    </c:title>
-    <c:autoTitleDeleted val="0"/>
-    <c:plotArea>
-      <c:barChart>
-        <c:barDir val="col"/>
-        <c:grouping val="clustered"/>
-        <c:ser>
-          <c:idx val="0"/>
-          <c:order val="0"/>
-          <c:tx>
-            <c:strRef>
-              <c:f>Sheet1!$B$1</c:f>
-              <c:strCache>
-                <c:ptCount val="1"/>
-                <c:pt idx="0">
-                  <c:v>Avg total time (us)</c:v>
-                </c:pt>
-              </c:strCache>
-            </c:strRef>
-          </c:tx>
-          <c:spPr>
-            <a:solidFill>
-              <a:srgbClr val="50BEAA"/>
-            </a:solidFill>
-          </c:spPr>
-          <c:cat>
-            <c:strRef>
-              <c:f>Sheet1!$A$2:$A$6</c:f>
-              <c:strCache>
-                <c:ptCount val="5"/>
-                <c:pt idx="0">
-                  <c:v>2 KB</c:v>
-                </c:pt>
-                <c:pt idx="1">
-                  <c:v>8 KB</c:v>
-                </c:pt>
-                <c:pt idx="2">
-                  <c:v>32 KB</c:v>
-                </c:pt>
-                <c:pt idx="3">
-                  <c:v>128 KB</c:v>
-                </c:pt>
-                <c:pt idx="4">
-                  <c:v>512 KB</c:v>
-                </c:pt>
-              </c:strCache>
-            </c:strRef>
-          </c:cat>
-          <c:val>
-            <c:numRef>
-              <c:f>Sheet1!$B$2:$B$6</c:f>
-              <c:numCache>
-                <c:formatCode>General</c:formatCode>
-                <c:ptCount val="5"/>
-                <c:pt idx="0">
-                  <c:v>337844</c:v>
-                </c:pt>
-                <c:pt idx="1">
-                  <c:v>91303</c:v>
-                </c:pt>
-                <c:pt idx="2">
-                  <c:v>45748</c:v>
-                </c:pt>
-                <c:pt idx="3">
-                  <c:v>47482</c:v>
-                </c:pt>
-                <c:pt idx="4">
-                  <c:v>44046</c:v>
-                </c:pt>
-              </c:numCache>
-            </c:numRef>
-          </c:val>
-        </c:ser>
-        <c:dLbls>
-          <c:txPr>
-            <a:bodyPr/>
-            <a:lstStyle/>
-            <a:p>
-              <a:pPr>
-                <a:defRPr sz="800"/>
-              </a:pPr>
-            </a:p>
-          </c:txPr>
-          <c:dLblPos val="outEnd"/>
-          <c:showLegendKey val="0"/>
-          <c:showVal val="1"/>
-          <c:showCatName val="0"/>
-          <c:showSerName val="0"/>
-          <c:showPercent val="0"/>
-          <c:showBubbleSize val="0"/>
-          <c:showLeaderLines val="1"/>
-        </c:dLbls>
-        <c:axId val="-2068027336"/>
-        <c:axId val="-2113994440"/>
-      </c:barChart>
-      <c:catAx>
-        <c:axId val="-2068027336"/>
-        <c:scaling>
-          <c:orientation val="minMax"/>
-        </c:scaling>
-        <c:delete val="0"/>
-        <c:axPos val="b"/>
-        <c:majorTickMark val="out"/>
-        <c:minorTickMark val="none"/>
-        <c:tickLblPos val="nextTo"/>
-        <c:txPr>
-          <a:bodyPr/>
-          <a:lstStyle/>
-          <a:p>
-            <a:pPr>
-              <a:defRPr sz="1000"/>
-            </a:pPr>
-          </a:p>
-        </c:txPr>
-        <c:crossAx val="-2113994440"/>
-        <c:crosses val="autoZero"/>
-        <c:auto val="1"/>
-        <c:lblAlgn val="ctr"/>
-        <c:lblOffset val="100"/>
-        <c:noMultiLvlLbl val="0"/>
-      </c:catAx>
-      <c:valAx>
-        <c:axId val="-2113994440"/>
-        <c:scaling/>
-        <c:delete val="0"/>
-        <c:axPos val="l"/>
-        <c:majorGridlines/>
-        <c:majorTickMark val="out"/>
-        <c:minorTickMark val="none"/>
-        <c:tickLblPos val="nextTo"/>
-        <c:txPr>
-          <a:bodyPr/>
-          <a:lstStyle/>
-          <a:p>
-            <a:pPr>
-              <a:defRPr sz="900"/>
-            </a:pPr>
-          </a:p>
-        </c:txPr>
-        <c:crossAx val="-2068027336"/>
-        <c:crosses val="autoZero"/>
-      </c:valAx>
-    </c:plotArea>
-    <c:dispBlanksAs val="gap"/>
-  </c:chart>
-  <c:txPr>
-    <a:bodyPr/>
-    <a:lstStyle/>
-    <a:p>
-      <a:pPr>
-        <a:defRPr sz="1800"/>
-      </a:pPr>
-      <a:endParaRPr lang="en-US"/>
-    </a:p>
-  </c:txPr>
-  <c:externalData r:id="rId1">
-    <c:autoUpdate val="0"/>
-  </c:externalData>
-</c:chartSpace>
 </file>
 
 <file path=ppt/slideLayouts/slideLayout1.xml><?xml version="1.0" encoding="utf-8"?>
@@ -3263,7 +3084,7 @@
     <p:bg>
       <p:bgPr>
         <a:solidFill>
-          <a:srgbClr val="0C121C"/>
+          <a:srgbClr val="070B16"/>
         </a:solidFill>
         <a:effectLst/>
       </p:bgPr>
@@ -3277,112 +3098,24 @@
       <p:grpSpPr/>
       <p:sp>
         <p:nvSpPr>
-          <p:cNvPr id="2" name="TextBox 1"/>
-          <p:cNvSpPr txBox="1"/>
+          <p:cNvPr id="2" name="Rectangle 1"/>
+          <p:cNvSpPr/>
           <p:nvPr/>
         </p:nvSpPr>
         <p:spPr>
           <a:xfrm>
-            <a:off x="411480" y="201168"/>
-            <a:ext cx="8778240" cy="713232"/>
+            <a:off x="0" y="0"/>
+            <a:ext cx="12191695" cy="109728"/>
           </a:xfrm>
           <a:prstGeom prst="rect">
             <a:avLst/>
           </a:prstGeom>
-          <a:noFill/>
-        </p:spPr>
-        <p:txBody>
-          <a:bodyPr wrap="none">
-            <a:spAutoFit/>
-          </a:bodyPr>
-          <a:lstStyle/>
-          <a:p>
-            <a:pPr>
-              <a:defRPr sz="3000" b="1">
-                <a:solidFill>
-                  <a:srgbClr val="F5F8FF"/>
-                </a:solidFill>
-              </a:defRPr>
-            </a:pPr>
-            <a:r>
-              <a:t>The Fastest Curve Was Not Trustworthy Until We Broke It</a:t>
-            </a:r>
-          </a:p>
-        </p:txBody>
-      </p:sp>
-      <p:sp>
-        <p:nvSpPr>
-          <p:cNvPr id="3" name="TextBox 2"/>
-          <p:cNvSpPr txBox="1"/>
-          <p:nvPr/>
-        </p:nvSpPr>
-        <p:spPr>
-          <a:xfrm>
-            <a:off x="438912" y="841248"/>
-            <a:ext cx="7863840" cy="320040"/>
-          </a:xfrm>
-          <a:prstGeom prst="rect">
-            <a:avLst/>
-          </a:prstGeom>
-          <a:noFill/>
-        </p:spPr>
-        <p:txBody>
-          <a:bodyPr wrap="none">
-            <a:spAutoFit/>
-          </a:bodyPr>
-          <a:lstStyle/>
-          <a:p>
-            <a:pPr>
-              <a:defRPr sz="1300">
-                <a:solidFill>
-                  <a:srgbClr val="A6B2C4"/>
-                </a:solidFill>
-              </a:defRPr>
-            </a:pPr>
-            <a:r>
-              <a:t>The result: chunk size mattered, but validation made the speedup believable</a:t>
-            </a:r>
-          </a:p>
-        </p:txBody>
-      </p:sp>
-      <p:graphicFrame>
-        <p:nvGraphicFramePr>
-          <p:cNvPr id="4" name="Chart 3"/>
-          <p:cNvGraphicFramePr>
-            <a:graphicFrameLocks noGrp="1"/>
-          </p:cNvGraphicFramePr>
-          <p:nvPr/>
-        </p:nvGraphicFramePr>
-        <p:xfrm>
-          <a:off x="502920" y="1417320"/>
-          <a:ext cx="6400800" cy="4343400"/>
-        </p:xfrm>
-        <a:graphic>
-          <a:graphicData uri="http://schemas.openxmlformats.org/drawingml/2006/chart">
-            <c:chart xmlns:c="http://schemas.openxmlformats.org/drawingml/2006/chart" r:id="rId2"/>
-          </a:graphicData>
-        </a:graphic>
-      </p:graphicFrame>
-      <p:sp>
-        <p:nvSpPr>
-          <p:cNvPr id="5" name="Rounded Rectangle 4"/>
-          <p:cNvSpPr/>
-          <p:nvPr/>
-        </p:nvSpPr>
-        <p:spPr>
-          <a:xfrm>
-            <a:off x="7360920" y="1325880"/>
-            <a:ext cx="4389120" cy="1143000"/>
-          </a:xfrm>
-          <a:prstGeom prst="roundRect">
-            <a:avLst/>
-          </a:prstGeom>
           <a:solidFill>
-            <a:srgbClr val="141F2F"/>
+            <a:srgbClr val="F59E0B"/>
           </a:solidFill>
           <a:ln>
             <a:solidFill>
-              <a:srgbClr val="28364B"/>
+              <a:srgbClr val="F59E0B"/>
             </a:solidFill>
           </a:ln>
         </p:spPr>
@@ -3410,14 +3143,14 @@
       </p:sp>
       <p:sp>
         <p:nvSpPr>
-          <p:cNvPr id="6" name="TextBox 5"/>
+          <p:cNvPr id="3" name="TextBox 2"/>
           <p:cNvSpPr txBox="1"/>
           <p:nvPr/>
         </p:nvSpPr>
         <p:spPr>
           <a:xfrm>
-            <a:off x="7635240" y="1463040"/>
-            <a:ext cx="3840480" cy="777240"/>
+            <a:off x="411480" y="283464"/>
+            <a:ext cx="2743200" cy="438912"/>
           </a:xfrm>
           <a:prstGeom prst="rect">
             <a:avLst/>
@@ -3433,26 +3166,26 @@
             <a:pPr>
               <a:defRPr sz="3800" b="1">
                 <a:solidFill>
-                  <a:srgbClr val="FFD25C"/>
+                  <a:srgbClr val="FACC15"/>
                 </a:solidFill>
               </a:defRPr>
             </a:pPr>
             <a:r>
-              <a:t>7.7x faster</a:t>
-            </a:r>
-          </a:p>
-        </p:txBody>
-      </p:sp>
-      <p:sp>
-        <p:nvSpPr>
-          <p:cNvPr id="7" name="TextBox 6"/>
+              <a:t>FAST LIES</a:t>
+            </a:r>
+          </a:p>
+        </p:txBody>
+      </p:sp>
+      <p:sp>
+        <p:nvSpPr>
+          <p:cNvPr id="4" name="TextBox 3"/>
           <p:cNvSpPr txBox="1"/>
           <p:nvPr/>
         </p:nvSpPr>
         <p:spPr>
           <a:xfrm>
-            <a:off x="7635240" y="2148840"/>
-            <a:ext cx="3840480" cy="320040"/>
+            <a:off x="3520440" y="320040"/>
+            <a:ext cx="7269480" cy="457200"/>
           </a:xfrm>
           <a:prstGeom prst="rect">
             <a:avLst/>
@@ -3466,38 +3199,73 @@
           <a:lstStyle/>
           <a:p>
             <a:pPr>
-              <a:defRPr sz="1100">
+              <a:defRPr sz="1700" b="1">
                 <a:solidFill>
-                  <a:srgbClr val="C6D0E0"/>
+                  <a:srgbClr val="E2E8F0"/>
                 </a:solidFill>
               </a:defRPr>
             </a:pPr>
             <a:r>
-              <a:t>512 KB chunks vs. 2 KB chunks, two laptops, 80,000 records</a:t>
-            </a:r>
-          </a:p>
-        </p:txBody>
-      </p:sp>
-      <p:sp>
-        <p:nvSpPr>
-          <p:cNvPr id="8" name="Rounded Rectangle 7"/>
+              <a:t>Why our 7.7x chunk-size speedup only counted after validation</a:t>
+            </a:r>
+          </a:p>
+        </p:txBody>
+      </p:sp>
+      <p:sp>
+        <p:nvSpPr>
+          <p:cNvPr id="5" name="TextBox 4"/>
+          <p:cNvSpPr txBox="1"/>
+          <p:nvPr/>
+        </p:nvSpPr>
+        <p:spPr>
+          <a:xfrm>
+            <a:off x="10561320" y="320040"/>
+            <a:ext cx="1143000" cy="274320"/>
+          </a:xfrm>
+          <a:prstGeom prst="rect">
+            <a:avLst/>
+          </a:prstGeom>
+          <a:noFill/>
+        </p:spPr>
+        <p:txBody>
+          <a:bodyPr wrap="none">
+            <a:spAutoFit/>
+          </a:bodyPr>
+          <a:lstStyle/>
+          <a:p>
+            <a:pPr algn="r">
+              <a:defRPr sz="950" b="0">
+                <a:solidFill>
+                  <a:srgbClr val="94A3B8"/>
+                </a:solidFill>
+              </a:defRPr>
+            </a:pPr>
+            <a:r>
+              <a:t>Anukrithi + Asim</a:t>
+            </a:r>
+          </a:p>
+        </p:txBody>
+      </p:sp>
+      <p:sp>
+        <p:nvSpPr>
+          <p:cNvPr id="6" name="Rounded Rectangle 5"/>
           <p:cNvSpPr/>
           <p:nvPr/>
         </p:nvSpPr>
         <p:spPr>
           <a:xfrm>
-            <a:off x="7360920" y="2743200"/>
-            <a:ext cx="4389120" cy="1417320"/>
+            <a:off x="411480" y="960120"/>
+            <a:ext cx="6995160" cy="4983480"/>
           </a:xfrm>
           <a:prstGeom prst="roundRect">
             <a:avLst/>
           </a:prstGeom>
           <a:solidFill>
-            <a:srgbClr val="141F2F"/>
+            <a:srgbClr val="111827"/>
           </a:solidFill>
           <a:ln>
             <a:solidFill>
-              <a:srgbClr val="28364B"/>
+              <a:srgbClr val="334155"/>
             </a:solidFill>
           </a:ln>
         </p:spPr>
@@ -3523,16 +3291,40 @@
           </a:p>
         </p:txBody>
       </p:sp>
-      <p:sp>
-        <p:nvSpPr>
-          <p:cNvPr id="9" name="TextBox 8"/>
+      <p:pic>
+        <p:nvPicPr>
+          <p:cNvPr id="7" name="Picture 6" descr="poster_chunk_chart.png"/>
+          <p:cNvPicPr>
+            <a:picLocks noChangeAspect="1"/>
+          </p:cNvPicPr>
+          <p:nvPr/>
+        </p:nvPicPr>
+        <p:blipFill>
+          <a:blip r:embed="rId2"/>
+          <a:stretch>
+            <a:fillRect/>
+          </a:stretch>
+        </p:blipFill>
+        <p:spPr>
+          <a:xfrm>
+            <a:off x="658368" y="1207008"/>
+            <a:ext cx="6510528" cy="4297680"/>
+          </a:xfrm>
+          <a:prstGeom prst="rect">
+            <a:avLst/>
+          </a:prstGeom>
+        </p:spPr>
+      </p:pic>
+      <p:sp>
+        <p:nvSpPr>
+          <p:cNvPr id="8" name="TextBox 7"/>
           <p:cNvSpPr txBox="1"/>
           <p:nvPr/>
         </p:nvSpPr>
         <p:spPr>
           <a:xfrm>
-            <a:off x="7635240" y="2889504"/>
-            <a:ext cx="3886200" cy="1060704"/>
+            <a:off x="749808" y="5440680"/>
+            <a:ext cx="6309360" cy="292608"/>
           </a:xfrm>
           <a:prstGeom prst="rect">
             <a:avLst/>
@@ -3545,51 +3337,39 @@
           </a:bodyPr>
           <a:lstStyle/>
           <a:p>
-            <a:pPr>
-              <a:defRPr sz="1400" b="1">
+            <a:pPr algn="ctr">
+              <a:defRPr sz="1100" b="0">
                 <a:solidFill>
-                  <a:srgbClr val="F5F8FF"/>
+                  <a:srgbClr val="CBD5E1"/>
                 </a:solidFill>
               </a:defRPr>
             </a:pPr>
             <a:r>
-              <a:t>Validation failures caught:</a:t>
-            </a:r>
-          </a:p>
-          <a:p>
-            <a:pPr>
-              <a:defRPr sz="1400" b="1">
-                <a:solidFill>
-                  <a:srgbClr val="F5F8FF"/>
-                </a:solidFill>
-              </a:defRPr>
-            </a:pPr>
-            <a:r>
-              <a:t>port collision | partial tree | cached partial result | binary layout | missing shards</a:t>
-            </a:r>
-          </a:p>
-        </p:txBody>
-      </p:sp>
-      <p:sp>
-        <p:nvSpPr>
-          <p:cNvPr id="10" name="Rounded Rectangle 9"/>
+              <a:t>30 runs per chunk size on two laptops over Wi-Fi</a:t>
+            </a:r>
+          </a:p>
+        </p:txBody>
+      </p:sp>
+      <p:sp>
+        <p:nvSpPr>
+          <p:cNvPr id="9" name="Rounded Rectangle 8"/>
           <p:cNvSpPr/>
           <p:nvPr/>
         </p:nvSpPr>
         <p:spPr>
           <a:xfrm>
-            <a:off x="7360920" y="4434840"/>
-            <a:ext cx="4389120" cy="960120"/>
+            <a:off x="7635240" y="960120"/>
+            <a:ext cx="4160520" cy="1325880"/>
           </a:xfrm>
           <a:prstGeom prst="roundRect">
             <a:avLst/>
           </a:prstGeom>
           <a:solidFill>
-            <a:srgbClr val="141F2F"/>
+            <a:srgbClr val="172033"/>
           </a:solidFill>
           <a:ln>
             <a:solidFill>
-              <a:srgbClr val="28364B"/>
+              <a:srgbClr val="475569"/>
             </a:solidFill>
           </a:ln>
         </p:spPr>
@@ -3617,14 +3397,14 @@
       </p:sp>
       <p:sp>
         <p:nvSpPr>
-          <p:cNvPr id="11" name="TextBox 10"/>
+          <p:cNvPr id="10" name="TextBox 9"/>
           <p:cNvSpPr txBox="1"/>
           <p:nvPr/>
         </p:nvSpPr>
         <p:spPr>
           <a:xfrm>
-            <a:off x="7635240" y="4572000"/>
-            <a:ext cx="3886200" cy="640080"/>
+            <a:off x="7909560" y="1097280"/>
+            <a:ext cx="1600200" cy="502920"/>
           </a:xfrm>
           <a:prstGeom prst="rect">
             <a:avLst/>
@@ -3638,40 +3418,28 @@
           <a:lstStyle/>
           <a:p>
             <a:pPr>
-              <a:defRPr sz="1500">
+              <a:defRPr sz="4200" b="1">
                 <a:solidFill>
-                  <a:srgbClr val="DCE6F2"/>
+                  <a:srgbClr val="FACC15"/>
                 </a:solidFill>
               </a:defRPr>
             </a:pPr>
             <a:r>
-              <a:t>Fairness: 4 clients each got 50 chunks</a:t>
-            </a:r>
-          </a:p>
-          <a:p>
-            <a:pPr>
-              <a:defRPr sz="1500">
-                <a:solidFill>
-                  <a:srgbClr val="DCE6F2"/>
-                </a:solidFill>
-              </a:defRPr>
-            </a:pPr>
-            <a:r>
-              <a:t>Failure: H down before gather failed fast</a:t>
-            </a:r>
-          </a:p>
-        </p:txBody>
-      </p:sp>
-      <p:sp>
-        <p:nvSpPr>
-          <p:cNvPr id="12" name="TextBox 11"/>
+              <a:t>7.7x</a:t>
+            </a:r>
+          </a:p>
+        </p:txBody>
+      </p:sp>
+      <p:sp>
+        <p:nvSpPr>
+          <p:cNvPr id="11" name="TextBox 10"/>
           <p:cNvSpPr txBox="1"/>
           <p:nvPr/>
         </p:nvSpPr>
         <p:spPr>
           <a:xfrm>
-            <a:off x="502920" y="6236208"/>
-            <a:ext cx="11155680" cy="274320"/>
+            <a:off x="9464040" y="1143000"/>
+            <a:ext cx="1965960" cy="347472"/>
           </a:xfrm>
           <a:prstGeom prst="rect">
             <a:avLst/>
@@ -3685,14 +3453,1224 @@
           <a:lstStyle/>
           <a:p>
             <a:pPr>
-              <a:defRPr sz="1100">
+              <a:defRPr sz="1500" b="1">
                 <a:solidFill>
-                  <a:srgbClr val="A6B2C4"/>
+                  <a:srgbClr val="F8FAFC"/>
                 </a:solidFill>
               </a:defRPr>
             </a:pPr>
             <a:r>
-              <a:t>Not a project summary: one finding, one tradeoff, and the failures that made the finding credible.</a:t>
+              <a:t>faster total time</a:t>
+            </a:r>
+          </a:p>
+        </p:txBody>
+      </p:sp>
+      <p:sp>
+        <p:nvSpPr>
+          <p:cNvPr id="12" name="TextBox 11"/>
+          <p:cNvSpPr txBox="1"/>
+          <p:nvPr/>
+        </p:nvSpPr>
+        <p:spPr>
+          <a:xfrm>
+            <a:off x="9464040" y="1517904"/>
+            <a:ext cx="1965960" cy="438912"/>
+          </a:xfrm>
+          <a:prstGeom prst="rect">
+            <a:avLst/>
+          </a:prstGeom>
+          <a:noFill/>
+        </p:spPr>
+        <p:txBody>
+          <a:bodyPr wrap="none">
+            <a:spAutoFit/>
+          </a:bodyPr>
+          <a:lstStyle/>
+          <a:p>
+            <a:pPr>
+              <a:defRPr sz="2000" b="1">
+                <a:solidFill>
+                  <a:srgbClr val="38BDF8"/>
+                </a:solidFill>
+              </a:defRPr>
+            </a:pPr>
+            <a:r>
+              <a:t>338 ms -&gt; 44 ms</a:t>
+            </a:r>
+          </a:p>
+        </p:txBody>
+      </p:sp>
+      <p:sp>
+        <p:nvSpPr>
+          <p:cNvPr id="13" name="TextBox 12"/>
+          <p:cNvSpPr txBox="1"/>
+          <p:nvPr/>
+        </p:nvSpPr>
+        <p:spPr>
+          <a:xfrm>
+            <a:off x="7909560" y="1938528"/>
+            <a:ext cx="3611880" cy="228600"/>
+          </a:xfrm>
+          <a:prstGeom prst="rect">
+            <a:avLst/>
+          </a:prstGeom>
+          <a:noFill/>
+        </p:spPr>
+        <p:txBody>
+          <a:bodyPr wrap="none">
+            <a:spAutoFit/>
+          </a:bodyPr>
+          <a:lstStyle/>
+          <a:p>
+            <a:pPr>
+              <a:defRPr sz="1050" b="0">
+                <a:solidFill>
+                  <a:srgbClr val="94A3B8"/>
+                </a:solidFill>
+              </a:defRPr>
+            </a:pPr>
+            <a:r>
+              <a:t>same records, different response shape</a:t>
+            </a:r>
+          </a:p>
+        </p:txBody>
+      </p:sp>
+      <p:sp>
+        <p:nvSpPr>
+          <p:cNvPr id="14" name="Rounded Rectangle 13"/>
+          <p:cNvSpPr/>
+          <p:nvPr/>
+        </p:nvSpPr>
+        <p:spPr>
+          <a:xfrm>
+            <a:off x="7635240" y="2514600"/>
+            <a:ext cx="4160520" cy="914400"/>
+          </a:xfrm>
+          <a:prstGeom prst="roundRect">
+            <a:avLst/>
+          </a:prstGeom>
+          <a:solidFill>
+            <a:srgbClr val="101826"/>
+          </a:solidFill>
+          <a:ln>
+            <a:solidFill>
+              <a:srgbClr val="334155"/>
+            </a:solidFill>
+          </a:ln>
+        </p:spPr>
+        <p:style>
+          <a:lnRef idx="1">
+            <a:schemeClr val="accent1"/>
+          </a:lnRef>
+          <a:fillRef idx="3">
+            <a:schemeClr val="accent1"/>
+          </a:fillRef>
+          <a:effectRef idx="2">
+            <a:schemeClr val="accent1"/>
+          </a:effectRef>
+          <a:fontRef idx="minor">
+            <a:schemeClr val="lt1"/>
+          </a:fontRef>
+        </p:style>
+        <p:txBody>
+          <a:bodyPr rtlCol="0" anchor="ctr"/>
+          <a:lstStyle/>
+          <a:p>
+            <a:pPr algn="ctr"/>
+          </a:p>
+        </p:txBody>
+      </p:sp>
+      <p:sp>
+        <p:nvSpPr>
+          <p:cNvPr id="15" name="TextBox 14"/>
+          <p:cNvSpPr txBox="1"/>
+          <p:nvPr/>
+        </p:nvSpPr>
+        <p:spPr>
+          <a:xfrm>
+            <a:off x="7882127" y="2651760"/>
+            <a:ext cx="3611880" cy="228600"/>
+          </a:xfrm>
+          <a:prstGeom prst="rect">
+            <a:avLst/>
+          </a:prstGeom>
+          <a:noFill/>
+        </p:spPr>
+        <p:txBody>
+          <a:bodyPr wrap="none">
+            <a:spAutoFit/>
+          </a:bodyPr>
+          <a:lstStyle/>
+          <a:p>
+            <a:pPr>
+              <a:defRPr sz="1400" b="1">
+                <a:solidFill>
+                  <a:srgbClr val="F8FAFC"/>
+                </a:solidFill>
+              </a:defRPr>
+            </a:pPr>
+            <a:r>
+              <a:t>Round-trip pressure collapsed</a:t>
+            </a:r>
+          </a:p>
+        </p:txBody>
+      </p:sp>
+      <p:sp>
+        <p:nvSpPr>
+          <p:cNvPr id="16" name="TextBox 15"/>
+          <p:cNvSpPr txBox="1"/>
+          <p:nvPr/>
+        </p:nvSpPr>
+        <p:spPr>
+          <a:xfrm>
+            <a:off x="7955279" y="2953512"/>
+            <a:ext cx="1051560" cy="320040"/>
+          </a:xfrm>
+          <a:prstGeom prst="rect">
+            <a:avLst/>
+          </a:prstGeom>
+          <a:noFill/>
+        </p:spPr>
+        <p:txBody>
+          <a:bodyPr wrap="none">
+            <a:spAutoFit/>
+          </a:bodyPr>
+          <a:lstStyle/>
+          <a:p>
+            <a:pPr algn="ctr">
+              <a:defRPr sz="2500" b="1">
+                <a:solidFill>
+                  <a:srgbClr val="FB7185"/>
+                </a:solidFill>
+              </a:defRPr>
+            </a:pPr>
+            <a:r>
+              <a:t>800</a:t>
+            </a:r>
+          </a:p>
+        </p:txBody>
+      </p:sp>
+      <p:sp>
+        <p:nvSpPr>
+          <p:cNvPr id="17" name="TextBox 16"/>
+          <p:cNvSpPr txBox="1"/>
+          <p:nvPr/>
+        </p:nvSpPr>
+        <p:spPr>
+          <a:xfrm>
+            <a:off x="9006840" y="2999232"/>
+            <a:ext cx="502920" cy="228600"/>
+          </a:xfrm>
+          <a:prstGeom prst="rect">
+            <a:avLst/>
+          </a:prstGeom>
+          <a:noFill/>
+        </p:spPr>
+        <p:txBody>
+          <a:bodyPr wrap="none">
+            <a:spAutoFit/>
+          </a:bodyPr>
+          <a:lstStyle/>
+          <a:p>
+            <a:pPr algn="ctr">
+              <a:defRPr sz="1300" b="0">
+                <a:solidFill>
+                  <a:srgbClr val="94A3B8"/>
+                </a:solidFill>
+              </a:defRPr>
+            </a:pPr>
+            <a:r>
+              <a:t>to</a:t>
+            </a:r>
+          </a:p>
+        </p:txBody>
+      </p:sp>
+      <p:sp>
+        <p:nvSpPr>
+          <p:cNvPr id="18" name="TextBox 17"/>
+          <p:cNvSpPr txBox="1"/>
+          <p:nvPr/>
+        </p:nvSpPr>
+        <p:spPr>
+          <a:xfrm>
+            <a:off x="9509760" y="2953512"/>
+            <a:ext cx="822960" cy="320040"/>
+          </a:xfrm>
+          <a:prstGeom prst="rect">
+            <a:avLst/>
+          </a:prstGeom>
+          <a:noFill/>
+        </p:spPr>
+        <p:txBody>
+          <a:bodyPr wrap="none">
+            <a:spAutoFit/>
+          </a:bodyPr>
+          <a:lstStyle/>
+          <a:p>
+            <a:pPr algn="ctr">
+              <a:defRPr sz="2500" b="1">
+                <a:solidFill>
+                  <a:srgbClr val="34D399"/>
+                </a:solidFill>
+              </a:defRPr>
+            </a:pPr>
+            <a:r>
+              <a:t>4</a:t>
+            </a:r>
+          </a:p>
+        </p:txBody>
+      </p:sp>
+      <p:sp>
+        <p:nvSpPr>
+          <p:cNvPr id="19" name="TextBox 18"/>
+          <p:cNvSpPr txBox="1"/>
+          <p:nvPr/>
+        </p:nvSpPr>
+        <p:spPr>
+          <a:xfrm>
+            <a:off x="10195560" y="3035808"/>
+            <a:ext cx="1005840" cy="182880"/>
+          </a:xfrm>
+          <a:prstGeom prst="rect">
+            <a:avLst/>
+          </a:prstGeom>
+          <a:noFill/>
+        </p:spPr>
+        <p:txBody>
+          <a:bodyPr wrap="none">
+            <a:spAutoFit/>
+          </a:bodyPr>
+          <a:lstStyle/>
+          <a:p>
+            <a:pPr>
+              <a:defRPr sz="1000" b="0">
+                <a:solidFill>
+                  <a:srgbClr val="CBD5E1"/>
+                </a:solidFill>
+              </a:defRPr>
+            </a:pPr>
+            <a:r>
+              <a:t>client calls</a:t>
+            </a:r>
+          </a:p>
+        </p:txBody>
+      </p:sp>
+      <p:sp>
+        <p:nvSpPr>
+          <p:cNvPr id="20" name="Rounded Rectangle 19"/>
+          <p:cNvSpPr/>
+          <p:nvPr/>
+        </p:nvSpPr>
+        <p:spPr>
+          <a:xfrm>
+            <a:off x="7635240" y="3703320"/>
+            <a:ext cx="4160520" cy="1508760"/>
+          </a:xfrm>
+          <a:prstGeom prst="roundRect">
+            <a:avLst/>
+          </a:prstGeom>
+          <a:solidFill>
+            <a:srgbClr val="111827"/>
+          </a:solidFill>
+          <a:ln>
+            <a:solidFill>
+              <a:srgbClr val="334155"/>
+            </a:solidFill>
+          </a:ln>
+        </p:spPr>
+        <p:style>
+          <a:lnRef idx="1">
+            <a:schemeClr val="accent1"/>
+          </a:lnRef>
+          <a:fillRef idx="3">
+            <a:schemeClr val="accent1"/>
+          </a:fillRef>
+          <a:effectRef idx="2">
+            <a:schemeClr val="accent1"/>
+          </a:effectRef>
+          <a:fontRef idx="minor">
+            <a:schemeClr val="lt1"/>
+          </a:fontRef>
+        </p:style>
+        <p:txBody>
+          <a:bodyPr rtlCol="0" anchor="ctr"/>
+          <a:lstStyle/>
+          <a:p>
+            <a:pPr algn="ctr"/>
+          </a:p>
+        </p:txBody>
+      </p:sp>
+      <p:sp>
+        <p:nvSpPr>
+          <p:cNvPr id="21" name="TextBox 20"/>
+          <p:cNvSpPr txBox="1"/>
+          <p:nvPr/>
+        </p:nvSpPr>
+        <p:spPr>
+          <a:xfrm>
+            <a:off x="7909560" y="3840480"/>
+            <a:ext cx="3611880" cy="228600"/>
+          </a:xfrm>
+          <a:prstGeom prst="rect">
+            <a:avLst/>
+          </a:prstGeom>
+          <a:noFill/>
+        </p:spPr>
+        <p:txBody>
+          <a:bodyPr wrap="none">
+            <a:spAutoFit/>
+          </a:bodyPr>
+          <a:lstStyle/>
+          <a:p>
+            <a:pPr>
+              <a:defRPr sz="1400" b="1">
+                <a:solidFill>
+                  <a:srgbClr val="F8FAFC"/>
+                </a:solidFill>
+              </a:defRPr>
+            </a:pPr>
+            <a:r>
+              <a:t>Validation gates we failed first</a:t>
+            </a:r>
+          </a:p>
+        </p:txBody>
+      </p:sp>
+      <p:sp>
+        <p:nvSpPr>
+          <p:cNvPr id="22" name="Rounded Rectangle 21"/>
+          <p:cNvSpPr/>
+          <p:nvPr/>
+        </p:nvSpPr>
+        <p:spPr>
+          <a:xfrm>
+            <a:off x="7891272" y="4224528"/>
+            <a:ext cx="512064" cy="310896"/>
+          </a:xfrm>
+          <a:prstGeom prst="roundRect">
+            <a:avLst/>
+          </a:prstGeom>
+          <a:solidFill>
+            <a:srgbClr val="1E293B"/>
+          </a:solidFill>
+          <a:ln>
+            <a:solidFill>
+              <a:srgbClr val="475569"/>
+            </a:solidFill>
+          </a:ln>
+        </p:spPr>
+        <p:style>
+          <a:lnRef idx="1">
+            <a:schemeClr val="accent1"/>
+          </a:lnRef>
+          <a:fillRef idx="3">
+            <a:schemeClr val="accent1"/>
+          </a:fillRef>
+          <a:effectRef idx="2">
+            <a:schemeClr val="accent1"/>
+          </a:effectRef>
+          <a:fontRef idx="minor">
+            <a:schemeClr val="lt1"/>
+          </a:fontRef>
+        </p:style>
+        <p:txBody>
+          <a:bodyPr rtlCol="0" anchor="ctr"/>
+          <a:lstStyle/>
+          <a:p>
+            <a:pPr algn="ctr"/>
+          </a:p>
+        </p:txBody>
+      </p:sp>
+      <p:sp>
+        <p:nvSpPr>
+          <p:cNvPr id="23" name="TextBox 22"/>
+          <p:cNvSpPr txBox="1"/>
+          <p:nvPr/>
+        </p:nvSpPr>
+        <p:spPr>
+          <a:xfrm>
+            <a:off x="7891272" y="4279392"/>
+            <a:ext cx="512064" cy="137160"/>
+          </a:xfrm>
+          <a:prstGeom prst="rect">
+            <a:avLst/>
+          </a:prstGeom>
+          <a:noFill/>
+        </p:spPr>
+        <p:txBody>
+          <a:bodyPr wrap="none">
+            <a:spAutoFit/>
+          </a:bodyPr>
+          <a:lstStyle/>
+          <a:p>
+            <a:pPr algn="ctr">
+              <a:defRPr sz="850" b="1">
+                <a:solidFill>
+                  <a:srgbClr val="FACC15"/>
+                </a:solidFill>
+              </a:defRPr>
+            </a:pPr>
+            <a:r>
+              <a:t>01</a:t>
+            </a:r>
+          </a:p>
+        </p:txBody>
+      </p:sp>
+      <p:sp>
+        <p:nvSpPr>
+          <p:cNvPr id="24" name="TextBox 23"/>
+          <p:cNvSpPr txBox="1"/>
+          <p:nvPr/>
+        </p:nvSpPr>
+        <p:spPr>
+          <a:xfrm>
+            <a:off x="7854696" y="4617720"/>
+            <a:ext cx="640080" cy="320040"/>
+          </a:xfrm>
+          <a:prstGeom prst="rect">
+            <a:avLst/>
+          </a:prstGeom>
+          <a:noFill/>
+        </p:spPr>
+        <p:txBody>
+          <a:bodyPr wrap="none">
+            <a:spAutoFit/>
+          </a:bodyPr>
+          <a:lstStyle/>
+          <a:p>
+            <a:pPr algn="ctr">
+              <a:defRPr sz="770" b="0">
+                <a:solidFill>
+                  <a:srgbClr val="CBD5E1"/>
+                </a:solidFill>
+              </a:defRPr>
+            </a:pPr>
+            <a:r>
+              <a:t>stale ports</a:t>
+            </a:r>
+          </a:p>
+        </p:txBody>
+      </p:sp>
+      <p:sp>
+        <p:nvSpPr>
+          <p:cNvPr id="25" name="Rounded Rectangle 24"/>
+          <p:cNvSpPr/>
+          <p:nvPr/>
+        </p:nvSpPr>
+        <p:spPr>
+          <a:xfrm>
+            <a:off x="8641080" y="4224528"/>
+            <a:ext cx="512064" cy="310896"/>
+          </a:xfrm>
+          <a:prstGeom prst="roundRect">
+            <a:avLst/>
+          </a:prstGeom>
+          <a:solidFill>
+            <a:srgbClr val="1E293B"/>
+          </a:solidFill>
+          <a:ln>
+            <a:solidFill>
+              <a:srgbClr val="475569"/>
+            </a:solidFill>
+          </a:ln>
+        </p:spPr>
+        <p:style>
+          <a:lnRef idx="1">
+            <a:schemeClr val="accent1"/>
+          </a:lnRef>
+          <a:fillRef idx="3">
+            <a:schemeClr val="accent1"/>
+          </a:fillRef>
+          <a:effectRef idx="2">
+            <a:schemeClr val="accent1"/>
+          </a:effectRef>
+          <a:fontRef idx="minor">
+            <a:schemeClr val="lt1"/>
+          </a:fontRef>
+        </p:style>
+        <p:txBody>
+          <a:bodyPr rtlCol="0" anchor="ctr"/>
+          <a:lstStyle/>
+          <a:p>
+            <a:pPr algn="ctr"/>
+          </a:p>
+        </p:txBody>
+      </p:sp>
+      <p:sp>
+        <p:nvSpPr>
+          <p:cNvPr id="26" name="TextBox 25"/>
+          <p:cNvSpPr txBox="1"/>
+          <p:nvPr/>
+        </p:nvSpPr>
+        <p:spPr>
+          <a:xfrm>
+            <a:off x="8641080" y="4279392"/>
+            <a:ext cx="512064" cy="137160"/>
+          </a:xfrm>
+          <a:prstGeom prst="rect">
+            <a:avLst/>
+          </a:prstGeom>
+          <a:noFill/>
+        </p:spPr>
+        <p:txBody>
+          <a:bodyPr wrap="none">
+            <a:spAutoFit/>
+          </a:bodyPr>
+          <a:lstStyle/>
+          <a:p>
+            <a:pPr algn="ctr">
+              <a:defRPr sz="850" b="1">
+                <a:solidFill>
+                  <a:srgbClr val="FACC15"/>
+                </a:solidFill>
+              </a:defRPr>
+            </a:pPr>
+            <a:r>
+              <a:t>02</a:t>
+            </a:r>
+          </a:p>
+        </p:txBody>
+      </p:sp>
+      <p:sp>
+        <p:nvSpPr>
+          <p:cNvPr id="27" name="TextBox 26"/>
+          <p:cNvSpPr txBox="1"/>
+          <p:nvPr/>
+        </p:nvSpPr>
+        <p:spPr>
+          <a:xfrm>
+            <a:off x="8604504" y="4617720"/>
+            <a:ext cx="640080" cy="320040"/>
+          </a:xfrm>
+          <a:prstGeom prst="rect">
+            <a:avLst/>
+          </a:prstGeom>
+          <a:noFill/>
+        </p:spPr>
+        <p:txBody>
+          <a:bodyPr wrap="none">
+            <a:spAutoFit/>
+          </a:bodyPr>
+          <a:lstStyle/>
+          <a:p>
+            <a:pPr algn="ctr">
+              <a:defRPr sz="770" b="0">
+                <a:solidFill>
+                  <a:srgbClr val="CBD5E1"/>
+                </a:solidFill>
+              </a:defRPr>
+            </a:pPr>
+            <a:r>
+              <a:t>partial tree</a:t>
+            </a:r>
+          </a:p>
+        </p:txBody>
+      </p:sp>
+      <p:sp>
+        <p:nvSpPr>
+          <p:cNvPr id="28" name="Rounded Rectangle 27"/>
+          <p:cNvSpPr/>
+          <p:nvPr/>
+        </p:nvSpPr>
+        <p:spPr>
+          <a:xfrm>
+            <a:off x="9390888" y="4224528"/>
+            <a:ext cx="512064" cy="310896"/>
+          </a:xfrm>
+          <a:prstGeom prst="roundRect">
+            <a:avLst/>
+          </a:prstGeom>
+          <a:solidFill>
+            <a:srgbClr val="1E293B"/>
+          </a:solidFill>
+          <a:ln>
+            <a:solidFill>
+              <a:srgbClr val="475569"/>
+            </a:solidFill>
+          </a:ln>
+        </p:spPr>
+        <p:style>
+          <a:lnRef idx="1">
+            <a:schemeClr val="accent1"/>
+          </a:lnRef>
+          <a:fillRef idx="3">
+            <a:schemeClr val="accent1"/>
+          </a:fillRef>
+          <a:effectRef idx="2">
+            <a:schemeClr val="accent1"/>
+          </a:effectRef>
+          <a:fontRef idx="minor">
+            <a:schemeClr val="lt1"/>
+          </a:fontRef>
+        </p:style>
+        <p:txBody>
+          <a:bodyPr rtlCol="0" anchor="ctr"/>
+          <a:lstStyle/>
+          <a:p>
+            <a:pPr algn="ctr"/>
+          </a:p>
+        </p:txBody>
+      </p:sp>
+      <p:sp>
+        <p:nvSpPr>
+          <p:cNvPr id="29" name="TextBox 28"/>
+          <p:cNvSpPr txBox="1"/>
+          <p:nvPr/>
+        </p:nvSpPr>
+        <p:spPr>
+          <a:xfrm>
+            <a:off x="9390888" y="4279392"/>
+            <a:ext cx="512064" cy="137160"/>
+          </a:xfrm>
+          <a:prstGeom prst="rect">
+            <a:avLst/>
+          </a:prstGeom>
+          <a:noFill/>
+        </p:spPr>
+        <p:txBody>
+          <a:bodyPr wrap="none">
+            <a:spAutoFit/>
+          </a:bodyPr>
+          <a:lstStyle/>
+          <a:p>
+            <a:pPr algn="ctr">
+              <a:defRPr sz="850" b="1">
+                <a:solidFill>
+                  <a:srgbClr val="FACC15"/>
+                </a:solidFill>
+              </a:defRPr>
+            </a:pPr>
+            <a:r>
+              <a:t>03</a:t>
+            </a:r>
+          </a:p>
+        </p:txBody>
+      </p:sp>
+      <p:sp>
+        <p:nvSpPr>
+          <p:cNvPr id="30" name="TextBox 29"/>
+          <p:cNvSpPr txBox="1"/>
+          <p:nvPr/>
+        </p:nvSpPr>
+        <p:spPr>
+          <a:xfrm>
+            <a:off x="9354312" y="4617720"/>
+            <a:ext cx="640080" cy="320040"/>
+          </a:xfrm>
+          <a:prstGeom prst="rect">
+            <a:avLst/>
+          </a:prstGeom>
+          <a:noFill/>
+        </p:spPr>
+        <p:txBody>
+          <a:bodyPr wrap="none">
+            <a:spAutoFit/>
+          </a:bodyPr>
+          <a:lstStyle/>
+          <a:p>
+            <a:pPr algn="ctr">
+              <a:defRPr sz="770" b="0">
+                <a:solidFill>
+                  <a:srgbClr val="CBD5E1"/>
+                </a:solidFill>
+              </a:defRPr>
+            </a:pPr>
+            <a:r>
+              <a:t>cache bug</a:t>
+            </a:r>
+          </a:p>
+        </p:txBody>
+      </p:sp>
+      <p:sp>
+        <p:nvSpPr>
+          <p:cNvPr id="31" name="Rounded Rectangle 30"/>
+          <p:cNvSpPr/>
+          <p:nvPr/>
+        </p:nvSpPr>
+        <p:spPr>
+          <a:xfrm>
+            <a:off x="10140696" y="4224528"/>
+            <a:ext cx="512064" cy="310896"/>
+          </a:xfrm>
+          <a:prstGeom prst="roundRect">
+            <a:avLst/>
+          </a:prstGeom>
+          <a:solidFill>
+            <a:srgbClr val="1E293B"/>
+          </a:solidFill>
+          <a:ln>
+            <a:solidFill>
+              <a:srgbClr val="475569"/>
+            </a:solidFill>
+          </a:ln>
+        </p:spPr>
+        <p:style>
+          <a:lnRef idx="1">
+            <a:schemeClr val="accent1"/>
+          </a:lnRef>
+          <a:fillRef idx="3">
+            <a:schemeClr val="accent1"/>
+          </a:fillRef>
+          <a:effectRef idx="2">
+            <a:schemeClr val="accent1"/>
+          </a:effectRef>
+          <a:fontRef idx="minor">
+            <a:schemeClr val="lt1"/>
+          </a:fontRef>
+        </p:style>
+        <p:txBody>
+          <a:bodyPr rtlCol="0" anchor="ctr"/>
+          <a:lstStyle/>
+          <a:p>
+            <a:pPr algn="ctr"/>
+          </a:p>
+        </p:txBody>
+      </p:sp>
+      <p:sp>
+        <p:nvSpPr>
+          <p:cNvPr id="32" name="TextBox 31"/>
+          <p:cNvSpPr txBox="1"/>
+          <p:nvPr/>
+        </p:nvSpPr>
+        <p:spPr>
+          <a:xfrm>
+            <a:off x="10140696" y="4279392"/>
+            <a:ext cx="512064" cy="137160"/>
+          </a:xfrm>
+          <a:prstGeom prst="rect">
+            <a:avLst/>
+          </a:prstGeom>
+          <a:noFill/>
+        </p:spPr>
+        <p:txBody>
+          <a:bodyPr wrap="none">
+            <a:spAutoFit/>
+          </a:bodyPr>
+          <a:lstStyle/>
+          <a:p>
+            <a:pPr algn="ctr">
+              <a:defRPr sz="850" b="1">
+                <a:solidFill>
+                  <a:srgbClr val="FACC15"/>
+                </a:solidFill>
+              </a:defRPr>
+            </a:pPr>
+            <a:r>
+              <a:t>04</a:t>
+            </a:r>
+          </a:p>
+        </p:txBody>
+      </p:sp>
+      <p:sp>
+        <p:nvSpPr>
+          <p:cNvPr id="33" name="TextBox 32"/>
+          <p:cNvSpPr txBox="1"/>
+          <p:nvPr/>
+        </p:nvSpPr>
+        <p:spPr>
+          <a:xfrm>
+            <a:off x="10104120" y="4617720"/>
+            <a:ext cx="640080" cy="320040"/>
+          </a:xfrm>
+          <a:prstGeom prst="rect">
+            <a:avLst/>
+          </a:prstGeom>
+          <a:noFill/>
+        </p:spPr>
+        <p:txBody>
+          <a:bodyPr wrap="none">
+            <a:spAutoFit/>
+          </a:bodyPr>
+          <a:lstStyle/>
+          <a:p>
+            <a:pPr algn="ctr">
+              <a:defRPr sz="770" b="0">
+                <a:solidFill>
+                  <a:srgbClr val="CBD5E1"/>
+                </a:solidFill>
+              </a:defRPr>
+            </a:pPr>
+            <a:r>
+              <a:t>binary layout</a:t>
+            </a:r>
+          </a:p>
+        </p:txBody>
+      </p:sp>
+      <p:sp>
+        <p:nvSpPr>
+          <p:cNvPr id="34" name="Rounded Rectangle 33"/>
+          <p:cNvSpPr/>
+          <p:nvPr/>
+        </p:nvSpPr>
+        <p:spPr>
+          <a:xfrm>
+            <a:off x="10890504" y="4224528"/>
+            <a:ext cx="512064" cy="310896"/>
+          </a:xfrm>
+          <a:prstGeom prst="roundRect">
+            <a:avLst/>
+          </a:prstGeom>
+          <a:solidFill>
+            <a:srgbClr val="1E293B"/>
+          </a:solidFill>
+          <a:ln>
+            <a:solidFill>
+              <a:srgbClr val="475569"/>
+            </a:solidFill>
+          </a:ln>
+        </p:spPr>
+        <p:style>
+          <a:lnRef idx="1">
+            <a:schemeClr val="accent1"/>
+          </a:lnRef>
+          <a:fillRef idx="3">
+            <a:schemeClr val="accent1"/>
+          </a:fillRef>
+          <a:effectRef idx="2">
+            <a:schemeClr val="accent1"/>
+          </a:effectRef>
+          <a:fontRef idx="minor">
+            <a:schemeClr val="lt1"/>
+          </a:fontRef>
+        </p:style>
+        <p:txBody>
+          <a:bodyPr rtlCol="0" anchor="ctr"/>
+          <a:lstStyle/>
+          <a:p>
+            <a:pPr algn="ctr"/>
+          </a:p>
+        </p:txBody>
+      </p:sp>
+      <p:sp>
+        <p:nvSpPr>
+          <p:cNvPr id="35" name="TextBox 34"/>
+          <p:cNvSpPr txBox="1"/>
+          <p:nvPr/>
+        </p:nvSpPr>
+        <p:spPr>
+          <a:xfrm>
+            <a:off x="10890504" y="4279392"/>
+            <a:ext cx="512064" cy="137160"/>
+          </a:xfrm>
+          <a:prstGeom prst="rect">
+            <a:avLst/>
+          </a:prstGeom>
+          <a:noFill/>
+        </p:spPr>
+        <p:txBody>
+          <a:bodyPr wrap="none">
+            <a:spAutoFit/>
+          </a:bodyPr>
+          <a:lstStyle/>
+          <a:p>
+            <a:pPr algn="ctr">
+              <a:defRPr sz="850" b="1">
+                <a:solidFill>
+                  <a:srgbClr val="FACC15"/>
+                </a:solidFill>
+              </a:defRPr>
+            </a:pPr>
+            <a:r>
+              <a:t>05</a:t>
+            </a:r>
+          </a:p>
+        </p:txBody>
+      </p:sp>
+      <p:sp>
+        <p:nvSpPr>
+          <p:cNvPr id="36" name="TextBox 35"/>
+          <p:cNvSpPr txBox="1"/>
+          <p:nvPr/>
+        </p:nvSpPr>
+        <p:spPr>
+          <a:xfrm>
+            <a:off x="10853928" y="4617720"/>
+            <a:ext cx="640080" cy="320040"/>
+          </a:xfrm>
+          <a:prstGeom prst="rect">
+            <a:avLst/>
+          </a:prstGeom>
+          <a:noFill/>
+        </p:spPr>
+        <p:txBody>
+          <a:bodyPr wrap="none">
+            <a:spAutoFit/>
+          </a:bodyPr>
+          <a:lstStyle/>
+          <a:p>
+            <a:pPr algn="ctr">
+              <a:defRPr sz="770" b="0">
+                <a:solidFill>
+                  <a:srgbClr val="CBD5E1"/>
+                </a:solidFill>
+              </a:defRPr>
+            </a:pPr>
+            <a:r>
+              <a:t>missing shards</a:t>
+            </a:r>
+          </a:p>
+        </p:txBody>
+      </p:sp>
+      <p:sp>
+        <p:nvSpPr>
+          <p:cNvPr id="37" name="Rounded Rectangle 36"/>
+          <p:cNvSpPr/>
+          <p:nvPr/>
+        </p:nvSpPr>
+        <p:spPr>
+          <a:xfrm>
+            <a:off x="7635240" y="5468112"/>
+            <a:ext cx="1965960" cy="685800"/>
+          </a:xfrm>
+          <a:prstGeom prst="roundRect">
+            <a:avLst/>
+          </a:prstGeom>
+          <a:solidFill>
+            <a:srgbClr val="13251F"/>
+          </a:solidFill>
+          <a:ln>
+            <a:solidFill>
+              <a:srgbClr val="34D399"/>
+            </a:solidFill>
+          </a:ln>
+        </p:spPr>
+        <p:style>
+          <a:lnRef idx="1">
+            <a:schemeClr val="accent1"/>
+          </a:lnRef>
+          <a:fillRef idx="3">
+            <a:schemeClr val="accent1"/>
+          </a:fillRef>
+          <a:effectRef idx="2">
+            <a:schemeClr val="accent1"/>
+          </a:effectRef>
+          <a:fontRef idx="minor">
+            <a:schemeClr val="lt1"/>
+          </a:fontRef>
+        </p:style>
+        <p:txBody>
+          <a:bodyPr rtlCol="0" anchor="ctr"/>
+          <a:lstStyle/>
+          <a:p>
+            <a:pPr algn="ctr"/>
+          </a:p>
+        </p:txBody>
+      </p:sp>
+      <p:sp>
+        <p:nvSpPr>
+          <p:cNvPr id="38" name="TextBox 37"/>
+          <p:cNvSpPr txBox="1"/>
+          <p:nvPr/>
+        </p:nvSpPr>
+        <p:spPr>
+          <a:xfrm>
+            <a:off x="7818120" y="5577840"/>
+            <a:ext cx="1600200" cy="182880"/>
+          </a:xfrm>
+          <a:prstGeom prst="rect">
+            <a:avLst/>
+          </a:prstGeom>
+          <a:noFill/>
+        </p:spPr>
+        <p:txBody>
+          <a:bodyPr wrap="none">
+            <a:spAutoFit/>
+          </a:bodyPr>
+          <a:lstStyle/>
+          <a:p>
+            <a:pPr>
+              <a:defRPr sz="1200" b="1">
+                <a:solidFill>
+                  <a:srgbClr val="BBF7D0"/>
+                </a:solidFill>
+              </a:defRPr>
+            </a:pPr>
+            <a:r>
+              <a:t>Fairness</a:t>
+            </a:r>
+          </a:p>
+        </p:txBody>
+      </p:sp>
+      <p:sp>
+        <p:nvSpPr>
+          <p:cNvPr id="39" name="TextBox 38"/>
+          <p:cNvSpPr txBox="1"/>
+          <p:nvPr/>
+        </p:nvSpPr>
+        <p:spPr>
+          <a:xfrm>
+            <a:off x="7818120" y="5815584"/>
+            <a:ext cx="1600200" cy="182880"/>
+          </a:xfrm>
+          <a:prstGeom prst="rect">
+            <a:avLst/>
+          </a:prstGeom>
+          <a:noFill/>
+        </p:spPr>
+        <p:txBody>
+          <a:bodyPr wrap="none">
+            <a:spAutoFit/>
+          </a:bodyPr>
+          <a:lstStyle/>
+          <a:p>
+            <a:pPr>
+              <a:defRPr sz="919" b="0">
+                <a:solidFill>
+                  <a:srgbClr val="DCFCE7"/>
+                </a:solidFill>
+              </a:defRPr>
+            </a:pPr>
+            <a:r>
+              <a:t>4 clients each got 50 chunks</a:t>
+            </a:r>
+          </a:p>
+        </p:txBody>
+      </p:sp>
+      <p:sp>
+        <p:nvSpPr>
+          <p:cNvPr id="40" name="Rounded Rectangle 39"/>
+          <p:cNvSpPr/>
+          <p:nvPr/>
+        </p:nvSpPr>
+        <p:spPr>
+          <a:xfrm>
+            <a:off x="9829800" y="5468112"/>
+            <a:ext cx="1965960" cy="685800"/>
+          </a:xfrm>
+          <a:prstGeom prst="roundRect">
+            <a:avLst/>
+          </a:prstGeom>
+          <a:solidFill>
+            <a:srgbClr val="2A1B13"/>
+          </a:solidFill>
+          <a:ln>
+            <a:solidFill>
+              <a:srgbClr val="F59E0B"/>
+            </a:solidFill>
+          </a:ln>
+        </p:spPr>
+        <p:style>
+          <a:lnRef idx="1">
+            <a:schemeClr val="accent1"/>
+          </a:lnRef>
+          <a:fillRef idx="3">
+            <a:schemeClr val="accent1"/>
+          </a:fillRef>
+          <a:effectRef idx="2">
+            <a:schemeClr val="accent1"/>
+          </a:effectRef>
+          <a:fontRef idx="minor">
+            <a:schemeClr val="lt1"/>
+          </a:fontRef>
+        </p:style>
+        <p:txBody>
+          <a:bodyPr rtlCol="0" anchor="ctr"/>
+          <a:lstStyle/>
+          <a:p>
+            <a:pPr algn="ctr"/>
+          </a:p>
+        </p:txBody>
+      </p:sp>
+      <p:sp>
+        <p:nvSpPr>
+          <p:cNvPr id="41" name="TextBox 40"/>
+          <p:cNvSpPr txBox="1"/>
+          <p:nvPr/>
+        </p:nvSpPr>
+        <p:spPr>
+          <a:xfrm>
+            <a:off x="10012680" y="5577840"/>
+            <a:ext cx="1600200" cy="182880"/>
+          </a:xfrm>
+          <a:prstGeom prst="rect">
+            <a:avLst/>
+          </a:prstGeom>
+          <a:noFill/>
+        </p:spPr>
+        <p:txBody>
+          <a:bodyPr wrap="none">
+            <a:spAutoFit/>
+          </a:bodyPr>
+          <a:lstStyle/>
+          <a:p>
+            <a:pPr>
+              <a:defRPr sz="1200" b="1">
+                <a:solidFill>
+                  <a:srgbClr val="FDE68A"/>
+                </a:solidFill>
+              </a:defRPr>
+            </a:pPr>
+            <a:r>
+              <a:t>Failure</a:t>
+            </a:r>
+          </a:p>
+        </p:txBody>
+      </p:sp>
+      <p:sp>
+        <p:nvSpPr>
+          <p:cNvPr id="42" name="TextBox 41"/>
+          <p:cNvSpPr txBox="1"/>
+          <p:nvPr/>
+        </p:nvSpPr>
+        <p:spPr>
+          <a:xfrm>
+            <a:off x="10012680" y="5815584"/>
+            <a:ext cx="1600200" cy="182880"/>
+          </a:xfrm>
+          <a:prstGeom prst="rect">
+            <a:avLst/>
+          </a:prstGeom>
+          <a:noFill/>
+        </p:spPr>
+        <p:txBody>
+          <a:bodyPr wrap="none">
+            <a:spAutoFit/>
+          </a:bodyPr>
+          <a:lstStyle/>
+          <a:p>
+            <a:pPr>
+              <a:defRPr sz="919" b="0">
+                <a:solidFill>
+                  <a:srgbClr val="FFEDD5"/>
+                </a:solidFill>
+              </a:defRPr>
+            </a:pPr>
+            <a:r>
+              <a:t>H down before gather failed fast</a:t>
+            </a:r>
+          </a:p>
+        </p:txBody>
+      </p:sp>
+      <p:sp>
+        <p:nvSpPr>
+          <p:cNvPr id="43" name="TextBox 42"/>
+          <p:cNvSpPr txBox="1"/>
+          <p:nvPr/>
+        </p:nvSpPr>
+        <p:spPr>
+          <a:xfrm>
+            <a:off x="502920" y="6263640"/>
+            <a:ext cx="11155680" cy="256032"/>
+          </a:xfrm>
+          <a:prstGeom prst="rect">
+            <a:avLst/>
+          </a:prstGeom>
+          <a:noFill/>
+        </p:spPr>
+        <p:txBody>
+          <a:bodyPr wrap="none">
+            <a:spAutoFit/>
+          </a:bodyPr>
+          <a:lstStyle/>
+          <a:p>
+            <a:pPr algn="ctr">
+              <a:defRPr sz="1300" b="1">
+                <a:solidFill>
+                  <a:srgbClr val="E2E8F0"/>
+                </a:solidFill>
+              </a:defRPr>
+            </a:pPr>
+            <a:r>
+              <a:t>Takeaway: chunk size is a performance knob; validation is what made the knob worth measuring.</a:t>
             </a:r>
           </a:p>
         </p:txBody>

</xml_diff>

<commit_message>
Correct mini2 poster finding around chunk-size knee
</commit_message>
<xml_diff>
--- a/mini2-poster.pptx
+++ b/mini2-poster.pptx
@@ -3150,7 +3150,7 @@
         <p:spPr>
           <a:xfrm>
             <a:off x="411480" y="283464"/>
-            <a:ext cx="2743200" cy="438912"/>
+            <a:ext cx="4160520" cy="438912"/>
           </a:xfrm>
           <a:prstGeom prst="rect">
             <a:avLst/>
@@ -3164,14 +3164,14 @@
           <a:lstStyle/>
           <a:p>
             <a:pPr>
-              <a:defRPr sz="3800" b="1">
+              <a:defRPr sz="3400" b="1">
                 <a:solidFill>
                   <a:srgbClr val="FACC15"/>
                 </a:solidFill>
               </a:defRPr>
             </a:pPr>
             <a:r>
-              <a:t>FAST LIES</a:t>
+              <a:t>THE 32 KB KNEE</a:t>
             </a:r>
           </a:p>
         </p:txBody>
@@ -3184,8 +3184,8 @@
         </p:nvSpPr>
         <p:spPr>
           <a:xfrm>
-            <a:off x="3520440" y="320040"/>
-            <a:ext cx="7269480" cy="457200"/>
+            <a:off x="4617720" y="320040"/>
+            <a:ext cx="6217920" cy="457200"/>
           </a:xfrm>
           <a:prstGeom prst="rect">
             <a:avLst/>
@@ -3199,14 +3199,14 @@
           <a:lstStyle/>
           <a:p>
             <a:pPr>
-              <a:defRPr sz="1700" b="1">
+              <a:defRPr sz="1600" b="1">
                 <a:solidFill>
                   <a:srgbClr val="E2E8F0"/>
                 </a:solidFill>
               </a:defRPr>
             </a:pPr>
             <a:r>
-              <a:t>Why our 7.7x chunk-size speedup only counted after validation</a:t>
+              <a:t>Repeated pages dominated until the gather/cache floor took over</a:t>
             </a:r>
           </a:p>
         </p:txBody>
@@ -3530,7 +3530,7 @@
               </a:defRPr>
             </a:pPr>
             <a:r>
-              <a:t>same records, different response shape</a:t>
+              <a:t>mean improvement from 2 KB to 512 KB</a:t>
             </a:r>
           </a:p>
         </p:txBody>
@@ -3610,7 +3610,7 @@
               </a:defRPr>
             </a:pPr>
             <a:r>
-              <a:t>Round-trip pressure collapsed</a:t>
+              <a:t>Why 50 pages ~= 4 pages</a:t>
             </a:r>
           </a:p>
         </p:txBody>
@@ -3624,7 +3624,7 @@
         <p:spPr>
           <a:xfrm>
             <a:off x="7955279" y="2953512"/>
-            <a:ext cx="1051560" cy="320040"/>
+            <a:ext cx="1143000" cy="320040"/>
           </a:xfrm>
           <a:prstGeom prst="rect">
             <a:avLst/>
@@ -3638,14 +3638,14 @@
           <a:lstStyle/>
           <a:p>
             <a:pPr algn="ctr">
-              <a:defRPr sz="2500" b="1">
+              <a:defRPr sz="2300" b="1">
                 <a:solidFill>
-                  <a:srgbClr val="FB7185"/>
+                  <a:srgbClr val="38BDF8"/>
                 </a:solidFill>
               </a:defRPr>
             </a:pPr>
             <a:r>
-              <a:t>800</a:t>
+              <a:t>45.7</a:t>
             </a:r>
           </a:p>
         </p:txBody>
@@ -3658,7 +3658,7 @@
         </p:nvSpPr>
         <p:spPr>
           <a:xfrm>
-            <a:off x="9006840" y="2999232"/>
+            <a:off x="9034272" y="3008376"/>
             <a:ext cx="502920" cy="228600"/>
           </a:xfrm>
           <a:prstGeom prst="rect">
@@ -3673,14 +3673,14 @@
           <a:lstStyle/>
           <a:p>
             <a:pPr algn="ctr">
-              <a:defRPr sz="1300" b="0">
+              <a:defRPr sz="1200" b="0">
                 <a:solidFill>
                   <a:srgbClr val="94A3B8"/>
                 </a:solidFill>
               </a:defRPr>
             </a:pPr>
             <a:r>
-              <a:t>to</a:t>
+              <a:t>vs</a:t>
             </a:r>
           </a:p>
         </p:txBody>
@@ -3693,8 +3693,8 @@
         </p:nvSpPr>
         <p:spPr>
           <a:xfrm>
-            <a:off x="9509760" y="2953512"/>
-            <a:ext cx="822960" cy="320040"/>
+            <a:off x="9555480" y="2953512"/>
+            <a:ext cx="1097280" cy="320040"/>
           </a:xfrm>
           <a:prstGeom prst="rect">
             <a:avLst/>
@@ -3708,14 +3708,14 @@
           <a:lstStyle/>
           <a:p>
             <a:pPr algn="ctr">
-              <a:defRPr sz="2500" b="1">
+              <a:defRPr sz="2300" b="1">
                 <a:solidFill>
-                  <a:srgbClr val="34D399"/>
+                  <a:srgbClr val="A78BFA"/>
                 </a:solidFill>
               </a:defRPr>
             </a:pPr>
             <a:r>
-              <a:t>4</a:t>
+              <a:t>44.0</a:t>
             </a:r>
           </a:p>
         </p:txBody>
@@ -3728,8 +3728,8 @@
         </p:nvSpPr>
         <p:spPr>
           <a:xfrm>
-            <a:off x="10195560" y="3035808"/>
-            <a:ext cx="1005840" cy="182880"/>
+            <a:off x="10561320" y="3035808"/>
+            <a:ext cx="640080" cy="182880"/>
           </a:xfrm>
           <a:prstGeom prst="rect">
             <a:avLst/>
@@ -3743,14 +3743,14 @@
           <a:lstStyle/>
           <a:p>
             <a:pPr>
-              <a:defRPr sz="1000" b="0">
+              <a:defRPr sz="950" b="0">
                 <a:solidFill>
                   <a:srgbClr val="CBD5E1"/>
                 </a:solidFill>
               </a:defRPr>
             </a:pPr>
             <a:r>
-              <a:t>client calls</a:t>
+              <a:t>ms mean</a:t>
             </a:r>
           </a:p>
         </p:txBody>
@@ -3830,31 +3830,241 @@
               </a:defRPr>
             </a:pPr>
             <a:r>
-              <a:t>Validation gates we failed first</a:t>
-            </a:r>
-          </a:p>
-        </p:txBody>
-      </p:sp>
-      <p:sp>
-        <p:nvSpPr>
-          <p:cNvPr id="22" name="Rounded Rectangle 21"/>
+              <a:t>The tradeoff after the knee</a:t>
+            </a:r>
+          </a:p>
+        </p:txBody>
+      </p:sp>
+      <p:sp>
+        <p:nvSpPr>
+          <p:cNvPr id="22" name="TextBox 21"/>
+          <p:cNvSpPr txBox="1"/>
+          <p:nvPr/>
+        </p:nvSpPr>
+        <p:spPr>
+          <a:xfrm>
+            <a:off x="7936992" y="4224528"/>
+            <a:ext cx="1005840" cy="256032"/>
+          </a:xfrm>
+          <a:prstGeom prst="rect">
+            <a:avLst/>
+          </a:prstGeom>
+          <a:noFill/>
+        </p:spPr>
+        <p:txBody>
+          <a:bodyPr wrap="none">
+            <a:spAutoFit/>
+          </a:bodyPr>
+          <a:lstStyle/>
+          <a:p>
+            <a:pPr algn="ctr">
+              <a:defRPr sz="1700" b="1">
+                <a:solidFill>
+                  <a:srgbClr val="38BDF8"/>
+                </a:solidFill>
+              </a:defRPr>
+            </a:pPr>
+            <a:r>
+              <a:t>32 KB</a:t>
+            </a:r>
+          </a:p>
+        </p:txBody>
+      </p:sp>
+      <p:sp>
+        <p:nvSpPr>
+          <p:cNvPr id="23" name="TextBox 22"/>
+          <p:cNvSpPr txBox="1"/>
+          <p:nvPr/>
+        </p:nvSpPr>
+        <p:spPr>
+          <a:xfrm>
+            <a:off x="9006840" y="4224528"/>
+            <a:ext cx="1005840" cy="256032"/>
+          </a:xfrm>
+          <a:prstGeom prst="rect">
+            <a:avLst/>
+          </a:prstGeom>
+          <a:noFill/>
+        </p:spPr>
+        <p:txBody>
+          <a:bodyPr wrap="none">
+            <a:spAutoFit/>
+          </a:bodyPr>
+          <a:lstStyle/>
+          <a:p>
+            <a:pPr algn="ctr">
+              <a:defRPr sz="1700" b="1">
+                <a:solidFill>
+                  <a:srgbClr val="A78BFA"/>
+                </a:solidFill>
+              </a:defRPr>
+            </a:pPr>
+            <a:r>
+              <a:t>512 KB</a:t>
+            </a:r>
+          </a:p>
+        </p:txBody>
+      </p:sp>
+      <p:sp>
+        <p:nvSpPr>
+          <p:cNvPr id="24" name="TextBox 23"/>
+          <p:cNvSpPr txBox="1"/>
+          <p:nvPr/>
+        </p:nvSpPr>
+        <p:spPr>
+          <a:xfrm>
+            <a:off x="10131552" y="4224528"/>
+            <a:ext cx="1005840" cy="256032"/>
+          </a:xfrm>
+          <a:prstGeom prst="rect">
+            <a:avLst/>
+          </a:prstGeom>
+          <a:noFill/>
+        </p:spPr>
+        <p:txBody>
+          <a:bodyPr wrap="none">
+            <a:spAutoFit/>
+          </a:bodyPr>
+          <a:lstStyle/>
+          <a:p>
+            <a:pPr algn="ctr">
+              <a:defRPr sz="1200" b="1">
+                <a:solidFill>
+                  <a:srgbClr val="CBD5E1"/>
+                </a:solidFill>
+              </a:defRPr>
+            </a:pPr>
+            <a:r>
+              <a:t>meaning</a:t>
+            </a:r>
+          </a:p>
+        </p:txBody>
+      </p:sp>
+      <p:sp>
+        <p:nvSpPr>
+          <p:cNvPr id="25" name="TextBox 24"/>
+          <p:cNvSpPr txBox="1"/>
+          <p:nvPr/>
+        </p:nvSpPr>
+        <p:spPr>
+          <a:xfrm>
+            <a:off x="7927848" y="4572000"/>
+            <a:ext cx="1005840" cy="201168"/>
+          </a:xfrm>
+          <a:prstGeom prst="rect">
+            <a:avLst/>
+          </a:prstGeom>
+          <a:noFill/>
+        </p:spPr>
+        <p:txBody>
+          <a:bodyPr wrap="none">
+            <a:spAutoFit/>
+          </a:bodyPr>
+          <a:lstStyle/>
+          <a:p>
+            <a:pPr algn="ctr">
+              <a:defRPr sz="1000" b="0">
+                <a:solidFill>
+                  <a:srgbClr val="DBEAFE"/>
+                </a:solidFill>
+              </a:defRPr>
+            </a:pPr>
+            <a:r>
+              <a:t>P90 61 ms</a:t>
+            </a:r>
+          </a:p>
+        </p:txBody>
+      </p:sp>
+      <p:sp>
+        <p:nvSpPr>
+          <p:cNvPr id="26" name="TextBox 25"/>
+          <p:cNvSpPr txBox="1"/>
+          <p:nvPr/>
+        </p:nvSpPr>
+        <p:spPr>
+          <a:xfrm>
+            <a:off x="9006840" y="4572000"/>
+            <a:ext cx="1005840" cy="201168"/>
+          </a:xfrm>
+          <a:prstGeom prst="rect">
+            <a:avLst/>
+          </a:prstGeom>
+          <a:noFill/>
+        </p:spPr>
+        <p:txBody>
+          <a:bodyPr wrap="none">
+            <a:spAutoFit/>
+          </a:bodyPr>
+          <a:lstStyle/>
+          <a:p>
+            <a:pPr algn="ctr">
+              <a:defRPr sz="1000" b="0">
+                <a:solidFill>
+                  <a:srgbClr val="EDE9FE"/>
+                </a:solidFill>
+              </a:defRPr>
+            </a:pPr>
+            <a:r>
+              <a:t>P90 110 ms</a:t>
+            </a:r>
+          </a:p>
+        </p:txBody>
+      </p:sp>
+      <p:sp>
+        <p:nvSpPr>
+          <p:cNvPr id="27" name="TextBox 26"/>
+          <p:cNvSpPr txBox="1"/>
+          <p:nvPr/>
+        </p:nvSpPr>
+        <p:spPr>
+          <a:xfrm>
+            <a:off x="10094976" y="4535424"/>
+            <a:ext cx="1188720" cy="402336"/>
+          </a:xfrm>
+          <a:prstGeom prst="rect">
+            <a:avLst/>
+          </a:prstGeom>
+          <a:noFill/>
+        </p:spPr>
+        <p:txBody>
+          <a:bodyPr wrap="none">
+            <a:spAutoFit/>
+          </a:bodyPr>
+          <a:lstStyle/>
+          <a:p>
+            <a:pPr algn="ctr">
+              <a:defRPr sz="869" b="0">
+                <a:solidFill>
+                  <a:srgbClr val="CBD5E1"/>
+                </a:solidFill>
+              </a:defRPr>
+            </a:pPr>
+            <a:r>
+              <a:t>larger chunks were faster typically, but spikier</a:t>
+            </a:r>
+          </a:p>
+        </p:txBody>
+      </p:sp>
+      <p:sp>
+        <p:nvSpPr>
+          <p:cNvPr id="28" name="Rounded Rectangle 27"/>
           <p:cNvSpPr/>
           <p:nvPr/>
         </p:nvSpPr>
         <p:spPr>
           <a:xfrm>
-            <a:off x="7891272" y="4224528"/>
-            <a:ext cx="512064" cy="310896"/>
+            <a:off x="7635240" y="5468112"/>
+            <a:ext cx="1965960" cy="685800"/>
           </a:xfrm>
           <a:prstGeom prst="roundRect">
             <a:avLst/>
           </a:prstGeom>
           <a:solidFill>
-            <a:srgbClr val="1E293B"/>
+            <a:srgbClr val="13251F"/>
           </a:solidFill>
           <a:ln>
             <a:solidFill>
-              <a:srgbClr val="475569"/>
+              <a:srgbClr val="34D399"/>
             </a:solidFill>
           </a:ln>
         </p:spPr>
@@ -3882,14 +4092,14 @@
       </p:sp>
       <p:sp>
         <p:nvSpPr>
-          <p:cNvPr id="23" name="TextBox 22"/>
+          <p:cNvPr id="29" name="TextBox 28"/>
           <p:cNvSpPr txBox="1"/>
           <p:nvPr/>
         </p:nvSpPr>
         <p:spPr>
           <a:xfrm>
-            <a:off x="7891272" y="4279392"/>
-            <a:ext cx="512064" cy="137160"/>
+            <a:off x="7818120" y="5577840"/>
+            <a:ext cx="1600200" cy="182880"/>
           </a:xfrm>
           <a:prstGeom prst="rect">
             <a:avLst/>
@@ -3902,29 +4112,29 @@
           </a:bodyPr>
           <a:lstStyle/>
           <a:p>
-            <a:pPr algn="ctr">
-              <a:defRPr sz="850" b="1">
+            <a:pPr>
+              <a:defRPr sz="1200" b="1">
                 <a:solidFill>
-                  <a:srgbClr val="FACC15"/>
+                  <a:srgbClr val="BBF7D0"/>
                 </a:solidFill>
               </a:defRPr>
             </a:pPr>
             <a:r>
-              <a:t>01</a:t>
-            </a:r>
-          </a:p>
-        </p:txBody>
-      </p:sp>
-      <p:sp>
-        <p:nvSpPr>
-          <p:cNvPr id="24" name="TextBox 23"/>
+              <a:t>Robust point</a:t>
+            </a:r>
+          </a:p>
+        </p:txBody>
+      </p:sp>
+      <p:sp>
+        <p:nvSpPr>
+          <p:cNvPr id="30" name="TextBox 29"/>
           <p:cNvSpPr txBox="1"/>
           <p:nvPr/>
         </p:nvSpPr>
         <p:spPr>
           <a:xfrm>
-            <a:off x="7854696" y="4617720"/>
-            <a:ext cx="640080" cy="320040"/>
+            <a:off x="7818120" y="5815584"/>
+            <a:ext cx="1600200" cy="182880"/>
           </a:xfrm>
           <a:prstGeom prst="rect">
             <a:avLst/>
@@ -3937,39 +4147,39 @@
           </a:bodyPr>
           <a:lstStyle/>
           <a:p>
-            <a:pPr algn="ctr">
-              <a:defRPr sz="770" b="0">
+            <a:pPr>
+              <a:defRPr sz="880" b="0">
                 <a:solidFill>
-                  <a:srgbClr val="CBD5E1"/>
+                  <a:srgbClr val="DCFCE7"/>
                 </a:solidFill>
               </a:defRPr>
             </a:pPr>
             <a:r>
-              <a:t>stale ports</a:t>
-            </a:r>
-          </a:p>
-        </p:txBody>
-      </p:sp>
-      <p:sp>
-        <p:nvSpPr>
-          <p:cNvPr id="25" name="Rounded Rectangle 24"/>
+              <a:t>32 KB: near-fastest mean, lower tail</a:t>
+            </a:r>
+          </a:p>
+        </p:txBody>
+      </p:sp>
+      <p:sp>
+        <p:nvSpPr>
+          <p:cNvPr id="31" name="Rounded Rectangle 30"/>
           <p:cNvSpPr/>
           <p:nvPr/>
         </p:nvSpPr>
         <p:spPr>
           <a:xfrm>
-            <a:off x="8641080" y="4224528"/>
-            <a:ext cx="512064" cy="310896"/>
+            <a:off x="9829800" y="5468112"/>
+            <a:ext cx="1965960" cy="685800"/>
           </a:xfrm>
           <a:prstGeom prst="roundRect">
             <a:avLst/>
           </a:prstGeom>
           <a:solidFill>
-            <a:srgbClr val="1E293B"/>
+            <a:srgbClr val="2A1B13"/>
           </a:solidFill>
           <a:ln>
             <a:solidFill>
-              <a:srgbClr val="475569"/>
+              <a:srgbClr val="F59E0B"/>
             </a:solidFill>
           </a:ln>
         </p:spPr>
@@ -3997,582 +4207,7 @@
       </p:sp>
       <p:sp>
         <p:nvSpPr>
-          <p:cNvPr id="26" name="TextBox 25"/>
-          <p:cNvSpPr txBox="1"/>
-          <p:nvPr/>
-        </p:nvSpPr>
-        <p:spPr>
-          <a:xfrm>
-            <a:off x="8641080" y="4279392"/>
-            <a:ext cx="512064" cy="137160"/>
-          </a:xfrm>
-          <a:prstGeom prst="rect">
-            <a:avLst/>
-          </a:prstGeom>
-          <a:noFill/>
-        </p:spPr>
-        <p:txBody>
-          <a:bodyPr wrap="none">
-            <a:spAutoFit/>
-          </a:bodyPr>
-          <a:lstStyle/>
-          <a:p>
-            <a:pPr algn="ctr">
-              <a:defRPr sz="850" b="1">
-                <a:solidFill>
-                  <a:srgbClr val="FACC15"/>
-                </a:solidFill>
-              </a:defRPr>
-            </a:pPr>
-            <a:r>
-              <a:t>02</a:t>
-            </a:r>
-          </a:p>
-        </p:txBody>
-      </p:sp>
-      <p:sp>
-        <p:nvSpPr>
-          <p:cNvPr id="27" name="TextBox 26"/>
-          <p:cNvSpPr txBox="1"/>
-          <p:nvPr/>
-        </p:nvSpPr>
-        <p:spPr>
-          <a:xfrm>
-            <a:off x="8604504" y="4617720"/>
-            <a:ext cx="640080" cy="320040"/>
-          </a:xfrm>
-          <a:prstGeom prst="rect">
-            <a:avLst/>
-          </a:prstGeom>
-          <a:noFill/>
-        </p:spPr>
-        <p:txBody>
-          <a:bodyPr wrap="none">
-            <a:spAutoFit/>
-          </a:bodyPr>
-          <a:lstStyle/>
-          <a:p>
-            <a:pPr algn="ctr">
-              <a:defRPr sz="770" b="0">
-                <a:solidFill>
-                  <a:srgbClr val="CBD5E1"/>
-                </a:solidFill>
-              </a:defRPr>
-            </a:pPr>
-            <a:r>
-              <a:t>partial tree</a:t>
-            </a:r>
-          </a:p>
-        </p:txBody>
-      </p:sp>
-      <p:sp>
-        <p:nvSpPr>
-          <p:cNvPr id="28" name="Rounded Rectangle 27"/>
-          <p:cNvSpPr/>
-          <p:nvPr/>
-        </p:nvSpPr>
-        <p:spPr>
-          <a:xfrm>
-            <a:off x="9390888" y="4224528"/>
-            <a:ext cx="512064" cy="310896"/>
-          </a:xfrm>
-          <a:prstGeom prst="roundRect">
-            <a:avLst/>
-          </a:prstGeom>
-          <a:solidFill>
-            <a:srgbClr val="1E293B"/>
-          </a:solidFill>
-          <a:ln>
-            <a:solidFill>
-              <a:srgbClr val="475569"/>
-            </a:solidFill>
-          </a:ln>
-        </p:spPr>
-        <p:style>
-          <a:lnRef idx="1">
-            <a:schemeClr val="accent1"/>
-          </a:lnRef>
-          <a:fillRef idx="3">
-            <a:schemeClr val="accent1"/>
-          </a:fillRef>
-          <a:effectRef idx="2">
-            <a:schemeClr val="accent1"/>
-          </a:effectRef>
-          <a:fontRef idx="minor">
-            <a:schemeClr val="lt1"/>
-          </a:fontRef>
-        </p:style>
-        <p:txBody>
-          <a:bodyPr rtlCol="0" anchor="ctr"/>
-          <a:lstStyle/>
-          <a:p>
-            <a:pPr algn="ctr"/>
-          </a:p>
-        </p:txBody>
-      </p:sp>
-      <p:sp>
-        <p:nvSpPr>
-          <p:cNvPr id="29" name="TextBox 28"/>
-          <p:cNvSpPr txBox="1"/>
-          <p:nvPr/>
-        </p:nvSpPr>
-        <p:spPr>
-          <a:xfrm>
-            <a:off x="9390888" y="4279392"/>
-            <a:ext cx="512064" cy="137160"/>
-          </a:xfrm>
-          <a:prstGeom prst="rect">
-            <a:avLst/>
-          </a:prstGeom>
-          <a:noFill/>
-        </p:spPr>
-        <p:txBody>
-          <a:bodyPr wrap="none">
-            <a:spAutoFit/>
-          </a:bodyPr>
-          <a:lstStyle/>
-          <a:p>
-            <a:pPr algn="ctr">
-              <a:defRPr sz="850" b="1">
-                <a:solidFill>
-                  <a:srgbClr val="FACC15"/>
-                </a:solidFill>
-              </a:defRPr>
-            </a:pPr>
-            <a:r>
-              <a:t>03</a:t>
-            </a:r>
-          </a:p>
-        </p:txBody>
-      </p:sp>
-      <p:sp>
-        <p:nvSpPr>
-          <p:cNvPr id="30" name="TextBox 29"/>
-          <p:cNvSpPr txBox="1"/>
-          <p:nvPr/>
-        </p:nvSpPr>
-        <p:spPr>
-          <a:xfrm>
-            <a:off x="9354312" y="4617720"/>
-            <a:ext cx="640080" cy="320040"/>
-          </a:xfrm>
-          <a:prstGeom prst="rect">
-            <a:avLst/>
-          </a:prstGeom>
-          <a:noFill/>
-        </p:spPr>
-        <p:txBody>
-          <a:bodyPr wrap="none">
-            <a:spAutoFit/>
-          </a:bodyPr>
-          <a:lstStyle/>
-          <a:p>
-            <a:pPr algn="ctr">
-              <a:defRPr sz="770" b="0">
-                <a:solidFill>
-                  <a:srgbClr val="CBD5E1"/>
-                </a:solidFill>
-              </a:defRPr>
-            </a:pPr>
-            <a:r>
-              <a:t>cache bug</a:t>
-            </a:r>
-          </a:p>
-        </p:txBody>
-      </p:sp>
-      <p:sp>
-        <p:nvSpPr>
-          <p:cNvPr id="31" name="Rounded Rectangle 30"/>
-          <p:cNvSpPr/>
-          <p:nvPr/>
-        </p:nvSpPr>
-        <p:spPr>
-          <a:xfrm>
-            <a:off x="10140696" y="4224528"/>
-            <a:ext cx="512064" cy="310896"/>
-          </a:xfrm>
-          <a:prstGeom prst="roundRect">
-            <a:avLst/>
-          </a:prstGeom>
-          <a:solidFill>
-            <a:srgbClr val="1E293B"/>
-          </a:solidFill>
-          <a:ln>
-            <a:solidFill>
-              <a:srgbClr val="475569"/>
-            </a:solidFill>
-          </a:ln>
-        </p:spPr>
-        <p:style>
-          <a:lnRef idx="1">
-            <a:schemeClr val="accent1"/>
-          </a:lnRef>
-          <a:fillRef idx="3">
-            <a:schemeClr val="accent1"/>
-          </a:fillRef>
-          <a:effectRef idx="2">
-            <a:schemeClr val="accent1"/>
-          </a:effectRef>
-          <a:fontRef idx="minor">
-            <a:schemeClr val="lt1"/>
-          </a:fontRef>
-        </p:style>
-        <p:txBody>
-          <a:bodyPr rtlCol="0" anchor="ctr"/>
-          <a:lstStyle/>
-          <a:p>
-            <a:pPr algn="ctr"/>
-          </a:p>
-        </p:txBody>
-      </p:sp>
-      <p:sp>
-        <p:nvSpPr>
           <p:cNvPr id="32" name="TextBox 31"/>
-          <p:cNvSpPr txBox="1"/>
-          <p:nvPr/>
-        </p:nvSpPr>
-        <p:spPr>
-          <a:xfrm>
-            <a:off x="10140696" y="4279392"/>
-            <a:ext cx="512064" cy="137160"/>
-          </a:xfrm>
-          <a:prstGeom prst="rect">
-            <a:avLst/>
-          </a:prstGeom>
-          <a:noFill/>
-        </p:spPr>
-        <p:txBody>
-          <a:bodyPr wrap="none">
-            <a:spAutoFit/>
-          </a:bodyPr>
-          <a:lstStyle/>
-          <a:p>
-            <a:pPr algn="ctr">
-              <a:defRPr sz="850" b="1">
-                <a:solidFill>
-                  <a:srgbClr val="FACC15"/>
-                </a:solidFill>
-              </a:defRPr>
-            </a:pPr>
-            <a:r>
-              <a:t>04</a:t>
-            </a:r>
-          </a:p>
-        </p:txBody>
-      </p:sp>
-      <p:sp>
-        <p:nvSpPr>
-          <p:cNvPr id="33" name="TextBox 32"/>
-          <p:cNvSpPr txBox="1"/>
-          <p:nvPr/>
-        </p:nvSpPr>
-        <p:spPr>
-          <a:xfrm>
-            <a:off x="10104120" y="4617720"/>
-            <a:ext cx="640080" cy="320040"/>
-          </a:xfrm>
-          <a:prstGeom prst="rect">
-            <a:avLst/>
-          </a:prstGeom>
-          <a:noFill/>
-        </p:spPr>
-        <p:txBody>
-          <a:bodyPr wrap="none">
-            <a:spAutoFit/>
-          </a:bodyPr>
-          <a:lstStyle/>
-          <a:p>
-            <a:pPr algn="ctr">
-              <a:defRPr sz="770" b="0">
-                <a:solidFill>
-                  <a:srgbClr val="CBD5E1"/>
-                </a:solidFill>
-              </a:defRPr>
-            </a:pPr>
-            <a:r>
-              <a:t>binary layout</a:t>
-            </a:r>
-          </a:p>
-        </p:txBody>
-      </p:sp>
-      <p:sp>
-        <p:nvSpPr>
-          <p:cNvPr id="34" name="Rounded Rectangle 33"/>
-          <p:cNvSpPr/>
-          <p:nvPr/>
-        </p:nvSpPr>
-        <p:spPr>
-          <a:xfrm>
-            <a:off x="10890504" y="4224528"/>
-            <a:ext cx="512064" cy="310896"/>
-          </a:xfrm>
-          <a:prstGeom prst="roundRect">
-            <a:avLst/>
-          </a:prstGeom>
-          <a:solidFill>
-            <a:srgbClr val="1E293B"/>
-          </a:solidFill>
-          <a:ln>
-            <a:solidFill>
-              <a:srgbClr val="475569"/>
-            </a:solidFill>
-          </a:ln>
-        </p:spPr>
-        <p:style>
-          <a:lnRef idx="1">
-            <a:schemeClr val="accent1"/>
-          </a:lnRef>
-          <a:fillRef idx="3">
-            <a:schemeClr val="accent1"/>
-          </a:fillRef>
-          <a:effectRef idx="2">
-            <a:schemeClr val="accent1"/>
-          </a:effectRef>
-          <a:fontRef idx="minor">
-            <a:schemeClr val="lt1"/>
-          </a:fontRef>
-        </p:style>
-        <p:txBody>
-          <a:bodyPr rtlCol="0" anchor="ctr"/>
-          <a:lstStyle/>
-          <a:p>
-            <a:pPr algn="ctr"/>
-          </a:p>
-        </p:txBody>
-      </p:sp>
-      <p:sp>
-        <p:nvSpPr>
-          <p:cNvPr id="35" name="TextBox 34"/>
-          <p:cNvSpPr txBox="1"/>
-          <p:nvPr/>
-        </p:nvSpPr>
-        <p:spPr>
-          <a:xfrm>
-            <a:off x="10890504" y="4279392"/>
-            <a:ext cx="512064" cy="137160"/>
-          </a:xfrm>
-          <a:prstGeom prst="rect">
-            <a:avLst/>
-          </a:prstGeom>
-          <a:noFill/>
-        </p:spPr>
-        <p:txBody>
-          <a:bodyPr wrap="none">
-            <a:spAutoFit/>
-          </a:bodyPr>
-          <a:lstStyle/>
-          <a:p>
-            <a:pPr algn="ctr">
-              <a:defRPr sz="850" b="1">
-                <a:solidFill>
-                  <a:srgbClr val="FACC15"/>
-                </a:solidFill>
-              </a:defRPr>
-            </a:pPr>
-            <a:r>
-              <a:t>05</a:t>
-            </a:r>
-          </a:p>
-        </p:txBody>
-      </p:sp>
-      <p:sp>
-        <p:nvSpPr>
-          <p:cNvPr id="36" name="TextBox 35"/>
-          <p:cNvSpPr txBox="1"/>
-          <p:nvPr/>
-        </p:nvSpPr>
-        <p:spPr>
-          <a:xfrm>
-            <a:off x="10853928" y="4617720"/>
-            <a:ext cx="640080" cy="320040"/>
-          </a:xfrm>
-          <a:prstGeom prst="rect">
-            <a:avLst/>
-          </a:prstGeom>
-          <a:noFill/>
-        </p:spPr>
-        <p:txBody>
-          <a:bodyPr wrap="none">
-            <a:spAutoFit/>
-          </a:bodyPr>
-          <a:lstStyle/>
-          <a:p>
-            <a:pPr algn="ctr">
-              <a:defRPr sz="770" b="0">
-                <a:solidFill>
-                  <a:srgbClr val="CBD5E1"/>
-                </a:solidFill>
-              </a:defRPr>
-            </a:pPr>
-            <a:r>
-              <a:t>missing shards</a:t>
-            </a:r>
-          </a:p>
-        </p:txBody>
-      </p:sp>
-      <p:sp>
-        <p:nvSpPr>
-          <p:cNvPr id="37" name="Rounded Rectangle 36"/>
-          <p:cNvSpPr/>
-          <p:nvPr/>
-        </p:nvSpPr>
-        <p:spPr>
-          <a:xfrm>
-            <a:off x="7635240" y="5468112"/>
-            <a:ext cx="1965960" cy="685800"/>
-          </a:xfrm>
-          <a:prstGeom prst="roundRect">
-            <a:avLst/>
-          </a:prstGeom>
-          <a:solidFill>
-            <a:srgbClr val="13251F"/>
-          </a:solidFill>
-          <a:ln>
-            <a:solidFill>
-              <a:srgbClr val="34D399"/>
-            </a:solidFill>
-          </a:ln>
-        </p:spPr>
-        <p:style>
-          <a:lnRef idx="1">
-            <a:schemeClr val="accent1"/>
-          </a:lnRef>
-          <a:fillRef idx="3">
-            <a:schemeClr val="accent1"/>
-          </a:fillRef>
-          <a:effectRef idx="2">
-            <a:schemeClr val="accent1"/>
-          </a:effectRef>
-          <a:fontRef idx="minor">
-            <a:schemeClr val="lt1"/>
-          </a:fontRef>
-        </p:style>
-        <p:txBody>
-          <a:bodyPr rtlCol="0" anchor="ctr"/>
-          <a:lstStyle/>
-          <a:p>
-            <a:pPr algn="ctr"/>
-          </a:p>
-        </p:txBody>
-      </p:sp>
-      <p:sp>
-        <p:nvSpPr>
-          <p:cNvPr id="38" name="TextBox 37"/>
-          <p:cNvSpPr txBox="1"/>
-          <p:nvPr/>
-        </p:nvSpPr>
-        <p:spPr>
-          <a:xfrm>
-            <a:off x="7818120" y="5577840"/>
-            <a:ext cx="1600200" cy="182880"/>
-          </a:xfrm>
-          <a:prstGeom prst="rect">
-            <a:avLst/>
-          </a:prstGeom>
-          <a:noFill/>
-        </p:spPr>
-        <p:txBody>
-          <a:bodyPr wrap="none">
-            <a:spAutoFit/>
-          </a:bodyPr>
-          <a:lstStyle/>
-          <a:p>
-            <a:pPr>
-              <a:defRPr sz="1200" b="1">
-                <a:solidFill>
-                  <a:srgbClr val="BBF7D0"/>
-                </a:solidFill>
-              </a:defRPr>
-            </a:pPr>
-            <a:r>
-              <a:t>Fairness</a:t>
-            </a:r>
-          </a:p>
-        </p:txBody>
-      </p:sp>
-      <p:sp>
-        <p:nvSpPr>
-          <p:cNvPr id="39" name="TextBox 38"/>
-          <p:cNvSpPr txBox="1"/>
-          <p:nvPr/>
-        </p:nvSpPr>
-        <p:spPr>
-          <a:xfrm>
-            <a:off x="7818120" y="5815584"/>
-            <a:ext cx="1600200" cy="182880"/>
-          </a:xfrm>
-          <a:prstGeom prst="rect">
-            <a:avLst/>
-          </a:prstGeom>
-          <a:noFill/>
-        </p:spPr>
-        <p:txBody>
-          <a:bodyPr wrap="none">
-            <a:spAutoFit/>
-          </a:bodyPr>
-          <a:lstStyle/>
-          <a:p>
-            <a:pPr>
-              <a:defRPr sz="919" b="0">
-                <a:solidFill>
-                  <a:srgbClr val="DCFCE7"/>
-                </a:solidFill>
-              </a:defRPr>
-            </a:pPr>
-            <a:r>
-              <a:t>4 clients each got 50 chunks</a:t>
-            </a:r>
-          </a:p>
-        </p:txBody>
-      </p:sp>
-      <p:sp>
-        <p:nvSpPr>
-          <p:cNvPr id="40" name="Rounded Rectangle 39"/>
-          <p:cNvSpPr/>
-          <p:nvPr/>
-        </p:nvSpPr>
-        <p:spPr>
-          <a:xfrm>
-            <a:off x="9829800" y="5468112"/>
-            <a:ext cx="1965960" cy="685800"/>
-          </a:xfrm>
-          <a:prstGeom prst="roundRect">
-            <a:avLst/>
-          </a:prstGeom>
-          <a:solidFill>
-            <a:srgbClr val="2A1B13"/>
-          </a:solidFill>
-          <a:ln>
-            <a:solidFill>
-              <a:srgbClr val="F59E0B"/>
-            </a:solidFill>
-          </a:ln>
-        </p:spPr>
-        <p:style>
-          <a:lnRef idx="1">
-            <a:schemeClr val="accent1"/>
-          </a:lnRef>
-          <a:fillRef idx="3">
-            <a:schemeClr val="accent1"/>
-          </a:fillRef>
-          <a:effectRef idx="2">
-            <a:schemeClr val="accent1"/>
-          </a:effectRef>
-          <a:fontRef idx="minor">
-            <a:schemeClr val="lt1"/>
-          </a:fontRef>
-        </p:style>
-        <p:txBody>
-          <a:bodyPr rtlCol="0" anchor="ctr"/>
-          <a:lstStyle/>
-          <a:p>
-            <a:pPr algn="ctr"/>
-          </a:p>
-        </p:txBody>
-      </p:sp>
-      <p:sp>
-        <p:nvSpPr>
-          <p:cNvPr id="41" name="TextBox 40"/>
           <p:cNvSpPr txBox="1"/>
           <p:nvPr/>
         </p:nvSpPr>
@@ -4600,14 +4235,14 @@
               </a:defRPr>
             </a:pPr>
             <a:r>
-              <a:t>Failure</a:t>
-            </a:r>
-          </a:p>
-        </p:txBody>
-      </p:sp>
-      <p:sp>
-        <p:nvSpPr>
-          <p:cNvPr id="42" name="TextBox 41"/>
+              <a:t>Validated first</a:t>
+            </a:r>
+          </a:p>
+        </p:txBody>
+      </p:sp>
+      <p:sp>
+        <p:nvSpPr>
+          <p:cNvPr id="33" name="TextBox 32"/>
           <p:cNvSpPr txBox="1"/>
           <p:nvPr/>
         </p:nvSpPr>
@@ -4628,21 +4263,21 @@
           <a:lstStyle/>
           <a:p>
             <a:pPr>
-              <a:defRPr sz="919" b="0">
+              <a:defRPr sz="850" b="0">
                 <a:solidFill>
                   <a:srgbClr val="FFEDD5"/>
                 </a:solidFill>
               </a:defRPr>
             </a:pPr>
             <a:r>
-              <a:t>H down before gather failed fast</a:t>
-            </a:r>
-          </a:p>
-        </p:txBody>
-      </p:sp>
-      <p:sp>
-        <p:nvSpPr>
-          <p:cNvPr id="43" name="TextBox 42"/>
+              <a:t>ports, tree, cache, cap, layout, shards</a:t>
+            </a:r>
+          </a:p>
+        </p:txBody>
+      </p:sp>
+      <p:sp>
+        <p:nvSpPr>
+          <p:cNvPr id="34" name="TextBox 33"/>
           <p:cNvSpPr txBox="1"/>
           <p:nvPr/>
         </p:nvSpPr>
@@ -4670,7 +4305,7 @@
               </a:defRPr>
             </a:pPr>
             <a:r>
-              <a:t>Takeaway: chunk size is a performance knob; validation is what made the knob worth measuring.</a:t>
+              <a:t>Takeaway: chunk size shifts cost from repeated paging to a fixed gather/transfer floor; 32 KB is the knee for this setup.</a:t>
             </a:r>
           </a:p>
         </p:txBody>

</xml_diff>

<commit_message>
Polish mini2 poster and source references
</commit_message>
<xml_diff>
--- a/mini2-poster.pptx
+++ b/mini2-poster.pptx
@@ -3248,7 +3248,42 @@
       </p:sp>
       <p:sp>
         <p:nvSpPr>
-          <p:cNvPr id="6" name="Rounded Rectangle 5"/>
+          <p:cNvPr id="6" name="TextBox 5"/>
+          <p:cNvSpPr txBox="1"/>
+          <p:nvPr/>
+        </p:nvSpPr>
+        <p:spPr>
+          <a:xfrm>
+            <a:off x="4645152" y="713232"/>
+            <a:ext cx="6035040" cy="201168"/>
+          </a:xfrm>
+          <a:prstGeom prst="rect">
+            <a:avLst/>
+          </a:prstGeom>
+          <a:noFill/>
+        </p:spPr>
+        <p:txBody>
+          <a:bodyPr wrap="none">
+            <a:spAutoFit/>
+          </a:bodyPr>
+          <a:lstStyle/>
+          <a:p>
+            <a:pPr>
+              <a:defRPr sz="950" b="0">
+                <a:solidFill>
+                  <a:srgbClr val="94A3B8"/>
+                </a:solidFill>
+              </a:defRPr>
+            </a:pPr>
+            <a:r>
+              <a:t>NYC 311 2020-present | 80k returned rows | 20-byte records | A-F host1, G/H/I host2 | 30 runs/size</a:t>
+            </a:r>
+          </a:p>
+        </p:txBody>
+      </p:sp>
+      <p:sp>
+        <p:nvSpPr>
+          <p:cNvPr id="7" name="Rounded Rectangle 6"/>
           <p:cNvSpPr/>
           <p:nvPr/>
         </p:nvSpPr>
@@ -3293,7 +3328,7 @@
       </p:sp>
       <p:pic>
         <p:nvPicPr>
-          <p:cNvPr id="7" name="Picture 6" descr="poster_chunk_chart.png"/>
+          <p:cNvPr id="8" name="Picture 7" descr="poster_chunk_chart.png"/>
           <p:cNvPicPr>
             <a:picLocks noChangeAspect="1"/>
           </p:cNvPicPr>
@@ -3317,7 +3352,7 @@
       </p:pic>
       <p:sp>
         <p:nvSpPr>
-          <p:cNvPr id="8" name="TextBox 7"/>
+          <p:cNvPr id="9" name="TextBox 8"/>
           <p:cNvSpPr txBox="1"/>
           <p:nvPr/>
         </p:nvSpPr>
@@ -3352,7 +3387,42 @@
       </p:sp>
       <p:sp>
         <p:nvSpPr>
-          <p:cNvPr id="9" name="Rounded Rectangle 8"/>
+          <p:cNvPr id="10" name="TextBox 9"/>
+          <p:cNvSpPr txBox="1"/>
+          <p:nvPr/>
+        </p:nvSpPr>
+        <p:spPr>
+          <a:xfrm>
+            <a:off x="749808" y="5669280"/>
+            <a:ext cx="6309360" cy="182880"/>
+          </a:xfrm>
+          <a:prstGeom prst="rect">
+            <a:avLst/>
+          </a:prstGeom>
+          <a:noFill/>
+        </p:spPr>
+        <p:txBody>
+          <a:bodyPr wrap="none">
+            <a:spAutoFit/>
+          </a:bodyPr>
+          <a:lstStyle/>
+          <a:p>
+            <a:pPr algn="ctr">
+              <a:defRPr sz="880" b="0">
+                <a:solidFill>
+                  <a:srgbClr val="94A3B8"/>
+                </a:solidFill>
+              </a:defRPr>
+            </a:pPr>
+            <a:r>
+              <a:t>keywords: page count | gather/cache floor | P90 tail | opportunity fairness | fail-fast</a:t>
+            </a:r>
+          </a:p>
+        </p:txBody>
+      </p:sp>
+      <p:sp>
+        <p:nvSpPr>
+          <p:cNvPr id="11" name="Rounded Rectangle 10"/>
           <p:cNvSpPr/>
           <p:nvPr/>
         </p:nvSpPr>
@@ -3397,7 +3467,7 @@
       </p:sp>
       <p:sp>
         <p:nvSpPr>
-          <p:cNvPr id="10" name="TextBox 9"/>
+          <p:cNvPr id="12" name="TextBox 11"/>
           <p:cNvSpPr txBox="1"/>
           <p:nvPr/>
         </p:nvSpPr>
@@ -3432,7 +3502,7 @@
       </p:sp>
       <p:sp>
         <p:nvSpPr>
-          <p:cNvPr id="11" name="TextBox 10"/>
+          <p:cNvPr id="13" name="TextBox 12"/>
           <p:cNvSpPr txBox="1"/>
           <p:nvPr/>
         </p:nvSpPr>
@@ -3467,7 +3537,7 @@
       </p:sp>
       <p:sp>
         <p:nvSpPr>
-          <p:cNvPr id="12" name="TextBox 11"/>
+          <p:cNvPr id="14" name="TextBox 13"/>
           <p:cNvSpPr txBox="1"/>
           <p:nvPr/>
         </p:nvSpPr>
@@ -3502,7 +3572,7 @@
       </p:sp>
       <p:sp>
         <p:nvSpPr>
-          <p:cNvPr id="13" name="TextBox 12"/>
+          <p:cNvPr id="15" name="TextBox 14"/>
           <p:cNvSpPr txBox="1"/>
           <p:nvPr/>
         </p:nvSpPr>
@@ -3537,7 +3607,7 @@
       </p:sp>
       <p:sp>
         <p:nvSpPr>
-          <p:cNvPr id="14" name="Rounded Rectangle 13"/>
+          <p:cNvPr id="16" name="Rounded Rectangle 15"/>
           <p:cNvSpPr/>
           <p:nvPr/>
         </p:nvSpPr>
@@ -3582,7 +3652,7 @@
       </p:sp>
       <p:sp>
         <p:nvSpPr>
-          <p:cNvPr id="15" name="TextBox 14"/>
+          <p:cNvPr id="17" name="TextBox 16"/>
           <p:cNvSpPr txBox="1"/>
           <p:nvPr/>
         </p:nvSpPr>
@@ -3617,7 +3687,7 @@
       </p:sp>
       <p:sp>
         <p:nvSpPr>
-          <p:cNvPr id="16" name="TextBox 15"/>
+          <p:cNvPr id="18" name="TextBox 17"/>
           <p:cNvSpPr txBox="1"/>
           <p:nvPr/>
         </p:nvSpPr>
@@ -3652,7 +3722,7 @@
       </p:sp>
       <p:sp>
         <p:nvSpPr>
-          <p:cNvPr id="17" name="TextBox 16"/>
+          <p:cNvPr id="19" name="TextBox 18"/>
           <p:cNvSpPr txBox="1"/>
           <p:nvPr/>
         </p:nvSpPr>
@@ -3687,7 +3757,7 @@
       </p:sp>
       <p:sp>
         <p:nvSpPr>
-          <p:cNvPr id="18" name="TextBox 17"/>
+          <p:cNvPr id="20" name="TextBox 19"/>
           <p:cNvSpPr txBox="1"/>
           <p:nvPr/>
         </p:nvSpPr>
@@ -3722,7 +3792,7 @@
       </p:sp>
       <p:sp>
         <p:nvSpPr>
-          <p:cNvPr id="19" name="TextBox 18"/>
+          <p:cNvPr id="21" name="TextBox 20"/>
           <p:cNvSpPr txBox="1"/>
           <p:nvPr/>
         </p:nvSpPr>
@@ -3757,7 +3827,7 @@
       </p:sp>
       <p:sp>
         <p:nvSpPr>
-          <p:cNvPr id="20" name="Rounded Rectangle 19"/>
+          <p:cNvPr id="22" name="Rounded Rectangle 21"/>
           <p:cNvSpPr/>
           <p:nvPr/>
         </p:nvSpPr>
@@ -3802,7 +3872,7 @@
       </p:sp>
       <p:sp>
         <p:nvSpPr>
-          <p:cNvPr id="21" name="TextBox 20"/>
+          <p:cNvPr id="23" name="TextBox 22"/>
           <p:cNvSpPr txBox="1"/>
           <p:nvPr/>
         </p:nvSpPr>
@@ -3837,7 +3907,7 @@
       </p:sp>
       <p:sp>
         <p:nvSpPr>
-          <p:cNvPr id="22" name="TextBox 21"/>
+          <p:cNvPr id="24" name="TextBox 23"/>
           <p:cNvSpPr txBox="1"/>
           <p:nvPr/>
         </p:nvSpPr>
@@ -3872,7 +3942,7 @@
       </p:sp>
       <p:sp>
         <p:nvSpPr>
-          <p:cNvPr id="23" name="TextBox 22"/>
+          <p:cNvPr id="25" name="TextBox 24"/>
           <p:cNvSpPr txBox="1"/>
           <p:nvPr/>
         </p:nvSpPr>
@@ -3907,7 +3977,7 @@
       </p:sp>
       <p:sp>
         <p:nvSpPr>
-          <p:cNvPr id="24" name="TextBox 23"/>
+          <p:cNvPr id="26" name="TextBox 25"/>
           <p:cNvSpPr txBox="1"/>
           <p:nvPr/>
         </p:nvSpPr>
@@ -3942,7 +4012,7 @@
       </p:sp>
       <p:sp>
         <p:nvSpPr>
-          <p:cNvPr id="25" name="TextBox 24"/>
+          <p:cNvPr id="27" name="TextBox 26"/>
           <p:cNvSpPr txBox="1"/>
           <p:nvPr/>
         </p:nvSpPr>
@@ -3977,7 +4047,7 @@
       </p:sp>
       <p:sp>
         <p:nvSpPr>
-          <p:cNvPr id="26" name="TextBox 25"/>
+          <p:cNvPr id="28" name="TextBox 27"/>
           <p:cNvSpPr txBox="1"/>
           <p:nvPr/>
         </p:nvSpPr>
@@ -4012,7 +4082,7 @@
       </p:sp>
       <p:sp>
         <p:nvSpPr>
-          <p:cNvPr id="27" name="TextBox 26"/>
+          <p:cNvPr id="29" name="TextBox 28"/>
           <p:cNvSpPr txBox="1"/>
           <p:nvPr/>
         </p:nvSpPr>
@@ -4047,7 +4117,7 @@
       </p:sp>
       <p:sp>
         <p:nvSpPr>
-          <p:cNvPr id="28" name="Rounded Rectangle 27"/>
+          <p:cNvPr id="30" name="Rounded Rectangle 29"/>
           <p:cNvSpPr/>
           <p:nvPr/>
         </p:nvSpPr>
@@ -4092,7 +4162,7 @@
       </p:sp>
       <p:sp>
         <p:nvSpPr>
-          <p:cNvPr id="29" name="TextBox 28"/>
+          <p:cNvPr id="31" name="TextBox 30"/>
           <p:cNvSpPr txBox="1"/>
           <p:nvPr/>
         </p:nvSpPr>
@@ -4127,7 +4197,7 @@
       </p:sp>
       <p:sp>
         <p:nvSpPr>
-          <p:cNvPr id="30" name="TextBox 29"/>
+          <p:cNvPr id="32" name="TextBox 31"/>
           <p:cNvSpPr txBox="1"/>
           <p:nvPr/>
         </p:nvSpPr>
@@ -4162,7 +4232,7 @@
       </p:sp>
       <p:sp>
         <p:nvSpPr>
-          <p:cNvPr id="31" name="Rounded Rectangle 30"/>
+          <p:cNvPr id="33" name="Rounded Rectangle 32"/>
           <p:cNvSpPr/>
           <p:nvPr/>
         </p:nvSpPr>
@@ -4207,7 +4277,7 @@
       </p:sp>
       <p:sp>
         <p:nvSpPr>
-          <p:cNvPr id="32" name="TextBox 31"/>
+          <p:cNvPr id="34" name="TextBox 33"/>
           <p:cNvSpPr txBox="1"/>
           <p:nvPr/>
         </p:nvSpPr>
@@ -4242,7 +4312,7 @@
       </p:sp>
       <p:sp>
         <p:nvSpPr>
-          <p:cNvPr id="33" name="TextBox 32"/>
+          <p:cNvPr id="35" name="TextBox 34"/>
           <p:cNvSpPr txBox="1"/>
           <p:nvPr/>
         </p:nvSpPr>
@@ -4277,7 +4347,7 @@
       </p:sp>
       <p:sp>
         <p:nvSpPr>
-          <p:cNvPr id="34" name="TextBox 33"/>
+          <p:cNvPr id="36" name="TextBox 35"/>
           <p:cNvSpPr txBox="1"/>
           <p:nvPr/>
         </p:nvSpPr>

</xml_diff>

<commit_message>
Refine mini2 poster layout and notes
</commit_message>
<xml_diff>
--- a/mini2-poster.pptx
+++ b/mini2-poster.pptx
@@ -105,6 +105,456 @@
     </a:lvl9pPr>
   </p:defaultTextStyle>
 </p:presentation>
+</file>
+
+<file path=ppt/notesMasters/notesMaster1.xml><?xml version="1.0" encoding="utf-8"?>
+<p:notesMaster xmlns:a="http://schemas.openxmlformats.org/drawingml/2006/main" xmlns:p="http://schemas.openxmlformats.org/presentationml/2006/main" xmlns:r="http://schemas.openxmlformats.org/officeDocument/2006/relationships">
+  <p:cSld>
+    <p:bg>
+      <p:bgRef idx="1001">
+        <a:schemeClr val="bg1"/>
+      </p:bgRef>
+    </p:bg>
+    <p:spTree>
+      <p:nvGrpSpPr>
+        <p:cNvPr id="1" name=""/>
+        <p:cNvGrpSpPr/>
+        <p:nvPr/>
+      </p:nvGrpSpPr>
+      <p:grpSpPr>
+        <a:xfrm>
+          <a:off x="0" y="0"/>
+          <a:ext cx="0" cy="0"/>
+          <a:chOff x="0" y="0"/>
+          <a:chExt cx="0" cy="0"/>
+        </a:xfrm>
+      </p:grpSpPr>
+      <p:sp>
+        <p:nvSpPr>
+          <p:cNvPr id="2" name="Header Placeholder 1"/>
+          <p:cNvSpPr>
+            <a:spLocks noGrp="1"/>
+          </p:cNvSpPr>
+          <p:nvPr>
+            <p:ph type="hdr" sz="quarter"/>
+          </p:nvPr>
+        </p:nvSpPr>
+        <p:spPr>
+          <a:xfrm>
+            <a:off x="0" y="0"/>
+            <a:ext cx="2971800" cy="457200"/>
+          </a:xfrm>
+          <a:prstGeom prst="rect">
+            <a:avLst/>
+          </a:prstGeom>
+        </p:spPr>
+        <p:txBody>
+          <a:bodyPr vert="horz" lIns="91440" tIns="45720" rIns="91440" bIns="45720" rtlCol="0"/>
+          <a:lstStyle>
+            <a:lvl1pPr algn="l">
+              <a:defRPr sz="1200"/>
+            </a:lvl1pPr>
+          </a:lstStyle>
+          <a:p>
+            <a:endParaRPr lang="en-US"/>
+          </a:p>
+        </p:txBody>
+      </p:sp>
+      <p:sp>
+        <p:nvSpPr>
+          <p:cNvPr id="3" name="Date Placeholder 2"/>
+          <p:cNvSpPr>
+            <a:spLocks noGrp="1"/>
+          </p:cNvSpPr>
+          <p:nvPr>
+            <p:ph type="dt" idx="1"/>
+          </p:nvPr>
+        </p:nvSpPr>
+        <p:spPr>
+          <a:xfrm>
+            <a:off x="3884613" y="0"/>
+            <a:ext cx="2971800" cy="457200"/>
+          </a:xfrm>
+          <a:prstGeom prst="rect">
+            <a:avLst/>
+          </a:prstGeom>
+        </p:spPr>
+        <p:txBody>
+          <a:bodyPr vert="horz" lIns="91440" tIns="45720" rIns="91440" bIns="45720" rtlCol="0"/>
+          <a:lstStyle>
+            <a:lvl1pPr algn="r">
+              <a:defRPr sz="1200"/>
+            </a:lvl1pPr>
+          </a:lstStyle>
+          <a:p>
+            <a:fld id="{0F89C1C7-3DCD-1040-A9CF-14679D8B5DDD}" type="datetimeFigureOut">
+              <a:rPr lang="en-US" smtClean="0"/>
+              <a:t>10/17/16</a:t>
+            </a:fld>
+            <a:endParaRPr lang="en-US"/>
+          </a:p>
+        </p:txBody>
+      </p:sp>
+      <p:sp>
+        <p:nvSpPr>
+          <p:cNvPr id="4" name="Slide Image Placeholder 3"/>
+          <p:cNvSpPr>
+            <a:spLocks noGrp="1" noRot="1" noChangeAspect="1"/>
+          </p:cNvSpPr>
+          <p:nvPr>
+            <p:ph type="sldImg" idx="2"/>
+          </p:nvPr>
+        </p:nvSpPr>
+        <p:spPr>
+          <a:xfrm>
+            <a:off x="1143000" y="685800"/>
+            <a:ext cx="4572000" cy="3429000"/>
+          </a:xfrm>
+          <a:prstGeom prst="rect">
+            <a:avLst/>
+          </a:prstGeom>
+          <a:noFill/>
+          <a:ln w="12700">
+            <a:solidFill>
+              <a:prstClr val="black"/>
+            </a:solidFill>
+          </a:ln>
+        </p:spPr>
+        <p:txBody>
+          <a:bodyPr vert="horz" lIns="91440" tIns="45720" rIns="91440" bIns="45720" rtlCol="0" anchor="ctr"/>
+          <a:lstStyle/>
+          <a:p>
+            <a:endParaRPr lang="en-US"/>
+          </a:p>
+        </p:txBody>
+      </p:sp>
+      <p:sp>
+        <p:nvSpPr>
+          <p:cNvPr id="5" name="Notes Placeholder 4"/>
+          <p:cNvSpPr>
+            <a:spLocks noGrp="1"/>
+          </p:cNvSpPr>
+          <p:nvPr>
+            <p:ph type="body" sz="quarter" idx="3"/>
+          </p:nvPr>
+        </p:nvSpPr>
+        <p:spPr>
+          <a:xfrm>
+            <a:off x="685800" y="4343400"/>
+            <a:ext cx="5486400" cy="4114800"/>
+          </a:xfrm>
+          <a:prstGeom prst="rect">
+            <a:avLst/>
+          </a:prstGeom>
+        </p:spPr>
+        <p:txBody>
+          <a:bodyPr vert="horz" lIns="91440" tIns="45720" rIns="91440" bIns="45720" rtlCol="0"/>
+          <a:lstStyle/>
+          <a:p>
+            <a:pPr lvl="0"/>
+            <a:r>
+              <a:rPr lang="en-US" smtClean="0"/>
+              <a:t>Click to edit Master text styles</a:t>
+            </a:r>
+          </a:p>
+          <a:p>
+            <a:pPr lvl="1"/>
+            <a:r>
+              <a:rPr lang="en-US" smtClean="0"/>
+              <a:t>Second level</a:t>
+            </a:r>
+          </a:p>
+          <a:p>
+            <a:pPr lvl="2"/>
+            <a:r>
+              <a:rPr lang="en-US" smtClean="0"/>
+              <a:t>Third level</a:t>
+            </a:r>
+          </a:p>
+          <a:p>
+            <a:pPr lvl="3"/>
+            <a:r>
+              <a:rPr lang="en-US" smtClean="0"/>
+              <a:t>Fourth level</a:t>
+            </a:r>
+          </a:p>
+          <a:p>
+            <a:pPr lvl="4"/>
+            <a:r>
+              <a:rPr lang="en-US" smtClean="0"/>
+              <a:t>Fifth level</a:t>
+            </a:r>
+            <a:endParaRPr lang="en-US"/>
+          </a:p>
+        </p:txBody>
+      </p:sp>
+      <p:sp>
+        <p:nvSpPr>
+          <p:cNvPr id="6" name="Footer Placeholder 5"/>
+          <p:cNvSpPr>
+            <a:spLocks noGrp="1"/>
+          </p:cNvSpPr>
+          <p:nvPr>
+            <p:ph type="ftr" sz="quarter" idx="4"/>
+          </p:nvPr>
+        </p:nvSpPr>
+        <p:spPr>
+          <a:xfrm>
+            <a:off x="0" y="8685213"/>
+            <a:ext cx="2971800" cy="457200"/>
+          </a:xfrm>
+          <a:prstGeom prst="rect">
+            <a:avLst/>
+          </a:prstGeom>
+        </p:spPr>
+        <p:txBody>
+          <a:bodyPr vert="horz" lIns="91440" tIns="45720" rIns="91440" bIns="45720" rtlCol="0" anchor="b"/>
+          <a:lstStyle>
+            <a:lvl1pPr algn="l">
+              <a:defRPr sz="1200"/>
+            </a:lvl1pPr>
+          </a:lstStyle>
+          <a:p>
+            <a:endParaRPr lang="en-US"/>
+          </a:p>
+        </p:txBody>
+      </p:sp>
+      <p:sp>
+        <p:nvSpPr>
+          <p:cNvPr id="7" name="Slide Number Placeholder 6"/>
+          <p:cNvSpPr>
+            <a:spLocks noGrp="1"/>
+          </p:cNvSpPr>
+          <p:nvPr>
+            <p:ph type="sldNum" sz="quarter" idx="5"/>
+          </p:nvPr>
+        </p:nvSpPr>
+        <p:spPr>
+          <a:xfrm>
+            <a:off x="3884613" y="8685213"/>
+            <a:ext cx="2971800" cy="457200"/>
+          </a:xfrm>
+          <a:prstGeom prst="rect">
+            <a:avLst/>
+          </a:prstGeom>
+        </p:spPr>
+        <p:txBody>
+          <a:bodyPr vert="horz" lIns="91440" tIns="45720" rIns="91440" bIns="45720" rtlCol="0" anchor="b"/>
+          <a:lstStyle>
+            <a:lvl1pPr algn="r">
+              <a:defRPr sz="1200"/>
+            </a:lvl1pPr>
+          </a:lstStyle>
+          <a:p>
+            <a:fld id="{BB5E49A5-4136-284D-997B-48E1D791AD67}" type="slidenum">
+              <a:rPr lang="en-US" smtClean="0"/>
+              <a:t>‹#›</a:t>
+            </a:fld>
+            <a:endParaRPr lang="en-US"/>
+          </a:p>
+        </p:txBody>
+      </p:sp>
+    </p:spTree>
+    <p:extLst>
+      <p:ext uri="{BB962C8B-B14F-4D97-AF65-F5344CB8AC3E}">
+        <p14:creationId xmlns:p14="http://schemas.microsoft.com/office/powerpoint/2010/main" val="2623252185"/>
+      </p:ext>
+    </p:extLst>
+  </p:cSld>
+  <p:clrMap bg1="lt1" tx1="dk1" bg2="lt2" tx2="dk2" accent1="accent1" accent2="accent2" accent3="accent3" accent4="accent4" accent5="accent5" accent6="accent6" hlink="hlink" folHlink="folHlink"/>
+  <p:notesStyle>
+    <a:lvl1pPr marL="0" algn="l" defTabSz="457200" rtl="0" eaLnBrk="1" latinLnBrk="0" hangingPunct="1">
+      <a:defRPr sz="1200" kern="1200">
+        <a:solidFill>
+          <a:schemeClr val="tx1"/>
+        </a:solidFill>
+        <a:latin typeface="+mn-lt"/>
+        <a:ea typeface="+mn-ea"/>
+        <a:cs typeface="+mn-cs"/>
+      </a:defRPr>
+    </a:lvl1pPr>
+    <a:lvl2pPr marL="457200" algn="l" defTabSz="457200" rtl="0" eaLnBrk="1" latinLnBrk="0" hangingPunct="1">
+      <a:defRPr sz="1200" kern="1200">
+        <a:solidFill>
+          <a:schemeClr val="tx1"/>
+        </a:solidFill>
+        <a:latin typeface="+mn-lt"/>
+        <a:ea typeface="+mn-ea"/>
+        <a:cs typeface="+mn-cs"/>
+      </a:defRPr>
+    </a:lvl2pPr>
+    <a:lvl3pPr marL="914400" algn="l" defTabSz="457200" rtl="0" eaLnBrk="1" latinLnBrk="0" hangingPunct="1">
+      <a:defRPr sz="1200" kern="1200">
+        <a:solidFill>
+          <a:schemeClr val="tx1"/>
+        </a:solidFill>
+        <a:latin typeface="+mn-lt"/>
+        <a:ea typeface="+mn-ea"/>
+        <a:cs typeface="+mn-cs"/>
+      </a:defRPr>
+    </a:lvl3pPr>
+    <a:lvl4pPr marL="1371600" algn="l" defTabSz="457200" rtl="0" eaLnBrk="1" latinLnBrk="0" hangingPunct="1">
+      <a:defRPr sz="1200" kern="1200">
+        <a:solidFill>
+          <a:schemeClr val="tx1"/>
+        </a:solidFill>
+        <a:latin typeface="+mn-lt"/>
+        <a:ea typeface="+mn-ea"/>
+        <a:cs typeface="+mn-cs"/>
+      </a:defRPr>
+    </a:lvl4pPr>
+    <a:lvl5pPr marL="1828800" algn="l" defTabSz="457200" rtl="0" eaLnBrk="1" latinLnBrk="0" hangingPunct="1">
+      <a:defRPr sz="1200" kern="1200">
+        <a:solidFill>
+          <a:schemeClr val="tx1"/>
+        </a:solidFill>
+        <a:latin typeface="+mn-lt"/>
+        <a:ea typeface="+mn-ea"/>
+        <a:cs typeface="+mn-cs"/>
+      </a:defRPr>
+    </a:lvl5pPr>
+    <a:lvl6pPr marL="2286000" algn="l" defTabSz="457200" rtl="0" eaLnBrk="1" latinLnBrk="0" hangingPunct="1">
+      <a:defRPr sz="1200" kern="1200">
+        <a:solidFill>
+          <a:schemeClr val="tx1"/>
+        </a:solidFill>
+        <a:latin typeface="+mn-lt"/>
+        <a:ea typeface="+mn-ea"/>
+        <a:cs typeface="+mn-cs"/>
+      </a:defRPr>
+    </a:lvl6pPr>
+    <a:lvl7pPr marL="2743200" algn="l" defTabSz="457200" rtl="0" eaLnBrk="1" latinLnBrk="0" hangingPunct="1">
+      <a:defRPr sz="1200" kern="1200">
+        <a:solidFill>
+          <a:schemeClr val="tx1"/>
+        </a:solidFill>
+        <a:latin typeface="+mn-lt"/>
+        <a:ea typeface="+mn-ea"/>
+        <a:cs typeface="+mn-cs"/>
+      </a:defRPr>
+    </a:lvl7pPr>
+    <a:lvl8pPr marL="3200400" algn="l" defTabSz="457200" rtl="0" eaLnBrk="1" latinLnBrk="0" hangingPunct="1">
+      <a:defRPr sz="1200" kern="1200">
+        <a:solidFill>
+          <a:schemeClr val="tx1"/>
+        </a:solidFill>
+        <a:latin typeface="+mn-lt"/>
+        <a:ea typeface="+mn-ea"/>
+        <a:cs typeface="+mn-cs"/>
+      </a:defRPr>
+    </a:lvl8pPr>
+    <a:lvl9pPr marL="3657600" algn="l" defTabSz="457200" rtl="0" eaLnBrk="1" latinLnBrk="0" hangingPunct="1">
+      <a:defRPr sz="1200" kern="1200">
+        <a:solidFill>
+          <a:schemeClr val="tx1"/>
+        </a:solidFill>
+        <a:latin typeface="+mn-lt"/>
+        <a:ea typeface="+mn-ea"/>
+        <a:cs typeface="+mn-cs"/>
+      </a:defRPr>
+    </a:lvl9pPr>
+  </p:notesStyle>
+</p:notesMaster>
+</file>
+
+<file path=ppt/notesSlides/notesSlide1.xml><?xml version="1.0" encoding="utf-8"?>
+<p:notes xmlns:a="http://schemas.openxmlformats.org/drawingml/2006/main" xmlns:p="http://schemas.openxmlformats.org/presentationml/2006/main" xmlns:r="http://schemas.openxmlformats.org/officeDocument/2006/relationships">
+  <p:cSld>
+    <p:spTree>
+      <p:nvGrpSpPr>
+        <p:cNvPr id="1" name=""/>
+        <p:cNvGrpSpPr/>
+        <p:nvPr/>
+      </p:nvGrpSpPr>
+      <p:grpSpPr>
+        <a:xfrm>
+          <a:off x="0" y="0"/>
+          <a:ext cx="0" cy="0"/>
+          <a:chOff x="0" y="0"/>
+          <a:chExt cx="0" cy="0"/>
+        </a:xfrm>
+      </p:grpSpPr>
+      <p:sp>
+        <p:nvSpPr>
+          <p:cNvPr id="2" name="Slide Image Placeholder 1"/>
+          <p:cNvSpPr>
+            <a:spLocks noGrp="1"/>
+          </p:cNvSpPr>
+          <p:nvPr>
+            <p:ph type="sldImg" idx="2"/>
+          </p:nvPr>
+        </p:nvSpPr>
+        <p:spPr/>
+      </p:sp>
+      <p:sp>
+        <p:nvSpPr>
+          <p:cNvPr id="3" name="Notes Placeholder 2"/>
+          <p:cNvSpPr>
+            <a:spLocks noGrp="1"/>
+          </p:cNvSpPr>
+          <p:nvPr>
+            <p:ph type="body" idx="3" sz="quarter"/>
+          </p:nvPr>
+        </p:nvSpPr>
+        <p:spPr/>
+        <p:txBody>
+          <a:bodyPr/>
+          <a:lstStyle/>
+          <a:p>
+            <a:r>
+              <a:t>I want to focus on one finding from our final run, not walk through the whole project checklist. We used NYC 311 service requests, converted a 90,000 row subset into compact 20 byte records, and returned 80,000 records through our two laptop, nine node gRPC tree. The only variable in this graph is chunk size. At first the result looks simple: 2 KB chunks took about 338 ms, and 512 KB chunks took about 44 ms, so the extreme speedup is 7.7x. But the part we found more interesting is that 32 KB used 50 pages and 512 KB used only 4 pages, yet their means were almost tied: 45.7 ms versus 44.0 ms. The slide is explaining why that happens.</a:t>
+            </a:r>
+          </a:p>
+          <a:p/>
+          <a:p>
+            <a:r>
+              <a:t>The tree diagram is the starting point. The client does not directly call B through I. The client only calls A, because A is the public entry point and owns the scatter-gather fan-in. On the first page, A has to query B, H, G, and I. B gathers C, D, and E, and E gathers F. Once those payloads return, A materializes the full 1.6 MB result and stores it in the cache under the request id. That first page is special because it pays the distributed gather cost. Later pages for the same request id do not gather the whole tree again; A slices the cached payload and returns the next chunk.</a:t>
+            </a:r>
+          </a:p>
+          <a:p/>
+          <a:p>
+            <a:r>
+              <a:t>That is why total time is not only bandwidth. The cost has four pieces: scatter-gather fan-in over Wi-Fi, cache materialization at A, amortized page cost for each QueryOnce call, and serialization/copy work for the protobuf bytes. Small chunks help on one part: each response is tiny. But they hurt badly on another part: we repeat the page path hundreds of times. Large chunks reduce the number of page calls, but each response is larger and the tail latency becomes more visible.</a:t>
+            </a:r>
+          </a:p>
+          <a:p/>
+          <a:p>
+            <a:r>
+              <a:t>The bottom-left diagram is there to avoid a common misunderstanding. The 338 ms at 2 KB is not one chunk response. It is all 800 page responses combined. Each 2 KB page is cheap, about 0.42 ms on average, but 800 cheap operations still add up. At 32 KB, the client only needs 50 pages, so most of the repeated paging overhead has already been amortized. Going from 50 pages down to 4 pages still helps a little, but now the fixed gather/cache floor and payload movement dominate. That is why 32 KB and 512 KB have almost the same mean.</a:t>
+            </a:r>
+          </a:p>
+          <a:p/>
+          <a:p>
+            <a:r>
+              <a:t>The fairness box shows why we did not just say 512 KB is the answer. At the 32 KB knee, four clients each got exactly 50 chunks through A's queue. Their finish times were not identical, but they were close: 116.8 to 121.8 ms, a 4.3 percent spread. So this is opportunity fairness. A gives clients equal turns, but network timing still creates slightly different wall-clock completion times.</a:t>
+            </a:r>
+          </a:p>
+          <a:p/>
+          <a:p>
+            <a:r>
+              <a:t>The conclusion is that the unique finding is not simply bigger chunks are faster. Chunk size shifts the bottleneck. Below 32 KB, repeated client-to-A paging dominates. Above 32 KB, the fixed gather/cache floor, serialization and copy work, and tail latency dominate. If we optimize only for mean or median, 512 KB wins by a little. If we care about robustness and fairness, 32 KB is the better operating point for this setup because it is nearly as fast but has much lower P90.</a:t>
+            </a:r>
+          </a:p>
+        </p:txBody>
+      </p:sp>
+      <p:sp>
+        <p:nvSpPr>
+          <p:cNvPr id="4" name="Slide Number Placeholder 3"/>
+          <p:cNvSpPr>
+            <a:spLocks noGrp="1"/>
+          </p:cNvSpPr>
+          <p:nvPr>
+            <p:ph type="sldNum" idx="5" sz="quarter"/>
+          </p:nvPr>
+        </p:nvSpPr>
+        <p:spPr/>
+      </p:sp>
+    </p:spTree>
+  </p:cSld>
+  <p:clrMapOvr>
+    <a:masterClrMapping/>
+  </p:clrMapOvr>
+</p:notes>
 </file>
 
 <file path=ppt/slideLayouts/slideLayout1.xml><?xml version="1.0" encoding="utf-8"?>
@@ -3149,8 +3599,8 @@
         </p:nvSpPr>
         <p:spPr>
           <a:xfrm>
-            <a:off x="320040" y="256032"/>
-            <a:ext cx="3474720" cy="411480"/>
+            <a:off x="292608" y="219456"/>
+            <a:ext cx="3246120" cy="384048"/>
           </a:xfrm>
           <a:prstGeom prst="rect">
             <a:avLst/>
@@ -3164,7 +3614,7 @@
           <a:lstStyle/>
           <a:p>
             <a:pPr>
-              <a:defRPr sz="3000" b="1">
+              <a:defRPr sz="2800" b="1">
                 <a:solidFill>
                   <a:srgbClr val="FACC15"/>
                 </a:solidFill>
@@ -3184,8 +3634,8 @@
         </p:nvSpPr>
         <p:spPr>
           <a:xfrm>
-            <a:off x="3749039" y="310896"/>
-            <a:ext cx="6675120" cy="310896"/>
+            <a:off x="3639312" y="256032"/>
+            <a:ext cx="6858000" cy="310896"/>
           </a:xfrm>
           <a:prstGeom prst="rect">
             <a:avLst/>
@@ -3199,7 +3649,7 @@
           <a:lstStyle/>
           <a:p>
             <a:pPr>
-              <a:defRPr sz="1500" b="1">
+              <a:defRPr sz="1450" b="1">
                 <a:solidFill>
                   <a:srgbClr val="E2E8F0"/>
                 </a:solidFill>
@@ -3289,8 +3739,8 @@
         </p:nvSpPr>
         <p:spPr>
           <a:xfrm>
-            <a:off x="320040" y="914400"/>
-            <a:ext cx="3886200" cy="2606040"/>
+            <a:off x="274320" y="896112"/>
+            <a:ext cx="4773168" cy="3200400"/>
           </a:xfrm>
           <a:prstGeom prst="roundRect">
             <a:avLst/>
@@ -3342,8 +3792,8 @@
         </p:blipFill>
         <p:spPr>
           <a:xfrm>
-            <a:off x="475488" y="1078992"/>
-            <a:ext cx="3566160" cy="2258568"/>
+            <a:off x="438912" y="1069848"/>
+            <a:ext cx="4462272" cy="2816352"/>
           </a:xfrm>
           <a:prstGeom prst="rect">
             <a:avLst/>
@@ -3358,8 +3808,8 @@
         </p:nvSpPr>
         <p:spPr>
           <a:xfrm>
-            <a:off x="4407408" y="914400"/>
-            <a:ext cx="3246120" cy="2606040"/>
+            <a:off x="5230368" y="896112"/>
+            <a:ext cx="2971800" cy="3200400"/>
           </a:xfrm>
           <a:prstGeom prst="roundRect">
             <a:avLst/>
@@ -3403,8 +3853,8 @@
         </p:nvSpPr>
         <p:spPr>
           <a:xfrm>
-            <a:off x="4590288" y="1042415"/>
-            <a:ext cx="2834640" cy="201168"/>
+            <a:off x="5413248" y="1024128"/>
+            <a:ext cx="2606040" cy="219456"/>
           </a:xfrm>
           <a:prstGeom prst="rect">
             <a:avLst/>
@@ -3425,46 +3875,46 @@
               </a:defRPr>
             </a:pPr>
             <a:r>
-              <a:t>Tree path: client only talks to A</a:t>
-            </a:r>
-          </a:p>
-        </p:txBody>
-      </p:sp>
-      <p:cxnSp>
-        <p:nvCxnSpPr>
-          <p:cNvPr id="11" name="Connector 10"/>
-          <p:cNvCxnSpPr/>
-          <p:nvPr/>
-        </p:nvCxnSpPr>
-        <p:spPr>
-          <a:xfrm>
-            <a:off x="4800600" y="1645920"/>
-            <a:ext cx="777240" cy="0"/>
-          </a:xfrm>
-          <a:prstGeom prst="line">
-            <a:avLst/>
-          </a:prstGeom>
-          <a:ln w="25400">
-            <a:solidFill>
-              <a:srgbClr val="38BDF8"/>
-            </a:solidFill>
-          </a:ln>
-        </p:spPr>
-        <p:style>
-          <a:lnRef idx="2">
-            <a:schemeClr val="accent1"/>
-          </a:lnRef>
-          <a:fillRef idx="0">
-            <a:schemeClr val="accent1"/>
-          </a:fillRef>
-          <a:effectRef idx="1">
-            <a:schemeClr val="accent1"/>
-          </a:effectRef>
-          <a:fontRef idx="minor">
-            <a:schemeClr val="tx1"/>
-          </a:fontRef>
-        </p:style>
-      </p:cxnSp>
+              <a:t>Scatter-gather fan-in</a:t>
+            </a:r>
+          </a:p>
+        </p:txBody>
+      </p:sp>
+      <p:sp>
+        <p:nvSpPr>
+          <p:cNvPr id="11" name="TextBox 10"/>
+          <p:cNvSpPr txBox="1"/>
+          <p:nvPr/>
+        </p:nvSpPr>
+        <p:spPr>
+          <a:xfrm>
+            <a:off x="5504688" y="1261872"/>
+            <a:ext cx="2423160" cy="182880"/>
+          </a:xfrm>
+          <a:prstGeom prst="rect">
+            <a:avLst/>
+          </a:prstGeom>
+          <a:noFill/>
+        </p:spPr>
+        <p:txBody>
+          <a:bodyPr wrap="none" lIns="36576" rIns="36576" tIns="18288" bIns="18288">
+            <a:spAutoFit/>
+          </a:bodyPr>
+          <a:lstStyle/>
+          <a:p>
+            <a:pPr algn="ctr">
+              <a:defRPr sz="919" b="1">
+                <a:solidFill>
+                  <a:srgbClr val="38BDF8"/>
+                </a:solidFill>
+              </a:defRPr>
+            </a:pPr>
+            <a:r>
+              <a:t>Client only calls A</a:t>
+            </a:r>
+          </a:p>
+        </p:txBody>
+      </p:sp>
       <p:cxnSp>
         <p:nvCxnSpPr>
           <p:cNvPr id="12" name="Connector 11"/>
@@ -3472,16 +3922,16 @@
           <p:nvPr/>
         </p:nvCxnSpPr>
         <p:spPr>
-          <a:xfrm flipH="1">
-            <a:off x="4937760" y="1645920"/>
-            <a:ext cx="640080" cy="594360"/>
+          <a:xfrm>
+            <a:off x="5623560" y="1810512"/>
+            <a:ext cx="731520" cy="0"/>
           </a:xfrm>
           <a:prstGeom prst="line">
             <a:avLst/>
           </a:prstGeom>
-          <a:ln w="13970">
+          <a:ln w="25400">
             <a:solidFill>
-              <a:srgbClr val="64748B"/>
+              <a:srgbClr val="38BDF8"/>
             </a:solidFill>
           </a:ln>
         </p:spPr>
@@ -3508,8 +3958,8 @@
         </p:nvCxnSpPr>
         <p:spPr>
           <a:xfrm flipH="1">
-            <a:off x="5486400" y="1645920"/>
-            <a:ext cx="91440" cy="594360"/>
+            <a:off x="5715000" y="1810512"/>
+            <a:ext cx="640080" cy="612648"/>
           </a:xfrm>
           <a:prstGeom prst="line">
             <a:avLst/>
@@ -3542,9 +3992,9 @@
           <p:nvPr/>
         </p:nvCxnSpPr>
         <p:spPr>
-          <a:xfrm>
-            <a:off x="5577840" y="1645920"/>
-            <a:ext cx="457200" cy="594360"/>
+          <a:xfrm flipH="1">
+            <a:off x="6263640" y="1810512"/>
+            <a:ext cx="91440" cy="612648"/>
           </a:xfrm>
           <a:prstGeom prst="line">
             <a:avLst/>
@@ -3578,8 +4028,8 @@
         </p:nvCxnSpPr>
         <p:spPr>
           <a:xfrm>
-            <a:off x="5577840" y="1645920"/>
-            <a:ext cx="1005840" cy="594360"/>
+            <a:off x="6355080" y="1810512"/>
+            <a:ext cx="457200" cy="612648"/>
           </a:xfrm>
           <a:prstGeom prst="line">
             <a:avLst/>
@@ -3612,9 +4062,9 @@
           <p:nvPr/>
         </p:nvCxnSpPr>
         <p:spPr>
-          <a:xfrm flipH="1">
-            <a:off x="4617720" y="2240280"/>
-            <a:ext cx="320040" cy="557784"/>
+          <a:xfrm>
+            <a:off x="6355080" y="1810512"/>
+            <a:ext cx="1005840" cy="612648"/>
           </a:xfrm>
           <a:prstGeom prst="line">
             <a:avLst/>
@@ -3647,9 +4097,9 @@
           <p:nvPr/>
         </p:nvCxnSpPr>
         <p:spPr>
-          <a:xfrm>
-            <a:off x="4937760" y="2240280"/>
-            <a:ext cx="45720" cy="557784"/>
+          <a:xfrm flipH="1">
+            <a:off x="5431536" y="2423160"/>
+            <a:ext cx="283464" cy="530352"/>
           </a:xfrm>
           <a:prstGeom prst="line">
             <a:avLst/>
@@ -3683,8 +4133,8 @@
         </p:nvCxnSpPr>
         <p:spPr>
           <a:xfrm>
-            <a:off x="4937760" y="2240280"/>
-            <a:ext cx="411480" cy="557784"/>
+            <a:off x="5715000" y="2423160"/>
+            <a:ext cx="64008" cy="530352"/>
           </a:xfrm>
           <a:prstGeom prst="line">
             <a:avLst/>
@@ -3718,8 +4168,8 @@
         </p:nvCxnSpPr>
         <p:spPr>
           <a:xfrm>
-            <a:off x="5349240" y="2798064"/>
-            <a:ext cx="0" cy="448056"/>
+            <a:off x="5715000" y="2423160"/>
+            <a:ext cx="411480" cy="530352"/>
           </a:xfrm>
           <a:prstGeom prst="line">
             <a:avLst/>
@@ -3745,18 +4195,53 @@
           </a:fontRef>
         </p:style>
       </p:cxnSp>
-      <p:sp>
-        <p:nvSpPr>
-          <p:cNvPr id="20" name="Oval 19"/>
+      <p:cxnSp>
+        <p:nvCxnSpPr>
+          <p:cNvPr id="20" name="Connector 19"/>
+          <p:cNvCxnSpPr/>
+          <p:nvPr/>
+        </p:nvCxnSpPr>
+        <p:spPr>
+          <a:xfrm>
+            <a:off x="6126480" y="2953512"/>
+            <a:ext cx="0" cy="448056"/>
+          </a:xfrm>
+          <a:prstGeom prst="line">
+            <a:avLst/>
+          </a:prstGeom>
+          <a:ln w="13970">
+            <a:solidFill>
+              <a:srgbClr val="64748B"/>
+            </a:solidFill>
+          </a:ln>
+        </p:spPr>
+        <p:style>
+          <a:lnRef idx="2">
+            <a:schemeClr val="accent1"/>
+          </a:lnRef>
+          <a:fillRef idx="0">
+            <a:schemeClr val="accent1"/>
+          </a:fillRef>
+          <a:effectRef idx="1">
+            <a:schemeClr val="accent1"/>
+          </a:effectRef>
+          <a:fontRef idx="minor">
+            <a:schemeClr val="tx1"/>
+          </a:fontRef>
+        </p:style>
+      </p:cxnSp>
+      <p:sp>
+        <p:nvSpPr>
+          <p:cNvPr id="21" name="Rounded Rectangle 20"/>
           <p:cNvSpPr/>
           <p:nvPr/>
         </p:nvSpPr>
         <p:spPr>
           <a:xfrm>
-            <a:off x="4636008" y="1481328"/>
-            <a:ext cx="329184" cy="329184"/>
-          </a:xfrm>
-          <a:prstGeom prst="ellipse">
+            <a:off x="5330952" y="1664208"/>
+            <a:ext cx="585216" cy="292608"/>
+          </a:xfrm>
+          <a:prstGeom prst="roundRect">
             <a:avLst/>
           </a:prstGeom>
           <a:solidFill>
@@ -3786,28 +4271,54 @@
           <a:bodyPr rtlCol="0" anchor="ctr"/>
           <a:lstStyle/>
           <a:p>
+            <a:pPr algn="ctr"/>
+          </a:p>
+        </p:txBody>
+      </p:sp>
+      <p:sp>
+        <p:nvSpPr>
+          <p:cNvPr id="22" name="TextBox 21"/>
+          <p:cNvSpPr txBox="1"/>
+          <p:nvPr/>
+        </p:nvSpPr>
+        <p:spPr>
+          <a:xfrm>
+            <a:off x="5358384" y="1728216"/>
+            <a:ext cx="530352" cy="146304"/>
+          </a:xfrm>
+          <a:prstGeom prst="rect">
+            <a:avLst/>
+          </a:prstGeom>
+          <a:noFill/>
+        </p:spPr>
+        <p:txBody>
+          <a:bodyPr wrap="none" lIns="36576" rIns="36576" tIns="18288" bIns="18288">
+            <a:spAutoFit/>
+          </a:bodyPr>
+          <a:lstStyle/>
+          <a:p>
             <a:pPr algn="ctr">
-              <a:defRPr b="1" sz="1000">
+              <a:defRPr sz="780" b="1">
                 <a:solidFill>
-                  <a:srgbClr val="F8FAFC"/>
+                  <a:srgbClr val="38BDF8"/>
                 </a:solidFill>
               </a:defRPr>
             </a:pPr>
             <a:r>
-              <a:t>C</a:t>
-            </a:r>
-          </a:p>
-        </p:txBody>
-      </p:sp>
-      <p:sp>
-        <p:nvSpPr>
-          <p:cNvPr id="21" name="Oval 20"/>
+              <a:t>Client</a:t>
+            </a:r>
+          </a:p>
+        </p:txBody>
+      </p:sp>
+      <p:sp>
+        <p:nvSpPr>
+          <p:cNvPr id="23" name="Oval 22"/>
           <p:cNvSpPr/>
           <p:nvPr/>
         </p:nvSpPr>
         <p:spPr>
           <a:xfrm>
-            <a:off x="5413248" y="1481328"/>
+            <a:off x="6190488" y="1645920"/>
             <a:ext cx="329184" cy="329184"/>
           </a:xfrm>
           <a:prstGeom prst="ellipse">
@@ -3855,13 +4366,13 @@
       </p:sp>
       <p:sp>
         <p:nvSpPr>
-          <p:cNvPr id="22" name="Oval 21"/>
+          <p:cNvPr id="24" name="Oval 23"/>
           <p:cNvSpPr/>
           <p:nvPr/>
         </p:nvSpPr>
         <p:spPr>
           <a:xfrm>
-            <a:off x="4773168" y="2075688"/>
+            <a:off x="5550408" y="2258568"/>
             <a:ext cx="329184" cy="329184"/>
           </a:xfrm>
           <a:prstGeom prst="ellipse">
@@ -3909,13 +4420,13 @@
       </p:sp>
       <p:sp>
         <p:nvSpPr>
-          <p:cNvPr id="23" name="Oval 22"/>
+          <p:cNvPr id="25" name="Oval 24"/>
           <p:cNvSpPr/>
           <p:nvPr/>
         </p:nvSpPr>
         <p:spPr>
           <a:xfrm>
-            <a:off x="4453128" y="2633472"/>
+            <a:off x="5266944" y="2788920"/>
             <a:ext cx="329184" cy="329184"/>
           </a:xfrm>
           <a:prstGeom prst="ellipse">
@@ -3963,13 +4474,13 @@
       </p:sp>
       <p:sp>
         <p:nvSpPr>
-          <p:cNvPr id="24" name="Oval 23"/>
+          <p:cNvPr id="26" name="Oval 25"/>
           <p:cNvSpPr/>
           <p:nvPr/>
         </p:nvSpPr>
         <p:spPr>
           <a:xfrm>
-            <a:off x="4818888" y="2633472"/>
+            <a:off x="5614416" y="2788920"/>
             <a:ext cx="329184" cy="329184"/>
           </a:xfrm>
           <a:prstGeom prst="ellipse">
@@ -4017,13 +4528,13 @@
       </p:sp>
       <p:sp>
         <p:nvSpPr>
-          <p:cNvPr id="25" name="Oval 24"/>
+          <p:cNvPr id="27" name="Oval 26"/>
           <p:cNvSpPr/>
           <p:nvPr/>
         </p:nvSpPr>
         <p:spPr>
           <a:xfrm>
-            <a:off x="5184648" y="2633472"/>
+            <a:off x="5961888" y="2788920"/>
             <a:ext cx="329184" cy="329184"/>
           </a:xfrm>
           <a:prstGeom prst="ellipse">
@@ -4071,13 +4582,13 @@
       </p:sp>
       <p:sp>
         <p:nvSpPr>
-          <p:cNvPr id="26" name="Oval 25"/>
+          <p:cNvPr id="28" name="Oval 27"/>
           <p:cNvSpPr/>
           <p:nvPr/>
         </p:nvSpPr>
         <p:spPr>
           <a:xfrm>
-            <a:off x="5184648" y="3081528"/>
+            <a:off x="5961888" y="3236976"/>
             <a:ext cx="329184" cy="329184"/>
           </a:xfrm>
           <a:prstGeom prst="ellipse">
@@ -4125,13 +4636,13 @@
       </p:sp>
       <p:sp>
         <p:nvSpPr>
-          <p:cNvPr id="27" name="Oval 26"/>
+          <p:cNvPr id="29" name="Oval 28"/>
           <p:cNvSpPr/>
           <p:nvPr/>
         </p:nvSpPr>
         <p:spPr>
           <a:xfrm>
-            <a:off x="5870448" y="2075688"/>
+            <a:off x="6647688" y="2258568"/>
             <a:ext cx="329184" cy="329184"/>
           </a:xfrm>
           <a:prstGeom prst="ellipse">
@@ -4179,13 +4690,13 @@
       </p:sp>
       <p:sp>
         <p:nvSpPr>
-          <p:cNvPr id="28" name="Oval 27"/>
+          <p:cNvPr id="30" name="Oval 29"/>
           <p:cNvSpPr/>
           <p:nvPr/>
         </p:nvSpPr>
         <p:spPr>
           <a:xfrm>
-            <a:off x="5321808" y="2075688"/>
+            <a:off x="6099048" y="2258568"/>
             <a:ext cx="329184" cy="329184"/>
           </a:xfrm>
           <a:prstGeom prst="ellipse">
@@ -4233,13 +4744,13 @@
       </p:sp>
       <p:sp>
         <p:nvSpPr>
-          <p:cNvPr id="29" name="Oval 28"/>
+          <p:cNvPr id="31" name="Oval 30"/>
           <p:cNvSpPr/>
           <p:nvPr/>
         </p:nvSpPr>
         <p:spPr>
           <a:xfrm>
-            <a:off x="6419088" y="2075688"/>
+            <a:off x="7196328" y="2258568"/>
             <a:ext cx="329184" cy="329184"/>
           </a:xfrm>
           <a:prstGeom prst="ellipse">
@@ -4287,14 +4798,14 @@
       </p:sp>
       <p:sp>
         <p:nvSpPr>
-          <p:cNvPr id="30" name="TextBox 29"/>
+          <p:cNvPr id="32" name="TextBox 31"/>
           <p:cNvSpPr txBox="1"/>
           <p:nvPr/>
         </p:nvSpPr>
         <p:spPr>
           <a:xfrm>
-            <a:off x="5897880" y="1444752"/>
-            <a:ext cx="1298448" cy="256032"/>
+            <a:off x="6812280" y="1627632"/>
+            <a:ext cx="1097280" cy="310896"/>
           </a:xfrm>
           <a:prstGeom prst="rect">
             <a:avLst/>
@@ -4307,29 +4818,68 @@
           </a:bodyPr>
           <a:lstStyle/>
           <a:p>
-            <a:pPr>
-              <a:defRPr sz="850" b="0">
+            <a:pPr algn="ctr">
+              <a:defRPr sz="780" b="0">
                 <a:solidFill>
                   <a:srgbClr val="94A3B8"/>
                 </a:solidFill>
               </a:defRPr>
             </a:pPr>
             <a:r>
-              <a:t>first page gathers B-I</a:t>
-            </a:r>
-          </a:p>
-        </p:txBody>
-      </p:sp>
-      <p:sp>
-        <p:nvSpPr>
-          <p:cNvPr id="31" name="Rounded Rectangle 30"/>
+              <a:t>first page gathers</a:t>
+            </a:r>
+            <a:br/>
+            <a:r>
+              <a:t>B-I once</a:t>
+            </a:r>
+          </a:p>
+        </p:txBody>
+      </p:sp>
+      <p:sp>
+        <p:nvSpPr>
+          <p:cNvPr id="33" name="TextBox 32"/>
+          <p:cNvSpPr txBox="1"/>
+          <p:nvPr/>
+        </p:nvSpPr>
+        <p:spPr>
+          <a:xfrm>
+            <a:off x="5468112" y="3703320"/>
+            <a:ext cx="2468880" cy="201168"/>
+          </a:xfrm>
+          <a:prstGeom prst="rect">
+            <a:avLst/>
+          </a:prstGeom>
+          <a:noFill/>
+        </p:spPr>
+        <p:txBody>
+          <a:bodyPr wrap="none" lIns="36576" rIns="36576" tIns="18288" bIns="18288">
+            <a:spAutoFit/>
+          </a:bodyPr>
+          <a:lstStyle/>
+          <a:p>
+            <a:pPr algn="ctr">
+              <a:defRPr sz="780" b="0">
+                <a:solidFill>
+                  <a:srgbClr val="CBD5E1"/>
+                </a:solidFill>
+              </a:defRPr>
+            </a:pPr>
+            <a:r>
+              <a:t>A materializes/cache-builds the 1.6 MB result</a:t>
+            </a:r>
+          </a:p>
+        </p:txBody>
+      </p:sp>
+      <p:sp>
+        <p:nvSpPr>
+          <p:cNvPr id="34" name="Rounded Rectangle 33"/>
           <p:cNvSpPr/>
           <p:nvPr/>
         </p:nvSpPr>
         <p:spPr>
           <a:xfrm>
-            <a:off x="7882127" y="914400"/>
-            <a:ext cx="3977639" cy="2606040"/>
+            <a:off x="8366760" y="896112"/>
+            <a:ext cx="3566160" cy="3200400"/>
           </a:xfrm>
           <a:prstGeom prst="roundRect">
             <a:avLst/>
@@ -4367,14 +4917,14 @@
       </p:sp>
       <p:sp>
         <p:nvSpPr>
-          <p:cNvPr id="32" name="TextBox 31"/>
+          <p:cNvPr id="35" name="TextBox 34"/>
           <p:cNvSpPr txBox="1"/>
           <p:nvPr/>
         </p:nvSpPr>
         <p:spPr>
           <a:xfrm>
-            <a:off x="8083296" y="1042415"/>
-            <a:ext cx="3566160" cy="201168"/>
+            <a:off x="8577072" y="1024128"/>
+            <a:ext cx="3154680" cy="219456"/>
           </a:xfrm>
           <a:prstGeom prst="rect">
             <a:avLst/>
@@ -4395,21 +4945,21 @@
               </a:defRPr>
             </a:pPr>
             <a:r>
-              <a:t>What total time is made of</a:t>
-            </a:r>
-          </a:p>
-        </p:txBody>
-      </p:sp>
-      <p:sp>
-        <p:nvSpPr>
-          <p:cNvPr id="33" name="Rounded Rectangle 32"/>
+              <a:t>Total time components</a:t>
+            </a:r>
+          </a:p>
+        </p:txBody>
+      </p:sp>
+      <p:sp>
+        <p:nvSpPr>
+          <p:cNvPr id="36" name="Rounded Rectangle 35"/>
           <p:cNvSpPr/>
           <p:nvPr/>
         </p:nvSpPr>
         <p:spPr>
           <a:xfrm>
-            <a:off x="8156448" y="1481328"/>
-            <a:ext cx="804672" cy="713232"/>
+            <a:off x="8613648" y="1444752"/>
+            <a:ext cx="2944368" cy="301752"/>
           </a:xfrm>
           <a:prstGeom prst="roundRect">
             <a:avLst/>
@@ -4447,14 +4997,14 @@
       </p:sp>
       <p:sp>
         <p:nvSpPr>
-          <p:cNvPr id="34" name="TextBox 33"/>
+          <p:cNvPr id="37" name="TextBox 36"/>
           <p:cNvSpPr txBox="1"/>
           <p:nvPr/>
         </p:nvSpPr>
         <p:spPr>
           <a:xfrm>
-            <a:off x="8193024" y="1572768"/>
-            <a:ext cx="731520" cy="182880"/>
+            <a:off x="8686800" y="1499616"/>
+            <a:ext cx="1170432" cy="146304"/>
           </a:xfrm>
           <a:prstGeom prst="rect">
             <a:avLst/>
@@ -4467,29 +5017,29 @@
           </a:bodyPr>
           <a:lstStyle/>
           <a:p>
-            <a:pPr algn="ctr">
-              <a:defRPr sz="830" b="1">
+            <a:pPr>
+              <a:defRPr sz="770" b="1">
                 <a:solidFill>
                   <a:srgbClr val="38BDF8"/>
                 </a:solidFill>
               </a:defRPr>
             </a:pPr>
             <a:r>
-              <a:t>first gather</a:t>
-            </a:r>
-          </a:p>
-        </p:txBody>
-      </p:sp>
-      <p:sp>
-        <p:nvSpPr>
-          <p:cNvPr id="35" name="TextBox 34"/>
+              <a:t>scatter-gather</a:t>
+            </a:r>
+          </a:p>
+        </p:txBody>
+      </p:sp>
+      <p:sp>
+        <p:nvSpPr>
+          <p:cNvPr id="38" name="TextBox 37"/>
           <p:cNvSpPr txBox="1"/>
           <p:nvPr/>
         </p:nvSpPr>
         <p:spPr>
           <a:xfrm>
-            <a:off x="8193024" y="1828800"/>
-            <a:ext cx="731520" cy="228600"/>
+            <a:off x="9912096" y="1499616"/>
+            <a:ext cx="1554480" cy="146304"/>
           </a:xfrm>
           <a:prstGeom prst="rect">
             <a:avLst/>
@@ -4502,29 +5052,29 @@
           </a:bodyPr>
           <a:lstStyle/>
           <a:p>
-            <a:pPr algn="ctr">
-              <a:defRPr sz="680" b="0">
+            <a:pPr>
+              <a:defRPr sz="710" b="0">
                 <a:solidFill>
                   <a:srgbClr val="CBD5E1"/>
                 </a:solidFill>
               </a:defRPr>
             </a:pPr>
             <a:r>
-              <a:t>B-I over Wi-Fi</a:t>
-            </a:r>
-          </a:p>
-        </p:txBody>
-      </p:sp>
-      <p:sp>
-        <p:nvSpPr>
-          <p:cNvPr id="36" name="TextBox 35"/>
+              <a:t>B-I fan-in over Wi-Fi</a:t>
+            </a:r>
+          </a:p>
+        </p:txBody>
+      </p:sp>
+      <p:sp>
+        <p:nvSpPr>
+          <p:cNvPr id="39" name="TextBox 38"/>
           <p:cNvSpPr txBox="1"/>
           <p:nvPr/>
         </p:nvSpPr>
         <p:spPr>
           <a:xfrm>
-            <a:off x="8970264" y="1709928"/>
-            <a:ext cx="146304" cy="201168"/>
+            <a:off x="10003536" y="1709928"/>
+            <a:ext cx="146304" cy="128016"/>
           </a:xfrm>
           <a:prstGeom prst="rect">
             <a:avLst/>
@@ -4538,7 +5088,7 @@
           <a:lstStyle/>
           <a:p>
             <a:pPr algn="ctr">
-              <a:defRPr sz="1200" b="1">
+              <a:defRPr sz="850" b="1">
                 <a:solidFill>
                   <a:srgbClr val="94A3B8"/>
                 </a:solidFill>
@@ -4552,14 +5102,14 @@
       </p:sp>
       <p:sp>
         <p:nvSpPr>
-          <p:cNvPr id="37" name="Rounded Rectangle 36"/>
+          <p:cNvPr id="40" name="Rounded Rectangle 39"/>
           <p:cNvSpPr/>
           <p:nvPr/>
         </p:nvSpPr>
         <p:spPr>
           <a:xfrm>
-            <a:off x="9070848" y="1481328"/>
-            <a:ext cx="804672" cy="713232"/>
+            <a:off x="8613648" y="1828800"/>
+            <a:ext cx="2944368" cy="301752"/>
           </a:xfrm>
           <a:prstGeom prst="roundRect">
             <a:avLst/>
@@ -4597,14 +5147,14 @@
       </p:sp>
       <p:sp>
         <p:nvSpPr>
-          <p:cNvPr id="38" name="TextBox 37"/>
+          <p:cNvPr id="41" name="TextBox 40"/>
           <p:cNvSpPr txBox="1"/>
           <p:nvPr/>
         </p:nvSpPr>
         <p:spPr>
           <a:xfrm>
-            <a:off x="9107424" y="1572768"/>
-            <a:ext cx="731520" cy="182880"/>
+            <a:off x="8686800" y="1883664"/>
+            <a:ext cx="1170432" cy="146304"/>
           </a:xfrm>
           <a:prstGeom prst="rect">
             <a:avLst/>
@@ -4617,29 +5167,29 @@
           </a:bodyPr>
           <a:lstStyle/>
           <a:p>
-            <a:pPr algn="ctr">
-              <a:defRPr sz="830" b="1">
+            <a:pPr>
+              <a:defRPr sz="770" b="1">
                 <a:solidFill>
                   <a:srgbClr val="34D399"/>
                 </a:solidFill>
               </a:defRPr>
             </a:pPr>
             <a:r>
-              <a:t>A cache/build</a:t>
-            </a:r>
-          </a:p>
-        </p:txBody>
-      </p:sp>
-      <p:sp>
-        <p:nvSpPr>
-          <p:cNvPr id="39" name="TextBox 38"/>
+              <a:t>cache materialization</a:t>
+            </a:r>
+          </a:p>
+        </p:txBody>
+      </p:sp>
+      <p:sp>
+        <p:nvSpPr>
+          <p:cNvPr id="42" name="TextBox 41"/>
           <p:cNvSpPr txBox="1"/>
           <p:nvPr/>
         </p:nvSpPr>
         <p:spPr>
           <a:xfrm>
-            <a:off x="9107424" y="1828800"/>
-            <a:ext cx="731520" cy="228600"/>
+            <a:off x="9912096" y="1883664"/>
+            <a:ext cx="1554480" cy="146304"/>
           </a:xfrm>
           <a:prstGeom prst="rect">
             <a:avLst/>
@@ -4652,29 +5202,29 @@
           </a:bodyPr>
           <a:lstStyle/>
           <a:p>
-            <a:pPr algn="ctr">
-              <a:defRPr sz="680" b="0">
+            <a:pPr>
+              <a:defRPr sz="710" b="0">
                 <a:solidFill>
                   <a:srgbClr val="CBD5E1"/>
                 </a:solidFill>
               </a:defRPr>
             </a:pPr>
             <a:r>
-              <a:t>assemble 1.6 MB</a:t>
-            </a:r>
-          </a:p>
-        </p:txBody>
-      </p:sp>
-      <p:sp>
-        <p:nvSpPr>
-          <p:cNvPr id="40" name="TextBox 39"/>
+              <a:t>A assembles 1.6 MB</a:t>
+            </a:r>
+          </a:p>
+        </p:txBody>
+      </p:sp>
+      <p:sp>
+        <p:nvSpPr>
+          <p:cNvPr id="43" name="TextBox 42"/>
           <p:cNvSpPr txBox="1"/>
           <p:nvPr/>
         </p:nvSpPr>
         <p:spPr>
           <a:xfrm>
-            <a:off x="9884664" y="1709928"/>
-            <a:ext cx="146304" cy="201168"/>
+            <a:off x="10003536" y="2093976"/>
+            <a:ext cx="146304" cy="128016"/>
           </a:xfrm>
           <a:prstGeom prst="rect">
             <a:avLst/>
@@ -4688,7 +5238,7 @@
           <a:lstStyle/>
           <a:p>
             <a:pPr algn="ctr">
-              <a:defRPr sz="1200" b="1">
+              <a:defRPr sz="850" b="1">
                 <a:solidFill>
                   <a:srgbClr val="94A3B8"/>
                 </a:solidFill>
@@ -4702,14 +5252,14 @@
       </p:sp>
       <p:sp>
         <p:nvSpPr>
-          <p:cNvPr id="41" name="Rounded Rectangle 40"/>
+          <p:cNvPr id="44" name="Rounded Rectangle 43"/>
           <p:cNvSpPr/>
           <p:nvPr/>
         </p:nvSpPr>
         <p:spPr>
           <a:xfrm>
-            <a:off x="9985248" y="1481328"/>
-            <a:ext cx="804672" cy="713232"/>
+            <a:off x="8613648" y="2212848"/>
+            <a:ext cx="2944368" cy="301752"/>
           </a:xfrm>
           <a:prstGeom prst="roundRect">
             <a:avLst/>
@@ -4747,14 +5297,14 @@
       </p:sp>
       <p:sp>
         <p:nvSpPr>
-          <p:cNvPr id="42" name="TextBox 41"/>
+          <p:cNvPr id="45" name="TextBox 44"/>
           <p:cNvSpPr txBox="1"/>
           <p:nvPr/>
         </p:nvSpPr>
         <p:spPr>
           <a:xfrm>
-            <a:off x="10021824" y="1572768"/>
-            <a:ext cx="731520" cy="182880"/>
+            <a:off x="8686800" y="2267712"/>
+            <a:ext cx="1170432" cy="146304"/>
           </a:xfrm>
           <a:prstGeom prst="rect">
             <a:avLst/>
@@ -4767,29 +5317,29 @@
           </a:bodyPr>
           <a:lstStyle/>
           <a:p>
-            <a:pPr algn="ctr">
-              <a:defRPr sz="830" b="1">
+            <a:pPr>
+              <a:defRPr sz="770" b="1">
                 <a:solidFill>
                   <a:srgbClr val="FACC15"/>
                 </a:solidFill>
               </a:defRPr>
             </a:pPr>
             <a:r>
-              <a:t>page overhead</a:t>
-            </a:r>
-          </a:p>
-        </p:txBody>
-      </p:sp>
-      <p:sp>
-        <p:nvSpPr>
-          <p:cNvPr id="43" name="TextBox 42"/>
+              <a:t>amortized page cost</a:t>
+            </a:r>
+          </a:p>
+        </p:txBody>
+      </p:sp>
+      <p:sp>
+        <p:nvSpPr>
+          <p:cNvPr id="46" name="TextBox 45"/>
           <p:cNvSpPr txBox="1"/>
           <p:nvPr/>
         </p:nvSpPr>
         <p:spPr>
           <a:xfrm>
-            <a:off x="10021824" y="1828800"/>
-            <a:ext cx="731520" cy="228600"/>
+            <a:off x="9912096" y="2267712"/>
+            <a:ext cx="1554480" cy="146304"/>
           </a:xfrm>
           <a:prstGeom prst="rect">
             <a:avLst/>
@@ -4802,8 +5352,8 @@
           </a:bodyPr>
           <a:lstStyle/>
           <a:p>
-            <a:pPr algn="ctr">
-              <a:defRPr sz="680" b="0">
+            <a:pPr>
+              <a:defRPr sz="710" b="0">
                 <a:solidFill>
                   <a:srgbClr val="CBD5E1"/>
                 </a:solidFill>
@@ -4817,14 +5367,14 @@
       </p:sp>
       <p:sp>
         <p:nvSpPr>
-          <p:cNvPr id="44" name="TextBox 43"/>
+          <p:cNvPr id="47" name="TextBox 46"/>
           <p:cNvSpPr txBox="1"/>
           <p:nvPr/>
         </p:nvSpPr>
         <p:spPr>
           <a:xfrm>
-            <a:off x="10799064" y="1709928"/>
-            <a:ext cx="146304" cy="201168"/>
+            <a:off x="10003536" y="2478024"/>
+            <a:ext cx="146304" cy="128016"/>
           </a:xfrm>
           <a:prstGeom prst="rect">
             <a:avLst/>
@@ -4838,7 +5388,7 @@
           <a:lstStyle/>
           <a:p>
             <a:pPr algn="ctr">
-              <a:defRPr sz="1200" b="1">
+              <a:defRPr sz="850" b="1">
                 <a:solidFill>
                   <a:srgbClr val="94A3B8"/>
                 </a:solidFill>
@@ -4852,14 +5402,14 @@
       </p:sp>
       <p:sp>
         <p:nvSpPr>
-          <p:cNvPr id="45" name="Rounded Rectangle 44"/>
+          <p:cNvPr id="48" name="Rounded Rectangle 47"/>
           <p:cNvSpPr/>
           <p:nvPr/>
         </p:nvSpPr>
         <p:spPr>
           <a:xfrm>
-            <a:off x="10899648" y="1481328"/>
-            <a:ext cx="804672" cy="713232"/>
+            <a:off x="8613648" y="2596896"/>
+            <a:ext cx="2944368" cy="301752"/>
           </a:xfrm>
           <a:prstGeom prst="roundRect">
             <a:avLst/>
@@ -4897,14 +5447,14 @@
       </p:sp>
       <p:sp>
         <p:nvSpPr>
-          <p:cNvPr id="46" name="TextBox 45"/>
+          <p:cNvPr id="49" name="TextBox 48"/>
           <p:cNvSpPr txBox="1"/>
           <p:nvPr/>
         </p:nvSpPr>
         <p:spPr>
           <a:xfrm>
-            <a:off x="10936224" y="1572768"/>
-            <a:ext cx="731520" cy="182880"/>
+            <a:off x="8686800" y="2651760"/>
+            <a:ext cx="1170432" cy="146304"/>
           </a:xfrm>
           <a:prstGeom prst="rect">
             <a:avLst/>
@@ -4917,29 +5467,29 @@
           </a:bodyPr>
           <a:lstStyle/>
           <a:p>
-            <a:pPr algn="ctr">
-              <a:defRPr sz="830" b="1">
+            <a:pPr>
+              <a:defRPr sz="770" b="1">
                 <a:solidFill>
                   <a:srgbClr val="A78BFA"/>
                 </a:solidFill>
               </a:defRPr>
             </a:pPr>
             <a:r>
-              <a:t>payload work</a:t>
-            </a:r>
-          </a:p>
-        </p:txBody>
-      </p:sp>
-      <p:sp>
-        <p:nvSpPr>
-          <p:cNvPr id="47" name="TextBox 46"/>
+              <a:t>serialization/copy</a:t>
+            </a:r>
+          </a:p>
+        </p:txBody>
+      </p:sp>
+      <p:sp>
+        <p:nvSpPr>
+          <p:cNvPr id="50" name="TextBox 49"/>
           <p:cNvSpPr txBox="1"/>
           <p:nvPr/>
         </p:nvSpPr>
         <p:spPr>
           <a:xfrm>
-            <a:off x="10936224" y="1828800"/>
-            <a:ext cx="731520" cy="228600"/>
+            <a:off x="9912096" y="2651760"/>
+            <a:ext cx="1554480" cy="146304"/>
           </a:xfrm>
           <a:prstGeom prst="rect">
             <a:avLst/>
@@ -4952,29 +5502,74 @@
           </a:bodyPr>
           <a:lstStyle/>
           <a:p>
-            <a:pPr algn="ctr">
-              <a:defRPr sz="680" b="0">
+            <a:pPr>
+              <a:defRPr sz="710" b="0">
                 <a:solidFill>
                   <a:srgbClr val="CBD5E1"/>
                 </a:solidFill>
               </a:defRPr>
             </a:pPr>
             <a:r>
-              <a:t>protobuf + copies</a:t>
-            </a:r>
-          </a:p>
-        </p:txBody>
-      </p:sp>
-      <p:sp>
-        <p:nvSpPr>
-          <p:cNvPr id="48" name="TextBox 47"/>
+              <a:t>protobuf bytes + slices</a:t>
+            </a:r>
+          </a:p>
+        </p:txBody>
+      </p:sp>
+      <p:sp>
+        <p:nvSpPr>
+          <p:cNvPr id="51" name="Rounded Rectangle 50"/>
+          <p:cNvSpPr/>
+          <p:nvPr/>
+        </p:nvSpPr>
+        <p:spPr>
+          <a:xfrm>
+            <a:off x="8668512" y="3182112"/>
+            <a:ext cx="2852928" cy="502920"/>
+          </a:xfrm>
+          <a:prstGeom prst="roundRect">
+            <a:avLst/>
+          </a:prstGeom>
+          <a:solidFill>
+            <a:srgbClr val="271C13"/>
+          </a:solidFill>
+          <a:ln>
+            <a:solidFill>
+              <a:srgbClr val="F59E0B"/>
+            </a:solidFill>
+          </a:ln>
+        </p:spPr>
+        <p:style>
+          <a:lnRef idx="1">
+            <a:schemeClr val="accent1"/>
+          </a:lnRef>
+          <a:fillRef idx="3">
+            <a:schemeClr val="accent1"/>
+          </a:fillRef>
+          <a:effectRef idx="2">
+            <a:schemeClr val="accent1"/>
+          </a:effectRef>
+          <a:fontRef idx="minor">
+            <a:schemeClr val="lt1"/>
+          </a:fontRef>
+        </p:style>
+        <p:txBody>
+          <a:bodyPr rtlCol="0" anchor="ctr"/>
+          <a:lstStyle/>
+          <a:p>
+            <a:pPr algn="ctr"/>
+          </a:p>
+        </p:txBody>
+      </p:sp>
+      <p:sp>
+        <p:nvSpPr>
+          <p:cNvPr id="52" name="TextBox 51"/>
           <p:cNvSpPr txBox="1"/>
           <p:nvPr/>
         </p:nvSpPr>
         <p:spPr>
           <a:xfrm>
-            <a:off x="8183879" y="2395728"/>
-            <a:ext cx="3429000" cy="566928"/>
+            <a:off x="8796528" y="3273552"/>
+            <a:ext cx="2578608" cy="256032"/>
           </a:xfrm>
           <a:prstGeom prst="rect">
             <a:avLst/>
@@ -4988,28 +5583,28 @@
           <a:lstStyle/>
           <a:p>
             <a:pPr algn="ctr">
-              <a:defRPr sz="819" b="0">
+              <a:defRPr sz="910" b="1">
                 <a:solidFill>
-                  <a:srgbClr val="CBD5E1"/>
+                  <a:srgbClr val="FDE68A"/>
                 </a:solidFill>
               </a:defRPr>
             </a:pPr>
             <a:r>
-              <a:t>Tiny chunks reduce payload per page, but multiply the page overhead. Large chunks cut page count, but each page carries more data and has worse tail risk.</a:t>
-            </a:r>
-          </a:p>
-        </p:txBody>
-      </p:sp>
-      <p:sp>
-        <p:nvSpPr>
-          <p:cNvPr id="49" name="Rounded Rectangle 48"/>
+              <a:t>32 KB has mostly paid off the page-count penalty.</a:t>
+            </a:r>
+          </a:p>
+        </p:txBody>
+      </p:sp>
+      <p:sp>
+        <p:nvSpPr>
+          <p:cNvPr id="53" name="Rounded Rectangle 52"/>
           <p:cNvSpPr/>
           <p:nvPr/>
         </p:nvSpPr>
         <p:spPr>
           <a:xfrm>
-            <a:off x="320040" y="3749039"/>
-            <a:ext cx="4160520" cy="2331720"/>
+            <a:off x="274320" y="4315968"/>
+            <a:ext cx="3063240" cy="1975104"/>
           </a:xfrm>
           <a:prstGeom prst="roundRect">
             <a:avLst/>
@@ -5047,14 +5642,14 @@
       </p:sp>
       <p:sp>
         <p:nvSpPr>
-          <p:cNvPr id="50" name="TextBox 49"/>
+          <p:cNvPr id="54" name="TextBox 53"/>
           <p:cNvSpPr txBox="1"/>
           <p:nvPr/>
         </p:nvSpPr>
         <p:spPr>
           <a:xfrm>
-            <a:off x="502920" y="3877056"/>
-            <a:ext cx="3703320" cy="228600"/>
+            <a:off x="457200" y="4443984"/>
+            <a:ext cx="2697480" cy="219456"/>
           </a:xfrm>
           <a:prstGeom prst="rect">
             <a:avLst/>
@@ -5068,28 +5663,28 @@
           <a:lstStyle/>
           <a:p>
             <a:pPr>
-              <a:defRPr sz="1250" b="1">
+              <a:defRPr sz="1200" b="1">
                 <a:solidFill>
                   <a:srgbClr val="F8FAFC"/>
                 </a:solidFill>
               </a:defRPr>
             </a:pPr>
             <a:r>
-              <a:t>Paging overhead adds up</a:t>
-            </a:r>
-          </a:p>
-        </p:txBody>
-      </p:sp>
-      <p:sp>
-        <p:nvSpPr>
-          <p:cNvPr id="51" name="TextBox 50"/>
+              <a:t>Page overhead multiplies</a:t>
+            </a:r>
+          </a:p>
+        </p:txBody>
+      </p:sp>
+      <p:sp>
+        <p:nvSpPr>
+          <p:cNvPr id="55" name="TextBox 54"/>
           <p:cNvSpPr txBox="1"/>
           <p:nvPr/>
         </p:nvSpPr>
         <p:spPr>
           <a:xfrm>
-            <a:off x="530352" y="4315968"/>
-            <a:ext cx="566928" cy="182880"/>
+            <a:off x="475488" y="4809744"/>
+            <a:ext cx="566928" cy="164592"/>
           </a:xfrm>
           <a:prstGeom prst="rect">
             <a:avLst/>
@@ -5103,7 +5698,7 @@
           <a:lstStyle/>
           <a:p>
             <a:pPr>
-              <a:defRPr sz="919" b="1">
+              <a:defRPr sz="890" b="1">
                 <a:solidFill>
                   <a:srgbClr val="FB7185"/>
                 </a:solidFill>
@@ -5117,14 +5712,14 @@
       </p:sp>
       <p:sp>
         <p:nvSpPr>
-          <p:cNvPr id="52" name="TextBox 51"/>
+          <p:cNvPr id="56" name="TextBox 55"/>
           <p:cNvSpPr txBox="1"/>
           <p:nvPr/>
         </p:nvSpPr>
         <p:spPr>
           <a:xfrm>
-            <a:off x="1051560" y="4315968"/>
-            <a:ext cx="658368" cy="182880"/>
+            <a:off x="1024128" y="4809744"/>
+            <a:ext cx="640080" cy="164592"/>
           </a:xfrm>
           <a:prstGeom prst="rect">
             <a:avLst/>
@@ -5138,7 +5733,7 @@
           <a:lstStyle/>
           <a:p>
             <a:pPr>
-              <a:defRPr sz="830" b="0">
+              <a:defRPr sz="790" b="0">
                 <a:solidFill>
                   <a:srgbClr val="CBD5E1"/>
                 </a:solidFill>
@@ -5152,14 +5747,14 @@
       </p:sp>
       <p:sp>
         <p:nvSpPr>
-          <p:cNvPr id="53" name="Rectangle 52"/>
+          <p:cNvPr id="57" name="Rectangle 56"/>
           <p:cNvSpPr/>
           <p:nvPr/>
         </p:nvSpPr>
         <p:spPr>
           <a:xfrm>
-            <a:off x="1755648" y="4334256"/>
-            <a:ext cx="64008" cy="155448"/>
+            <a:off x="1737360" y="4818888"/>
+            <a:ext cx="41148" cy="146304"/>
           </a:xfrm>
           <a:prstGeom prst="rect">
             <a:avLst/>
@@ -5197,14 +5792,14 @@
       </p:sp>
       <p:sp>
         <p:nvSpPr>
-          <p:cNvPr id="54" name="Rectangle 53"/>
+          <p:cNvPr id="58" name="Rectangle 57"/>
           <p:cNvSpPr/>
           <p:nvPr/>
         </p:nvSpPr>
         <p:spPr>
           <a:xfrm>
-            <a:off x="1851660" y="4334256"/>
-            <a:ext cx="64008" cy="155448"/>
+            <a:off x="1792224" y="4818888"/>
+            <a:ext cx="41148" cy="146304"/>
           </a:xfrm>
           <a:prstGeom prst="rect">
             <a:avLst/>
@@ -5242,14 +5837,14 @@
       </p:sp>
       <p:sp>
         <p:nvSpPr>
-          <p:cNvPr id="55" name="Rectangle 54"/>
+          <p:cNvPr id="59" name="Rectangle 58"/>
           <p:cNvSpPr/>
           <p:nvPr/>
         </p:nvSpPr>
         <p:spPr>
           <a:xfrm>
-            <a:off x="1947672" y="4334256"/>
-            <a:ext cx="64008" cy="155448"/>
+            <a:off x="1847088" y="4818888"/>
+            <a:ext cx="41148" cy="146304"/>
           </a:xfrm>
           <a:prstGeom prst="rect">
             <a:avLst/>
@@ -5287,14 +5882,14 @@
       </p:sp>
       <p:sp>
         <p:nvSpPr>
-          <p:cNvPr id="56" name="Rectangle 55"/>
+          <p:cNvPr id="60" name="Rectangle 59"/>
           <p:cNvSpPr/>
           <p:nvPr/>
         </p:nvSpPr>
         <p:spPr>
           <a:xfrm>
-            <a:off x="2043684" y="4334256"/>
-            <a:ext cx="64008" cy="155448"/>
+            <a:off x="1901952" y="4818888"/>
+            <a:ext cx="41148" cy="146304"/>
           </a:xfrm>
           <a:prstGeom prst="rect">
             <a:avLst/>
@@ -5332,14 +5927,14 @@
       </p:sp>
       <p:sp>
         <p:nvSpPr>
-          <p:cNvPr id="57" name="Rectangle 56"/>
+          <p:cNvPr id="61" name="Rectangle 60"/>
           <p:cNvSpPr/>
           <p:nvPr/>
         </p:nvSpPr>
         <p:spPr>
           <a:xfrm>
-            <a:off x="2139696" y="4334256"/>
-            <a:ext cx="64008" cy="155448"/>
+            <a:off x="1956815" y="4818888"/>
+            <a:ext cx="41148" cy="146304"/>
           </a:xfrm>
           <a:prstGeom prst="rect">
             <a:avLst/>
@@ -5377,14 +5972,14 @@
       </p:sp>
       <p:sp>
         <p:nvSpPr>
-          <p:cNvPr id="58" name="Rectangle 57"/>
+          <p:cNvPr id="62" name="Rectangle 61"/>
           <p:cNvSpPr/>
           <p:nvPr/>
         </p:nvSpPr>
         <p:spPr>
           <a:xfrm>
-            <a:off x="2235708" y="4334256"/>
-            <a:ext cx="64008" cy="155448"/>
+            <a:off x="2011679" y="4818888"/>
+            <a:ext cx="41148" cy="146304"/>
           </a:xfrm>
           <a:prstGeom prst="rect">
             <a:avLst/>
@@ -5422,14 +6017,14 @@
       </p:sp>
       <p:sp>
         <p:nvSpPr>
-          <p:cNvPr id="59" name="Rectangle 58"/>
+          <p:cNvPr id="63" name="Rectangle 62"/>
           <p:cNvSpPr/>
           <p:nvPr/>
         </p:nvSpPr>
         <p:spPr>
           <a:xfrm>
-            <a:off x="2331720" y="4334256"/>
-            <a:ext cx="64008" cy="155448"/>
+            <a:off x="2066543" y="4818888"/>
+            <a:ext cx="41148" cy="146304"/>
           </a:xfrm>
           <a:prstGeom prst="rect">
             <a:avLst/>
@@ -5467,14 +6062,14 @@
       </p:sp>
       <p:sp>
         <p:nvSpPr>
-          <p:cNvPr id="60" name="Rectangle 59"/>
+          <p:cNvPr id="64" name="Rectangle 63"/>
           <p:cNvSpPr/>
           <p:nvPr/>
         </p:nvSpPr>
         <p:spPr>
           <a:xfrm>
-            <a:off x="2427732" y="4334256"/>
-            <a:ext cx="64008" cy="155448"/>
+            <a:off x="2121408" y="4818888"/>
+            <a:ext cx="41148" cy="146304"/>
           </a:xfrm>
           <a:prstGeom prst="rect">
             <a:avLst/>
@@ -5512,14 +6107,14 @@
       </p:sp>
       <p:sp>
         <p:nvSpPr>
-          <p:cNvPr id="61" name="Rectangle 60"/>
+          <p:cNvPr id="65" name="Rectangle 64"/>
           <p:cNvSpPr/>
           <p:nvPr/>
         </p:nvSpPr>
         <p:spPr>
           <a:xfrm>
-            <a:off x="2523744" y="4334256"/>
-            <a:ext cx="64008" cy="155448"/>
+            <a:off x="2176272" y="4818888"/>
+            <a:ext cx="41148" cy="146304"/>
           </a:xfrm>
           <a:prstGeom prst="rect">
             <a:avLst/>
@@ -5557,14 +6152,14 @@
       </p:sp>
       <p:sp>
         <p:nvSpPr>
-          <p:cNvPr id="62" name="Rectangle 61"/>
+          <p:cNvPr id="66" name="Rectangle 65"/>
           <p:cNvSpPr/>
           <p:nvPr/>
         </p:nvSpPr>
         <p:spPr>
           <a:xfrm>
-            <a:off x="2619756" y="4334256"/>
-            <a:ext cx="64008" cy="155448"/>
+            <a:off x="2231136" y="4818888"/>
+            <a:ext cx="41148" cy="146304"/>
           </a:xfrm>
           <a:prstGeom prst="rect">
             <a:avLst/>
@@ -5602,14 +6197,14 @@
       </p:sp>
       <p:sp>
         <p:nvSpPr>
-          <p:cNvPr id="63" name="Rectangle 62"/>
+          <p:cNvPr id="67" name="Rectangle 66"/>
           <p:cNvSpPr/>
           <p:nvPr/>
         </p:nvSpPr>
         <p:spPr>
           <a:xfrm>
-            <a:off x="2715768" y="4334256"/>
-            <a:ext cx="64008" cy="155448"/>
+            <a:off x="2286000" y="4818888"/>
+            <a:ext cx="41148" cy="146304"/>
           </a:xfrm>
           <a:prstGeom prst="rect">
             <a:avLst/>
@@ -5647,14 +6242,14 @@
       </p:sp>
       <p:sp>
         <p:nvSpPr>
-          <p:cNvPr id="64" name="Rectangle 63"/>
+          <p:cNvPr id="68" name="Rectangle 67"/>
           <p:cNvSpPr/>
           <p:nvPr/>
         </p:nvSpPr>
         <p:spPr>
           <a:xfrm>
-            <a:off x="2811780" y="4334256"/>
-            <a:ext cx="64008" cy="155448"/>
+            <a:off x="2340863" y="4818888"/>
+            <a:ext cx="41148" cy="146304"/>
           </a:xfrm>
           <a:prstGeom prst="rect">
             <a:avLst/>
@@ -5692,14 +6287,14 @@
       </p:sp>
       <p:sp>
         <p:nvSpPr>
-          <p:cNvPr id="65" name="Rectangle 64"/>
+          <p:cNvPr id="69" name="Rectangle 68"/>
           <p:cNvSpPr/>
           <p:nvPr/>
         </p:nvSpPr>
         <p:spPr>
           <a:xfrm>
-            <a:off x="2907791" y="4334256"/>
-            <a:ext cx="64008" cy="155448"/>
+            <a:off x="2395728" y="4818888"/>
+            <a:ext cx="41148" cy="146304"/>
           </a:xfrm>
           <a:prstGeom prst="rect">
             <a:avLst/>
@@ -5737,14 +6332,14 @@
       </p:sp>
       <p:sp>
         <p:nvSpPr>
-          <p:cNvPr id="66" name="Rectangle 65"/>
+          <p:cNvPr id="70" name="Rectangle 69"/>
           <p:cNvSpPr/>
           <p:nvPr/>
         </p:nvSpPr>
         <p:spPr>
           <a:xfrm>
-            <a:off x="3003804" y="4334256"/>
-            <a:ext cx="64008" cy="155448"/>
+            <a:off x="2450591" y="4818888"/>
+            <a:ext cx="41148" cy="146304"/>
           </a:xfrm>
           <a:prstGeom prst="rect">
             <a:avLst/>
@@ -5782,14 +6377,14 @@
       </p:sp>
       <p:sp>
         <p:nvSpPr>
-          <p:cNvPr id="67" name="Rectangle 66"/>
+          <p:cNvPr id="71" name="Rectangle 70"/>
           <p:cNvSpPr/>
           <p:nvPr/>
         </p:nvSpPr>
         <p:spPr>
           <a:xfrm>
-            <a:off x="3099815" y="4334256"/>
-            <a:ext cx="64008" cy="155448"/>
+            <a:off x="2505456" y="4818888"/>
+            <a:ext cx="41148" cy="146304"/>
           </a:xfrm>
           <a:prstGeom prst="rect">
             <a:avLst/>
@@ -5827,14 +6422,14 @@
       </p:sp>
       <p:sp>
         <p:nvSpPr>
-          <p:cNvPr id="68" name="Rectangle 67"/>
+          <p:cNvPr id="72" name="Rectangle 71"/>
           <p:cNvSpPr/>
           <p:nvPr/>
         </p:nvSpPr>
         <p:spPr>
           <a:xfrm>
-            <a:off x="3195828" y="4334256"/>
-            <a:ext cx="64008" cy="155448"/>
+            <a:off x="2560320" y="4818888"/>
+            <a:ext cx="41148" cy="146304"/>
           </a:xfrm>
           <a:prstGeom prst="rect">
             <a:avLst/>
@@ -5872,14 +6467,104 @@
       </p:sp>
       <p:sp>
         <p:nvSpPr>
-          <p:cNvPr id="69" name="TextBox 68"/>
+          <p:cNvPr id="73" name="Rectangle 72"/>
+          <p:cNvSpPr/>
+          <p:nvPr/>
+        </p:nvSpPr>
+        <p:spPr>
+          <a:xfrm>
+            <a:off x="2615184" y="4818888"/>
+            <a:ext cx="41148" cy="146304"/>
+          </a:xfrm>
+          <a:prstGeom prst="rect">
+            <a:avLst/>
+          </a:prstGeom>
+          <a:solidFill>
+            <a:srgbClr val="FB7185"/>
+          </a:solidFill>
+          <a:ln>
+            <a:solidFill>
+              <a:srgbClr val="FB7185"/>
+            </a:solidFill>
+          </a:ln>
+        </p:spPr>
+        <p:style>
+          <a:lnRef idx="1">
+            <a:schemeClr val="accent1"/>
+          </a:lnRef>
+          <a:fillRef idx="3">
+            <a:schemeClr val="accent1"/>
+          </a:fillRef>
+          <a:effectRef idx="2">
+            <a:schemeClr val="accent1"/>
+          </a:effectRef>
+          <a:fontRef idx="minor">
+            <a:schemeClr val="lt1"/>
+          </a:fontRef>
+        </p:style>
+        <p:txBody>
+          <a:bodyPr rtlCol="0" anchor="ctr"/>
+          <a:lstStyle/>
+          <a:p>
+            <a:pPr algn="ctr"/>
+          </a:p>
+        </p:txBody>
+      </p:sp>
+      <p:sp>
+        <p:nvSpPr>
+          <p:cNvPr id="74" name="Rectangle 73"/>
+          <p:cNvSpPr/>
+          <p:nvPr/>
+        </p:nvSpPr>
+        <p:spPr>
+          <a:xfrm>
+            <a:off x="2670048" y="4818888"/>
+            <a:ext cx="41148" cy="146304"/>
+          </a:xfrm>
+          <a:prstGeom prst="rect">
+            <a:avLst/>
+          </a:prstGeom>
+          <a:solidFill>
+            <a:srgbClr val="FB7185"/>
+          </a:solidFill>
+          <a:ln>
+            <a:solidFill>
+              <a:srgbClr val="FB7185"/>
+            </a:solidFill>
+          </a:ln>
+        </p:spPr>
+        <p:style>
+          <a:lnRef idx="1">
+            <a:schemeClr val="accent1"/>
+          </a:lnRef>
+          <a:fillRef idx="3">
+            <a:schemeClr val="accent1"/>
+          </a:fillRef>
+          <a:effectRef idx="2">
+            <a:schemeClr val="accent1"/>
+          </a:effectRef>
+          <a:fontRef idx="minor">
+            <a:schemeClr val="lt1"/>
+          </a:fontRef>
+        </p:style>
+        <p:txBody>
+          <a:bodyPr rtlCol="0" anchor="ctr"/>
+          <a:lstStyle/>
+          <a:p>
+            <a:pPr algn="ctr"/>
+          </a:p>
+        </p:txBody>
+      </p:sp>
+      <p:sp>
+        <p:nvSpPr>
+          <p:cNvPr id="75" name="TextBox 74"/>
           <p:cNvSpPr txBox="1"/>
           <p:nvPr/>
         </p:nvSpPr>
         <p:spPr>
           <a:xfrm>
-            <a:off x="3154680" y="4315968"/>
-            <a:ext cx="1078992" cy="228600"/>
+            <a:off x="475488" y="5193792"/>
+            <a:ext cx="566928" cy="164592"/>
           </a:xfrm>
           <a:prstGeom prst="rect">
             <a:avLst/>
@@ -5893,42 +6578,7 @@
           <a:lstStyle/>
           <a:p>
             <a:pPr>
-              <a:defRPr sz="740" b="0">
-                <a:solidFill>
-                  <a:srgbClr val="94A3B8"/>
-                </a:solidFill>
-              </a:defRPr>
-            </a:pPr>
-            <a:r>
-              <a:t>~0.42 ms/page, but 800x</a:t>
-            </a:r>
-          </a:p>
-        </p:txBody>
-      </p:sp>
-      <p:sp>
-        <p:nvSpPr>
-          <p:cNvPr id="70" name="TextBox 69"/>
-          <p:cNvSpPr txBox="1"/>
-          <p:nvPr/>
-        </p:nvSpPr>
-        <p:spPr>
-          <a:xfrm>
-            <a:off x="530352" y="4818888"/>
-            <a:ext cx="566928" cy="182880"/>
-          </a:xfrm>
-          <a:prstGeom prst="rect">
-            <a:avLst/>
-          </a:prstGeom>
-          <a:noFill/>
-        </p:spPr>
-        <p:txBody>
-          <a:bodyPr wrap="none" lIns="36576" rIns="36576" tIns="18288" bIns="18288">
-            <a:spAutoFit/>
-          </a:bodyPr>
-          <a:lstStyle/>
-          <a:p>
-            <a:pPr>
-              <a:defRPr sz="919" b="1">
+              <a:defRPr sz="890" b="1">
                 <a:solidFill>
                   <a:srgbClr val="38BDF8"/>
                 </a:solidFill>
@@ -5942,14 +6592,14 @@
       </p:sp>
       <p:sp>
         <p:nvSpPr>
-          <p:cNvPr id="71" name="TextBox 70"/>
+          <p:cNvPr id="76" name="TextBox 75"/>
           <p:cNvSpPr txBox="1"/>
           <p:nvPr/>
         </p:nvSpPr>
         <p:spPr>
           <a:xfrm>
-            <a:off x="1051560" y="4818888"/>
-            <a:ext cx="658368" cy="182880"/>
+            <a:off x="1024128" y="5193792"/>
+            <a:ext cx="640080" cy="164592"/>
           </a:xfrm>
           <a:prstGeom prst="rect">
             <a:avLst/>
@@ -5963,7 +6613,7 @@
           <a:lstStyle/>
           <a:p>
             <a:pPr>
-              <a:defRPr sz="830" b="0">
+              <a:defRPr sz="790" b="0">
                 <a:solidFill>
                   <a:srgbClr val="CBD5E1"/>
                 </a:solidFill>
@@ -5977,14 +6627,14 @@
       </p:sp>
       <p:sp>
         <p:nvSpPr>
-          <p:cNvPr id="72" name="Rectangle 71"/>
+          <p:cNvPr id="77" name="Rectangle 76"/>
           <p:cNvSpPr/>
           <p:nvPr/>
         </p:nvSpPr>
         <p:spPr>
           <a:xfrm>
-            <a:off x="1755648" y="4837176"/>
-            <a:ext cx="64008" cy="155448"/>
+            <a:off x="1737360" y="5202936"/>
+            <a:ext cx="41148" cy="146304"/>
           </a:xfrm>
           <a:prstGeom prst="rect">
             <a:avLst/>
@@ -6022,14 +6672,14 @@
       </p:sp>
       <p:sp>
         <p:nvSpPr>
-          <p:cNvPr id="73" name="Rectangle 72"/>
+          <p:cNvPr id="78" name="Rectangle 77"/>
           <p:cNvSpPr/>
           <p:nvPr/>
         </p:nvSpPr>
         <p:spPr>
           <a:xfrm>
-            <a:off x="1851660" y="4837176"/>
-            <a:ext cx="64008" cy="155448"/>
+            <a:off x="1792224" y="5202936"/>
+            <a:ext cx="41148" cy="146304"/>
           </a:xfrm>
           <a:prstGeom prst="rect">
             <a:avLst/>
@@ -6067,14 +6717,14 @@
       </p:sp>
       <p:sp>
         <p:nvSpPr>
-          <p:cNvPr id="74" name="Rectangle 73"/>
+          <p:cNvPr id="79" name="Rectangle 78"/>
           <p:cNvSpPr/>
           <p:nvPr/>
         </p:nvSpPr>
         <p:spPr>
           <a:xfrm>
-            <a:off x="1947672" y="4837176"/>
-            <a:ext cx="64008" cy="155448"/>
+            <a:off x="1847088" y="5202936"/>
+            <a:ext cx="41148" cy="146304"/>
           </a:xfrm>
           <a:prstGeom prst="rect">
             <a:avLst/>
@@ -6112,14 +6762,14 @@
       </p:sp>
       <p:sp>
         <p:nvSpPr>
-          <p:cNvPr id="75" name="Rectangle 74"/>
+          <p:cNvPr id="80" name="Rectangle 79"/>
           <p:cNvSpPr/>
           <p:nvPr/>
         </p:nvSpPr>
         <p:spPr>
           <a:xfrm>
-            <a:off x="2043684" y="4837176"/>
-            <a:ext cx="64008" cy="155448"/>
+            <a:off x="1901952" y="5202936"/>
+            <a:ext cx="41148" cy="146304"/>
           </a:xfrm>
           <a:prstGeom prst="rect">
             <a:avLst/>
@@ -6157,14 +6807,14 @@
       </p:sp>
       <p:sp>
         <p:nvSpPr>
-          <p:cNvPr id="76" name="Rectangle 75"/>
+          <p:cNvPr id="81" name="Rectangle 80"/>
           <p:cNvSpPr/>
           <p:nvPr/>
         </p:nvSpPr>
         <p:spPr>
           <a:xfrm>
-            <a:off x="2139696" y="4837176"/>
-            <a:ext cx="64008" cy="155448"/>
+            <a:off x="1956815" y="5202936"/>
+            <a:ext cx="41148" cy="146304"/>
           </a:xfrm>
           <a:prstGeom prst="rect">
             <a:avLst/>
@@ -6202,14 +6852,14 @@
       </p:sp>
       <p:sp>
         <p:nvSpPr>
-          <p:cNvPr id="77" name="Rectangle 76"/>
+          <p:cNvPr id="82" name="Rectangle 81"/>
           <p:cNvSpPr/>
           <p:nvPr/>
         </p:nvSpPr>
         <p:spPr>
           <a:xfrm>
-            <a:off x="2235708" y="4837176"/>
-            <a:ext cx="64008" cy="155448"/>
+            <a:off x="2011679" y="5202936"/>
+            <a:ext cx="41148" cy="146304"/>
           </a:xfrm>
           <a:prstGeom prst="rect">
             <a:avLst/>
@@ -6247,14 +6897,14 @@
       </p:sp>
       <p:sp>
         <p:nvSpPr>
-          <p:cNvPr id="78" name="Rectangle 77"/>
+          <p:cNvPr id="83" name="Rectangle 82"/>
           <p:cNvSpPr/>
           <p:nvPr/>
         </p:nvSpPr>
         <p:spPr>
           <a:xfrm>
-            <a:off x="2331720" y="4837176"/>
-            <a:ext cx="64008" cy="155448"/>
+            <a:off x="2066543" y="5202936"/>
+            <a:ext cx="41148" cy="146304"/>
           </a:xfrm>
           <a:prstGeom prst="rect">
             <a:avLst/>
@@ -6292,14 +6942,14 @@
       </p:sp>
       <p:sp>
         <p:nvSpPr>
-          <p:cNvPr id="79" name="Rectangle 78"/>
+          <p:cNvPr id="84" name="Rectangle 83"/>
           <p:cNvSpPr/>
           <p:nvPr/>
         </p:nvSpPr>
         <p:spPr>
           <a:xfrm>
-            <a:off x="2427732" y="4837176"/>
-            <a:ext cx="64008" cy="155448"/>
+            <a:off x="2121408" y="5202936"/>
+            <a:ext cx="41148" cy="146304"/>
           </a:xfrm>
           <a:prstGeom prst="rect">
             <a:avLst/>
@@ -6337,14 +6987,14 @@
       </p:sp>
       <p:sp>
         <p:nvSpPr>
-          <p:cNvPr id="80" name="Rectangle 79"/>
+          <p:cNvPr id="85" name="Rectangle 84"/>
           <p:cNvSpPr/>
           <p:nvPr/>
         </p:nvSpPr>
         <p:spPr>
           <a:xfrm>
-            <a:off x="2523744" y="4837176"/>
-            <a:ext cx="64008" cy="155448"/>
+            <a:off x="2176272" y="5202936"/>
+            <a:ext cx="41148" cy="146304"/>
           </a:xfrm>
           <a:prstGeom prst="rect">
             <a:avLst/>
@@ -6382,14 +7032,764 @@
       </p:sp>
       <p:sp>
         <p:nvSpPr>
-          <p:cNvPr id="81" name="Rectangle 80"/>
+          <p:cNvPr id="86" name="TextBox 85"/>
+          <p:cNvSpPr txBox="1"/>
+          <p:nvPr/>
+        </p:nvSpPr>
+        <p:spPr>
+          <a:xfrm>
+            <a:off x="475488" y="5577840"/>
+            <a:ext cx="566928" cy="164592"/>
+          </a:xfrm>
+          <a:prstGeom prst="rect">
+            <a:avLst/>
+          </a:prstGeom>
+          <a:noFill/>
+        </p:spPr>
+        <p:txBody>
+          <a:bodyPr wrap="none" lIns="36576" rIns="36576" tIns="18288" bIns="18288">
+            <a:spAutoFit/>
+          </a:bodyPr>
+          <a:lstStyle/>
+          <a:p>
+            <a:pPr>
+              <a:defRPr sz="890" b="1">
+                <a:solidFill>
+                  <a:srgbClr val="A78BFA"/>
+                </a:solidFill>
+              </a:defRPr>
+            </a:pPr>
+            <a:r>
+              <a:t>512 KB</a:t>
+            </a:r>
+          </a:p>
+        </p:txBody>
+      </p:sp>
+      <p:sp>
+        <p:nvSpPr>
+          <p:cNvPr id="87" name="TextBox 86"/>
+          <p:cNvSpPr txBox="1"/>
+          <p:nvPr/>
+        </p:nvSpPr>
+        <p:spPr>
+          <a:xfrm>
+            <a:off x="1024128" y="5577840"/>
+            <a:ext cx="640080" cy="164592"/>
+          </a:xfrm>
+          <a:prstGeom prst="rect">
+            <a:avLst/>
+          </a:prstGeom>
+          <a:noFill/>
+        </p:spPr>
+        <p:txBody>
+          <a:bodyPr wrap="none" lIns="36576" rIns="36576" tIns="18288" bIns="18288">
+            <a:spAutoFit/>
+          </a:bodyPr>
+          <a:lstStyle/>
+          <a:p>
+            <a:pPr>
+              <a:defRPr sz="790" b="0">
+                <a:solidFill>
+                  <a:srgbClr val="CBD5E1"/>
+                </a:solidFill>
+              </a:defRPr>
+            </a:pPr>
+            <a:r>
+              <a:t>4 pages</a:t>
+            </a:r>
+          </a:p>
+        </p:txBody>
+      </p:sp>
+      <p:sp>
+        <p:nvSpPr>
+          <p:cNvPr id="88" name="Rectangle 87"/>
           <p:cNvSpPr/>
           <p:nvPr/>
         </p:nvSpPr>
         <p:spPr>
           <a:xfrm>
-            <a:off x="2619756" y="4837176"/>
-            <a:ext cx="64008" cy="155448"/>
+            <a:off x="1737360" y="5586984"/>
+            <a:ext cx="41148" cy="146304"/>
+          </a:xfrm>
+          <a:prstGeom prst="rect">
+            <a:avLst/>
+          </a:prstGeom>
+          <a:solidFill>
+            <a:srgbClr val="A78BFA"/>
+          </a:solidFill>
+          <a:ln>
+            <a:solidFill>
+              <a:srgbClr val="A78BFA"/>
+            </a:solidFill>
+          </a:ln>
+        </p:spPr>
+        <p:style>
+          <a:lnRef idx="1">
+            <a:schemeClr val="accent1"/>
+          </a:lnRef>
+          <a:fillRef idx="3">
+            <a:schemeClr val="accent1"/>
+          </a:fillRef>
+          <a:effectRef idx="2">
+            <a:schemeClr val="accent1"/>
+          </a:effectRef>
+          <a:fontRef idx="minor">
+            <a:schemeClr val="lt1"/>
+          </a:fontRef>
+        </p:style>
+        <p:txBody>
+          <a:bodyPr rtlCol="0" anchor="ctr"/>
+          <a:lstStyle/>
+          <a:p>
+            <a:pPr algn="ctr"/>
+          </a:p>
+        </p:txBody>
+      </p:sp>
+      <p:sp>
+        <p:nvSpPr>
+          <p:cNvPr id="89" name="Rectangle 88"/>
+          <p:cNvSpPr/>
+          <p:nvPr/>
+        </p:nvSpPr>
+        <p:spPr>
+          <a:xfrm>
+            <a:off x="1792224" y="5586984"/>
+            <a:ext cx="41148" cy="146304"/>
+          </a:xfrm>
+          <a:prstGeom prst="rect">
+            <a:avLst/>
+          </a:prstGeom>
+          <a:solidFill>
+            <a:srgbClr val="A78BFA"/>
+          </a:solidFill>
+          <a:ln>
+            <a:solidFill>
+              <a:srgbClr val="A78BFA"/>
+            </a:solidFill>
+          </a:ln>
+        </p:spPr>
+        <p:style>
+          <a:lnRef idx="1">
+            <a:schemeClr val="accent1"/>
+          </a:lnRef>
+          <a:fillRef idx="3">
+            <a:schemeClr val="accent1"/>
+          </a:fillRef>
+          <a:effectRef idx="2">
+            <a:schemeClr val="accent1"/>
+          </a:effectRef>
+          <a:fontRef idx="minor">
+            <a:schemeClr val="lt1"/>
+          </a:fontRef>
+        </p:style>
+        <p:txBody>
+          <a:bodyPr rtlCol="0" anchor="ctr"/>
+          <a:lstStyle/>
+          <a:p>
+            <a:pPr algn="ctr"/>
+          </a:p>
+        </p:txBody>
+      </p:sp>
+      <p:sp>
+        <p:nvSpPr>
+          <p:cNvPr id="90" name="Rectangle 89"/>
+          <p:cNvSpPr/>
+          <p:nvPr/>
+        </p:nvSpPr>
+        <p:spPr>
+          <a:xfrm>
+            <a:off x="1847088" y="5586984"/>
+            <a:ext cx="41148" cy="146304"/>
+          </a:xfrm>
+          <a:prstGeom prst="rect">
+            <a:avLst/>
+          </a:prstGeom>
+          <a:solidFill>
+            <a:srgbClr val="A78BFA"/>
+          </a:solidFill>
+          <a:ln>
+            <a:solidFill>
+              <a:srgbClr val="A78BFA"/>
+            </a:solidFill>
+          </a:ln>
+        </p:spPr>
+        <p:style>
+          <a:lnRef idx="1">
+            <a:schemeClr val="accent1"/>
+          </a:lnRef>
+          <a:fillRef idx="3">
+            <a:schemeClr val="accent1"/>
+          </a:fillRef>
+          <a:effectRef idx="2">
+            <a:schemeClr val="accent1"/>
+          </a:effectRef>
+          <a:fontRef idx="minor">
+            <a:schemeClr val="lt1"/>
+          </a:fontRef>
+        </p:style>
+        <p:txBody>
+          <a:bodyPr rtlCol="0" anchor="ctr"/>
+          <a:lstStyle/>
+          <a:p>
+            <a:pPr algn="ctr"/>
+          </a:p>
+        </p:txBody>
+      </p:sp>
+      <p:sp>
+        <p:nvSpPr>
+          <p:cNvPr id="91" name="TextBox 90"/>
+          <p:cNvSpPr txBox="1"/>
+          <p:nvPr/>
+        </p:nvSpPr>
+        <p:spPr>
+          <a:xfrm>
+            <a:off x="475488" y="5989320"/>
+            <a:ext cx="2651760" cy="164592"/>
+          </a:xfrm>
+          <a:prstGeom prst="rect">
+            <a:avLst/>
+          </a:prstGeom>
+          <a:noFill/>
+        </p:spPr>
+        <p:txBody>
+          <a:bodyPr wrap="none" lIns="36576" rIns="36576" tIns="18288" bIns="18288">
+            <a:spAutoFit/>
+          </a:bodyPr>
+          <a:lstStyle/>
+          <a:p>
+            <a:pPr algn="ctr">
+              <a:defRPr sz="800" b="1">
+                <a:solidFill>
+                  <a:srgbClr val="FACC15"/>
+                </a:solidFill>
+              </a:defRPr>
+            </a:pPr>
+            <a:r>
+              <a:t>338 ms is all 800 pages, not one chunk.</a:t>
+            </a:r>
+          </a:p>
+        </p:txBody>
+      </p:sp>
+      <p:sp>
+        <p:nvSpPr>
+          <p:cNvPr id="92" name="Rounded Rectangle 91"/>
+          <p:cNvSpPr/>
+          <p:nvPr/>
+        </p:nvSpPr>
+        <p:spPr>
+          <a:xfrm>
+            <a:off x="3538728" y="4315968"/>
+            <a:ext cx="3977639" cy="1975104"/>
+          </a:xfrm>
+          <a:prstGeom prst="roundRect">
+            <a:avLst/>
+          </a:prstGeom>
+          <a:solidFill>
+            <a:srgbClr val="0F172A"/>
+          </a:solidFill>
+          <a:ln>
+            <a:solidFill>
+              <a:srgbClr val="334155"/>
+            </a:solidFill>
+          </a:ln>
+        </p:spPr>
+        <p:style>
+          <a:lnRef idx="1">
+            <a:schemeClr val="accent1"/>
+          </a:lnRef>
+          <a:fillRef idx="3">
+            <a:schemeClr val="accent1"/>
+          </a:fillRef>
+          <a:effectRef idx="2">
+            <a:schemeClr val="accent1"/>
+          </a:effectRef>
+          <a:fontRef idx="minor">
+            <a:schemeClr val="lt1"/>
+          </a:fontRef>
+        </p:style>
+        <p:txBody>
+          <a:bodyPr rtlCol="0" anchor="ctr"/>
+          <a:lstStyle/>
+          <a:p>
+            <a:pPr algn="ctr"/>
+          </a:p>
+        </p:txBody>
+      </p:sp>
+      <p:sp>
+        <p:nvSpPr>
+          <p:cNvPr id="93" name="TextBox 92"/>
+          <p:cNvSpPr txBox="1"/>
+          <p:nvPr/>
+        </p:nvSpPr>
+        <p:spPr>
+          <a:xfrm>
+            <a:off x="3730752" y="4443984"/>
+            <a:ext cx="3611880" cy="219456"/>
+          </a:xfrm>
+          <a:prstGeom prst="rect">
+            <a:avLst/>
+          </a:prstGeom>
+          <a:noFill/>
+        </p:spPr>
+        <p:txBody>
+          <a:bodyPr wrap="none" lIns="36576" rIns="36576" tIns="18288" bIns="18288">
+            <a:spAutoFit/>
+          </a:bodyPr>
+          <a:lstStyle/>
+          <a:p>
+            <a:pPr algn="ctr">
+              <a:defRPr sz="1200" b="1">
+                <a:solidFill>
+                  <a:srgbClr val="F8FAFC"/>
+                </a:solidFill>
+              </a:defRPr>
+            </a:pPr>
+            <a:r>
+              <a:t>Fairness: equal turns, not identical latency</a:t>
+            </a:r>
+          </a:p>
+        </p:txBody>
+      </p:sp>
+      <p:sp>
+        <p:nvSpPr>
+          <p:cNvPr id="94" name="TextBox 93"/>
+          <p:cNvSpPr txBox="1"/>
+          <p:nvPr/>
+        </p:nvSpPr>
+        <p:spPr>
+          <a:xfrm>
+            <a:off x="3767328" y="4828032"/>
+            <a:ext cx="411480" cy="146304"/>
+          </a:xfrm>
+          <a:prstGeom prst="rect">
+            <a:avLst/>
+          </a:prstGeom>
+          <a:noFill/>
+        </p:spPr>
+        <p:txBody>
+          <a:bodyPr wrap="none" lIns="36576" rIns="36576" tIns="18288" bIns="18288">
+            <a:spAutoFit/>
+          </a:bodyPr>
+          <a:lstStyle/>
+          <a:p>
+            <a:pPr>
+              <a:defRPr sz="750" b="1">
+                <a:solidFill>
+                  <a:srgbClr val="38BDF8"/>
+                </a:solidFill>
+              </a:defRPr>
+            </a:pPr>
+            <a:r>
+              <a:t>cli1</a:t>
+            </a:r>
+          </a:p>
+        </p:txBody>
+      </p:sp>
+      <p:cxnSp>
+        <p:nvCxnSpPr>
+          <p:cNvPr id="95" name="Connector 94"/>
+          <p:cNvCxnSpPr/>
+          <p:nvPr/>
+        </p:nvCxnSpPr>
+        <p:spPr>
+          <a:xfrm>
+            <a:off x="4206240" y="4901184"/>
+            <a:ext cx="621792" cy="0"/>
+          </a:xfrm>
+          <a:prstGeom prst="line">
+            <a:avLst/>
+          </a:prstGeom>
+          <a:ln w="15240">
+            <a:solidFill>
+              <a:srgbClr val="38BDF8"/>
+            </a:solidFill>
+          </a:ln>
+        </p:spPr>
+        <p:style>
+          <a:lnRef idx="2">
+            <a:schemeClr val="accent1"/>
+          </a:lnRef>
+          <a:fillRef idx="0">
+            <a:schemeClr val="accent1"/>
+          </a:fillRef>
+          <a:effectRef idx="1">
+            <a:schemeClr val="accent1"/>
+          </a:effectRef>
+          <a:fontRef idx="minor">
+            <a:schemeClr val="tx1"/>
+          </a:fontRef>
+        </p:style>
+      </p:cxnSp>
+      <p:sp>
+        <p:nvSpPr>
+          <p:cNvPr id="96" name="TextBox 95"/>
+          <p:cNvSpPr txBox="1"/>
+          <p:nvPr/>
+        </p:nvSpPr>
+        <p:spPr>
+          <a:xfrm>
+            <a:off x="3767328" y="5084064"/>
+            <a:ext cx="411480" cy="146304"/>
+          </a:xfrm>
+          <a:prstGeom prst="rect">
+            <a:avLst/>
+          </a:prstGeom>
+          <a:noFill/>
+        </p:spPr>
+        <p:txBody>
+          <a:bodyPr wrap="none" lIns="36576" rIns="36576" tIns="18288" bIns="18288">
+            <a:spAutoFit/>
+          </a:bodyPr>
+          <a:lstStyle/>
+          <a:p>
+            <a:pPr>
+              <a:defRPr sz="750" b="1">
+                <a:solidFill>
+                  <a:srgbClr val="34D399"/>
+                </a:solidFill>
+              </a:defRPr>
+            </a:pPr>
+            <a:r>
+              <a:t>cli2</a:t>
+            </a:r>
+          </a:p>
+        </p:txBody>
+      </p:sp>
+      <p:cxnSp>
+        <p:nvCxnSpPr>
+          <p:cNvPr id="97" name="Connector 96"/>
+          <p:cNvCxnSpPr/>
+          <p:nvPr/>
+        </p:nvCxnSpPr>
+        <p:spPr>
+          <a:xfrm>
+            <a:off x="4206240" y="5157216"/>
+            <a:ext cx="621792" cy="0"/>
+          </a:xfrm>
+          <a:prstGeom prst="line">
+            <a:avLst/>
+          </a:prstGeom>
+          <a:ln w="15240">
+            <a:solidFill>
+              <a:srgbClr val="34D399"/>
+            </a:solidFill>
+          </a:ln>
+        </p:spPr>
+        <p:style>
+          <a:lnRef idx="2">
+            <a:schemeClr val="accent1"/>
+          </a:lnRef>
+          <a:fillRef idx="0">
+            <a:schemeClr val="accent1"/>
+          </a:fillRef>
+          <a:effectRef idx="1">
+            <a:schemeClr val="accent1"/>
+          </a:effectRef>
+          <a:fontRef idx="minor">
+            <a:schemeClr val="tx1"/>
+          </a:fontRef>
+        </p:style>
+      </p:cxnSp>
+      <p:sp>
+        <p:nvSpPr>
+          <p:cNvPr id="98" name="TextBox 97"/>
+          <p:cNvSpPr txBox="1"/>
+          <p:nvPr/>
+        </p:nvSpPr>
+        <p:spPr>
+          <a:xfrm>
+            <a:off x="3767328" y="5340096"/>
+            <a:ext cx="411480" cy="146304"/>
+          </a:xfrm>
+          <a:prstGeom prst="rect">
+            <a:avLst/>
+          </a:prstGeom>
+          <a:noFill/>
+        </p:spPr>
+        <p:txBody>
+          <a:bodyPr wrap="none" lIns="36576" rIns="36576" tIns="18288" bIns="18288">
+            <a:spAutoFit/>
+          </a:bodyPr>
+          <a:lstStyle/>
+          <a:p>
+            <a:pPr>
+              <a:defRPr sz="750" b="1">
+                <a:solidFill>
+                  <a:srgbClr val="FACC15"/>
+                </a:solidFill>
+              </a:defRPr>
+            </a:pPr>
+            <a:r>
+              <a:t>cli3</a:t>
+            </a:r>
+          </a:p>
+        </p:txBody>
+      </p:sp>
+      <p:cxnSp>
+        <p:nvCxnSpPr>
+          <p:cNvPr id="99" name="Connector 98"/>
+          <p:cNvCxnSpPr/>
+          <p:nvPr/>
+        </p:nvCxnSpPr>
+        <p:spPr>
+          <a:xfrm>
+            <a:off x="4206240" y="5413248"/>
+            <a:ext cx="621792" cy="0"/>
+          </a:xfrm>
+          <a:prstGeom prst="line">
+            <a:avLst/>
+          </a:prstGeom>
+          <a:ln w="15240">
+            <a:solidFill>
+              <a:srgbClr val="FACC15"/>
+            </a:solidFill>
+          </a:ln>
+        </p:spPr>
+        <p:style>
+          <a:lnRef idx="2">
+            <a:schemeClr val="accent1"/>
+          </a:lnRef>
+          <a:fillRef idx="0">
+            <a:schemeClr val="accent1"/>
+          </a:fillRef>
+          <a:effectRef idx="1">
+            <a:schemeClr val="accent1"/>
+          </a:effectRef>
+          <a:fontRef idx="minor">
+            <a:schemeClr val="tx1"/>
+          </a:fontRef>
+        </p:style>
+      </p:cxnSp>
+      <p:sp>
+        <p:nvSpPr>
+          <p:cNvPr id="100" name="TextBox 99"/>
+          <p:cNvSpPr txBox="1"/>
+          <p:nvPr/>
+        </p:nvSpPr>
+        <p:spPr>
+          <a:xfrm>
+            <a:off x="3767328" y="5596128"/>
+            <a:ext cx="411480" cy="146304"/>
+          </a:xfrm>
+          <a:prstGeom prst="rect">
+            <a:avLst/>
+          </a:prstGeom>
+          <a:noFill/>
+        </p:spPr>
+        <p:txBody>
+          <a:bodyPr wrap="none" lIns="36576" rIns="36576" tIns="18288" bIns="18288">
+            <a:spAutoFit/>
+          </a:bodyPr>
+          <a:lstStyle/>
+          <a:p>
+            <a:pPr>
+              <a:defRPr sz="750" b="1">
+                <a:solidFill>
+                  <a:srgbClr val="A78BFA"/>
+                </a:solidFill>
+              </a:defRPr>
+            </a:pPr>
+            <a:r>
+              <a:t>cli4</a:t>
+            </a:r>
+          </a:p>
+        </p:txBody>
+      </p:sp>
+      <p:cxnSp>
+        <p:nvCxnSpPr>
+          <p:cNvPr id="101" name="Connector 100"/>
+          <p:cNvCxnSpPr/>
+          <p:nvPr/>
+        </p:nvCxnSpPr>
+        <p:spPr>
+          <a:xfrm>
+            <a:off x="4206240" y="5669280"/>
+            <a:ext cx="621792" cy="0"/>
+          </a:xfrm>
+          <a:prstGeom prst="line">
+            <a:avLst/>
+          </a:prstGeom>
+          <a:ln w="15240">
+            <a:solidFill>
+              <a:srgbClr val="A78BFA"/>
+            </a:solidFill>
+          </a:ln>
+        </p:spPr>
+        <p:style>
+          <a:lnRef idx="2">
+            <a:schemeClr val="accent1"/>
+          </a:lnRef>
+          <a:fillRef idx="0">
+            <a:schemeClr val="accent1"/>
+          </a:fillRef>
+          <a:effectRef idx="1">
+            <a:schemeClr val="accent1"/>
+          </a:effectRef>
+          <a:fontRef idx="minor">
+            <a:schemeClr val="tx1"/>
+          </a:fontRef>
+        </p:style>
+      </p:cxnSp>
+      <p:sp>
+        <p:nvSpPr>
+          <p:cNvPr id="102" name="Rounded Rectangle 101"/>
+          <p:cNvSpPr/>
+          <p:nvPr/>
+        </p:nvSpPr>
+        <p:spPr>
+          <a:xfrm>
+            <a:off x="4919472" y="4873752"/>
+            <a:ext cx="713232" cy="658368"/>
+          </a:xfrm>
+          <a:prstGeom prst="roundRect">
+            <a:avLst/>
+          </a:prstGeom>
+          <a:solidFill>
+            <a:srgbClr val="172033"/>
+          </a:solidFill>
+          <a:ln>
+            <a:solidFill>
+              <a:srgbClr val="FACC15"/>
+            </a:solidFill>
+          </a:ln>
+        </p:spPr>
+        <p:style>
+          <a:lnRef idx="1">
+            <a:schemeClr val="accent1"/>
+          </a:lnRef>
+          <a:fillRef idx="3">
+            <a:schemeClr val="accent1"/>
+          </a:fillRef>
+          <a:effectRef idx="2">
+            <a:schemeClr val="accent1"/>
+          </a:effectRef>
+          <a:fontRef idx="minor">
+            <a:schemeClr val="lt1"/>
+          </a:fontRef>
+        </p:style>
+        <p:txBody>
+          <a:bodyPr rtlCol="0" anchor="ctr"/>
+          <a:lstStyle/>
+          <a:p>
+            <a:pPr algn="ctr"/>
+          </a:p>
+        </p:txBody>
+      </p:sp>
+      <p:sp>
+        <p:nvSpPr>
+          <p:cNvPr id="103" name="TextBox 102"/>
+          <p:cNvSpPr txBox="1"/>
+          <p:nvPr/>
+        </p:nvSpPr>
+        <p:spPr>
+          <a:xfrm>
+            <a:off x="4992624" y="5020056"/>
+            <a:ext cx="566928" cy="146304"/>
+          </a:xfrm>
+          <a:prstGeom prst="rect">
+            <a:avLst/>
+          </a:prstGeom>
+          <a:noFill/>
+        </p:spPr>
+        <p:txBody>
+          <a:bodyPr wrap="none" lIns="36576" rIns="36576" tIns="18288" bIns="18288">
+            <a:spAutoFit/>
+          </a:bodyPr>
+          <a:lstStyle/>
+          <a:p>
+            <a:pPr algn="ctr">
+              <a:defRPr sz="1300" b="1">
+                <a:solidFill>
+                  <a:srgbClr val="FACC15"/>
+                </a:solidFill>
+              </a:defRPr>
+            </a:pPr>
+            <a:r>
+              <a:t>A</a:t>
+            </a:r>
+          </a:p>
+        </p:txBody>
+      </p:sp>
+      <p:sp>
+        <p:nvSpPr>
+          <p:cNvPr id="104" name="TextBox 103"/>
+          <p:cNvSpPr txBox="1"/>
+          <p:nvPr/>
+        </p:nvSpPr>
+        <p:spPr>
+          <a:xfrm>
+            <a:off x="4974336" y="5239512"/>
+            <a:ext cx="603504" cy="128016"/>
+          </a:xfrm>
+          <a:prstGeom prst="rect">
+            <a:avLst/>
+          </a:prstGeom>
+          <a:noFill/>
+        </p:spPr>
+        <p:txBody>
+          <a:bodyPr wrap="none" lIns="36576" rIns="36576" tIns="18288" bIns="18288">
+            <a:spAutoFit/>
+          </a:bodyPr>
+          <a:lstStyle/>
+          <a:p>
+            <a:pPr algn="ctr">
+              <a:defRPr sz="700" b="1">
+                <a:solidFill>
+                  <a:srgbClr val="FACC15"/>
+                </a:solidFill>
+              </a:defRPr>
+            </a:pPr>
+            <a:r>
+              <a:t>queue</a:t>
+            </a:r>
+          </a:p>
+        </p:txBody>
+      </p:sp>
+      <p:cxnSp>
+        <p:nvCxnSpPr>
+          <p:cNvPr id="105" name="Connector 104"/>
+          <p:cNvCxnSpPr/>
+          <p:nvPr/>
+        </p:nvCxnSpPr>
+        <p:spPr>
+          <a:xfrm>
+            <a:off x="5669280" y="5193792"/>
+            <a:ext cx="457200" cy="0"/>
+          </a:xfrm>
+          <a:prstGeom prst="line">
+            <a:avLst/>
+          </a:prstGeom>
+          <a:ln w="12700">
+            <a:solidFill>
+              <a:srgbClr val="38BDF8"/>
+            </a:solidFill>
+          </a:ln>
+        </p:spPr>
+        <p:style>
+          <a:lnRef idx="2">
+            <a:schemeClr val="accent1"/>
+          </a:lnRef>
+          <a:fillRef idx="0">
+            <a:schemeClr val="accent1"/>
+          </a:fillRef>
+          <a:effectRef idx="1">
+            <a:schemeClr val="accent1"/>
+          </a:effectRef>
+          <a:fontRef idx="minor">
+            <a:schemeClr val="tx1"/>
+          </a:fontRef>
+        </p:style>
+      </p:cxnSp>
+      <p:sp>
+        <p:nvSpPr>
+          <p:cNvPr id="106" name="Rectangle 105"/>
+          <p:cNvSpPr/>
+          <p:nvPr/>
+        </p:nvSpPr>
+        <p:spPr>
+          <a:xfrm>
+            <a:off x="6199632" y="5074920"/>
+            <a:ext cx="146304" cy="219456"/>
           </a:xfrm>
           <a:prstGeom prst="rect">
             <a:avLst/>
@@ -6425,121 +7825,211 @@
           </a:p>
         </p:txBody>
       </p:sp>
-      <p:sp>
-        <p:nvSpPr>
-          <p:cNvPr id="82" name="TextBox 81"/>
-          <p:cNvSpPr txBox="1"/>
-          <p:nvPr/>
-        </p:nvSpPr>
-        <p:spPr>
-          <a:xfrm>
-            <a:off x="3154680" y="4818888"/>
-            <a:ext cx="1078992" cy="228600"/>
-          </a:xfrm>
-          <a:prstGeom prst="rect">
-            <a:avLst/>
-          </a:prstGeom>
-          <a:noFill/>
-        </p:spPr>
-        <p:txBody>
-          <a:bodyPr wrap="none" lIns="36576" rIns="36576" tIns="18288" bIns="18288">
-            <a:spAutoFit/>
-          </a:bodyPr>
-          <a:lstStyle/>
-          <a:p>
-            <a:pPr>
-              <a:defRPr sz="740" b="0">
-                <a:solidFill>
-                  <a:srgbClr val="94A3B8"/>
-                </a:solidFill>
-              </a:defRPr>
-            </a:pPr>
-            <a:r>
-              <a:t>~0.91 ms/page, knee</a:t>
-            </a:r>
-          </a:p>
-        </p:txBody>
-      </p:sp>
-      <p:sp>
-        <p:nvSpPr>
-          <p:cNvPr id="83" name="TextBox 82"/>
-          <p:cNvSpPr txBox="1"/>
-          <p:nvPr/>
-        </p:nvSpPr>
-        <p:spPr>
-          <a:xfrm>
-            <a:off x="530352" y="5321808"/>
-            <a:ext cx="566928" cy="182880"/>
-          </a:xfrm>
-          <a:prstGeom prst="rect">
-            <a:avLst/>
-          </a:prstGeom>
-          <a:noFill/>
-        </p:spPr>
-        <p:txBody>
-          <a:bodyPr wrap="none" lIns="36576" rIns="36576" tIns="18288" bIns="18288">
-            <a:spAutoFit/>
-          </a:bodyPr>
-          <a:lstStyle/>
-          <a:p>
-            <a:pPr>
-              <a:defRPr sz="919" b="1">
-                <a:solidFill>
-                  <a:srgbClr val="A78BFA"/>
-                </a:solidFill>
-              </a:defRPr>
-            </a:pPr>
-            <a:r>
-              <a:t>512 KB</a:t>
-            </a:r>
-          </a:p>
-        </p:txBody>
-      </p:sp>
-      <p:sp>
-        <p:nvSpPr>
-          <p:cNvPr id="84" name="TextBox 83"/>
-          <p:cNvSpPr txBox="1"/>
-          <p:nvPr/>
-        </p:nvSpPr>
-        <p:spPr>
-          <a:xfrm>
-            <a:off x="1051560" y="5321808"/>
-            <a:ext cx="658368" cy="182880"/>
-          </a:xfrm>
-          <a:prstGeom prst="rect">
-            <a:avLst/>
-          </a:prstGeom>
-          <a:noFill/>
-        </p:spPr>
-        <p:txBody>
-          <a:bodyPr wrap="none" lIns="36576" rIns="36576" tIns="18288" bIns="18288">
-            <a:spAutoFit/>
-          </a:bodyPr>
-          <a:lstStyle/>
-          <a:p>
-            <a:pPr>
-              <a:defRPr sz="830" b="0">
-                <a:solidFill>
-                  <a:srgbClr val="CBD5E1"/>
-                </a:solidFill>
-              </a:defRPr>
-            </a:pPr>
-            <a:r>
-              <a:t>4 pages</a:t>
-            </a:r>
-          </a:p>
-        </p:txBody>
-      </p:sp>
-      <p:sp>
-        <p:nvSpPr>
-          <p:cNvPr id="85" name="Rectangle 84"/>
+      <p:cxnSp>
+        <p:nvCxnSpPr>
+          <p:cNvPr id="107" name="Connector 106"/>
+          <p:cNvCxnSpPr/>
+          <p:nvPr/>
+        </p:nvCxnSpPr>
+        <p:spPr>
+          <a:xfrm>
+            <a:off x="5669280" y="5193792"/>
+            <a:ext cx="694944" cy="0"/>
+          </a:xfrm>
+          <a:prstGeom prst="line">
+            <a:avLst/>
+          </a:prstGeom>
+          <a:ln w="12700">
+            <a:solidFill>
+              <a:srgbClr val="34D399"/>
+            </a:solidFill>
+          </a:ln>
+        </p:spPr>
+        <p:style>
+          <a:lnRef idx="2">
+            <a:schemeClr val="accent1"/>
+          </a:lnRef>
+          <a:fillRef idx="0">
+            <a:schemeClr val="accent1"/>
+          </a:fillRef>
+          <a:effectRef idx="1">
+            <a:schemeClr val="accent1"/>
+          </a:effectRef>
+          <a:fontRef idx="minor">
+            <a:schemeClr val="tx1"/>
+          </a:fontRef>
+        </p:style>
+      </p:cxnSp>
+      <p:sp>
+        <p:nvSpPr>
+          <p:cNvPr id="108" name="Rectangle 107"/>
           <p:cNvSpPr/>
           <p:nvPr/>
         </p:nvSpPr>
         <p:spPr>
           <a:xfrm>
-            <a:off x="1755648" y="5340096"/>
-            <a:ext cx="64008" cy="155448"/>
+            <a:off x="6437376" y="5074920"/>
+            <a:ext cx="146304" cy="219456"/>
+          </a:xfrm>
+          <a:prstGeom prst="rect">
+            <a:avLst/>
+          </a:prstGeom>
+          <a:solidFill>
+            <a:srgbClr val="34D399"/>
+          </a:solidFill>
+          <a:ln>
+            <a:solidFill>
+              <a:srgbClr val="34D399"/>
+            </a:solidFill>
+          </a:ln>
+        </p:spPr>
+        <p:style>
+          <a:lnRef idx="1">
+            <a:schemeClr val="accent1"/>
+          </a:lnRef>
+          <a:fillRef idx="3">
+            <a:schemeClr val="accent1"/>
+          </a:fillRef>
+          <a:effectRef idx="2">
+            <a:schemeClr val="accent1"/>
+          </a:effectRef>
+          <a:fontRef idx="minor">
+            <a:schemeClr val="lt1"/>
+          </a:fontRef>
+        </p:style>
+        <p:txBody>
+          <a:bodyPr rtlCol="0" anchor="ctr"/>
+          <a:lstStyle/>
+          <a:p>
+            <a:pPr algn="ctr"/>
+          </a:p>
+        </p:txBody>
+      </p:sp>
+      <p:cxnSp>
+        <p:nvCxnSpPr>
+          <p:cNvPr id="109" name="Connector 108"/>
+          <p:cNvCxnSpPr/>
+          <p:nvPr/>
+        </p:nvCxnSpPr>
+        <p:spPr>
+          <a:xfrm>
+            <a:off x="5669280" y="5193792"/>
+            <a:ext cx="932688" cy="0"/>
+          </a:xfrm>
+          <a:prstGeom prst="line">
+            <a:avLst/>
+          </a:prstGeom>
+          <a:ln w="12700">
+            <a:solidFill>
+              <a:srgbClr val="FACC15"/>
+            </a:solidFill>
+          </a:ln>
+        </p:spPr>
+        <p:style>
+          <a:lnRef idx="2">
+            <a:schemeClr val="accent1"/>
+          </a:lnRef>
+          <a:fillRef idx="0">
+            <a:schemeClr val="accent1"/>
+          </a:fillRef>
+          <a:effectRef idx="1">
+            <a:schemeClr val="accent1"/>
+          </a:effectRef>
+          <a:fontRef idx="minor">
+            <a:schemeClr val="tx1"/>
+          </a:fontRef>
+        </p:style>
+      </p:cxnSp>
+      <p:sp>
+        <p:nvSpPr>
+          <p:cNvPr id="110" name="Rectangle 109"/>
+          <p:cNvSpPr/>
+          <p:nvPr/>
+        </p:nvSpPr>
+        <p:spPr>
+          <a:xfrm>
+            <a:off x="6675120" y="5074920"/>
+            <a:ext cx="146304" cy="219456"/>
+          </a:xfrm>
+          <a:prstGeom prst="rect">
+            <a:avLst/>
+          </a:prstGeom>
+          <a:solidFill>
+            <a:srgbClr val="FACC15"/>
+          </a:solidFill>
+          <a:ln>
+            <a:solidFill>
+              <a:srgbClr val="FACC15"/>
+            </a:solidFill>
+          </a:ln>
+        </p:spPr>
+        <p:style>
+          <a:lnRef idx="1">
+            <a:schemeClr val="accent1"/>
+          </a:lnRef>
+          <a:fillRef idx="3">
+            <a:schemeClr val="accent1"/>
+          </a:fillRef>
+          <a:effectRef idx="2">
+            <a:schemeClr val="accent1"/>
+          </a:effectRef>
+          <a:fontRef idx="minor">
+            <a:schemeClr val="lt1"/>
+          </a:fontRef>
+        </p:style>
+        <p:txBody>
+          <a:bodyPr rtlCol="0" anchor="ctr"/>
+          <a:lstStyle/>
+          <a:p>
+            <a:pPr algn="ctr"/>
+          </a:p>
+        </p:txBody>
+      </p:sp>
+      <p:cxnSp>
+        <p:nvCxnSpPr>
+          <p:cNvPr id="111" name="Connector 110"/>
+          <p:cNvCxnSpPr/>
+          <p:nvPr/>
+        </p:nvCxnSpPr>
+        <p:spPr>
+          <a:xfrm>
+            <a:off x="5669280" y="5193792"/>
+            <a:ext cx="1170432" cy="0"/>
+          </a:xfrm>
+          <a:prstGeom prst="line">
+            <a:avLst/>
+          </a:prstGeom>
+          <a:ln w="12700">
+            <a:solidFill>
+              <a:srgbClr val="A78BFA"/>
+            </a:solidFill>
+          </a:ln>
+        </p:spPr>
+        <p:style>
+          <a:lnRef idx="2">
+            <a:schemeClr val="accent1"/>
+          </a:lnRef>
+          <a:fillRef idx="0">
+            <a:schemeClr val="accent1"/>
+          </a:fillRef>
+          <a:effectRef idx="1">
+            <a:schemeClr val="accent1"/>
+          </a:effectRef>
+          <a:fontRef idx="minor">
+            <a:schemeClr val="tx1"/>
+          </a:fontRef>
+        </p:style>
+      </p:cxnSp>
+      <p:sp>
+        <p:nvSpPr>
+          <p:cNvPr id="112" name="Rectangle 111"/>
+          <p:cNvSpPr/>
+          <p:nvPr/>
+        </p:nvSpPr>
+        <p:spPr>
+          <a:xfrm>
+            <a:off x="6912864" y="5074920"/>
+            <a:ext cx="146304" cy="219456"/>
           </a:xfrm>
           <a:prstGeom prst="rect">
             <a:avLst/>
@@ -6577,149 +8067,14 @@
       </p:sp>
       <p:sp>
         <p:nvSpPr>
-          <p:cNvPr id="86" name="Rectangle 85"/>
-          <p:cNvSpPr/>
-          <p:nvPr/>
-        </p:nvSpPr>
-        <p:spPr>
-          <a:xfrm>
-            <a:off x="1851660" y="5340096"/>
-            <a:ext cx="64008" cy="155448"/>
-          </a:xfrm>
-          <a:prstGeom prst="rect">
-            <a:avLst/>
-          </a:prstGeom>
-          <a:solidFill>
-            <a:srgbClr val="A78BFA"/>
-          </a:solidFill>
-          <a:ln>
-            <a:solidFill>
-              <a:srgbClr val="A78BFA"/>
-            </a:solidFill>
-          </a:ln>
-        </p:spPr>
-        <p:style>
-          <a:lnRef idx="1">
-            <a:schemeClr val="accent1"/>
-          </a:lnRef>
-          <a:fillRef idx="3">
-            <a:schemeClr val="accent1"/>
-          </a:fillRef>
-          <a:effectRef idx="2">
-            <a:schemeClr val="accent1"/>
-          </a:effectRef>
-          <a:fontRef idx="minor">
-            <a:schemeClr val="lt1"/>
-          </a:fontRef>
-        </p:style>
-        <p:txBody>
-          <a:bodyPr rtlCol="0" anchor="ctr"/>
-          <a:lstStyle/>
-          <a:p>
-            <a:pPr algn="ctr"/>
-          </a:p>
-        </p:txBody>
-      </p:sp>
-      <p:sp>
-        <p:nvSpPr>
-          <p:cNvPr id="87" name="Rectangle 86"/>
-          <p:cNvSpPr/>
-          <p:nvPr/>
-        </p:nvSpPr>
-        <p:spPr>
-          <a:xfrm>
-            <a:off x="1947672" y="5340096"/>
-            <a:ext cx="64008" cy="155448"/>
-          </a:xfrm>
-          <a:prstGeom prst="rect">
-            <a:avLst/>
-          </a:prstGeom>
-          <a:solidFill>
-            <a:srgbClr val="A78BFA"/>
-          </a:solidFill>
-          <a:ln>
-            <a:solidFill>
-              <a:srgbClr val="A78BFA"/>
-            </a:solidFill>
-          </a:ln>
-        </p:spPr>
-        <p:style>
-          <a:lnRef idx="1">
-            <a:schemeClr val="accent1"/>
-          </a:lnRef>
-          <a:fillRef idx="3">
-            <a:schemeClr val="accent1"/>
-          </a:fillRef>
-          <a:effectRef idx="2">
-            <a:schemeClr val="accent1"/>
-          </a:effectRef>
-          <a:fontRef idx="minor">
-            <a:schemeClr val="lt1"/>
-          </a:fontRef>
-        </p:style>
-        <p:txBody>
-          <a:bodyPr rtlCol="0" anchor="ctr"/>
-          <a:lstStyle/>
-          <a:p>
-            <a:pPr algn="ctr"/>
-          </a:p>
-        </p:txBody>
-      </p:sp>
-      <p:sp>
-        <p:nvSpPr>
-          <p:cNvPr id="88" name="Rectangle 87"/>
-          <p:cNvSpPr/>
-          <p:nvPr/>
-        </p:nvSpPr>
-        <p:spPr>
-          <a:xfrm>
-            <a:off x="2043684" y="5340096"/>
-            <a:ext cx="64008" cy="155448"/>
-          </a:xfrm>
-          <a:prstGeom prst="rect">
-            <a:avLst/>
-          </a:prstGeom>
-          <a:solidFill>
-            <a:srgbClr val="A78BFA"/>
-          </a:solidFill>
-          <a:ln>
-            <a:solidFill>
-              <a:srgbClr val="A78BFA"/>
-            </a:solidFill>
-          </a:ln>
-        </p:spPr>
-        <p:style>
-          <a:lnRef idx="1">
-            <a:schemeClr val="accent1"/>
-          </a:lnRef>
-          <a:fillRef idx="3">
-            <a:schemeClr val="accent1"/>
-          </a:fillRef>
-          <a:effectRef idx="2">
-            <a:schemeClr val="accent1"/>
-          </a:effectRef>
-          <a:fontRef idx="minor">
-            <a:schemeClr val="lt1"/>
-          </a:fontRef>
-        </p:style>
-        <p:txBody>
-          <a:bodyPr rtlCol="0" anchor="ctr"/>
-          <a:lstStyle/>
-          <a:p>
-            <a:pPr algn="ctr"/>
-          </a:p>
-        </p:txBody>
-      </p:sp>
-      <p:sp>
-        <p:nvSpPr>
-          <p:cNvPr id="89" name="TextBox 88"/>
+          <p:cNvPr id="113" name="TextBox 112"/>
           <p:cNvSpPr txBox="1"/>
           <p:nvPr/>
         </p:nvSpPr>
         <p:spPr>
           <a:xfrm>
-            <a:off x="3154680" y="5321808"/>
-            <a:ext cx="1078992" cy="228600"/>
+            <a:off x="3822191" y="5760720"/>
+            <a:ext cx="3401568" cy="292608"/>
           </a:xfrm>
           <a:prstGeom prst="rect">
             <a:avLst/>
@@ -6732,543 +8087,29 @@
           </a:bodyPr>
           <a:lstStyle/>
           <a:p>
-            <a:pPr>
-              <a:defRPr sz="740" b="0">
-                <a:solidFill>
-                  <a:srgbClr val="94A3B8"/>
-                </a:solidFill>
-              </a:defRPr>
-            </a:pPr>
-            <a:r>
-              <a:t>~11 ms/page, few but bigger</a:t>
-            </a:r>
-          </a:p>
-        </p:txBody>
-      </p:sp>
-      <p:sp>
-        <p:nvSpPr>
-          <p:cNvPr id="90" name="TextBox 89"/>
-          <p:cNvSpPr txBox="1"/>
-          <p:nvPr/>
-        </p:nvSpPr>
-        <p:spPr>
-          <a:xfrm>
-            <a:off x="530352" y="5715000"/>
-            <a:ext cx="3703320" cy="201168"/>
-          </a:xfrm>
-          <a:prstGeom prst="rect">
-            <a:avLst/>
-          </a:prstGeom>
-          <a:noFill/>
-        </p:spPr>
-        <p:txBody>
-          <a:bodyPr wrap="none" lIns="36576" rIns="36576" tIns="18288" bIns="18288">
-            <a:spAutoFit/>
-          </a:bodyPr>
-          <a:lstStyle/>
-          <a:p>
             <a:pPr algn="ctr">
-              <a:defRPr sz="869" b="1">
-                <a:solidFill>
-                  <a:srgbClr val="FACC15"/>
-                </a:solidFill>
-              </a:defRPr>
-            </a:pPr>
-            <a:r>
-              <a:t>Total is all pages combined, not one chunk response.</a:t>
-            </a:r>
-          </a:p>
-        </p:txBody>
-      </p:sp>
-      <p:sp>
-        <p:nvSpPr>
-          <p:cNvPr id="91" name="Rounded Rectangle 90"/>
-          <p:cNvSpPr/>
-          <p:nvPr/>
-        </p:nvSpPr>
-        <p:spPr>
-          <a:xfrm>
-            <a:off x="4709160" y="3749039"/>
-            <a:ext cx="2788920" cy="2331720"/>
-          </a:xfrm>
-          <a:prstGeom prst="roundRect">
-            <a:avLst/>
-          </a:prstGeom>
-          <a:solidFill>
-            <a:srgbClr val="0F172A"/>
-          </a:solidFill>
-          <a:ln>
-            <a:solidFill>
-              <a:srgbClr val="334155"/>
-            </a:solidFill>
-          </a:ln>
-        </p:spPr>
-        <p:style>
-          <a:lnRef idx="1">
-            <a:schemeClr val="accent1"/>
-          </a:lnRef>
-          <a:fillRef idx="3">
-            <a:schemeClr val="accent1"/>
-          </a:fillRef>
-          <a:effectRef idx="2">
-            <a:schemeClr val="accent1"/>
-          </a:effectRef>
-          <a:fontRef idx="minor">
-            <a:schemeClr val="lt1"/>
-          </a:fontRef>
-        </p:style>
-        <p:txBody>
-          <a:bodyPr rtlCol="0" anchor="ctr"/>
-          <a:lstStyle/>
-          <a:p>
-            <a:pPr algn="ctr"/>
-          </a:p>
-        </p:txBody>
-      </p:sp>
-      <p:sp>
-        <p:nvSpPr>
-          <p:cNvPr id="92" name="TextBox 91"/>
-          <p:cNvSpPr txBox="1"/>
-          <p:nvPr/>
-        </p:nvSpPr>
-        <p:spPr>
-          <a:xfrm>
-            <a:off x="4892040" y="3877056"/>
-            <a:ext cx="2423160" cy="228600"/>
-          </a:xfrm>
-          <a:prstGeom prst="rect">
-            <a:avLst/>
-          </a:prstGeom>
-          <a:noFill/>
-        </p:spPr>
-        <p:txBody>
-          <a:bodyPr wrap="none" lIns="36576" rIns="36576" tIns="18288" bIns="18288">
-            <a:spAutoFit/>
-          </a:bodyPr>
-          <a:lstStyle/>
-          <a:p>
-            <a:pPr algn="ctr">
-              <a:defRPr sz="1250" b="1">
-                <a:solidFill>
-                  <a:srgbClr val="F8FAFC"/>
-                </a:solidFill>
-              </a:defRPr>
-            </a:pPr>
-            <a:r>
-              <a:t>Fairness at 32 KB</a:t>
-            </a:r>
-          </a:p>
-        </p:txBody>
-      </p:sp>
-      <p:sp>
-        <p:nvSpPr>
-          <p:cNvPr id="93" name="TextBox 92"/>
-          <p:cNvSpPr txBox="1"/>
-          <p:nvPr/>
-        </p:nvSpPr>
-        <p:spPr>
-          <a:xfrm>
-            <a:off x="4956048" y="4315968"/>
-            <a:ext cx="438912" cy="164592"/>
-          </a:xfrm>
-          <a:prstGeom prst="rect">
-            <a:avLst/>
-          </a:prstGeom>
-          <a:noFill/>
-        </p:spPr>
-        <p:txBody>
-          <a:bodyPr wrap="none" lIns="36576" rIns="36576" tIns="18288" bIns="18288">
-            <a:spAutoFit/>
-          </a:bodyPr>
-          <a:lstStyle/>
-          <a:p>
-            <a:pPr>
-              <a:defRPr sz="780" b="0">
+              <a:defRPr sz="819" b="0">
                 <a:solidFill>
                   <a:srgbClr val="CBD5E1"/>
                 </a:solidFill>
               </a:defRPr>
             </a:pPr>
             <a:r>
-              <a:t>cli1</a:t>
-            </a:r>
-          </a:p>
-        </p:txBody>
-      </p:sp>
-      <p:cxnSp>
-        <p:nvCxnSpPr>
-          <p:cNvPr id="94" name="Connector 93"/>
-          <p:cNvCxnSpPr/>
-          <p:nvPr/>
-        </p:nvCxnSpPr>
-        <p:spPr>
-          <a:xfrm>
-            <a:off x="5422392" y="4398264"/>
-            <a:ext cx="594360" cy="0"/>
-          </a:xfrm>
-          <a:prstGeom prst="line">
-            <a:avLst/>
-          </a:prstGeom>
-          <a:ln w="12700">
-            <a:solidFill>
-              <a:srgbClr val="38BDF8"/>
-            </a:solidFill>
-          </a:ln>
-        </p:spPr>
-        <p:style>
-          <a:lnRef idx="2">
-            <a:schemeClr val="accent1"/>
-          </a:lnRef>
-          <a:fillRef idx="0">
-            <a:schemeClr val="accent1"/>
-          </a:fillRef>
-          <a:effectRef idx="1">
-            <a:schemeClr val="accent1"/>
-          </a:effectRef>
-          <a:fontRef idx="minor">
-            <a:schemeClr val="tx1"/>
-          </a:fontRef>
-        </p:style>
-      </p:cxnSp>
-      <p:sp>
-        <p:nvSpPr>
-          <p:cNvPr id="95" name="TextBox 94"/>
-          <p:cNvSpPr txBox="1"/>
-          <p:nvPr/>
-        </p:nvSpPr>
-        <p:spPr>
-          <a:xfrm>
-            <a:off x="4956048" y="4626864"/>
-            <a:ext cx="438912" cy="164592"/>
-          </a:xfrm>
-          <a:prstGeom prst="rect">
-            <a:avLst/>
-          </a:prstGeom>
-          <a:noFill/>
-        </p:spPr>
-        <p:txBody>
-          <a:bodyPr wrap="none" lIns="36576" rIns="36576" tIns="18288" bIns="18288">
-            <a:spAutoFit/>
-          </a:bodyPr>
-          <a:lstStyle/>
-          <a:p>
-            <a:pPr>
-              <a:defRPr sz="780" b="0">
-                <a:solidFill>
-                  <a:srgbClr val="CBD5E1"/>
-                </a:solidFill>
-              </a:defRPr>
-            </a:pPr>
-            <a:r>
-              <a:t>cli2</a:t>
-            </a:r>
-          </a:p>
-        </p:txBody>
-      </p:sp>
-      <p:cxnSp>
-        <p:nvCxnSpPr>
-          <p:cNvPr id="96" name="Connector 95"/>
-          <p:cNvCxnSpPr/>
-          <p:nvPr/>
-        </p:nvCxnSpPr>
-        <p:spPr>
-          <a:xfrm>
-            <a:off x="5422392" y="4709160"/>
-            <a:ext cx="594360" cy="0"/>
-          </a:xfrm>
-          <a:prstGeom prst="line">
-            <a:avLst/>
-          </a:prstGeom>
-          <a:ln w="12700">
-            <a:solidFill>
-              <a:srgbClr val="38BDF8"/>
-            </a:solidFill>
-          </a:ln>
-        </p:spPr>
-        <p:style>
-          <a:lnRef idx="2">
-            <a:schemeClr val="accent1"/>
-          </a:lnRef>
-          <a:fillRef idx="0">
-            <a:schemeClr val="accent1"/>
-          </a:fillRef>
-          <a:effectRef idx="1">
-            <a:schemeClr val="accent1"/>
-          </a:effectRef>
-          <a:fontRef idx="minor">
-            <a:schemeClr val="tx1"/>
-          </a:fontRef>
-        </p:style>
-      </p:cxnSp>
-      <p:sp>
-        <p:nvSpPr>
-          <p:cNvPr id="97" name="TextBox 96"/>
-          <p:cNvSpPr txBox="1"/>
-          <p:nvPr/>
-        </p:nvSpPr>
-        <p:spPr>
-          <a:xfrm>
-            <a:off x="4956048" y="4937759"/>
-            <a:ext cx="438912" cy="164592"/>
-          </a:xfrm>
-          <a:prstGeom prst="rect">
-            <a:avLst/>
-          </a:prstGeom>
-          <a:noFill/>
-        </p:spPr>
-        <p:txBody>
-          <a:bodyPr wrap="none" lIns="36576" rIns="36576" tIns="18288" bIns="18288">
-            <a:spAutoFit/>
-          </a:bodyPr>
-          <a:lstStyle/>
-          <a:p>
-            <a:pPr>
-              <a:defRPr sz="780" b="0">
-                <a:solidFill>
-                  <a:srgbClr val="CBD5E1"/>
-                </a:solidFill>
-              </a:defRPr>
-            </a:pPr>
-            <a:r>
-              <a:t>cli3</a:t>
-            </a:r>
-          </a:p>
-        </p:txBody>
-      </p:sp>
-      <p:cxnSp>
-        <p:nvCxnSpPr>
-          <p:cNvPr id="98" name="Connector 97"/>
-          <p:cNvCxnSpPr/>
-          <p:nvPr/>
-        </p:nvCxnSpPr>
-        <p:spPr>
-          <a:xfrm>
-            <a:off x="5422392" y="5020055"/>
-            <a:ext cx="594360" cy="0"/>
-          </a:xfrm>
-          <a:prstGeom prst="line">
-            <a:avLst/>
-          </a:prstGeom>
-          <a:ln w="12700">
-            <a:solidFill>
-              <a:srgbClr val="38BDF8"/>
-            </a:solidFill>
-          </a:ln>
-        </p:spPr>
-        <p:style>
-          <a:lnRef idx="2">
-            <a:schemeClr val="accent1"/>
-          </a:lnRef>
-          <a:fillRef idx="0">
-            <a:schemeClr val="accent1"/>
-          </a:fillRef>
-          <a:effectRef idx="1">
-            <a:schemeClr val="accent1"/>
-          </a:effectRef>
-          <a:fontRef idx="minor">
-            <a:schemeClr val="tx1"/>
-          </a:fontRef>
-        </p:style>
-      </p:cxnSp>
-      <p:sp>
-        <p:nvSpPr>
-          <p:cNvPr id="99" name="TextBox 98"/>
-          <p:cNvSpPr txBox="1"/>
-          <p:nvPr/>
-        </p:nvSpPr>
-        <p:spPr>
-          <a:xfrm>
-            <a:off x="4956048" y="5248656"/>
-            <a:ext cx="438912" cy="164592"/>
-          </a:xfrm>
-          <a:prstGeom prst="rect">
-            <a:avLst/>
-          </a:prstGeom>
-          <a:noFill/>
-        </p:spPr>
-        <p:txBody>
-          <a:bodyPr wrap="none" lIns="36576" rIns="36576" tIns="18288" bIns="18288">
-            <a:spAutoFit/>
-          </a:bodyPr>
-          <a:lstStyle/>
-          <a:p>
-            <a:pPr>
-              <a:defRPr sz="780" b="0">
-                <a:solidFill>
-                  <a:srgbClr val="CBD5E1"/>
-                </a:solidFill>
-              </a:defRPr>
-            </a:pPr>
-            <a:r>
-              <a:t>cli4</a:t>
-            </a:r>
-          </a:p>
-        </p:txBody>
-      </p:sp>
-      <p:cxnSp>
-        <p:nvCxnSpPr>
-          <p:cNvPr id="100" name="Connector 99"/>
-          <p:cNvCxnSpPr/>
-          <p:nvPr/>
-        </p:nvCxnSpPr>
-        <p:spPr>
-          <a:xfrm>
-            <a:off x="5422392" y="5330952"/>
-            <a:ext cx="594360" cy="0"/>
-          </a:xfrm>
-          <a:prstGeom prst="line">
-            <a:avLst/>
-          </a:prstGeom>
-          <a:ln w="12700">
-            <a:solidFill>
-              <a:srgbClr val="38BDF8"/>
-            </a:solidFill>
-          </a:ln>
-        </p:spPr>
-        <p:style>
-          <a:lnRef idx="2">
-            <a:schemeClr val="accent1"/>
-          </a:lnRef>
-          <a:fillRef idx="0">
-            <a:schemeClr val="accent1"/>
-          </a:fillRef>
-          <a:effectRef idx="1">
-            <a:schemeClr val="accent1"/>
-          </a:effectRef>
-          <a:fontRef idx="minor">
-            <a:schemeClr val="tx1"/>
-          </a:fontRef>
-        </p:style>
-      </p:cxnSp>
-      <p:sp>
-        <p:nvSpPr>
-          <p:cNvPr id="101" name="Rounded Rectangle 100"/>
+              <a:t>Each client received 50 chunks; finish spread was 4.3% (116.8-121.8 ms).</a:t>
+            </a:r>
+          </a:p>
+        </p:txBody>
+      </p:sp>
+      <p:sp>
+        <p:nvSpPr>
+          <p:cNvPr id="114" name="Rounded Rectangle 113"/>
           <p:cNvSpPr/>
           <p:nvPr/>
         </p:nvSpPr>
         <p:spPr>
           <a:xfrm>
-            <a:off x="6080760" y="4370832"/>
-            <a:ext cx="658368" cy="658368"/>
-          </a:xfrm>
-          <a:prstGeom prst="roundRect">
-            <a:avLst/>
-          </a:prstGeom>
-          <a:solidFill>
-            <a:srgbClr val="172033"/>
-          </a:solidFill>
-          <a:ln>
-            <a:solidFill>
-              <a:srgbClr val="FACC15"/>
-            </a:solidFill>
-          </a:ln>
-        </p:spPr>
-        <p:style>
-          <a:lnRef idx="1">
-            <a:schemeClr val="accent1"/>
-          </a:lnRef>
-          <a:fillRef idx="3">
-            <a:schemeClr val="accent1"/>
-          </a:fillRef>
-          <a:effectRef idx="2">
-            <a:schemeClr val="accent1"/>
-          </a:effectRef>
-          <a:fontRef idx="minor">
-            <a:schemeClr val="lt1"/>
-          </a:fontRef>
-        </p:style>
-        <p:txBody>
-          <a:bodyPr rtlCol="0" anchor="ctr"/>
-          <a:lstStyle/>
-          <a:p>
-            <a:pPr algn="ctr"/>
-          </a:p>
-        </p:txBody>
-      </p:sp>
-      <p:sp>
-        <p:nvSpPr>
-          <p:cNvPr id="102" name="TextBox 101"/>
-          <p:cNvSpPr txBox="1"/>
-          <p:nvPr/>
-        </p:nvSpPr>
-        <p:spPr>
-          <a:xfrm>
-            <a:off x="6144768" y="4553712"/>
-            <a:ext cx="530352" cy="201168"/>
-          </a:xfrm>
-          <a:prstGeom prst="rect">
-            <a:avLst/>
-          </a:prstGeom>
-          <a:noFill/>
-        </p:spPr>
-        <p:txBody>
-          <a:bodyPr wrap="none" lIns="36576" rIns="36576" tIns="18288" bIns="18288">
-            <a:spAutoFit/>
-          </a:bodyPr>
-          <a:lstStyle/>
-          <a:p>
-            <a:pPr algn="ctr">
-              <a:defRPr sz="800" b="1">
-                <a:solidFill>
-                  <a:srgbClr val="FACC15"/>
-                </a:solidFill>
-              </a:defRPr>
-            </a:pPr>
-            <a:r>
-              <a:t>A queue</a:t>
-            </a:r>
-          </a:p>
-        </p:txBody>
-      </p:sp>
-      <p:sp>
-        <p:nvSpPr>
-          <p:cNvPr id="103" name="TextBox 102"/>
-          <p:cNvSpPr txBox="1"/>
-          <p:nvPr/>
-        </p:nvSpPr>
-        <p:spPr>
-          <a:xfrm>
-            <a:off x="4983480" y="5349240"/>
-            <a:ext cx="2148840" cy="411480"/>
-          </a:xfrm>
-          <a:prstGeom prst="rect">
-            <a:avLst/>
-          </a:prstGeom>
-          <a:noFill/>
-        </p:spPr>
-        <p:txBody>
-          <a:bodyPr wrap="none" lIns="36576" rIns="36576" tIns="18288" bIns="18288">
-            <a:spAutoFit/>
-          </a:bodyPr>
-          <a:lstStyle/>
-          <a:p>
-            <a:pPr algn="ctr">
-              <a:defRPr sz="900" b="0">
-                <a:solidFill>
-                  <a:srgbClr val="CBD5E1"/>
-                </a:solidFill>
-              </a:defRPr>
-            </a:pPr>
-            <a:r>
-              <a:t>each client: 50 chunks</a:t>
-            </a:r>
-            <a:br/>
-            <a:r>
-              <a:t>116.8-121.8 ms, 4.3% spread</a:t>
-            </a:r>
-          </a:p>
-        </p:txBody>
-      </p:sp>
-      <p:sp>
-        <p:nvSpPr>
-          <p:cNvPr id="104" name="Rounded Rectangle 103"/>
-          <p:cNvSpPr/>
-          <p:nvPr/>
-        </p:nvSpPr>
-        <p:spPr>
-          <a:xfrm>
-            <a:off x="7726679" y="3749039"/>
-            <a:ext cx="4133087" cy="2331720"/>
+            <a:off x="7726679" y="4315968"/>
+            <a:ext cx="4206240" cy="1975104"/>
           </a:xfrm>
           <a:prstGeom prst="roundRect">
             <a:avLst/>
@@ -7306,14 +8147,14 @@
       </p:sp>
       <p:sp>
         <p:nvSpPr>
-          <p:cNvPr id="105" name="TextBox 104"/>
+          <p:cNvPr id="115" name="TextBox 114"/>
           <p:cNvSpPr txBox="1"/>
           <p:nvPr/>
         </p:nvSpPr>
         <p:spPr>
           <a:xfrm>
-            <a:off x="7973568" y="3858768"/>
-            <a:ext cx="1143000" cy="457200"/>
+            <a:off x="7973568" y="4434840"/>
+            <a:ext cx="1051560" cy="384048"/>
           </a:xfrm>
           <a:prstGeom prst="rect">
             <a:avLst/>
@@ -7327,7 +8168,7 @@
           <a:lstStyle/>
           <a:p>
             <a:pPr>
-              <a:defRPr sz="3200" b="1">
+              <a:defRPr sz="3000" b="1">
                 <a:solidFill>
                   <a:srgbClr val="FACC15"/>
                 </a:solidFill>
@@ -7341,14 +8182,14 @@
       </p:sp>
       <p:sp>
         <p:nvSpPr>
-          <p:cNvPr id="106" name="TextBox 105"/>
+          <p:cNvPr id="116" name="TextBox 115"/>
           <p:cNvSpPr txBox="1"/>
           <p:nvPr/>
         </p:nvSpPr>
         <p:spPr>
           <a:xfrm>
-            <a:off x="9070848" y="3950208"/>
-            <a:ext cx="2331720" cy="320040"/>
+            <a:off x="9006840" y="4535424"/>
+            <a:ext cx="2423160" cy="256032"/>
           </a:xfrm>
           <a:prstGeom prst="rect">
             <a:avLst/>
@@ -7362,7 +8203,7 @@
           <a:lstStyle/>
           <a:p>
             <a:pPr>
-              <a:defRPr sz="1800" b="1">
+              <a:defRPr sz="1700" b="1">
                 <a:solidFill>
                   <a:srgbClr val="38BDF8"/>
                 </a:solidFill>
@@ -7376,14 +8217,14 @@
       </p:sp>
       <p:sp>
         <p:nvSpPr>
-          <p:cNvPr id="107" name="TextBox 106"/>
+          <p:cNvPr id="117" name="TextBox 116"/>
           <p:cNvSpPr txBox="1"/>
           <p:nvPr/>
         </p:nvSpPr>
         <p:spPr>
           <a:xfrm>
-            <a:off x="7973568" y="4462272"/>
-            <a:ext cx="3474720" cy="256032"/>
+            <a:off x="7973568" y="4892040"/>
+            <a:ext cx="3474720" cy="182880"/>
           </a:xfrm>
           <a:prstGeom prst="rect">
             <a:avLst/>
@@ -7397,7 +8238,7 @@
           <a:lstStyle/>
           <a:p>
             <a:pPr>
-              <a:defRPr sz="900" b="0">
+              <a:defRPr sz="869" b="0">
                 <a:solidFill>
                   <a:srgbClr val="94A3B8"/>
                 </a:solidFill>
@@ -7411,14 +8252,14 @@
       </p:sp>
       <p:sp>
         <p:nvSpPr>
-          <p:cNvPr id="108" name="Rounded Rectangle 107"/>
+          <p:cNvPr id="118" name="Rounded Rectangle 117"/>
           <p:cNvSpPr/>
           <p:nvPr/>
         </p:nvSpPr>
         <p:spPr>
           <a:xfrm>
-            <a:off x="8001000" y="4864608"/>
-            <a:ext cx="1444752" cy="658368"/>
+            <a:off x="8010144" y="5230368"/>
+            <a:ext cx="1463040" cy="566928"/>
           </a:xfrm>
           <a:prstGeom prst="roundRect">
             <a:avLst/>
@@ -7456,14 +8297,14 @@
       </p:sp>
       <p:sp>
         <p:nvSpPr>
-          <p:cNvPr id="109" name="Rounded Rectangle 108"/>
+          <p:cNvPr id="119" name="Rounded Rectangle 118"/>
           <p:cNvSpPr/>
           <p:nvPr/>
         </p:nvSpPr>
         <p:spPr>
           <a:xfrm>
-            <a:off x="9646920" y="4864608"/>
-            <a:ext cx="1444752" cy="658368"/>
+            <a:off x="9710928" y="5230368"/>
+            <a:ext cx="1463040" cy="566928"/>
           </a:xfrm>
           <a:prstGeom prst="roundRect">
             <a:avLst/>
@@ -7501,14 +8342,14 @@
       </p:sp>
       <p:sp>
         <p:nvSpPr>
-          <p:cNvPr id="110" name="TextBox 109"/>
+          <p:cNvPr id="120" name="TextBox 119"/>
           <p:cNvSpPr txBox="1"/>
           <p:nvPr/>
         </p:nvSpPr>
         <p:spPr>
           <a:xfrm>
-            <a:off x="8101583" y="4983480"/>
-            <a:ext cx="1234440" cy="164592"/>
+            <a:off x="8119872" y="5340096"/>
+            <a:ext cx="1243584" cy="146304"/>
           </a:xfrm>
           <a:prstGeom prst="rect">
             <a:avLst/>
@@ -7522,7 +8363,7 @@
           <a:lstStyle/>
           <a:p>
             <a:pPr algn="ctr">
-              <a:defRPr sz="1100" b="1">
+              <a:defRPr sz="1050" b="1">
                 <a:solidFill>
                   <a:srgbClr val="38BDF8"/>
                 </a:solidFill>
@@ -7536,14 +8377,14 @@
       </p:sp>
       <p:sp>
         <p:nvSpPr>
-          <p:cNvPr id="111" name="TextBox 110"/>
+          <p:cNvPr id="121" name="TextBox 120"/>
           <p:cNvSpPr txBox="1"/>
           <p:nvPr/>
         </p:nvSpPr>
         <p:spPr>
           <a:xfrm>
-            <a:off x="8101583" y="5193792"/>
-            <a:ext cx="1234440" cy="164592"/>
+            <a:off x="8119872" y="5532120"/>
+            <a:ext cx="1243584" cy="146304"/>
           </a:xfrm>
           <a:prstGeom prst="rect">
             <a:avLst/>
@@ -7557,7 +8398,7 @@
           <a:lstStyle/>
           <a:p>
             <a:pPr algn="ctr">
-              <a:defRPr sz="780" b="0">
+              <a:defRPr sz="740" b="0">
                 <a:solidFill>
                   <a:srgbClr val="DBEAFE"/>
                 </a:solidFill>
@@ -7571,14 +8412,14 @@
       </p:sp>
       <p:sp>
         <p:nvSpPr>
-          <p:cNvPr id="112" name="TextBox 111"/>
+          <p:cNvPr id="122" name="TextBox 121"/>
           <p:cNvSpPr txBox="1"/>
           <p:nvPr/>
         </p:nvSpPr>
         <p:spPr>
           <a:xfrm>
-            <a:off x="9747504" y="4983480"/>
-            <a:ext cx="1234440" cy="164592"/>
+            <a:off x="9820656" y="5340096"/>
+            <a:ext cx="1243584" cy="146304"/>
           </a:xfrm>
           <a:prstGeom prst="rect">
             <a:avLst/>
@@ -7592,7 +8433,7 @@
           <a:lstStyle/>
           <a:p>
             <a:pPr algn="ctr">
-              <a:defRPr sz="1100" b="1">
+              <a:defRPr sz="1050" b="1">
                 <a:solidFill>
                   <a:srgbClr val="A78BFA"/>
                 </a:solidFill>
@@ -7606,14 +8447,14 @@
       </p:sp>
       <p:sp>
         <p:nvSpPr>
-          <p:cNvPr id="113" name="TextBox 112"/>
+          <p:cNvPr id="123" name="TextBox 122"/>
           <p:cNvSpPr txBox="1"/>
           <p:nvPr/>
         </p:nvSpPr>
         <p:spPr>
           <a:xfrm>
-            <a:off x="9747504" y="5193792"/>
-            <a:ext cx="1234440" cy="164592"/>
+            <a:off x="9820656" y="5532120"/>
+            <a:ext cx="1243584" cy="146304"/>
           </a:xfrm>
           <a:prstGeom prst="rect">
             <a:avLst/>
@@ -7627,7 +8468,7 @@
           <a:lstStyle/>
           <a:p>
             <a:pPr algn="ctr">
-              <a:defRPr sz="780" b="0">
+              <a:defRPr sz="740" b="0">
                 <a:solidFill>
                   <a:srgbClr val="EDE9FE"/>
                 </a:solidFill>
@@ -7641,14 +8482,14 @@
       </p:sp>
       <p:sp>
         <p:nvSpPr>
-          <p:cNvPr id="114" name="TextBox 113"/>
+          <p:cNvPr id="124" name="TextBox 123"/>
           <p:cNvSpPr txBox="1"/>
           <p:nvPr/>
         </p:nvSpPr>
         <p:spPr>
           <a:xfrm>
-            <a:off x="8065008" y="5687568"/>
-            <a:ext cx="3429000" cy="201168"/>
+            <a:off x="8065008" y="5943600"/>
+            <a:ext cx="3429000" cy="164592"/>
           </a:xfrm>
           <a:prstGeom prst="rect">
             <a:avLst/>
@@ -7662,28 +8503,28 @@
           <a:lstStyle/>
           <a:p>
             <a:pPr algn="ctr">
-              <a:defRPr sz="880" b="1">
+              <a:defRPr sz="840" b="1">
                 <a:solidFill>
                   <a:srgbClr val="FACC15"/>
                 </a:solidFill>
               </a:defRPr>
             </a:pPr>
             <a:r>
-              <a:t>Why same? At 32 KB, most page-count cost is already gone.</a:t>
-            </a:r>
-          </a:p>
-        </p:txBody>
-      </p:sp>
-      <p:sp>
-        <p:nvSpPr>
-          <p:cNvPr id="115" name="TextBox 114"/>
+              <a:t>At 32 KB, page-count cost is mostly amortized.</a:t>
+            </a:r>
+          </a:p>
+        </p:txBody>
+      </p:sp>
+      <p:sp>
+        <p:nvSpPr>
+          <p:cNvPr id="125" name="TextBox 124"/>
           <p:cNvSpPr txBox="1"/>
           <p:nvPr/>
         </p:nvSpPr>
         <p:spPr>
           <a:xfrm>
-            <a:off x="411480" y="6272784"/>
-            <a:ext cx="11384280" cy="256032"/>
+            <a:off x="411480" y="6437376"/>
+            <a:ext cx="11384280" cy="201168"/>
           </a:xfrm>
           <a:prstGeom prst="rect">
             <a:avLst/>
@@ -7697,14 +8538,14 @@
           <a:lstStyle/>
           <a:p>
             <a:pPr algn="ctr">
-              <a:defRPr sz="1200" b="1">
+              <a:defRPr sz="1070" b="1">
                 <a:solidFill>
                   <a:srgbClr val="E2E8F0"/>
                 </a:solidFill>
               </a:defRPr>
             </a:pPr>
             <a:r>
-              <a:t>Takeaway: first page gathers/cache-builds once; chunk size mainly controls how many later client-to-A page costs are repeated.</a:t>
+              <a:t>Takeaway: first page gathers/cache-builds once; chunk size controls how many later client-to-A page costs are repeated.</a:t>
             </a:r>
           </a:p>
         </p:txBody>
@@ -8035,4 +8876,324 @@
   </a:objectDefaults>
   <a:extraClrSchemeLst/>
 </a:theme>
+</file>
+
+<file path=ppt/theme/theme2.xml><?xml version="1.0" encoding="utf-8"?>
+<a:theme xmlns:a="http://schemas.openxmlformats.org/drawingml/2006/main" name="Office Theme">
+  <a:themeElements>
+    <a:clrScheme name="Office">
+      <a:dk1>
+        <a:sysClr val="windowText" lastClr="000000"/>
+      </a:dk1>
+      <a:lt1>
+        <a:sysClr val="window" lastClr="FFFFFF"/>
+      </a:lt1>
+      <a:dk2>
+        <a:srgbClr val="1F497D"/>
+      </a:dk2>
+      <a:lt2>
+        <a:srgbClr val="EEECE1"/>
+      </a:lt2>
+      <a:accent1>
+        <a:srgbClr val="4F81BD"/>
+      </a:accent1>
+      <a:accent2>
+        <a:srgbClr val="C0504D"/>
+      </a:accent2>
+      <a:accent3>
+        <a:srgbClr val="9BBB59"/>
+      </a:accent3>
+      <a:accent4>
+        <a:srgbClr val="8064A2"/>
+      </a:accent4>
+      <a:accent5>
+        <a:srgbClr val="4BACC6"/>
+      </a:accent5>
+      <a:accent6>
+        <a:srgbClr val="F79646"/>
+      </a:accent6>
+      <a:hlink>
+        <a:srgbClr val="0000FF"/>
+      </a:hlink>
+      <a:folHlink>
+        <a:srgbClr val="800080"/>
+      </a:folHlink>
+    </a:clrScheme>
+    <a:fontScheme name="Office">
+      <a:majorFont>
+        <a:latin typeface="Calibri"/>
+        <a:ea typeface=""/>
+        <a:cs typeface=""/>
+        <a:font script="Jpan" typeface="ＭＳ Ｐゴシック"/>
+        <a:font script="Hang" typeface="맑은 고딕"/>
+        <a:font script="Hans" typeface="宋体"/>
+        <a:font script="Hant" typeface="新細明體"/>
+        <a:font script="Arab" typeface="Times New Roman"/>
+        <a:font script="Hebr" typeface="Times New Roman"/>
+        <a:font script="Thai" typeface="Angsana New"/>
+        <a:font script="Ethi" typeface="Nyala"/>
+        <a:font script="Beng" typeface="Vrinda"/>
+        <a:font script="Gujr" typeface="Shruti"/>
+        <a:font script="Khmr" typeface="MoolBoran"/>
+        <a:font script="Knda" typeface="Tunga"/>
+        <a:font script="Guru" typeface="Raavi"/>
+        <a:font script="Cans" typeface="Euphemia"/>
+        <a:font script="Cher" typeface="Plantagenet Cherokee"/>
+        <a:font script="Yiii" typeface="Microsoft Yi Baiti"/>
+        <a:font script="Tibt" typeface="Microsoft Himalaya"/>
+        <a:font script="Thaa" typeface="MV Boli"/>
+        <a:font script="Deva" typeface="Mangal"/>
+        <a:font script="Telu" typeface="Gautami"/>
+        <a:font script="Taml" typeface="Latha"/>
+        <a:font script="Syrc" typeface="Estrangelo Edessa"/>
+        <a:font script="Orya" typeface="Kalinga"/>
+        <a:font script="Mlym" typeface="Kartika"/>
+        <a:font script="Laoo" typeface="DokChampa"/>
+        <a:font script="Sinh" typeface="Iskoola Pota"/>
+        <a:font script="Mong" typeface="Mongolian Baiti"/>
+        <a:font script="Viet" typeface="Times New Roman"/>
+        <a:font script="Uigh" typeface="Microsoft Uighur"/>
+        <a:font script="Geor" typeface="Sylfaen"/>
+      </a:majorFont>
+      <a:minorFont>
+        <a:latin typeface="Calibri"/>
+        <a:ea typeface=""/>
+        <a:cs typeface=""/>
+        <a:font script="Jpan" typeface="ＭＳ Ｐゴシック"/>
+        <a:font script="Hang" typeface="맑은 고딕"/>
+        <a:font script="Hans" typeface="宋体"/>
+        <a:font script="Hant" typeface="新細明體"/>
+        <a:font script="Arab" typeface="Arial"/>
+        <a:font script="Hebr" typeface="Arial"/>
+        <a:font script="Thai" typeface="Cordia New"/>
+        <a:font script="Ethi" typeface="Nyala"/>
+        <a:font script="Beng" typeface="Vrinda"/>
+        <a:font script="Gujr" typeface="Shruti"/>
+        <a:font script="Khmr" typeface="DaunPenh"/>
+        <a:font script="Knda" typeface="Tunga"/>
+        <a:font script="Guru" typeface="Raavi"/>
+        <a:font script="Cans" typeface="Euphemia"/>
+        <a:font script="Cher" typeface="Plantagenet Cherokee"/>
+        <a:font script="Yiii" typeface="Microsoft Yi Baiti"/>
+        <a:font script="Tibt" typeface="Microsoft Himalaya"/>
+        <a:font script="Thaa" typeface="MV Boli"/>
+        <a:font script="Deva" typeface="Mangal"/>
+        <a:font script="Telu" typeface="Gautami"/>
+        <a:font script="Taml" typeface="Latha"/>
+        <a:font script="Syrc" typeface="Estrangelo Edessa"/>
+        <a:font script="Orya" typeface="Kalinga"/>
+        <a:font script="Mlym" typeface="Kartika"/>
+        <a:font script="Laoo" typeface="DokChampa"/>
+        <a:font script="Sinh" typeface="Iskoola Pota"/>
+        <a:font script="Mong" typeface="Mongolian Baiti"/>
+        <a:font script="Viet" typeface="Arial"/>
+        <a:font script="Uigh" typeface="Microsoft Uighur"/>
+        <a:font script="Geor" typeface="Sylfaen"/>
+      </a:minorFont>
+    </a:fontScheme>
+    <a:fmtScheme name="Office">
+      <a:fillStyleLst>
+        <a:solidFill>
+          <a:schemeClr val="phClr"/>
+        </a:solidFill>
+        <a:gradFill rotWithShape="1">
+          <a:gsLst>
+            <a:gs pos="0">
+              <a:schemeClr val="phClr">
+                <a:tint val="50000"/>
+                <a:satMod val="300000"/>
+              </a:schemeClr>
+            </a:gs>
+            <a:gs pos="35000">
+              <a:schemeClr val="phClr">
+                <a:tint val="37000"/>
+                <a:satMod val="300000"/>
+              </a:schemeClr>
+            </a:gs>
+            <a:gs pos="100000">
+              <a:schemeClr val="phClr">
+                <a:tint val="15000"/>
+                <a:satMod val="350000"/>
+              </a:schemeClr>
+            </a:gs>
+          </a:gsLst>
+          <a:lin ang="16200000" scaled="1"/>
+        </a:gradFill>
+        <a:gradFill rotWithShape="1">
+          <a:gsLst>
+            <a:gs pos="0">
+              <a:schemeClr val="phClr">
+                <a:tint val="100000"/>
+                <a:shade val="100000"/>
+                <a:satMod val="130000"/>
+              </a:schemeClr>
+            </a:gs>
+            <a:gs pos="100000">
+              <a:schemeClr val="phClr">
+                <a:tint val="50000"/>
+                <a:shade val="100000"/>
+                <a:satMod val="350000"/>
+              </a:schemeClr>
+            </a:gs>
+          </a:gsLst>
+          <a:lin ang="16200000" scaled="0"/>
+        </a:gradFill>
+      </a:fillStyleLst>
+      <a:lnStyleLst>
+        <a:ln w="9525" cap="flat" cmpd="sng" algn="ctr">
+          <a:solidFill>
+            <a:schemeClr val="phClr">
+              <a:shade val="95000"/>
+              <a:satMod val="105000"/>
+            </a:schemeClr>
+          </a:solidFill>
+          <a:prstDash val="solid"/>
+        </a:ln>
+        <a:ln w="25400" cap="flat" cmpd="sng" algn="ctr">
+          <a:solidFill>
+            <a:schemeClr val="phClr"/>
+          </a:solidFill>
+          <a:prstDash val="solid"/>
+        </a:ln>
+        <a:ln w="38100" cap="flat" cmpd="sng" algn="ctr">
+          <a:solidFill>
+            <a:schemeClr val="phClr"/>
+          </a:solidFill>
+          <a:prstDash val="solid"/>
+        </a:ln>
+      </a:lnStyleLst>
+      <a:effectStyleLst>
+        <a:effectStyle>
+          <a:effectLst>
+            <a:outerShdw blurRad="40000" dist="20000" dir="5400000" rotWithShape="0">
+              <a:srgbClr val="000000">
+                <a:alpha val="38000"/>
+              </a:srgbClr>
+            </a:outerShdw>
+          </a:effectLst>
+        </a:effectStyle>
+        <a:effectStyle>
+          <a:effectLst>
+            <a:outerShdw blurRad="40000" dist="23000" dir="5400000" rotWithShape="0">
+              <a:srgbClr val="000000">
+                <a:alpha val="35000"/>
+              </a:srgbClr>
+            </a:outerShdw>
+          </a:effectLst>
+        </a:effectStyle>
+        <a:effectStyle>
+          <a:effectLst>
+            <a:outerShdw blurRad="40000" dist="23000" dir="5400000" rotWithShape="0">
+              <a:srgbClr val="000000">
+                <a:alpha val="35000"/>
+              </a:srgbClr>
+            </a:outerShdw>
+          </a:effectLst>
+          <a:scene3d>
+            <a:camera prst="orthographicFront">
+              <a:rot lat="0" lon="0" rev="0"/>
+            </a:camera>
+            <a:lightRig rig="threePt" dir="t">
+              <a:rot lat="0" lon="0" rev="1200000"/>
+            </a:lightRig>
+          </a:scene3d>
+          <a:sp3d>
+            <a:bevelT w="63500" h="25400"/>
+          </a:sp3d>
+        </a:effectStyle>
+      </a:effectStyleLst>
+      <a:bgFillStyleLst>
+        <a:solidFill>
+          <a:schemeClr val="phClr"/>
+        </a:solidFill>
+        <a:gradFill rotWithShape="1">
+          <a:gsLst>
+            <a:gs pos="0">
+              <a:schemeClr val="phClr">
+                <a:tint val="40000"/>
+                <a:satMod val="350000"/>
+              </a:schemeClr>
+            </a:gs>
+            <a:gs pos="40000">
+              <a:schemeClr val="phClr">
+                <a:tint val="45000"/>
+                <a:shade val="99000"/>
+                <a:satMod val="350000"/>
+              </a:schemeClr>
+            </a:gs>
+            <a:gs pos="100000">
+              <a:schemeClr val="phClr">
+                <a:shade val="20000"/>
+                <a:satMod val="255000"/>
+              </a:schemeClr>
+            </a:gs>
+          </a:gsLst>
+          <a:path path="circle">
+            <a:fillToRect l="50000" t="-80000" r="50000" b="180000"/>
+          </a:path>
+        </a:gradFill>
+        <a:gradFill rotWithShape="1">
+          <a:gsLst>
+            <a:gs pos="0">
+              <a:schemeClr val="phClr">
+                <a:tint val="80000"/>
+                <a:satMod val="300000"/>
+              </a:schemeClr>
+            </a:gs>
+            <a:gs pos="100000">
+              <a:schemeClr val="phClr">
+                <a:shade val="30000"/>
+                <a:satMod val="200000"/>
+              </a:schemeClr>
+            </a:gs>
+          </a:gsLst>
+          <a:path path="circle">
+            <a:fillToRect l="50000" t="50000" r="50000" b="50000"/>
+          </a:path>
+        </a:gradFill>
+      </a:bgFillStyleLst>
+    </a:fmtScheme>
+  </a:themeElements>
+  <a:objectDefaults>
+    <a:spDef>
+      <a:spPr/>
+      <a:bodyPr/>
+      <a:lstStyle/>
+      <a:style>
+        <a:lnRef idx="1">
+          <a:schemeClr val="accent1"/>
+        </a:lnRef>
+        <a:fillRef idx="3">
+          <a:schemeClr val="accent1"/>
+        </a:fillRef>
+        <a:effectRef idx="2">
+          <a:schemeClr val="accent1"/>
+        </a:effectRef>
+        <a:fontRef idx="minor">
+          <a:schemeClr val="lt1"/>
+        </a:fontRef>
+      </a:style>
+    </a:spDef>
+    <a:lnDef>
+      <a:spPr/>
+      <a:bodyPr/>
+      <a:lstStyle/>
+      <a:style>
+        <a:lnRef idx="2">
+          <a:schemeClr val="accent1"/>
+        </a:lnRef>
+        <a:fillRef idx="0">
+          <a:schemeClr val="accent1"/>
+        </a:fillRef>
+        <a:effectRef idx="1">
+          <a:schemeClr val="accent1"/>
+        </a:effectRef>
+        <a:fontRef idx="minor">
+          <a:schemeClr val="tx1"/>
+        </a:fontRef>
+      </a:style>
+    </a:lnDef>
+  </a:objectDefaults>
+  <a:extraClrSchemeLst/>
+</a:theme>
 </file>
</xml_diff>

<commit_message>
Replace report and poster with revised versions
</commit_message>
<xml_diff>
--- a/mini2-poster.pptx
+++ b/mini2-poster.pptx
@@ -4,10 +4,13 @@
   <p:sldMasterIdLst>
     <p:sldMasterId id="2147483648" r:id="rId1"/>
   </p:sldMasterIdLst>
+  <p:notesMasterIdLst>
+    <p:notesMasterId r:id="rId3"/>
+  </p:notesMasterIdLst>
   <p:sldIdLst>
-    <p:sldId id="256" r:id="rId7"/>
+    <p:sldId id="256" r:id="rId2"/>
   </p:sldIdLst>
-  <p:sldSz cx="12191695" cy="6858000" type="screen4x3"/>
+  <p:sldSz cx="12192000" cy="6858000"/>
   <p:notesSz cx="6858000" cy="9144000"/>
   <p:defaultTextStyle>
     <a:defPPr>
@@ -104,11 +107,27 @@
       </a:defRPr>
     </a:lvl9pPr>
   </p:defaultTextStyle>
+  <p:extLst>
+    <p:ext uri="{EFAFB233-063F-42B5-8137-9DF3F51BA10A}">
+      <p15:sldGuideLst xmlns:p15="http://schemas.microsoft.com/office/powerpoint/2012/main">
+        <p15:guide id="1" orient="horz" pos="2160">
+          <p15:clr>
+            <a:srgbClr val="A4A3A4"/>
+          </p15:clr>
+        </p15:guide>
+        <p15:guide id="2" pos="2880">
+          <p15:clr>
+            <a:srgbClr val="A4A3A4"/>
+          </p15:clr>
+        </p15:guide>
+      </p15:sldGuideLst>
+    </p:ext>
+  </p:extLst>
 </p:presentation>
 </file>
 
 <file path=ppt/notesMasters/notesMaster1.xml><?xml version="1.0" encoding="utf-8"?>
-<p:notesMaster xmlns:a="http://schemas.openxmlformats.org/drawingml/2006/main" xmlns:p="http://schemas.openxmlformats.org/presentationml/2006/main" xmlns:r="http://schemas.openxmlformats.org/officeDocument/2006/relationships">
+<p:notesMaster xmlns:a="http://schemas.openxmlformats.org/drawingml/2006/main" xmlns:r="http://schemas.openxmlformats.org/officeDocument/2006/relationships" xmlns:p="http://schemas.openxmlformats.org/presentationml/2006/main">
   <p:cSld>
     <p:bg>
       <p:bgRef idx="1001">
@@ -129,241 +148,16 @@
           <a:chExt cx="0" cy="0"/>
         </a:xfrm>
       </p:grpSpPr>
-      <p:sp>
-        <p:nvSpPr>
-          <p:cNvPr id="2" name="Header Placeholder 1"/>
-          <p:cNvSpPr>
-            <a:spLocks noGrp="1"/>
-          </p:cNvSpPr>
-          <p:nvPr>
-            <p:ph type="hdr" sz="quarter"/>
-          </p:nvPr>
-        </p:nvSpPr>
-        <p:spPr>
-          <a:xfrm>
-            <a:off x="0" y="0"/>
-            <a:ext cx="2971800" cy="457200"/>
-          </a:xfrm>
-          <a:prstGeom prst="rect">
-            <a:avLst/>
-          </a:prstGeom>
-        </p:spPr>
-        <p:txBody>
-          <a:bodyPr vert="horz" lIns="91440" tIns="45720" rIns="91440" bIns="45720" rtlCol="0"/>
-          <a:lstStyle>
-            <a:lvl1pPr algn="l">
-              <a:defRPr sz="1200"/>
-            </a:lvl1pPr>
-          </a:lstStyle>
-          <a:p>
-            <a:endParaRPr lang="en-US"/>
-          </a:p>
-        </p:txBody>
-      </p:sp>
-      <p:sp>
-        <p:nvSpPr>
-          <p:cNvPr id="3" name="Date Placeholder 2"/>
-          <p:cNvSpPr>
-            <a:spLocks noGrp="1"/>
-          </p:cNvSpPr>
-          <p:nvPr>
-            <p:ph type="dt" idx="1"/>
-          </p:nvPr>
-        </p:nvSpPr>
-        <p:spPr>
-          <a:xfrm>
-            <a:off x="3884613" y="0"/>
-            <a:ext cx="2971800" cy="457200"/>
-          </a:xfrm>
-          <a:prstGeom prst="rect">
-            <a:avLst/>
-          </a:prstGeom>
-        </p:spPr>
-        <p:txBody>
-          <a:bodyPr vert="horz" lIns="91440" tIns="45720" rIns="91440" bIns="45720" rtlCol="0"/>
-          <a:lstStyle>
-            <a:lvl1pPr algn="r">
-              <a:defRPr sz="1200"/>
-            </a:lvl1pPr>
-          </a:lstStyle>
-          <a:p>
-            <a:fld id="{0F89C1C7-3DCD-1040-A9CF-14679D8B5DDD}" type="datetimeFigureOut">
-              <a:rPr lang="en-US" smtClean="0"/>
-              <a:t>10/17/16</a:t>
-            </a:fld>
-            <a:endParaRPr lang="en-US"/>
-          </a:p>
-        </p:txBody>
-      </p:sp>
-      <p:sp>
-        <p:nvSpPr>
-          <p:cNvPr id="4" name="Slide Image Placeholder 3"/>
-          <p:cNvSpPr>
-            <a:spLocks noGrp="1" noRot="1" noChangeAspect="1"/>
-          </p:cNvSpPr>
-          <p:nvPr>
-            <p:ph type="sldImg" idx="2"/>
-          </p:nvPr>
-        </p:nvSpPr>
-        <p:spPr>
-          <a:xfrm>
-            <a:off x="1143000" y="685800"/>
-            <a:ext cx="4572000" cy="3429000"/>
-          </a:xfrm>
-          <a:prstGeom prst="rect">
-            <a:avLst/>
-          </a:prstGeom>
-          <a:noFill/>
-          <a:ln w="12700">
-            <a:solidFill>
-              <a:prstClr val="black"/>
-            </a:solidFill>
-          </a:ln>
-        </p:spPr>
-        <p:txBody>
-          <a:bodyPr vert="horz" lIns="91440" tIns="45720" rIns="91440" bIns="45720" rtlCol="0" anchor="ctr"/>
-          <a:lstStyle/>
-          <a:p>
-            <a:endParaRPr lang="en-US"/>
-          </a:p>
-        </p:txBody>
-      </p:sp>
-      <p:sp>
-        <p:nvSpPr>
-          <p:cNvPr id="5" name="Notes Placeholder 4"/>
-          <p:cNvSpPr>
-            <a:spLocks noGrp="1"/>
-          </p:cNvSpPr>
-          <p:nvPr>
-            <p:ph type="body" sz="quarter" idx="3"/>
-          </p:nvPr>
-        </p:nvSpPr>
-        <p:spPr>
-          <a:xfrm>
-            <a:off x="685800" y="4343400"/>
-            <a:ext cx="5486400" cy="4114800"/>
-          </a:xfrm>
-          <a:prstGeom prst="rect">
-            <a:avLst/>
-          </a:prstGeom>
-        </p:spPr>
-        <p:txBody>
-          <a:bodyPr vert="horz" lIns="91440" tIns="45720" rIns="91440" bIns="45720" rtlCol="0"/>
-          <a:lstStyle/>
-          <a:p>
-            <a:pPr lvl="0"/>
-            <a:r>
-              <a:rPr lang="en-US" smtClean="0"/>
-              <a:t>Click to edit Master text styles</a:t>
-            </a:r>
-          </a:p>
-          <a:p>
-            <a:pPr lvl="1"/>
-            <a:r>
-              <a:rPr lang="en-US" smtClean="0"/>
-              <a:t>Second level</a:t>
-            </a:r>
-          </a:p>
-          <a:p>
-            <a:pPr lvl="2"/>
-            <a:r>
-              <a:rPr lang="en-US" smtClean="0"/>
-              <a:t>Third level</a:t>
-            </a:r>
-          </a:p>
-          <a:p>
-            <a:pPr lvl="3"/>
-            <a:r>
-              <a:rPr lang="en-US" smtClean="0"/>
-              <a:t>Fourth level</a:t>
-            </a:r>
-          </a:p>
-          <a:p>
-            <a:pPr lvl="4"/>
-            <a:r>
-              <a:rPr lang="en-US" smtClean="0"/>
-              <a:t>Fifth level</a:t>
-            </a:r>
-            <a:endParaRPr lang="en-US"/>
-          </a:p>
-        </p:txBody>
-      </p:sp>
-      <p:sp>
-        <p:nvSpPr>
-          <p:cNvPr id="6" name="Footer Placeholder 5"/>
-          <p:cNvSpPr>
-            <a:spLocks noGrp="1"/>
-          </p:cNvSpPr>
-          <p:nvPr>
-            <p:ph type="ftr" sz="quarter" idx="4"/>
-          </p:nvPr>
-        </p:nvSpPr>
-        <p:spPr>
-          <a:xfrm>
-            <a:off x="0" y="8685213"/>
-            <a:ext cx="2971800" cy="457200"/>
-          </a:xfrm>
-          <a:prstGeom prst="rect">
-            <a:avLst/>
-          </a:prstGeom>
-        </p:spPr>
-        <p:txBody>
-          <a:bodyPr vert="horz" lIns="91440" tIns="45720" rIns="91440" bIns="45720" rtlCol="0" anchor="b"/>
-          <a:lstStyle>
-            <a:lvl1pPr algn="l">
-              <a:defRPr sz="1200"/>
-            </a:lvl1pPr>
-          </a:lstStyle>
-          <a:p>
-            <a:endParaRPr lang="en-US"/>
-          </a:p>
-        </p:txBody>
-      </p:sp>
-      <p:sp>
-        <p:nvSpPr>
-          <p:cNvPr id="7" name="Slide Number Placeholder 6"/>
-          <p:cNvSpPr>
-            <a:spLocks noGrp="1"/>
-          </p:cNvSpPr>
-          <p:nvPr>
-            <p:ph type="sldNum" sz="quarter" idx="5"/>
-          </p:nvPr>
-        </p:nvSpPr>
-        <p:spPr>
-          <a:xfrm>
-            <a:off x="3884613" y="8685213"/>
-            <a:ext cx="2971800" cy="457200"/>
-          </a:xfrm>
-          <a:prstGeom prst="rect">
-            <a:avLst/>
-          </a:prstGeom>
-        </p:spPr>
-        <p:txBody>
-          <a:bodyPr vert="horz" lIns="91440" tIns="45720" rIns="91440" bIns="45720" rtlCol="0" anchor="b"/>
-          <a:lstStyle>
-            <a:lvl1pPr algn="r">
-              <a:defRPr sz="1200"/>
-            </a:lvl1pPr>
-          </a:lstStyle>
-          <a:p>
-            <a:fld id="{BB5E49A5-4136-284D-997B-48E1D791AD67}" type="slidenum">
-              <a:rPr lang="en-US" smtClean="0"/>
-              <a:t>‹#›</a:t>
-            </a:fld>
-            <a:endParaRPr lang="en-US"/>
-          </a:p>
-        </p:txBody>
-      </p:sp>
     </p:spTree>
     <p:extLst>
       <p:ext uri="{BB962C8B-B14F-4D97-AF65-F5344CB8AC3E}">
-        <p14:creationId xmlns:p14="http://schemas.microsoft.com/office/powerpoint/2010/main" val="2623252185"/>
+        <p14:creationId xmlns:p14="http://schemas.microsoft.com/office/powerpoint/2010/main" val="2622704938"/>
       </p:ext>
     </p:extLst>
   </p:cSld>
   <p:clrMap bg1="lt1" tx1="dk1" bg2="lt2" tx2="dk2" accent1="accent1" accent2="accent2" accent3="accent3" accent4="accent4" accent5="accent5" accent6="accent6" hlink="hlink" folHlink="folHlink"/>
   <p:notesStyle>
-    <a:lvl1pPr marL="0" algn="l" defTabSz="457200" rtl="0" eaLnBrk="1" latinLnBrk="0" hangingPunct="1">
+    <a:lvl1pPr marL="0" algn="l" defTabSz="914400" rtl="0" eaLnBrk="1" latinLnBrk="0" hangingPunct="1">
       <a:defRPr sz="1200" kern="1200">
         <a:solidFill>
           <a:schemeClr val="tx1"/>
@@ -373,7 +167,7 @@
         <a:cs typeface="+mn-cs"/>
       </a:defRPr>
     </a:lvl1pPr>
-    <a:lvl2pPr marL="457200" algn="l" defTabSz="457200" rtl="0" eaLnBrk="1" latinLnBrk="0" hangingPunct="1">
+    <a:lvl2pPr marL="457200" algn="l" defTabSz="914400" rtl="0" eaLnBrk="1" latinLnBrk="0" hangingPunct="1">
       <a:defRPr sz="1200" kern="1200">
         <a:solidFill>
           <a:schemeClr val="tx1"/>
@@ -383,7 +177,7 @@
         <a:cs typeface="+mn-cs"/>
       </a:defRPr>
     </a:lvl2pPr>
-    <a:lvl3pPr marL="914400" algn="l" defTabSz="457200" rtl="0" eaLnBrk="1" latinLnBrk="0" hangingPunct="1">
+    <a:lvl3pPr marL="914400" algn="l" defTabSz="914400" rtl="0" eaLnBrk="1" latinLnBrk="0" hangingPunct="1">
       <a:defRPr sz="1200" kern="1200">
         <a:solidFill>
           <a:schemeClr val="tx1"/>
@@ -393,7 +187,7 @@
         <a:cs typeface="+mn-cs"/>
       </a:defRPr>
     </a:lvl3pPr>
-    <a:lvl4pPr marL="1371600" algn="l" defTabSz="457200" rtl="0" eaLnBrk="1" latinLnBrk="0" hangingPunct="1">
+    <a:lvl4pPr marL="1371600" algn="l" defTabSz="914400" rtl="0" eaLnBrk="1" latinLnBrk="0" hangingPunct="1">
       <a:defRPr sz="1200" kern="1200">
         <a:solidFill>
           <a:schemeClr val="tx1"/>
@@ -403,7 +197,7 @@
         <a:cs typeface="+mn-cs"/>
       </a:defRPr>
     </a:lvl4pPr>
-    <a:lvl5pPr marL="1828800" algn="l" defTabSz="457200" rtl="0" eaLnBrk="1" latinLnBrk="0" hangingPunct="1">
+    <a:lvl5pPr marL="1828800" algn="l" defTabSz="914400" rtl="0" eaLnBrk="1" latinLnBrk="0" hangingPunct="1">
       <a:defRPr sz="1200" kern="1200">
         <a:solidFill>
           <a:schemeClr val="tx1"/>
@@ -413,7 +207,7 @@
         <a:cs typeface="+mn-cs"/>
       </a:defRPr>
     </a:lvl5pPr>
-    <a:lvl6pPr marL="2286000" algn="l" defTabSz="457200" rtl="0" eaLnBrk="1" latinLnBrk="0" hangingPunct="1">
+    <a:lvl6pPr marL="2286000" algn="l" defTabSz="914400" rtl="0" eaLnBrk="1" latinLnBrk="0" hangingPunct="1">
       <a:defRPr sz="1200" kern="1200">
         <a:solidFill>
           <a:schemeClr val="tx1"/>
@@ -423,7 +217,7 @@
         <a:cs typeface="+mn-cs"/>
       </a:defRPr>
     </a:lvl6pPr>
-    <a:lvl7pPr marL="2743200" algn="l" defTabSz="457200" rtl="0" eaLnBrk="1" latinLnBrk="0" hangingPunct="1">
+    <a:lvl7pPr marL="2743200" algn="l" defTabSz="914400" rtl="0" eaLnBrk="1" latinLnBrk="0" hangingPunct="1">
       <a:defRPr sz="1200" kern="1200">
         <a:solidFill>
           <a:schemeClr val="tx1"/>
@@ -433,7 +227,7 @@
         <a:cs typeface="+mn-cs"/>
       </a:defRPr>
     </a:lvl7pPr>
-    <a:lvl8pPr marL="3200400" algn="l" defTabSz="457200" rtl="0" eaLnBrk="1" latinLnBrk="0" hangingPunct="1">
+    <a:lvl8pPr marL="3200400" algn="l" defTabSz="914400" rtl="0" eaLnBrk="1" latinLnBrk="0" hangingPunct="1">
       <a:defRPr sz="1200" kern="1200">
         <a:solidFill>
           <a:schemeClr val="tx1"/>
@@ -443,7 +237,7 @@
         <a:cs typeface="+mn-cs"/>
       </a:defRPr>
     </a:lvl8pPr>
-    <a:lvl9pPr marL="3657600" algn="l" defTabSz="457200" rtl="0" eaLnBrk="1" latinLnBrk="0" hangingPunct="1">
+    <a:lvl9pPr marL="3657600" algn="l" defTabSz="914400" rtl="0" eaLnBrk="1" latinLnBrk="0" hangingPunct="1">
       <a:defRPr sz="1200" kern="1200">
         <a:solidFill>
           <a:schemeClr val="tx1"/>
@@ -458,7 +252,7 @@
 </file>
 
 <file path=ppt/notesSlides/notesSlide1.xml><?xml version="1.0" encoding="utf-8"?>
-<p:notes xmlns:a="http://schemas.openxmlformats.org/drawingml/2006/main" xmlns:p="http://schemas.openxmlformats.org/presentationml/2006/main" xmlns:r="http://schemas.openxmlformats.org/officeDocument/2006/relationships">
+<p:notes xmlns:a="http://schemas.openxmlformats.org/drawingml/2006/main" xmlns:r="http://schemas.openxmlformats.org/officeDocument/2006/relationships" xmlns:p="http://schemas.openxmlformats.org/presentationml/2006/main">
   <p:cSld>
     <p:spTree>
       <p:nvGrpSpPr>
@@ -478,7 +272,7 @@
         <p:nvSpPr>
           <p:cNvPr id="2" name="Slide Image Placeholder 1"/>
           <p:cNvSpPr>
-            <a:spLocks noGrp="1"/>
+            <a:spLocks noGrp="1" noRot="1" noChangeAspect="1"/>
           </p:cNvSpPr>
           <p:nvPr>
             <p:ph type="sldImg" idx="2"/>
@@ -493,7 +287,7 @@
             <a:spLocks noGrp="1"/>
           </p:cNvSpPr>
           <p:nvPr>
-            <p:ph type="body" idx="3" sz="quarter"/>
+            <p:ph type="body" sz="quarter" idx="3"/>
           </p:nvPr>
         </p:nvSpPr>
         <p:spPr/>
@@ -502,38 +296,225 @@
           <a:lstStyle/>
           <a:p>
             <a:r>
-              <a:t>I want to focus on one finding from our final run, not walk through the whole project checklist. We used NYC 311 service requests, converted a 90,000 row subset into compact 20 byte records, and returned 80,000 records through our two laptop, nine node gRPC tree. The only variable in this graph is chunk size. At first the result looks simple: 2 KB chunks took about 338 ms, and 512 KB chunks took about 44 ms, so the extreme speedup is 7.7x. But the part we found more interesting is that 32 KB used 50 pages and 512 KB used only 4 pages, yet their means were almost tied: 45.7 ms versus 44.0 ms. The slide is explaining why that happens.</a:t>
-            </a:r>
-          </a:p>
-          <a:p/>
-          <a:p>
-            <a:r>
-              <a:t>The tree diagram is the starting point. The client does not directly call B through I. The client only calls A, because A is the public entry point and owns the scatter-gather fan-in. On the first page, A has to query B, H, G, and I. B gathers C, D, and E, and E gathers F. Once those payloads return, A materializes the full 1.6 MB result and stores it in the cache under the request id. That first page is special because it pays the distributed gather cost. Later pages for the same request id do not gather the whole tree again; A slices the cached payload and returns the next chunk.</a:t>
-            </a:r>
-          </a:p>
-          <a:p/>
-          <a:p>
-            <a:r>
-              <a:t>That is why total time is not only bandwidth. The cost has four pieces: scatter-gather fan-in over Wi-Fi, cache materialization at A, amortized page cost for each QueryOnce call, and serialization/copy work for the protobuf bytes. Small chunks help on one part: each response is tiny. But they hurt badly on another part: we repeat the page path hundreds of times. Large chunks reduce the number of page calls, but each response is larger and the tail latency becomes more visible.</a:t>
-            </a:r>
-          </a:p>
-          <a:p/>
-          <a:p>
-            <a:r>
-              <a:t>The bottom-left diagram is there to avoid a common misunderstanding. The 338 ms at 2 KB is not one chunk response. It is all 800 page responses combined. Each 2 KB page is cheap, about 0.42 ms on average, but 800 cheap operations still add up. At 32 KB, the client only needs 50 pages, so most of the repeated paging overhead has already been amortized. Going from 50 pages down to 4 pages still helps a little, but now the fixed gather/cache floor and payload movement dominate. That is why 32 KB and 512 KB have almost the same mean.</a:t>
-            </a:r>
-          </a:p>
-          <a:p/>
-          <a:p>
-            <a:r>
-              <a:t>The fairness box shows why we did not just say 512 KB is the answer. At the 32 KB knee, four clients each got exactly 50 chunks through A's queue. Their finish times were not identical, but they were close: 116.8 to 121.8 ms, a 4.3 percent spread. So this is opportunity fairness. A gives clients equal turns, but network timing still creates slightly different wall-clock completion times.</a:t>
-            </a:r>
-          </a:p>
-          <a:p/>
-          <a:p>
-            <a:r>
-              <a:t>The conclusion is that the unique finding is not simply bigger chunks are faster. Chunk size shifts the bottleneck. Below 32 KB, repeated client-to-A paging dominates. Above 32 KB, the fixed gather/cache floor, serialization and copy work, and tail latency dominate. If we optimize only for mean or median, 512 KB wins by a little. If we care about robustness and fairness, 32 KB is the better operating point for this setup because it is nearly as fast but has much lower P90.</a:t>
-            </a:r>
+              <a:rPr lang="en-US" dirty="0"/>
+              <a:t>Anu: For our mini 2, </a:t>
+            </a:r>
+            <a:r>
+              <a:rPr dirty="0"/>
+              <a:t>We used NYC 311 service requests, c</a:t>
+            </a:r>
+            <a:r>
+              <a:rPr lang="en-US" dirty="0"/>
+              <a:t>onverted a 90,000 row subset into compact 20-byte typed binary records, and returned 80,000 of those records through a nine-node </a:t>
+            </a:r>
+            <a:r>
+              <a:rPr lang="en-US" dirty="0" err="1"/>
+              <a:t>gRPC</a:t>
+            </a:r>
+            <a:r>
+              <a:rPr lang="en-US" dirty="0"/>
+              <a:t> tree spread across two laptops on Wi-Fi. A through F on one machine, G, H, and our Python node I on the other. The only variable we changed across runs was chunk size. Everything else stayed the same — same data, same tree, same two laptops, 30 runs per chunk size.</a:t>
+            </a:r>
+          </a:p>
+          <a:p>
+            <a:endParaRPr lang="en-US" dirty="0"/>
+          </a:p>
+          <a:p>
+            <a:r>
+              <a:rPr lang="en-US" dirty="0"/>
+              <a:t>At the extremes, the result looks obvious. 2 KB chunks averaged 338 </a:t>
+            </a:r>
+            <a:r>
+              <a:rPr lang="en-US" dirty="0" err="1"/>
+              <a:t>ms.</a:t>
+            </a:r>
+            <a:r>
+              <a:rPr lang="en-US" dirty="0"/>
+              <a:t> 512 KB chunks averaged 44 </a:t>
+            </a:r>
+            <a:r>
+              <a:rPr lang="en-US" dirty="0" err="1"/>
+              <a:t>ms.</a:t>
+            </a:r>
+            <a:r>
+              <a:rPr lang="en-US" dirty="0"/>
+              <a:t> 7.7x faster, bigger chunks win, done. But that's not the finding.</a:t>
+            </a:r>
+          </a:p>
+          <a:p>
+            <a:endParaRPr lang="en-US" dirty="0"/>
+          </a:p>
+          <a:p>
+            <a:r>
+              <a:rPr dirty="0"/>
+              <a:t>the part we found more interesting is</a:t>
+            </a:r>
+            <a:r>
+              <a:rPr lang="en-US" dirty="0"/>
+              <a:t> what happens in the middle. At 32 KB, we needed 50 pages to return the full result. At 512 KB, we needed only 4. That's going from 50 round trips down to 4 — and the means are 45.7 versus 44.0 milliseconds. 1.7 </a:t>
+            </a:r>
+            <a:r>
+              <a:rPr lang="en-US" dirty="0" err="1"/>
+              <a:t>ms</a:t>
+            </a:r>
+            <a:r>
+              <a:rPr lang="en-US" dirty="0"/>
+              <a:t> apart. So cutting 46 pages out of the request barely moved the number at all, and that needs an explanation.</a:t>
+            </a:r>
+            <a:r>
+              <a:rPr dirty="0"/>
+              <a:t> </a:t>
+            </a:r>
+            <a:endParaRPr lang="en-US" dirty="0"/>
+          </a:p>
+          <a:p>
+            <a:endParaRPr lang="en-US" dirty="0"/>
+          </a:p>
+          <a:p>
+            <a:r>
+              <a:rPr lang="en-US" dirty="0"/>
+              <a:t>To understand it, you have to look at the tree. The client only ever talks to A — A is the sole public entry point and owns the scatter-gather fan-in.  On the very first page of any request, A fans out and gathers from B, H, G, and I, which recursively gather their own children. Once those payloads return, A assembles the full 1.6 MB result and caches it under that request ID. That first page is the only one that pays the distributed gather cost. Every page after that is just A slicing the cached payload and returning the next chunk — the tree doesn't get touched again.</a:t>
+            </a:r>
+          </a:p>
+          <a:p>
+            <a:endParaRPr dirty="0"/>
+          </a:p>
+          <a:p>
+            <a:r>
+              <a:rPr dirty="0"/>
+              <a:t>That is why total time is not only bandwidth. The cost has four pieces: scatter-gather fan-in over Wi-Fi, cache materialization at A, amortized page cost for each </a:t>
+            </a:r>
+            <a:r>
+              <a:rPr dirty="0" err="1"/>
+              <a:t>QueryOnce</a:t>
+            </a:r>
+            <a:r>
+              <a:rPr dirty="0"/>
+              <a:t> call, and serialization/copy work for the </a:t>
+            </a:r>
+            <a:r>
+              <a:rPr dirty="0" err="1"/>
+              <a:t>protobuf</a:t>
+            </a:r>
+            <a:r>
+              <a:rPr dirty="0"/>
+              <a:t> bytes. </a:t>
+            </a:r>
+            <a:r>
+              <a:rPr lang="en-US" dirty="0"/>
+              <a:t>Small chunks help on page size but multiply the page count. </a:t>
+            </a:r>
+            <a:r>
+              <a:rPr dirty="0"/>
+              <a:t>Large chunks reduce the number of page calls, but each response is larger and the tail latency becomes more visible.</a:t>
+            </a:r>
+          </a:p>
+          <a:p>
+            <a:endParaRPr dirty="0"/>
+          </a:p>
+          <a:p>
+            <a:r>
+              <a:rPr lang="en-US" dirty="0"/>
+              <a:t>Asim: </a:t>
+            </a:r>
+            <a:r>
+              <a:rPr dirty="0"/>
+              <a:t>The bottom-left diagram is there to avoid a common misunderstanding. The 338 </a:t>
+            </a:r>
+            <a:r>
+              <a:rPr dirty="0" err="1"/>
+              <a:t>ms</a:t>
+            </a:r>
+            <a:r>
+              <a:rPr dirty="0"/>
+              <a:t> at 2 KB is not one chunk response. It is all 800 page responses combined. Each 2 KB page is cheap, about 0.42 </a:t>
+            </a:r>
+            <a:r>
+              <a:rPr dirty="0" err="1"/>
+              <a:t>ms</a:t>
+            </a:r>
+            <a:r>
+              <a:rPr dirty="0"/>
+              <a:t> on average, but 800 cheap operations still add up. At 32 KB, the client only needs 50 pages, so most of the repeated paging overhead has already been amortized. </a:t>
+            </a:r>
+            <a:r>
+              <a:rPr lang="en-US" sz="1200" b="0" i="1" kern="1200" dirty="0">
+                <a:solidFill>
+                  <a:schemeClr val="tx1"/>
+                </a:solidFill>
+                <a:effectLst/>
+                <a:latin typeface="+mn-lt"/>
+                <a:ea typeface="+mn-ea"/>
+                <a:cs typeface="+mn-cs"/>
+              </a:rPr>
+              <a:t>So the total time is page count multiplied by per-page cost, plus the first gather/cache cost. </a:t>
+            </a:r>
+            <a:r>
+              <a:rPr dirty="0"/>
+              <a:t>Going from 50 pages down to 4 pages still helps a little, but now the fixed gather/cache floor and payload movement dominate. </a:t>
+            </a:r>
+            <a:r>
+              <a:rPr lang="en-US" sz="1200" b="0" i="1" kern="1200" dirty="0">
+                <a:solidFill>
+                  <a:schemeClr val="tx1"/>
+                </a:solidFill>
+                <a:effectLst/>
+                <a:latin typeface="+mn-lt"/>
+                <a:ea typeface="+mn-ea"/>
+                <a:cs typeface="+mn-cs"/>
+              </a:rPr>
+              <a:t>That is why 32 KB and 512 KB have almost the same mean even though 512 KB uses far fewer pages.</a:t>
+            </a:r>
+          </a:p>
+          <a:p>
+            <a:endParaRPr dirty="0"/>
+          </a:p>
+          <a:p>
+            <a:r>
+              <a:rPr dirty="0"/>
+              <a:t>The fairness box shows why we did not just say 512 KB is the answer. At the 32 KB knee, four clients each got exactly 50 chunks through A's queue. Their finish times were not identical, but they were close: 116.8 to 121.8 </a:t>
+            </a:r>
+            <a:r>
+              <a:rPr dirty="0" err="1"/>
+              <a:t>ms</a:t>
+            </a:r>
+            <a:r>
+              <a:rPr dirty="0"/>
+              <a:t>, a 4.3 percent spread. So this is opportunity fairness. A gives clients equal turns, but network timing still creates slightly different wall-clock completion times.</a:t>
+            </a:r>
+            <a:r>
+              <a:rPr lang="en-US" dirty="0"/>
+              <a:t> 512 KB would make this worse: fewer, heavier pages mean one client's slow gather blocks the queue for longer.</a:t>
+            </a:r>
+          </a:p>
+          <a:p>
+            <a:endParaRPr dirty="0"/>
+          </a:p>
+          <a:p>
+            <a:r>
+              <a:rPr lang="en-US" dirty="0"/>
+              <a:t>So the actual design decision here isn't just "which chunk size is fastest." It's: what are you optimizing for? If it's raw mean speed, 512 KB wins by about 1.7 </a:t>
+            </a:r>
+            <a:r>
+              <a:rPr lang="en-US" dirty="0" err="1"/>
+              <a:t>ms.</a:t>
+            </a:r>
+            <a:r>
+              <a:rPr lang="en-US" dirty="0"/>
+              <a:t> If it's robustness, tail behavior, and concurrent client fairness, 32 KB is the better operating point — it's already past most of the page-count penalty and it keeps tail risk manageable.</a:t>
+            </a:r>
+          </a:p>
+          <a:p>
+            <a:endParaRPr lang="en-US" dirty="0"/>
+          </a:p>
+          <a:p>
+            <a:r>
+              <a:rPr lang="en-US" dirty="0"/>
+              <a:t>The takeaway at the bottom of the slide says it cleanly: the first page gathers and cache-builds once. Chunk size controls how many times you repeat the client-to-A page cost after that. Below 32 KB, repeated pages dominate. Above 32 KB, the fixed gather floor and tail variance dominate. The useful discovery isn't that bigger chunks are faster — it's where the bottleneck shifts and why.</a:t>
+            </a:r>
+          </a:p>
+          <a:p>
+            <a:endParaRPr dirty="0"/>
           </a:p>
         </p:txBody>
       </p:sp>
@@ -544,7 +525,7 @@
             <a:spLocks noGrp="1"/>
           </p:cNvSpPr>
           <p:nvPr>
-            <p:ph type="sldNum" idx="5" sz="quarter"/>
+            <p:ph type="sldNum" sz="quarter" idx="5"/>
           </p:nvPr>
         </p:nvSpPr>
         <p:spPr/>
@@ -595,10 +576,9 @@
           <a:lstStyle/>
           <a:p>
             <a:r>
-              <a:rPr lang="en-US" smtClean="0"/>
+              <a:rPr lang="en-US"/>
               <a:t>Click to edit Master title style</a:t>
             </a:r>
-            <a:endParaRPr lang="en-US"/>
           </a:p>
         </p:txBody>
       </p:sp>
@@ -714,10 +694,9 @@
           </a:lstStyle>
           <a:p>
             <a:r>
-              <a:rPr lang="en-US" smtClean="0"/>
+              <a:rPr lang="en-US"/>
               <a:t>Click to edit Master subtitle style</a:t>
             </a:r>
-            <a:endParaRPr lang="en-US"/>
           </a:p>
         </p:txBody>
       </p:sp>
@@ -738,7 +717,7 @@
           <a:p>
             <a:fld id="{5BCAD085-E8A6-8845-BD4E-CB4CCA059FC4}" type="datetimeFigureOut">
               <a:rPr lang="en-US" smtClean="0"/>
-              <a:t>1/27/13</a:t>
+              <a:t>5/11/26</a:t>
             </a:fld>
             <a:endParaRPr lang="en-US"/>
           </a:p>
@@ -832,10 +811,9 @@
           <a:lstStyle/>
           <a:p>
             <a:r>
-              <a:rPr lang="en-US" smtClean="0"/>
+              <a:rPr lang="en-US"/>
               <a:t>Click to edit Master title style</a:t>
             </a:r>
-            <a:endParaRPr lang="en-US"/>
           </a:p>
         </p:txBody>
       </p:sp>
@@ -856,38 +834,37 @@
           <a:p>
             <a:pPr lvl="0"/>
             <a:r>
-              <a:rPr lang="en-US" smtClean="0"/>
+              <a:rPr lang="en-US"/>
               <a:t>Click to edit Master text styles</a:t>
             </a:r>
           </a:p>
           <a:p>
             <a:pPr lvl="1"/>
             <a:r>
-              <a:rPr lang="en-US" smtClean="0"/>
+              <a:rPr lang="en-US"/>
               <a:t>Second level</a:t>
             </a:r>
           </a:p>
           <a:p>
             <a:pPr lvl="2"/>
             <a:r>
-              <a:rPr lang="en-US" smtClean="0"/>
+              <a:rPr lang="en-US"/>
               <a:t>Third level</a:t>
             </a:r>
           </a:p>
           <a:p>
             <a:pPr lvl="3"/>
             <a:r>
-              <a:rPr lang="en-US" smtClean="0"/>
+              <a:rPr lang="en-US"/>
               <a:t>Fourth level</a:t>
             </a:r>
           </a:p>
           <a:p>
             <a:pPr lvl="4"/>
             <a:r>
-              <a:rPr lang="en-US" smtClean="0"/>
+              <a:rPr lang="en-US"/>
               <a:t>Fifth level</a:t>
             </a:r>
-            <a:endParaRPr lang="en-US"/>
           </a:p>
         </p:txBody>
       </p:sp>
@@ -908,7 +885,7 @@
           <a:p>
             <a:fld id="{5BCAD085-E8A6-8845-BD4E-CB4CCA059FC4}" type="datetimeFigureOut">
               <a:rPr lang="en-US" smtClean="0"/>
-              <a:t>1/27/13</a:t>
+              <a:t>5/11/26</a:t>
             </a:fld>
             <a:endParaRPr lang="en-US"/>
           </a:p>
@@ -1007,10 +984,9 @@
           <a:lstStyle/>
           <a:p>
             <a:r>
-              <a:rPr lang="en-US" smtClean="0"/>
+              <a:rPr lang="en-US"/>
               <a:t>Click to edit Master title style</a:t>
             </a:r>
-            <a:endParaRPr lang="en-US"/>
           </a:p>
         </p:txBody>
       </p:sp>
@@ -1036,38 +1012,37 @@
           <a:p>
             <a:pPr lvl="0"/>
             <a:r>
-              <a:rPr lang="en-US" smtClean="0"/>
+              <a:rPr lang="en-US"/>
               <a:t>Click to edit Master text styles</a:t>
             </a:r>
           </a:p>
           <a:p>
             <a:pPr lvl="1"/>
             <a:r>
-              <a:rPr lang="en-US" smtClean="0"/>
+              <a:rPr lang="en-US"/>
               <a:t>Second level</a:t>
             </a:r>
           </a:p>
           <a:p>
             <a:pPr lvl="2"/>
             <a:r>
-              <a:rPr lang="en-US" smtClean="0"/>
+              <a:rPr lang="en-US"/>
               <a:t>Third level</a:t>
             </a:r>
           </a:p>
           <a:p>
             <a:pPr lvl="3"/>
             <a:r>
-              <a:rPr lang="en-US" smtClean="0"/>
+              <a:rPr lang="en-US"/>
               <a:t>Fourth level</a:t>
             </a:r>
           </a:p>
           <a:p>
             <a:pPr lvl="4"/>
             <a:r>
-              <a:rPr lang="en-US" smtClean="0"/>
+              <a:rPr lang="en-US"/>
               <a:t>Fifth level</a:t>
             </a:r>
-            <a:endParaRPr lang="en-US"/>
           </a:p>
         </p:txBody>
       </p:sp>
@@ -1088,7 +1063,7 @@
           <a:p>
             <a:fld id="{5BCAD085-E8A6-8845-BD4E-CB4CCA059FC4}" type="datetimeFigureOut">
               <a:rPr lang="en-US" smtClean="0"/>
-              <a:t>1/27/13</a:t>
+              <a:t>5/11/26</a:t>
             </a:fld>
             <a:endParaRPr lang="en-US"/>
           </a:p>
@@ -1182,10 +1157,9 @@
           <a:lstStyle/>
           <a:p>
             <a:r>
-              <a:rPr lang="en-US" smtClean="0"/>
+              <a:rPr lang="en-US"/>
               <a:t>Click to edit Master title style</a:t>
             </a:r>
-            <a:endParaRPr lang="en-US"/>
           </a:p>
         </p:txBody>
       </p:sp>
@@ -1206,38 +1180,37 @@
           <a:p>
             <a:pPr lvl="0"/>
             <a:r>
-              <a:rPr lang="en-US" smtClean="0"/>
+              <a:rPr lang="en-US"/>
               <a:t>Click to edit Master text styles</a:t>
             </a:r>
           </a:p>
           <a:p>
             <a:pPr lvl="1"/>
             <a:r>
-              <a:rPr lang="en-US" smtClean="0"/>
+              <a:rPr lang="en-US"/>
               <a:t>Second level</a:t>
             </a:r>
           </a:p>
           <a:p>
             <a:pPr lvl="2"/>
             <a:r>
-              <a:rPr lang="en-US" smtClean="0"/>
+              <a:rPr lang="en-US"/>
               <a:t>Third level</a:t>
             </a:r>
           </a:p>
           <a:p>
             <a:pPr lvl="3"/>
             <a:r>
-              <a:rPr lang="en-US" smtClean="0"/>
+              <a:rPr lang="en-US"/>
               <a:t>Fourth level</a:t>
             </a:r>
           </a:p>
           <a:p>
             <a:pPr lvl="4"/>
             <a:r>
-              <a:rPr lang="en-US" smtClean="0"/>
+              <a:rPr lang="en-US"/>
               <a:t>Fifth level</a:t>
             </a:r>
-            <a:endParaRPr lang="en-US"/>
           </a:p>
         </p:txBody>
       </p:sp>
@@ -1258,7 +1231,7 @@
           <a:p>
             <a:fld id="{5BCAD085-E8A6-8845-BD4E-CB4CCA059FC4}" type="datetimeFigureOut">
               <a:rPr lang="en-US" smtClean="0"/>
-              <a:t>1/27/13</a:t>
+              <a:t>5/11/26</a:t>
             </a:fld>
             <a:endParaRPr lang="en-US"/>
           </a:p>
@@ -1361,10 +1334,9 @@
           </a:lstStyle>
           <a:p>
             <a:r>
-              <a:rPr lang="en-US" smtClean="0"/>
+              <a:rPr lang="en-US"/>
               <a:t>Click to edit Master title style</a:t>
             </a:r>
-            <a:endParaRPr lang="en-US"/>
           </a:p>
         </p:txBody>
       </p:sp>
@@ -1481,7 +1453,7 @@
           <a:p>
             <a:pPr lvl="0"/>
             <a:r>
-              <a:rPr lang="en-US" smtClean="0"/>
+              <a:rPr lang="en-US"/>
               <a:t>Click to edit Master text styles</a:t>
             </a:r>
           </a:p>
@@ -1504,7 +1476,7 @@
           <a:p>
             <a:fld id="{5BCAD085-E8A6-8845-BD4E-CB4CCA059FC4}" type="datetimeFigureOut">
               <a:rPr lang="en-US" smtClean="0"/>
-              <a:t>1/27/13</a:t>
+              <a:t>5/11/26</a:t>
             </a:fld>
             <a:endParaRPr lang="en-US"/>
           </a:p>
@@ -1598,10 +1570,9 @@
           <a:lstStyle/>
           <a:p>
             <a:r>
-              <a:rPr lang="en-US" smtClean="0"/>
+              <a:rPr lang="en-US"/>
               <a:t>Click to edit Master title style</a:t>
             </a:r>
-            <a:endParaRPr lang="en-US"/>
           </a:p>
         </p:txBody>
       </p:sp>
@@ -1655,38 +1626,37 @@
           <a:p>
             <a:pPr lvl="0"/>
             <a:r>
-              <a:rPr lang="en-US" smtClean="0"/>
+              <a:rPr lang="en-US"/>
               <a:t>Click to edit Master text styles</a:t>
             </a:r>
           </a:p>
           <a:p>
             <a:pPr lvl="1"/>
             <a:r>
-              <a:rPr lang="en-US" smtClean="0"/>
+              <a:rPr lang="en-US"/>
               <a:t>Second level</a:t>
             </a:r>
           </a:p>
           <a:p>
             <a:pPr lvl="2"/>
             <a:r>
-              <a:rPr lang="en-US" smtClean="0"/>
+              <a:rPr lang="en-US"/>
               <a:t>Third level</a:t>
             </a:r>
           </a:p>
           <a:p>
             <a:pPr lvl="3"/>
             <a:r>
-              <a:rPr lang="en-US" smtClean="0"/>
+              <a:rPr lang="en-US"/>
               <a:t>Fourth level</a:t>
             </a:r>
           </a:p>
           <a:p>
             <a:pPr lvl="4"/>
             <a:r>
-              <a:rPr lang="en-US" smtClean="0"/>
+              <a:rPr lang="en-US"/>
               <a:t>Fifth level</a:t>
             </a:r>
-            <a:endParaRPr lang="en-US"/>
           </a:p>
         </p:txBody>
       </p:sp>
@@ -1740,38 +1710,37 @@
           <a:p>
             <a:pPr lvl="0"/>
             <a:r>
-              <a:rPr lang="en-US" smtClean="0"/>
+              <a:rPr lang="en-US"/>
               <a:t>Click to edit Master text styles</a:t>
             </a:r>
           </a:p>
           <a:p>
             <a:pPr lvl="1"/>
             <a:r>
-              <a:rPr lang="en-US" smtClean="0"/>
+              <a:rPr lang="en-US"/>
               <a:t>Second level</a:t>
             </a:r>
           </a:p>
           <a:p>
             <a:pPr lvl="2"/>
             <a:r>
-              <a:rPr lang="en-US" smtClean="0"/>
+              <a:rPr lang="en-US"/>
               <a:t>Third level</a:t>
             </a:r>
           </a:p>
           <a:p>
             <a:pPr lvl="3"/>
             <a:r>
-              <a:rPr lang="en-US" smtClean="0"/>
+              <a:rPr lang="en-US"/>
               <a:t>Fourth level</a:t>
             </a:r>
           </a:p>
           <a:p>
             <a:pPr lvl="4"/>
             <a:r>
-              <a:rPr lang="en-US" smtClean="0"/>
+              <a:rPr lang="en-US"/>
               <a:t>Fifth level</a:t>
             </a:r>
-            <a:endParaRPr lang="en-US"/>
           </a:p>
         </p:txBody>
       </p:sp>
@@ -1792,7 +1761,7 @@
           <a:p>
             <a:fld id="{5BCAD085-E8A6-8845-BD4E-CB4CCA059FC4}" type="datetimeFigureOut">
               <a:rPr lang="en-US" smtClean="0"/>
-              <a:t>1/27/13</a:t>
+              <a:t>5/11/26</a:t>
             </a:fld>
             <a:endParaRPr lang="en-US"/>
           </a:p>
@@ -1890,10 +1859,9 @@
           </a:lstStyle>
           <a:p>
             <a:r>
-              <a:rPr lang="en-US" smtClean="0"/>
+              <a:rPr lang="en-US"/>
               <a:t>Click to edit Master title style</a:t>
             </a:r>
-            <a:endParaRPr lang="en-US"/>
           </a:p>
         </p:txBody>
       </p:sp>
@@ -1956,7 +1924,7 @@
           <a:p>
             <a:pPr lvl="0"/>
             <a:r>
-              <a:rPr lang="en-US" smtClean="0"/>
+              <a:rPr lang="en-US"/>
               <a:t>Click to edit Master text styles</a:t>
             </a:r>
           </a:p>
@@ -2012,38 +1980,37 @@
           <a:p>
             <a:pPr lvl="0"/>
             <a:r>
-              <a:rPr lang="en-US" smtClean="0"/>
+              <a:rPr lang="en-US"/>
               <a:t>Click to edit Master text styles</a:t>
             </a:r>
           </a:p>
           <a:p>
             <a:pPr lvl="1"/>
             <a:r>
-              <a:rPr lang="en-US" smtClean="0"/>
+              <a:rPr lang="en-US"/>
               <a:t>Second level</a:t>
             </a:r>
           </a:p>
           <a:p>
             <a:pPr lvl="2"/>
             <a:r>
-              <a:rPr lang="en-US" smtClean="0"/>
+              <a:rPr lang="en-US"/>
               <a:t>Third level</a:t>
             </a:r>
           </a:p>
           <a:p>
             <a:pPr lvl="3"/>
             <a:r>
-              <a:rPr lang="en-US" smtClean="0"/>
+              <a:rPr lang="en-US"/>
               <a:t>Fourth level</a:t>
             </a:r>
           </a:p>
           <a:p>
             <a:pPr lvl="4"/>
             <a:r>
-              <a:rPr lang="en-US" smtClean="0"/>
+              <a:rPr lang="en-US"/>
               <a:t>Fifth level</a:t>
             </a:r>
-            <a:endParaRPr lang="en-US"/>
           </a:p>
         </p:txBody>
       </p:sp>
@@ -2106,7 +2073,7 @@
           <a:p>
             <a:pPr lvl="0"/>
             <a:r>
-              <a:rPr lang="en-US" smtClean="0"/>
+              <a:rPr lang="en-US"/>
               <a:t>Click to edit Master text styles</a:t>
             </a:r>
           </a:p>
@@ -2162,38 +2129,37 @@
           <a:p>
             <a:pPr lvl="0"/>
             <a:r>
-              <a:rPr lang="en-US" smtClean="0"/>
+              <a:rPr lang="en-US"/>
               <a:t>Click to edit Master text styles</a:t>
             </a:r>
           </a:p>
           <a:p>
             <a:pPr lvl="1"/>
             <a:r>
-              <a:rPr lang="en-US" smtClean="0"/>
+              <a:rPr lang="en-US"/>
               <a:t>Second level</a:t>
             </a:r>
           </a:p>
           <a:p>
             <a:pPr lvl="2"/>
             <a:r>
-              <a:rPr lang="en-US" smtClean="0"/>
+              <a:rPr lang="en-US"/>
               <a:t>Third level</a:t>
             </a:r>
           </a:p>
           <a:p>
             <a:pPr lvl="3"/>
             <a:r>
-              <a:rPr lang="en-US" smtClean="0"/>
+              <a:rPr lang="en-US"/>
               <a:t>Fourth level</a:t>
             </a:r>
           </a:p>
           <a:p>
             <a:pPr lvl="4"/>
             <a:r>
-              <a:rPr lang="en-US" smtClean="0"/>
+              <a:rPr lang="en-US"/>
               <a:t>Fifth level</a:t>
             </a:r>
-            <a:endParaRPr lang="en-US"/>
           </a:p>
         </p:txBody>
       </p:sp>
@@ -2214,7 +2180,7 @@
           <a:p>
             <a:fld id="{5BCAD085-E8A6-8845-BD4E-CB4CCA059FC4}" type="datetimeFigureOut">
               <a:rPr lang="en-US" smtClean="0"/>
-              <a:t>1/27/13</a:t>
+              <a:t>5/11/26</a:t>
             </a:fld>
             <a:endParaRPr lang="en-US"/>
           </a:p>
@@ -2308,10 +2274,9 @@
           <a:lstStyle/>
           <a:p>
             <a:r>
-              <a:rPr lang="en-US" smtClean="0"/>
+              <a:rPr lang="en-US"/>
               <a:t>Click to edit Master title style</a:t>
             </a:r>
-            <a:endParaRPr lang="en-US"/>
           </a:p>
         </p:txBody>
       </p:sp>
@@ -2332,7 +2297,7 @@
           <a:p>
             <a:fld id="{5BCAD085-E8A6-8845-BD4E-CB4CCA059FC4}" type="datetimeFigureOut">
               <a:rPr lang="en-US" smtClean="0"/>
-              <a:t>1/27/13</a:t>
+              <a:t>5/11/26</a:t>
             </a:fld>
             <a:endParaRPr lang="en-US"/>
           </a:p>
@@ -2427,7 +2392,7 @@
           <a:p>
             <a:fld id="{5BCAD085-E8A6-8845-BD4E-CB4CCA059FC4}" type="datetimeFigureOut">
               <a:rPr lang="en-US" smtClean="0"/>
-              <a:t>1/27/13</a:t>
+              <a:t>5/11/26</a:t>
             </a:fld>
             <a:endParaRPr lang="en-US"/>
           </a:p>
@@ -2530,10 +2495,9 @@
           </a:lstStyle>
           <a:p>
             <a:r>
-              <a:rPr lang="en-US" smtClean="0"/>
+              <a:rPr lang="en-US"/>
               <a:t>Click to edit Master title style</a:t>
             </a:r>
-            <a:endParaRPr lang="en-US"/>
           </a:p>
         </p:txBody>
       </p:sp>
@@ -2587,38 +2551,37 @@
           <a:p>
             <a:pPr lvl="0"/>
             <a:r>
-              <a:rPr lang="en-US" smtClean="0"/>
+              <a:rPr lang="en-US"/>
               <a:t>Click to edit Master text styles</a:t>
             </a:r>
           </a:p>
           <a:p>
             <a:pPr lvl="1"/>
             <a:r>
-              <a:rPr lang="en-US" smtClean="0"/>
+              <a:rPr lang="en-US"/>
               <a:t>Second level</a:t>
             </a:r>
           </a:p>
           <a:p>
             <a:pPr lvl="2"/>
             <a:r>
-              <a:rPr lang="en-US" smtClean="0"/>
+              <a:rPr lang="en-US"/>
               <a:t>Third level</a:t>
             </a:r>
           </a:p>
           <a:p>
             <a:pPr lvl="3"/>
             <a:r>
-              <a:rPr lang="en-US" smtClean="0"/>
+              <a:rPr lang="en-US"/>
               <a:t>Fourth level</a:t>
             </a:r>
           </a:p>
           <a:p>
             <a:pPr lvl="4"/>
             <a:r>
-              <a:rPr lang="en-US" smtClean="0"/>
+              <a:rPr lang="en-US"/>
               <a:t>Fifth level</a:t>
             </a:r>
-            <a:endParaRPr lang="en-US"/>
           </a:p>
         </p:txBody>
       </p:sp>
@@ -2681,7 +2644,7 @@
           <a:p>
             <a:pPr lvl="0"/>
             <a:r>
-              <a:rPr lang="en-US" smtClean="0"/>
+              <a:rPr lang="en-US"/>
               <a:t>Click to edit Master text styles</a:t>
             </a:r>
           </a:p>
@@ -2704,7 +2667,7 @@
           <a:p>
             <a:fld id="{5BCAD085-E8A6-8845-BD4E-CB4CCA059FC4}" type="datetimeFigureOut">
               <a:rPr lang="en-US" smtClean="0"/>
-              <a:t>1/27/13</a:t>
+              <a:t>5/11/26</a:t>
             </a:fld>
             <a:endParaRPr lang="en-US"/>
           </a:p>
@@ -2807,10 +2770,9 @@
           </a:lstStyle>
           <a:p>
             <a:r>
-              <a:rPr lang="en-US" smtClean="0"/>
+              <a:rPr lang="en-US"/>
               <a:t>Click to edit Master title style</a:t>
             </a:r>
-            <a:endParaRPr lang="en-US"/>
           </a:p>
         </p:txBody>
       </p:sp>
@@ -2934,7 +2896,7 @@
           <a:p>
             <a:pPr lvl="0"/>
             <a:r>
-              <a:rPr lang="en-US" smtClean="0"/>
+              <a:rPr lang="en-US"/>
               <a:t>Click to edit Master text styles</a:t>
             </a:r>
           </a:p>
@@ -2957,7 +2919,7 @@
           <a:p>
             <a:fld id="{5BCAD085-E8A6-8845-BD4E-CB4CCA059FC4}" type="datetimeFigureOut">
               <a:rPr lang="en-US" smtClean="0"/>
-              <a:t>1/27/13</a:t>
+              <a:t>5/11/26</a:t>
             </a:fld>
             <a:endParaRPr lang="en-US"/>
           </a:p>
@@ -3066,10 +3028,9 @@
           <a:lstStyle/>
           <a:p>
             <a:r>
-              <a:rPr lang="en-US" smtClean="0"/>
+              <a:rPr lang="en-US"/>
               <a:t>Click to edit Master title style</a:t>
             </a:r>
-            <a:endParaRPr lang="en-US"/>
           </a:p>
         </p:txBody>
       </p:sp>
@@ -3100,38 +3061,37 @@
           <a:p>
             <a:pPr lvl="0"/>
             <a:r>
-              <a:rPr lang="en-US" smtClean="0"/>
+              <a:rPr lang="en-US"/>
               <a:t>Click to edit Master text styles</a:t>
             </a:r>
           </a:p>
           <a:p>
             <a:pPr lvl="1"/>
             <a:r>
-              <a:rPr lang="en-US" smtClean="0"/>
+              <a:rPr lang="en-US"/>
               <a:t>Second level</a:t>
             </a:r>
           </a:p>
           <a:p>
             <a:pPr lvl="2"/>
             <a:r>
-              <a:rPr lang="en-US" smtClean="0"/>
+              <a:rPr lang="en-US"/>
               <a:t>Third level</a:t>
             </a:r>
           </a:p>
           <a:p>
             <a:pPr lvl="3"/>
             <a:r>
-              <a:rPr lang="en-US" smtClean="0"/>
+              <a:rPr lang="en-US"/>
               <a:t>Fourth level</a:t>
             </a:r>
           </a:p>
           <a:p>
             <a:pPr lvl="4"/>
             <a:r>
-              <a:rPr lang="en-US" smtClean="0"/>
+              <a:rPr lang="en-US"/>
               <a:t>Fifth level</a:t>
             </a:r>
-            <a:endParaRPr lang="en-US"/>
           </a:p>
         </p:txBody>
       </p:sp>
@@ -3170,7 +3130,7 @@
           <a:p>
             <a:fld id="{5BCAD085-E8A6-8845-BD4E-CB4CCA059FC4}" type="datetimeFigureOut">
               <a:rPr lang="en-US" smtClean="0"/>
-              <a:t>1/27/13</a:t>
+              <a:t>5/11/26</a:t>
             </a:fld>
             <a:endParaRPr lang="en-US"/>
           </a:p>
@@ -3529,7 +3489,7 @@
 </file>
 
 <file path=ppt/slides/slide1.xml><?xml version="1.0" encoding="utf-8"?>
-<p:sld xmlns:a="http://schemas.openxmlformats.org/drawingml/2006/main" xmlns:p="http://schemas.openxmlformats.org/presentationml/2006/main" xmlns:r="http://schemas.openxmlformats.org/officeDocument/2006/relationships">
+<p:sld xmlns:a="http://schemas.openxmlformats.org/drawingml/2006/main" xmlns:r="http://schemas.openxmlformats.org/officeDocument/2006/relationships" xmlns:p="http://schemas.openxmlformats.org/presentationml/2006/main">
   <p:cSld>
     <p:bg>
       <p:bgPr>
@@ -3545,7 +3505,14 @@
         <p:cNvGrpSpPr/>
         <p:nvPr/>
       </p:nvGrpSpPr>
-      <p:grpSpPr/>
+      <p:grpSpPr>
+        <a:xfrm>
+          <a:off x="0" y="0"/>
+          <a:ext cx="0" cy="0"/>
+          <a:chOff x="0" y="0"/>
+          <a:chExt cx="0" cy="0"/>
+        </a:xfrm>
+      </p:grpSpPr>
       <p:sp>
         <p:nvSpPr>
           <p:cNvPr id="2" name="Rectangle 1"/>
@@ -3588,6 +3555,7 @@
           <a:lstStyle/>
           <a:p>
             <a:pPr algn="ctr"/>
+            <a:endParaRPr/>
           </a:p>
         </p:txBody>
       </p:sp>
@@ -3608,7 +3576,7 @@
           <a:noFill/>
         </p:spPr>
         <p:txBody>
-          <a:bodyPr wrap="none" lIns="36576" rIns="36576" tIns="18288" bIns="18288">
+          <a:bodyPr wrap="none" lIns="36576" tIns="18288" rIns="36576" bIns="18288">
             <a:spAutoFit/>
           </a:bodyPr>
           <a:lstStyle/>
@@ -3635,7 +3603,7 @@
         <p:spPr>
           <a:xfrm>
             <a:off x="3639312" y="256032"/>
-            <a:ext cx="6858000" cy="310896"/>
+            <a:ext cx="4198329" cy="260071"/>
           </a:xfrm>
           <a:prstGeom prst="rect">
             <a:avLst/>
@@ -3643,7 +3611,7 @@
           <a:noFill/>
         </p:spPr>
         <p:txBody>
-          <a:bodyPr wrap="none" lIns="36576" rIns="36576" tIns="18288" bIns="18288">
+          <a:bodyPr wrap="none" lIns="36576" tIns="18288" rIns="36576" bIns="18288">
             <a:spAutoFit/>
           </a:bodyPr>
           <a:lstStyle/>
@@ -3656,8 +3624,14 @@
               </a:defRPr>
             </a:pPr>
             <a:r>
+              <a:rPr dirty="0"/>
               <a:t>Why 50 pages at 32 KB almost tied 4 pages at 512 KB</a:t>
             </a:r>
+            <a:r>
+              <a:rPr lang="en-US" dirty="0"/>
+              <a:t>?</a:t>
+            </a:r>
+            <a:endParaRPr dirty="0"/>
           </a:p>
         </p:txBody>
       </p:sp>
@@ -3669,8 +3643,8 @@
         </p:nvSpPr>
         <p:spPr>
           <a:xfrm>
-            <a:off x="10607040" y="310896"/>
-            <a:ext cx="1188720" cy="219456"/>
+            <a:off x="10444300" y="310896"/>
+            <a:ext cx="1351460" cy="175433"/>
           </a:xfrm>
           <a:prstGeom prst="rect">
             <a:avLst/>
@@ -3678,7 +3652,7 @@
           <a:noFill/>
         </p:spPr>
         <p:txBody>
-          <a:bodyPr wrap="none" lIns="36576" rIns="36576" tIns="18288" bIns="18288">
+          <a:bodyPr wrap="none" lIns="36576" tIns="18288" rIns="36576" bIns="18288">
             <a:spAutoFit/>
           </a:bodyPr>
           <a:lstStyle/>
@@ -3691,6 +3665,11 @@
               </a:defRPr>
             </a:pPr>
             <a:r>
+              <a:rPr lang="en-US" dirty="0"/>
+              <a:t>CMPE 275 </a:t>
+            </a:r>
+            <a:r>
+              <a:rPr dirty="0"/>
               <a:t>Anukrithi + Asim</a:t>
             </a:r>
           </a:p>
@@ -3713,7 +3692,7 @@
           <a:noFill/>
         </p:spPr>
         <p:txBody>
-          <a:bodyPr wrap="none" lIns="36576" rIns="36576" tIns="18288" bIns="18288">
+          <a:bodyPr wrap="none" lIns="36576" tIns="18288" rIns="36576" bIns="18288">
             <a:spAutoFit/>
           </a:bodyPr>
           <a:lstStyle/>
@@ -3726,6 +3705,7 @@
               </a:defRPr>
             </a:pPr>
             <a:r>
+              <a:rPr dirty="0"/>
               <a:t>NYC 311 2020-present | 80k returned rows | 20-byte records | A-F host1, G/H/I host2 | 30 runs/chunk</a:t>
             </a:r>
           </a:p>
@@ -3739,8 +3719,8 @@
         </p:nvSpPr>
         <p:spPr>
           <a:xfrm>
-            <a:off x="274320" y="896112"/>
-            <a:ext cx="4773168" cy="3200400"/>
+            <a:off x="176981" y="896112"/>
+            <a:ext cx="4870507" cy="3200400"/>
           </a:xfrm>
           <a:prstGeom prst="roundRect">
             <a:avLst/>
@@ -3773,6 +3753,7 @@
           <a:lstStyle/>
           <a:p>
             <a:pPr algn="ctr"/>
+            <a:endParaRPr/>
           </a:p>
         </p:txBody>
       </p:sp>
@@ -3785,7 +3766,7 @@
           <p:nvPr/>
         </p:nvPicPr>
         <p:blipFill>
-          <a:blip r:embed="rId2"/>
+          <a:blip r:embed="rId3"/>
           <a:stretch>
             <a:fillRect/>
           </a:stretch>
@@ -3842,6 +3823,7 @@
           <a:lstStyle/>
           <a:p>
             <a:pPr algn="ctr"/>
+            <a:endParaRPr/>
           </a:p>
         </p:txBody>
       </p:sp>
@@ -3862,7 +3844,7 @@
           <a:noFill/>
         </p:spPr>
         <p:txBody>
-          <a:bodyPr wrap="none" lIns="36576" rIns="36576" tIns="18288" bIns="18288">
+          <a:bodyPr wrap="none" lIns="36576" tIns="18288" rIns="36576" bIns="18288">
             <a:spAutoFit/>
           </a:bodyPr>
           <a:lstStyle/>
@@ -3897,7 +3879,7 @@
           <a:noFill/>
         </p:spPr>
         <p:txBody>
-          <a:bodyPr wrap="none" lIns="36576" rIns="36576" tIns="18288" bIns="18288">
+          <a:bodyPr wrap="none" lIns="36576" tIns="18288" rIns="36576" bIns="18288">
             <a:spAutoFit/>
           </a:bodyPr>
           <a:lstStyle/>
@@ -4272,6 +4254,7 @@
           <a:lstStyle/>
           <a:p>
             <a:pPr algn="ctr"/>
+            <a:endParaRPr/>
           </a:p>
         </p:txBody>
       </p:sp>
@@ -4292,7 +4275,7 @@
           <a:noFill/>
         </p:spPr>
         <p:txBody>
-          <a:bodyPr wrap="none" lIns="36576" rIns="36576" tIns="18288" bIns="18288">
+          <a:bodyPr wrap="none" lIns="36576" tIns="18288" rIns="36576" bIns="18288">
             <a:spAutoFit/>
           </a:bodyPr>
           <a:lstStyle/>
@@ -4352,7 +4335,7 @@
           <a:lstStyle/>
           <a:p>
             <a:pPr algn="ctr">
-              <a:defRPr b="1" sz="1000">
+              <a:defRPr sz="1000" b="1">
                 <a:solidFill>
                   <a:srgbClr val="FACC15"/>
                 </a:solidFill>
@@ -4406,7 +4389,7 @@
           <a:lstStyle/>
           <a:p>
             <a:pPr algn="ctr">
-              <a:defRPr b="1" sz="1000">
+              <a:defRPr sz="1000" b="1">
                 <a:solidFill>
                   <a:srgbClr val="F8FAFC"/>
                 </a:solidFill>
@@ -4460,7 +4443,7 @@
           <a:lstStyle/>
           <a:p>
             <a:pPr algn="ctr">
-              <a:defRPr b="1" sz="1000">
+              <a:defRPr sz="1000" b="1">
                 <a:solidFill>
                   <a:srgbClr val="F8FAFC"/>
                 </a:solidFill>
@@ -4514,7 +4497,7 @@
           <a:lstStyle/>
           <a:p>
             <a:pPr algn="ctr">
-              <a:defRPr b="1" sz="1000">
+              <a:defRPr sz="1000" b="1">
                 <a:solidFill>
                   <a:srgbClr val="F8FAFC"/>
                 </a:solidFill>
@@ -4568,7 +4551,7 @@
           <a:lstStyle/>
           <a:p>
             <a:pPr algn="ctr">
-              <a:defRPr b="1" sz="1000">
+              <a:defRPr sz="1000" b="1">
                 <a:solidFill>
                   <a:srgbClr val="F8FAFC"/>
                 </a:solidFill>
@@ -4622,7 +4605,7 @@
           <a:lstStyle/>
           <a:p>
             <a:pPr algn="ctr">
-              <a:defRPr b="1" sz="1000">
+              <a:defRPr sz="1000" b="1">
                 <a:solidFill>
                   <a:srgbClr val="F8FAFC"/>
                 </a:solidFill>
@@ -4676,7 +4659,7 @@
           <a:lstStyle/>
           <a:p>
             <a:pPr algn="ctr">
-              <a:defRPr b="1" sz="1000">
+              <a:defRPr sz="1000" b="1">
                 <a:solidFill>
                   <a:srgbClr val="F8FAFC"/>
                 </a:solidFill>
@@ -4730,7 +4713,7 @@
           <a:lstStyle/>
           <a:p>
             <a:pPr algn="ctr">
-              <a:defRPr b="1" sz="1000">
+              <a:defRPr sz="1000" b="1">
                 <a:solidFill>
                   <a:srgbClr val="F8FAFC"/>
                 </a:solidFill>
@@ -4784,7 +4767,7 @@
           <a:lstStyle/>
           <a:p>
             <a:pPr algn="ctr">
-              <a:defRPr b="1" sz="1000">
+              <a:defRPr sz="1000" b="1">
                 <a:solidFill>
                   <a:srgbClr val="BBF7D0"/>
                 </a:solidFill>
@@ -4813,7 +4796,7 @@
           <a:noFill/>
         </p:spPr>
         <p:txBody>
-          <a:bodyPr wrap="none" lIns="36576" rIns="36576" tIns="18288" bIns="18288">
+          <a:bodyPr wrap="none" lIns="36576" tIns="18288" rIns="36576" bIns="18288">
             <a:spAutoFit/>
           </a:bodyPr>
           <a:lstStyle/>
@@ -4852,7 +4835,7 @@
           <a:noFill/>
         </p:spPr>
         <p:txBody>
-          <a:bodyPr wrap="none" lIns="36576" rIns="36576" tIns="18288" bIns="18288">
+          <a:bodyPr wrap="none" lIns="36576" tIns="18288" rIns="36576" bIns="18288">
             <a:spAutoFit/>
           </a:bodyPr>
           <a:lstStyle/>
@@ -4912,6 +4895,7 @@
           <a:lstStyle/>
           <a:p>
             <a:pPr algn="ctr"/>
+            <a:endParaRPr/>
           </a:p>
         </p:txBody>
       </p:sp>
@@ -4932,7 +4916,7 @@
           <a:noFill/>
         </p:spPr>
         <p:txBody>
-          <a:bodyPr wrap="none" lIns="36576" rIns="36576" tIns="18288" bIns="18288">
+          <a:bodyPr wrap="none" lIns="36576" tIns="18288" rIns="36576" bIns="18288">
             <a:spAutoFit/>
           </a:bodyPr>
           <a:lstStyle/>
@@ -4992,6 +4976,7 @@
           <a:lstStyle/>
           <a:p>
             <a:pPr algn="ctr"/>
+            <a:endParaRPr/>
           </a:p>
         </p:txBody>
       </p:sp>
@@ -5012,7 +4997,7 @@
           <a:noFill/>
         </p:spPr>
         <p:txBody>
-          <a:bodyPr wrap="none" lIns="36576" rIns="36576" tIns="18288" bIns="18288">
+          <a:bodyPr wrap="none" lIns="36576" tIns="18288" rIns="36576" bIns="18288">
             <a:spAutoFit/>
           </a:bodyPr>
           <a:lstStyle/>
@@ -5047,7 +5032,7 @@
           <a:noFill/>
         </p:spPr>
         <p:txBody>
-          <a:bodyPr wrap="none" lIns="36576" rIns="36576" tIns="18288" bIns="18288">
+          <a:bodyPr wrap="none" lIns="36576" tIns="18288" rIns="36576" bIns="18288">
             <a:spAutoFit/>
           </a:bodyPr>
           <a:lstStyle/>
@@ -5082,7 +5067,7 @@
           <a:noFill/>
         </p:spPr>
         <p:txBody>
-          <a:bodyPr wrap="none" lIns="36576" rIns="36576" tIns="18288" bIns="18288">
+          <a:bodyPr wrap="none" lIns="36576" tIns="18288" rIns="36576" bIns="18288">
             <a:spAutoFit/>
           </a:bodyPr>
           <a:lstStyle/>
@@ -5142,6 +5127,7 @@
           <a:lstStyle/>
           <a:p>
             <a:pPr algn="ctr"/>
+            <a:endParaRPr/>
           </a:p>
         </p:txBody>
       </p:sp>
@@ -5162,7 +5148,7 @@
           <a:noFill/>
         </p:spPr>
         <p:txBody>
-          <a:bodyPr wrap="none" lIns="36576" rIns="36576" tIns="18288" bIns="18288">
+          <a:bodyPr wrap="none" lIns="36576" tIns="18288" rIns="36576" bIns="18288">
             <a:spAutoFit/>
           </a:bodyPr>
           <a:lstStyle/>
@@ -5197,7 +5183,7 @@
           <a:noFill/>
         </p:spPr>
         <p:txBody>
-          <a:bodyPr wrap="none" lIns="36576" rIns="36576" tIns="18288" bIns="18288">
+          <a:bodyPr wrap="none" lIns="36576" tIns="18288" rIns="36576" bIns="18288">
             <a:spAutoFit/>
           </a:bodyPr>
           <a:lstStyle/>
@@ -5232,7 +5218,7 @@
           <a:noFill/>
         </p:spPr>
         <p:txBody>
-          <a:bodyPr wrap="none" lIns="36576" rIns="36576" tIns="18288" bIns="18288">
+          <a:bodyPr wrap="none" lIns="36576" tIns="18288" rIns="36576" bIns="18288">
             <a:spAutoFit/>
           </a:bodyPr>
           <a:lstStyle/>
@@ -5292,6 +5278,7 @@
           <a:lstStyle/>
           <a:p>
             <a:pPr algn="ctr"/>
+            <a:endParaRPr/>
           </a:p>
         </p:txBody>
       </p:sp>
@@ -5312,7 +5299,7 @@
           <a:noFill/>
         </p:spPr>
         <p:txBody>
-          <a:bodyPr wrap="none" lIns="36576" rIns="36576" tIns="18288" bIns="18288">
+          <a:bodyPr wrap="none" lIns="36576" tIns="18288" rIns="36576" bIns="18288">
             <a:spAutoFit/>
           </a:bodyPr>
           <a:lstStyle/>
@@ -5347,7 +5334,7 @@
           <a:noFill/>
         </p:spPr>
         <p:txBody>
-          <a:bodyPr wrap="none" lIns="36576" rIns="36576" tIns="18288" bIns="18288">
+          <a:bodyPr wrap="none" lIns="36576" tIns="18288" rIns="36576" bIns="18288">
             <a:spAutoFit/>
           </a:bodyPr>
           <a:lstStyle/>
@@ -5382,7 +5369,7 @@
           <a:noFill/>
         </p:spPr>
         <p:txBody>
-          <a:bodyPr wrap="none" lIns="36576" rIns="36576" tIns="18288" bIns="18288">
+          <a:bodyPr wrap="none" lIns="36576" tIns="18288" rIns="36576" bIns="18288">
             <a:spAutoFit/>
           </a:bodyPr>
           <a:lstStyle/>
@@ -5442,6 +5429,7 @@
           <a:lstStyle/>
           <a:p>
             <a:pPr algn="ctr"/>
+            <a:endParaRPr/>
           </a:p>
         </p:txBody>
       </p:sp>
@@ -5462,7 +5450,7 @@
           <a:noFill/>
         </p:spPr>
         <p:txBody>
-          <a:bodyPr wrap="none" lIns="36576" rIns="36576" tIns="18288" bIns="18288">
+          <a:bodyPr wrap="none" lIns="36576" tIns="18288" rIns="36576" bIns="18288">
             <a:spAutoFit/>
           </a:bodyPr>
           <a:lstStyle/>
@@ -5497,7 +5485,7 @@
           <a:noFill/>
         </p:spPr>
         <p:txBody>
-          <a:bodyPr wrap="none" lIns="36576" rIns="36576" tIns="18288" bIns="18288">
+          <a:bodyPr wrap="none" lIns="36576" tIns="18288" rIns="36576" bIns="18288">
             <a:spAutoFit/>
           </a:bodyPr>
           <a:lstStyle/>
@@ -5557,6 +5545,7 @@
           <a:lstStyle/>
           <a:p>
             <a:pPr algn="ctr"/>
+            <a:endParaRPr/>
           </a:p>
         </p:txBody>
       </p:sp>
@@ -5577,7 +5566,7 @@
           <a:noFill/>
         </p:spPr>
         <p:txBody>
-          <a:bodyPr wrap="none" lIns="36576" rIns="36576" tIns="18288" bIns="18288">
+          <a:bodyPr wrap="none" lIns="36576" tIns="18288" rIns="36576" bIns="18288">
             <a:spAutoFit/>
           </a:bodyPr>
           <a:lstStyle/>
@@ -5637,6 +5626,7 @@
           <a:lstStyle/>
           <a:p>
             <a:pPr algn="ctr"/>
+            <a:endParaRPr/>
           </a:p>
         </p:txBody>
       </p:sp>
@@ -5657,7 +5647,7 @@
           <a:noFill/>
         </p:spPr>
         <p:txBody>
-          <a:bodyPr wrap="none" lIns="36576" rIns="36576" tIns="18288" bIns="18288">
+          <a:bodyPr wrap="none" lIns="36576" tIns="18288" rIns="36576" bIns="18288">
             <a:spAutoFit/>
           </a:bodyPr>
           <a:lstStyle/>
@@ -5692,7 +5682,7 @@
           <a:noFill/>
         </p:spPr>
         <p:txBody>
-          <a:bodyPr wrap="none" lIns="36576" rIns="36576" tIns="18288" bIns="18288">
+          <a:bodyPr wrap="none" lIns="36576" tIns="18288" rIns="36576" bIns="18288">
             <a:spAutoFit/>
           </a:bodyPr>
           <a:lstStyle/>
@@ -5727,7 +5717,7 @@
           <a:noFill/>
         </p:spPr>
         <p:txBody>
-          <a:bodyPr wrap="none" lIns="36576" rIns="36576" tIns="18288" bIns="18288">
+          <a:bodyPr wrap="none" lIns="36576" tIns="18288" rIns="36576" bIns="18288">
             <a:spAutoFit/>
           </a:bodyPr>
           <a:lstStyle/>
@@ -5787,6 +5777,7 @@
           <a:lstStyle/>
           <a:p>
             <a:pPr algn="ctr"/>
+            <a:endParaRPr/>
           </a:p>
         </p:txBody>
       </p:sp>
@@ -5832,6 +5823,7 @@
           <a:lstStyle/>
           <a:p>
             <a:pPr algn="ctr"/>
+            <a:endParaRPr/>
           </a:p>
         </p:txBody>
       </p:sp>
@@ -5877,6 +5869,7 @@
           <a:lstStyle/>
           <a:p>
             <a:pPr algn="ctr"/>
+            <a:endParaRPr/>
           </a:p>
         </p:txBody>
       </p:sp>
@@ -5922,6 +5915,7 @@
           <a:lstStyle/>
           <a:p>
             <a:pPr algn="ctr"/>
+            <a:endParaRPr/>
           </a:p>
         </p:txBody>
       </p:sp>
@@ -5967,6 +5961,7 @@
           <a:lstStyle/>
           <a:p>
             <a:pPr algn="ctr"/>
+            <a:endParaRPr/>
           </a:p>
         </p:txBody>
       </p:sp>
@@ -6012,6 +6007,7 @@
           <a:lstStyle/>
           <a:p>
             <a:pPr algn="ctr"/>
+            <a:endParaRPr/>
           </a:p>
         </p:txBody>
       </p:sp>
@@ -6057,6 +6053,7 @@
           <a:lstStyle/>
           <a:p>
             <a:pPr algn="ctr"/>
+            <a:endParaRPr/>
           </a:p>
         </p:txBody>
       </p:sp>
@@ -6102,6 +6099,7 @@
           <a:lstStyle/>
           <a:p>
             <a:pPr algn="ctr"/>
+            <a:endParaRPr/>
           </a:p>
         </p:txBody>
       </p:sp>
@@ -6147,6 +6145,7 @@
           <a:lstStyle/>
           <a:p>
             <a:pPr algn="ctr"/>
+            <a:endParaRPr/>
           </a:p>
         </p:txBody>
       </p:sp>
@@ -6192,6 +6191,7 @@
           <a:lstStyle/>
           <a:p>
             <a:pPr algn="ctr"/>
+            <a:endParaRPr/>
           </a:p>
         </p:txBody>
       </p:sp>
@@ -6237,6 +6237,7 @@
           <a:lstStyle/>
           <a:p>
             <a:pPr algn="ctr"/>
+            <a:endParaRPr/>
           </a:p>
         </p:txBody>
       </p:sp>
@@ -6282,6 +6283,7 @@
           <a:lstStyle/>
           <a:p>
             <a:pPr algn="ctr"/>
+            <a:endParaRPr/>
           </a:p>
         </p:txBody>
       </p:sp>
@@ -6327,6 +6329,7 @@
           <a:lstStyle/>
           <a:p>
             <a:pPr algn="ctr"/>
+            <a:endParaRPr/>
           </a:p>
         </p:txBody>
       </p:sp>
@@ -6372,6 +6375,7 @@
           <a:lstStyle/>
           <a:p>
             <a:pPr algn="ctr"/>
+            <a:endParaRPr/>
           </a:p>
         </p:txBody>
       </p:sp>
@@ -6417,6 +6421,7 @@
           <a:lstStyle/>
           <a:p>
             <a:pPr algn="ctr"/>
+            <a:endParaRPr/>
           </a:p>
         </p:txBody>
       </p:sp>
@@ -6462,6 +6467,7 @@
           <a:lstStyle/>
           <a:p>
             <a:pPr algn="ctr"/>
+            <a:endParaRPr/>
           </a:p>
         </p:txBody>
       </p:sp>
@@ -6507,6 +6513,7 @@
           <a:lstStyle/>
           <a:p>
             <a:pPr algn="ctr"/>
+            <a:endParaRPr/>
           </a:p>
         </p:txBody>
       </p:sp>
@@ -6552,6 +6559,7 @@
           <a:lstStyle/>
           <a:p>
             <a:pPr algn="ctr"/>
+            <a:endParaRPr/>
           </a:p>
         </p:txBody>
       </p:sp>
@@ -6572,7 +6580,7 @@
           <a:noFill/>
         </p:spPr>
         <p:txBody>
-          <a:bodyPr wrap="none" lIns="36576" rIns="36576" tIns="18288" bIns="18288">
+          <a:bodyPr wrap="none" lIns="36576" tIns="18288" rIns="36576" bIns="18288">
             <a:spAutoFit/>
           </a:bodyPr>
           <a:lstStyle/>
@@ -6607,7 +6615,7 @@
           <a:noFill/>
         </p:spPr>
         <p:txBody>
-          <a:bodyPr wrap="none" lIns="36576" rIns="36576" tIns="18288" bIns="18288">
+          <a:bodyPr wrap="none" lIns="36576" tIns="18288" rIns="36576" bIns="18288">
             <a:spAutoFit/>
           </a:bodyPr>
           <a:lstStyle/>
@@ -6667,6 +6675,7 @@
           <a:lstStyle/>
           <a:p>
             <a:pPr algn="ctr"/>
+            <a:endParaRPr/>
           </a:p>
         </p:txBody>
       </p:sp>
@@ -6712,6 +6721,7 @@
           <a:lstStyle/>
           <a:p>
             <a:pPr algn="ctr"/>
+            <a:endParaRPr/>
           </a:p>
         </p:txBody>
       </p:sp>
@@ -6757,6 +6767,7 @@
           <a:lstStyle/>
           <a:p>
             <a:pPr algn="ctr"/>
+            <a:endParaRPr/>
           </a:p>
         </p:txBody>
       </p:sp>
@@ -6802,6 +6813,7 @@
           <a:lstStyle/>
           <a:p>
             <a:pPr algn="ctr"/>
+            <a:endParaRPr/>
           </a:p>
         </p:txBody>
       </p:sp>
@@ -6847,6 +6859,7 @@
           <a:lstStyle/>
           <a:p>
             <a:pPr algn="ctr"/>
+            <a:endParaRPr/>
           </a:p>
         </p:txBody>
       </p:sp>
@@ -6892,6 +6905,7 @@
           <a:lstStyle/>
           <a:p>
             <a:pPr algn="ctr"/>
+            <a:endParaRPr/>
           </a:p>
         </p:txBody>
       </p:sp>
@@ -6937,6 +6951,7 @@
           <a:lstStyle/>
           <a:p>
             <a:pPr algn="ctr"/>
+            <a:endParaRPr/>
           </a:p>
         </p:txBody>
       </p:sp>
@@ -6982,6 +6997,7 @@
           <a:lstStyle/>
           <a:p>
             <a:pPr algn="ctr"/>
+            <a:endParaRPr/>
           </a:p>
         </p:txBody>
       </p:sp>
@@ -7027,6 +7043,7 @@
           <a:lstStyle/>
           <a:p>
             <a:pPr algn="ctr"/>
+            <a:endParaRPr/>
           </a:p>
         </p:txBody>
       </p:sp>
@@ -7047,7 +7064,7 @@
           <a:noFill/>
         </p:spPr>
         <p:txBody>
-          <a:bodyPr wrap="none" lIns="36576" rIns="36576" tIns="18288" bIns="18288">
+          <a:bodyPr wrap="none" lIns="36576" tIns="18288" rIns="36576" bIns="18288">
             <a:spAutoFit/>
           </a:bodyPr>
           <a:lstStyle/>
@@ -7082,7 +7099,7 @@
           <a:noFill/>
         </p:spPr>
         <p:txBody>
-          <a:bodyPr wrap="none" lIns="36576" rIns="36576" tIns="18288" bIns="18288">
+          <a:bodyPr wrap="none" lIns="36576" tIns="18288" rIns="36576" bIns="18288">
             <a:spAutoFit/>
           </a:bodyPr>
           <a:lstStyle/>
@@ -7142,6 +7159,7 @@
           <a:lstStyle/>
           <a:p>
             <a:pPr algn="ctr"/>
+            <a:endParaRPr/>
           </a:p>
         </p:txBody>
       </p:sp>
@@ -7187,6 +7205,7 @@
           <a:lstStyle/>
           <a:p>
             <a:pPr algn="ctr"/>
+            <a:endParaRPr/>
           </a:p>
         </p:txBody>
       </p:sp>
@@ -7232,6 +7251,7 @@
           <a:lstStyle/>
           <a:p>
             <a:pPr algn="ctr"/>
+            <a:endParaRPr/>
           </a:p>
         </p:txBody>
       </p:sp>
@@ -7252,7 +7272,7 @@
           <a:noFill/>
         </p:spPr>
         <p:txBody>
-          <a:bodyPr wrap="none" lIns="36576" rIns="36576" tIns="18288" bIns="18288">
+          <a:bodyPr wrap="none" lIns="36576" tIns="18288" rIns="36576" bIns="18288">
             <a:spAutoFit/>
           </a:bodyPr>
           <a:lstStyle/>
@@ -7312,6 +7332,7 @@
           <a:lstStyle/>
           <a:p>
             <a:pPr algn="ctr"/>
+            <a:endParaRPr/>
           </a:p>
         </p:txBody>
       </p:sp>
@@ -7332,7 +7353,7 @@
           <a:noFill/>
         </p:spPr>
         <p:txBody>
-          <a:bodyPr wrap="none" lIns="36576" rIns="36576" tIns="18288" bIns="18288">
+          <a:bodyPr wrap="none" lIns="36576" tIns="18288" rIns="36576" bIns="18288">
             <a:spAutoFit/>
           </a:bodyPr>
           <a:lstStyle/>
@@ -7367,7 +7388,7 @@
           <a:noFill/>
         </p:spPr>
         <p:txBody>
-          <a:bodyPr wrap="none" lIns="36576" rIns="36576" tIns="18288" bIns="18288">
+          <a:bodyPr wrap="none" lIns="36576" tIns="18288" rIns="36576" bIns="18288">
             <a:spAutoFit/>
           </a:bodyPr>
           <a:lstStyle/>
@@ -7437,7 +7458,7 @@
           <a:noFill/>
         </p:spPr>
         <p:txBody>
-          <a:bodyPr wrap="none" lIns="36576" rIns="36576" tIns="18288" bIns="18288">
+          <a:bodyPr wrap="none" lIns="36576" tIns="18288" rIns="36576" bIns="18288">
             <a:spAutoFit/>
           </a:bodyPr>
           <a:lstStyle/>
@@ -7507,7 +7528,7 @@
           <a:noFill/>
         </p:spPr>
         <p:txBody>
-          <a:bodyPr wrap="none" lIns="36576" rIns="36576" tIns="18288" bIns="18288">
+          <a:bodyPr wrap="none" lIns="36576" tIns="18288" rIns="36576" bIns="18288">
             <a:spAutoFit/>
           </a:bodyPr>
           <a:lstStyle/>
@@ -7577,7 +7598,7 @@
           <a:noFill/>
         </p:spPr>
         <p:txBody>
-          <a:bodyPr wrap="none" lIns="36576" rIns="36576" tIns="18288" bIns="18288">
+          <a:bodyPr wrap="none" lIns="36576" tIns="18288" rIns="36576" bIns="18288">
             <a:spAutoFit/>
           </a:bodyPr>
           <a:lstStyle/>
@@ -7672,6 +7693,7 @@
           <a:lstStyle/>
           <a:p>
             <a:pPr algn="ctr"/>
+            <a:endParaRPr/>
           </a:p>
         </p:txBody>
       </p:sp>
@@ -7692,7 +7714,7 @@
           <a:noFill/>
         </p:spPr>
         <p:txBody>
-          <a:bodyPr wrap="none" lIns="36576" rIns="36576" tIns="18288" bIns="18288">
+          <a:bodyPr wrap="none" lIns="36576" tIns="18288" rIns="36576" bIns="18288">
             <a:spAutoFit/>
           </a:bodyPr>
           <a:lstStyle/>
@@ -7727,7 +7749,7 @@
           <a:noFill/>
         </p:spPr>
         <p:txBody>
-          <a:bodyPr wrap="none" lIns="36576" rIns="36576" tIns="18288" bIns="18288">
+          <a:bodyPr wrap="none" lIns="36576" tIns="18288" rIns="36576" bIns="18288">
             <a:spAutoFit/>
           </a:bodyPr>
           <a:lstStyle/>
@@ -7822,6 +7844,7 @@
           <a:lstStyle/>
           <a:p>
             <a:pPr algn="ctr"/>
+            <a:endParaRPr/>
           </a:p>
         </p:txBody>
       </p:sp>
@@ -7902,6 +7925,7 @@
           <a:lstStyle/>
           <a:p>
             <a:pPr algn="ctr"/>
+            <a:endParaRPr/>
           </a:p>
         </p:txBody>
       </p:sp>
@@ -7982,6 +8006,7 @@
           <a:lstStyle/>
           <a:p>
             <a:pPr algn="ctr"/>
+            <a:endParaRPr/>
           </a:p>
         </p:txBody>
       </p:sp>
@@ -8062,6 +8087,7 @@
           <a:lstStyle/>
           <a:p>
             <a:pPr algn="ctr"/>
+            <a:endParaRPr/>
           </a:p>
         </p:txBody>
       </p:sp>
@@ -8082,7 +8108,7 @@
           <a:noFill/>
         </p:spPr>
         <p:txBody>
-          <a:bodyPr wrap="none" lIns="36576" rIns="36576" tIns="18288" bIns="18288">
+          <a:bodyPr wrap="none" lIns="36576" tIns="18288" rIns="36576" bIns="18288">
             <a:spAutoFit/>
           </a:bodyPr>
           <a:lstStyle/>
@@ -8142,6 +8168,7 @@
           <a:lstStyle/>
           <a:p>
             <a:pPr algn="ctr"/>
+            <a:endParaRPr/>
           </a:p>
         </p:txBody>
       </p:sp>
@@ -8162,7 +8189,7 @@
           <a:noFill/>
         </p:spPr>
         <p:txBody>
-          <a:bodyPr wrap="none" lIns="36576" rIns="36576" tIns="18288" bIns="18288">
+          <a:bodyPr wrap="none" lIns="36576" tIns="18288" rIns="36576" bIns="18288">
             <a:spAutoFit/>
           </a:bodyPr>
           <a:lstStyle/>
@@ -8197,7 +8224,7 @@
           <a:noFill/>
         </p:spPr>
         <p:txBody>
-          <a:bodyPr wrap="none" lIns="36576" rIns="36576" tIns="18288" bIns="18288">
+          <a:bodyPr wrap="none" lIns="36576" tIns="18288" rIns="36576" bIns="18288">
             <a:spAutoFit/>
           </a:bodyPr>
           <a:lstStyle/>
@@ -8232,7 +8259,7 @@
           <a:noFill/>
         </p:spPr>
         <p:txBody>
-          <a:bodyPr wrap="none" lIns="36576" rIns="36576" tIns="18288" bIns="18288">
+          <a:bodyPr wrap="none" lIns="36576" tIns="18288" rIns="36576" bIns="18288">
             <a:spAutoFit/>
           </a:bodyPr>
           <a:lstStyle/>
@@ -8292,6 +8319,7 @@
           <a:lstStyle/>
           <a:p>
             <a:pPr algn="ctr"/>
+            <a:endParaRPr/>
           </a:p>
         </p:txBody>
       </p:sp>
@@ -8337,6 +8365,7 @@
           <a:lstStyle/>
           <a:p>
             <a:pPr algn="ctr"/>
+            <a:endParaRPr/>
           </a:p>
         </p:txBody>
       </p:sp>
@@ -8357,7 +8386,7 @@
           <a:noFill/>
         </p:spPr>
         <p:txBody>
-          <a:bodyPr wrap="none" lIns="36576" rIns="36576" tIns="18288" bIns="18288">
+          <a:bodyPr wrap="none" lIns="36576" tIns="18288" rIns="36576" bIns="18288">
             <a:spAutoFit/>
           </a:bodyPr>
           <a:lstStyle/>
@@ -8392,7 +8421,7 @@
           <a:noFill/>
         </p:spPr>
         <p:txBody>
-          <a:bodyPr wrap="none" lIns="36576" rIns="36576" tIns="18288" bIns="18288">
+          <a:bodyPr wrap="none" lIns="36576" tIns="18288" rIns="36576" bIns="18288">
             <a:spAutoFit/>
           </a:bodyPr>
           <a:lstStyle/>
@@ -8427,7 +8456,7 @@
           <a:noFill/>
         </p:spPr>
         <p:txBody>
-          <a:bodyPr wrap="none" lIns="36576" rIns="36576" tIns="18288" bIns="18288">
+          <a:bodyPr wrap="none" lIns="36576" tIns="18288" rIns="36576" bIns="18288">
             <a:spAutoFit/>
           </a:bodyPr>
           <a:lstStyle/>
@@ -8462,7 +8491,7 @@
           <a:noFill/>
         </p:spPr>
         <p:txBody>
-          <a:bodyPr wrap="none" lIns="36576" rIns="36576" tIns="18288" bIns="18288">
+          <a:bodyPr wrap="none" lIns="36576" tIns="18288" rIns="36576" bIns="18288">
             <a:spAutoFit/>
           </a:bodyPr>
           <a:lstStyle/>
@@ -8497,7 +8526,7 @@
           <a:noFill/>
         </p:spPr>
         <p:txBody>
-          <a:bodyPr wrap="none" lIns="36576" rIns="36576" tIns="18288" bIns="18288">
+          <a:bodyPr wrap="none" lIns="36576" tIns="18288" rIns="36576" bIns="18288">
             <a:spAutoFit/>
           </a:bodyPr>
           <a:lstStyle/>
@@ -8532,7 +8561,7 @@
           <a:noFill/>
         </p:spPr>
         <p:txBody>
-          <a:bodyPr wrap="none" lIns="36576" rIns="36576" tIns="18288" bIns="18288">
+          <a:bodyPr wrap="none" lIns="36576" tIns="18288" rIns="36576" bIns="18288">
             <a:spAutoFit/>
           </a:bodyPr>
           <a:lstStyle/>
@@ -8547,6 +8576,207 @@
             <a:r>
               <a:t>Takeaway: first page gathers/cache-builds once; chunk size controls how many later client-to-A page costs are repeated.</a:t>
             </a:r>
+          </a:p>
+        </p:txBody>
+      </p:sp>
+      <p:sp>
+        <p:nvSpPr>
+          <p:cNvPr id="126" name="TextBox 125">
+            <a:extLst>
+              <a:ext uri="{FF2B5EF4-FFF2-40B4-BE49-F238E27FC236}">
+                <a16:creationId xmlns:a16="http://schemas.microsoft.com/office/drawing/2014/main" id="{FE135A38-9D36-960C-C91F-B0FA80DE703B}"/>
+              </a:ext>
+            </a:extLst>
+          </p:cNvPr>
+          <p:cNvSpPr txBox="1"/>
+          <p:nvPr/>
+        </p:nvSpPr>
+        <p:spPr>
+          <a:xfrm>
+            <a:off x="2743200" y="4721045"/>
+            <a:ext cx="594360" cy="378565"/>
+          </a:xfrm>
+          <a:prstGeom prst="rect">
+            <a:avLst/>
+          </a:prstGeom>
+          <a:noFill/>
+        </p:spPr>
+        <p:txBody>
+          <a:bodyPr wrap="square" lIns="36576" tIns="18288" rIns="36576" bIns="18288">
+            <a:spAutoFit/>
+          </a:bodyPr>
+          <a:lstStyle/>
+          <a:p>
+            <a:pPr algn="ctr">
+              <a:defRPr sz="740" b="0">
+                <a:solidFill>
+                  <a:srgbClr val="94A3B8"/>
+                </a:solidFill>
+              </a:defRPr>
+            </a:pPr>
+            <a:r>
+              <a:rPr dirty="0"/>
+              <a:t>~0.42 </a:t>
+            </a:r>
+            <a:r>
+              <a:rPr dirty="0" err="1"/>
+              <a:t>ms</a:t>
+            </a:r>
+            <a:r>
+              <a:rPr dirty="0"/>
+              <a:t>/page, but 800x</a:t>
+            </a:r>
+          </a:p>
+        </p:txBody>
+      </p:sp>
+      <p:sp>
+        <p:nvSpPr>
+          <p:cNvPr id="127" name="TextBox 126">
+            <a:extLst>
+              <a:ext uri="{FF2B5EF4-FFF2-40B4-BE49-F238E27FC236}">
+                <a16:creationId xmlns:a16="http://schemas.microsoft.com/office/drawing/2014/main" id="{169B63FE-F611-B85A-2C60-B02F78F135E2}"/>
+              </a:ext>
+            </a:extLst>
+          </p:cNvPr>
+          <p:cNvSpPr txBox="1"/>
+          <p:nvPr/>
+        </p:nvSpPr>
+        <p:spPr>
+          <a:xfrm>
+            <a:off x="2414214" y="5202141"/>
+            <a:ext cx="1078992" cy="228600"/>
+          </a:xfrm>
+          <a:prstGeom prst="rect">
+            <a:avLst/>
+          </a:prstGeom>
+          <a:noFill/>
+        </p:spPr>
+        <p:txBody>
+          <a:bodyPr wrap="none" lIns="36576" tIns="18288" rIns="36576" bIns="18288">
+            <a:spAutoFit/>
+          </a:bodyPr>
+          <a:lstStyle/>
+          <a:p>
+            <a:pPr>
+              <a:defRPr sz="740" b="0">
+                <a:solidFill>
+                  <a:srgbClr val="94A3B8"/>
+                </a:solidFill>
+              </a:defRPr>
+            </a:pPr>
+            <a:r>
+              <a:rPr dirty="0"/>
+              <a:t>~0.91 </a:t>
+            </a:r>
+            <a:r>
+              <a:rPr dirty="0" err="1"/>
+              <a:t>ms</a:t>
+            </a:r>
+            <a:r>
+              <a:rPr dirty="0"/>
+              <a:t>/page, knee</a:t>
+            </a:r>
+          </a:p>
+        </p:txBody>
+      </p:sp>
+      <p:sp>
+        <p:nvSpPr>
+          <p:cNvPr id="128" name="TextBox 127">
+            <a:extLst>
+              <a:ext uri="{FF2B5EF4-FFF2-40B4-BE49-F238E27FC236}">
+                <a16:creationId xmlns:a16="http://schemas.microsoft.com/office/drawing/2014/main" id="{47BAB282-4A61-55A5-1C15-6CA5CEB0C999}"/>
+              </a:ext>
+            </a:extLst>
+          </p:cNvPr>
+          <p:cNvSpPr txBox="1"/>
+          <p:nvPr/>
+        </p:nvSpPr>
+        <p:spPr>
+          <a:xfrm>
+            <a:off x="2087117" y="5559552"/>
+            <a:ext cx="1078992" cy="228600"/>
+          </a:xfrm>
+          <a:prstGeom prst="rect">
+            <a:avLst/>
+          </a:prstGeom>
+          <a:noFill/>
+        </p:spPr>
+        <p:txBody>
+          <a:bodyPr wrap="none" lIns="36576" tIns="18288" rIns="36576" bIns="18288">
+            <a:spAutoFit/>
+          </a:bodyPr>
+          <a:lstStyle/>
+          <a:p>
+            <a:pPr>
+              <a:defRPr sz="740" b="0">
+                <a:solidFill>
+                  <a:srgbClr val="94A3B8"/>
+                </a:solidFill>
+              </a:defRPr>
+            </a:pPr>
+            <a:r>
+              <a:rPr dirty="0"/>
+              <a:t>~11 </a:t>
+            </a:r>
+            <a:r>
+              <a:rPr dirty="0" err="1"/>
+              <a:t>ms</a:t>
+            </a:r>
+            <a:r>
+              <a:rPr dirty="0"/>
+              <a:t>/page, few but bigger</a:t>
+            </a:r>
+          </a:p>
+        </p:txBody>
+      </p:sp>
+      <p:sp>
+        <p:nvSpPr>
+          <p:cNvPr id="129" name="TextBox 128">
+            <a:extLst>
+              <a:ext uri="{FF2B5EF4-FFF2-40B4-BE49-F238E27FC236}">
+                <a16:creationId xmlns:a16="http://schemas.microsoft.com/office/drawing/2014/main" id="{5A2D05E7-E3FA-48C8-4C6C-538E00185E53}"/>
+              </a:ext>
+            </a:extLst>
+          </p:cNvPr>
+          <p:cNvSpPr txBox="1"/>
+          <p:nvPr/>
+        </p:nvSpPr>
+        <p:spPr>
+          <a:xfrm>
+            <a:off x="201070" y="2324135"/>
+            <a:ext cx="384048" cy="307777"/>
+          </a:xfrm>
+          <a:prstGeom prst="rect">
+            <a:avLst/>
+          </a:prstGeom>
+          <a:noFill/>
+        </p:spPr>
+        <p:txBody>
+          <a:bodyPr wrap="square" lIns="36576" tIns="18288" rIns="36576" bIns="18288">
+            <a:spAutoFit/>
+          </a:bodyPr>
+          <a:lstStyle/>
+          <a:p>
+            <a:pPr algn="ctr">
+              <a:defRPr sz="880" b="0">
+                <a:solidFill>
+                  <a:srgbClr val="94A3B8"/>
+                </a:solidFill>
+              </a:defRPr>
+            </a:pPr>
+            <a:r>
+              <a:rPr lang="en-US" dirty="0"/>
+              <a:t>C</a:t>
+            </a:r>
+            <a:r>
+              <a:rPr dirty="0"/>
+              <a:t>hunk</a:t>
+            </a:r>
+            <a:r>
+              <a:rPr lang="en-US" dirty="0"/>
+              <a:t> size</a:t>
+            </a:r>
+            <a:endParaRPr dirty="0"/>
           </a:p>
         </p:txBody>
       </p:sp>
@@ -8889,44 +9119,44 @@
         <a:sysClr val="window" lastClr="FFFFFF"/>
       </a:lt1>
       <a:dk2>
-        <a:srgbClr val="1F497D"/>
+        <a:srgbClr val="0E2841"/>
       </a:dk2>
       <a:lt2>
-        <a:srgbClr val="EEECE1"/>
+        <a:srgbClr val="E8E8E8"/>
       </a:lt2>
       <a:accent1>
-        <a:srgbClr val="4F81BD"/>
+        <a:srgbClr val="156082"/>
       </a:accent1>
       <a:accent2>
-        <a:srgbClr val="C0504D"/>
+        <a:srgbClr val="E97132"/>
       </a:accent2>
       <a:accent3>
-        <a:srgbClr val="9BBB59"/>
+        <a:srgbClr val="196B24"/>
       </a:accent3>
       <a:accent4>
-        <a:srgbClr val="8064A2"/>
+        <a:srgbClr val="0F9ED5"/>
       </a:accent4>
       <a:accent5>
-        <a:srgbClr val="4BACC6"/>
+        <a:srgbClr val="A02B93"/>
       </a:accent5>
       <a:accent6>
-        <a:srgbClr val="F79646"/>
+        <a:srgbClr val="4EA72E"/>
       </a:accent6>
       <a:hlink>
-        <a:srgbClr val="0000FF"/>
+        <a:srgbClr val="467886"/>
       </a:hlink>
       <a:folHlink>
-        <a:srgbClr val="800080"/>
+        <a:srgbClr val="96607D"/>
       </a:folHlink>
     </a:clrScheme>
     <a:fontScheme name="Office">
       <a:majorFont>
-        <a:latin typeface="Calibri"/>
+        <a:latin typeface="Aptos Display" panose="02110004020202020204"/>
         <a:ea typeface=""/>
         <a:cs typeface=""/>
-        <a:font script="Jpan" typeface="ＭＳ Ｐゴシック"/>
+        <a:font script="Jpan" typeface="游ゴシック Light"/>
         <a:font script="Hang" typeface="맑은 고딕"/>
-        <a:font script="Hans" typeface="宋体"/>
+        <a:font script="Hans" typeface="等线 Light"/>
         <a:font script="Hant" typeface="新細明體"/>
         <a:font script="Arab" typeface="Times New Roman"/>
         <a:font script="Hebr" typeface="Times New Roman"/>
@@ -8954,14 +9184,31 @@
         <a:font script="Viet" typeface="Times New Roman"/>
         <a:font script="Uigh" typeface="Microsoft Uighur"/>
         <a:font script="Geor" typeface="Sylfaen"/>
+        <a:font script="Armn" typeface="Arial"/>
+        <a:font script="Bugi" typeface="Leelawadee UI"/>
+        <a:font script="Bopo" typeface="Microsoft JhengHei"/>
+        <a:font script="Java" typeface="Javanese Text"/>
+        <a:font script="Lisu" typeface="Segoe UI"/>
+        <a:font script="Mymr" typeface="Myanmar Text"/>
+        <a:font script="Nkoo" typeface="Ebrima"/>
+        <a:font script="Olck" typeface="Nirmala UI"/>
+        <a:font script="Osma" typeface="Ebrima"/>
+        <a:font script="Phag" typeface="Phagspa"/>
+        <a:font script="Syrn" typeface="Estrangelo Edessa"/>
+        <a:font script="Syrj" typeface="Estrangelo Edessa"/>
+        <a:font script="Syre" typeface="Estrangelo Edessa"/>
+        <a:font script="Sora" typeface="Nirmala UI"/>
+        <a:font script="Tale" typeface="Microsoft Tai Le"/>
+        <a:font script="Talu" typeface="Microsoft New Tai Lue"/>
+        <a:font script="Tfng" typeface="Ebrima"/>
       </a:majorFont>
       <a:minorFont>
-        <a:latin typeface="Calibri"/>
+        <a:latin typeface="Aptos" panose="02110004020202020204"/>
         <a:ea typeface=""/>
         <a:cs typeface=""/>
-        <a:font script="Jpan" typeface="ＭＳ Ｐゴシック"/>
+        <a:font script="Jpan" typeface="游ゴシック"/>
         <a:font script="Hang" typeface="맑은 고딕"/>
-        <a:font script="Hans" typeface="宋体"/>
+        <a:font script="Hans" typeface="等线"/>
         <a:font script="Hant" typeface="新細明體"/>
         <a:font script="Arab" typeface="Arial"/>
         <a:font script="Hebr" typeface="Arial"/>
@@ -8989,6 +9236,23 @@
         <a:font script="Viet" typeface="Arial"/>
         <a:font script="Uigh" typeface="Microsoft Uighur"/>
         <a:font script="Geor" typeface="Sylfaen"/>
+        <a:font script="Armn" typeface="Arial"/>
+        <a:font script="Bugi" typeface="Leelawadee UI"/>
+        <a:font script="Bopo" typeface="Microsoft JhengHei"/>
+        <a:font script="Java" typeface="Javanese Text"/>
+        <a:font script="Lisu" typeface="Segoe UI"/>
+        <a:font script="Mymr" typeface="Myanmar Text"/>
+        <a:font script="Nkoo" typeface="Ebrima"/>
+        <a:font script="Olck" typeface="Nirmala UI"/>
+        <a:font script="Osma" typeface="Ebrima"/>
+        <a:font script="Phag" typeface="Phagspa"/>
+        <a:font script="Syrn" typeface="Estrangelo Edessa"/>
+        <a:font script="Syrj" typeface="Estrangelo Edessa"/>
+        <a:font script="Syre" typeface="Estrangelo Edessa"/>
+        <a:font script="Sora" typeface="Nirmala UI"/>
+        <a:font script="Tale" typeface="Microsoft Tai Le"/>
+        <a:font script="Talu" typeface="Microsoft New Tai Lue"/>
+        <a:font script="Tfng" typeface="Ebrima"/>
       </a:minorFont>
     </a:fontScheme>
     <a:fmtScheme name="Office">
@@ -9000,180 +9264,136 @@
           <a:gsLst>
             <a:gs pos="0">
               <a:schemeClr val="phClr">
-                <a:tint val="50000"/>
-                <a:satMod val="300000"/>
+                <a:lumMod val="110000"/>
+                <a:satMod val="105000"/>
+                <a:tint val="67000"/>
               </a:schemeClr>
             </a:gs>
-            <a:gs pos="35000">
+            <a:gs pos="50000">
               <a:schemeClr val="phClr">
-                <a:tint val="37000"/>
-                <a:satMod val="300000"/>
+                <a:lumMod val="105000"/>
+                <a:satMod val="103000"/>
+                <a:tint val="73000"/>
               </a:schemeClr>
             </a:gs>
             <a:gs pos="100000">
               <a:schemeClr val="phClr">
-                <a:tint val="15000"/>
-                <a:satMod val="350000"/>
+                <a:lumMod val="105000"/>
+                <a:satMod val="109000"/>
+                <a:tint val="81000"/>
               </a:schemeClr>
             </a:gs>
           </a:gsLst>
-          <a:lin ang="16200000" scaled="1"/>
+          <a:lin ang="5400000" scaled="0"/>
         </a:gradFill>
         <a:gradFill rotWithShape="1">
           <a:gsLst>
             <a:gs pos="0">
               <a:schemeClr val="phClr">
-                <a:tint val="100000"/>
+                <a:satMod val="103000"/>
+                <a:lumMod val="102000"/>
+                <a:tint val="94000"/>
+              </a:schemeClr>
+            </a:gs>
+            <a:gs pos="50000">
+              <a:schemeClr val="phClr">
+                <a:satMod val="110000"/>
+                <a:lumMod val="100000"/>
                 <a:shade val="100000"/>
-                <a:satMod val="130000"/>
               </a:schemeClr>
             </a:gs>
             <a:gs pos="100000">
               <a:schemeClr val="phClr">
-                <a:tint val="50000"/>
-                <a:shade val="100000"/>
-                <a:satMod val="350000"/>
+                <a:lumMod val="99000"/>
+                <a:satMod val="120000"/>
+                <a:shade val="78000"/>
               </a:schemeClr>
             </a:gs>
           </a:gsLst>
-          <a:lin ang="16200000" scaled="0"/>
+          <a:lin ang="5400000" scaled="0"/>
         </a:gradFill>
       </a:fillStyleLst>
       <a:lnStyleLst>
-        <a:ln w="9525" cap="flat" cmpd="sng" algn="ctr">
+        <a:ln w="12700" cap="flat" cmpd="sng" algn="ctr">
           <a:solidFill>
-            <a:schemeClr val="phClr">
-              <a:shade val="95000"/>
-              <a:satMod val="105000"/>
-            </a:schemeClr>
+            <a:schemeClr val="phClr"/>
           </a:solidFill>
           <a:prstDash val="solid"/>
+          <a:miter lim="800000"/>
+        </a:ln>
+        <a:ln w="19050" cap="flat" cmpd="sng" algn="ctr">
+          <a:solidFill>
+            <a:schemeClr val="phClr"/>
+          </a:solidFill>
+          <a:prstDash val="solid"/>
+          <a:miter lim="800000"/>
         </a:ln>
         <a:ln w="25400" cap="flat" cmpd="sng" algn="ctr">
           <a:solidFill>
             <a:schemeClr val="phClr"/>
           </a:solidFill>
           <a:prstDash val="solid"/>
-        </a:ln>
-        <a:ln w="38100" cap="flat" cmpd="sng" algn="ctr">
-          <a:solidFill>
-            <a:schemeClr val="phClr"/>
-          </a:solidFill>
-          <a:prstDash val="solid"/>
+          <a:miter lim="800000"/>
         </a:ln>
       </a:lnStyleLst>
       <a:effectStyleLst>
         <a:effectStyle>
+          <a:effectLst/>
+        </a:effectStyle>
+        <a:effectStyle>
+          <a:effectLst/>
+        </a:effectStyle>
+        <a:effectStyle>
           <a:effectLst>
-            <a:outerShdw blurRad="40000" dist="20000" dir="5400000" rotWithShape="0">
+            <a:outerShdw blurRad="57150" dist="19050" dir="5400000" algn="ctr" rotWithShape="0">
               <a:srgbClr val="000000">
-                <a:alpha val="38000"/>
+                <a:alpha val="63000"/>
               </a:srgbClr>
             </a:outerShdw>
           </a:effectLst>
-        </a:effectStyle>
-        <a:effectStyle>
-          <a:effectLst>
-            <a:outerShdw blurRad="40000" dist="23000" dir="5400000" rotWithShape="0">
-              <a:srgbClr val="000000">
-                <a:alpha val="35000"/>
-              </a:srgbClr>
-            </a:outerShdw>
-          </a:effectLst>
-        </a:effectStyle>
-        <a:effectStyle>
-          <a:effectLst>
-            <a:outerShdw blurRad="40000" dist="23000" dir="5400000" rotWithShape="0">
-              <a:srgbClr val="000000">
-                <a:alpha val="35000"/>
-              </a:srgbClr>
-            </a:outerShdw>
-          </a:effectLst>
-          <a:scene3d>
-            <a:camera prst="orthographicFront">
-              <a:rot lat="0" lon="0" rev="0"/>
-            </a:camera>
-            <a:lightRig rig="threePt" dir="t">
-              <a:rot lat="0" lon="0" rev="1200000"/>
-            </a:lightRig>
-          </a:scene3d>
-          <a:sp3d>
-            <a:bevelT w="63500" h="25400"/>
-          </a:sp3d>
         </a:effectStyle>
       </a:effectStyleLst>
       <a:bgFillStyleLst>
         <a:solidFill>
           <a:schemeClr val="phClr"/>
         </a:solidFill>
+        <a:solidFill>
+          <a:schemeClr val="phClr">
+            <a:tint val="95000"/>
+            <a:satMod val="170000"/>
+          </a:schemeClr>
+        </a:solidFill>
         <a:gradFill rotWithShape="1">
           <a:gsLst>
             <a:gs pos="0">
               <a:schemeClr val="phClr">
-                <a:tint val="40000"/>
-                <a:satMod val="350000"/>
+                <a:tint val="93000"/>
+                <a:satMod val="150000"/>
+                <a:shade val="98000"/>
+                <a:lumMod val="102000"/>
               </a:schemeClr>
             </a:gs>
-            <a:gs pos="40000">
+            <a:gs pos="50000">
               <a:schemeClr val="phClr">
-                <a:tint val="45000"/>
-                <a:shade val="99000"/>
-                <a:satMod val="350000"/>
+                <a:tint val="98000"/>
+                <a:satMod val="130000"/>
+                <a:shade val="90000"/>
+                <a:lumMod val="103000"/>
               </a:schemeClr>
             </a:gs>
             <a:gs pos="100000">
               <a:schemeClr val="phClr">
-                <a:shade val="20000"/>
-                <a:satMod val="255000"/>
+                <a:shade val="63000"/>
+                <a:satMod val="120000"/>
               </a:schemeClr>
             </a:gs>
           </a:gsLst>
-          <a:path path="circle">
-            <a:fillToRect l="50000" t="-80000" r="50000" b="180000"/>
-          </a:path>
-        </a:gradFill>
-        <a:gradFill rotWithShape="1">
-          <a:gsLst>
-            <a:gs pos="0">
-              <a:schemeClr val="phClr">
-                <a:tint val="80000"/>
-                <a:satMod val="300000"/>
-              </a:schemeClr>
-            </a:gs>
-            <a:gs pos="100000">
-              <a:schemeClr val="phClr">
-                <a:shade val="30000"/>
-                <a:satMod val="200000"/>
-              </a:schemeClr>
-            </a:gs>
-          </a:gsLst>
-          <a:path path="circle">
-            <a:fillToRect l="50000" t="50000" r="50000" b="50000"/>
-          </a:path>
+          <a:lin ang="5400000" scaled="0"/>
         </a:gradFill>
       </a:bgFillStyleLst>
     </a:fmtScheme>
   </a:themeElements>
   <a:objectDefaults>
-    <a:spDef>
-      <a:spPr/>
-      <a:bodyPr/>
-      <a:lstStyle/>
-      <a:style>
-        <a:lnRef idx="1">
-          <a:schemeClr val="accent1"/>
-        </a:lnRef>
-        <a:fillRef idx="3">
-          <a:schemeClr val="accent1"/>
-        </a:fillRef>
-        <a:effectRef idx="2">
-          <a:schemeClr val="accent1"/>
-        </a:effectRef>
-        <a:fontRef idx="minor">
-          <a:schemeClr val="lt1"/>
-        </a:fontRef>
-      </a:style>
-    </a:spDef>
     <a:lnDef>
       <a:spPr/>
       <a:bodyPr/>
@@ -9195,5 +9415,10 @@
     </a:lnDef>
   </a:objectDefaults>
   <a:extraClrSchemeLst/>
+  <a:extLst>
+    <a:ext uri="{05A4C25C-085E-4340-85A3-A5531E510DB2}">
+      <thm15:themeFamily xmlns:thm15="http://schemas.microsoft.com/office/thememl/2012/main" name="Office Theme" id="{2E142A2C-CD16-42D6-873A-C26D2A0506FA}" vid="{1BDDFF52-6CD6-40A5-AB3C-68EB2F1E4D0A}"/>
+    </a:ext>
+  </a:extLst>
 </a:theme>
 </file>
</xml_diff>

<commit_message>
Update final poster and submission paths
</commit_message>
<xml_diff>
--- a/mini2-poster.pptx
+++ b/mini2-poster.pptx
@@ -305,7 +305,7 @@
             </a:r>
             <a:r>
               <a:rPr lang="en-US" dirty="0"/>
-              <a:t>onverted a 90,000 row subset into compact 20-byte typed binary records, and returned 80,000 of those records through a nine-node </a:t>
+              <a:t>onverted a 80,000 row subset into compact 20-byte typed binary records, and returned 80,000 of those records through a nine-node </a:t>
             </a:r>
             <a:r>
               <a:rPr lang="en-US" dirty="0" err="1"/>
@@ -8517,8 +8517,8 @@
         </p:nvSpPr>
         <p:spPr>
           <a:xfrm>
-            <a:off x="8065008" y="5943600"/>
-            <a:ext cx="3429000" cy="164592"/>
+            <a:off x="8019288" y="5833872"/>
+            <a:ext cx="3712464" cy="553998"/>
           </a:xfrm>
           <a:prstGeom prst="rect">
             <a:avLst/>
@@ -8526,7 +8526,7 @@
           <a:noFill/>
         </p:spPr>
         <p:txBody>
-          <a:bodyPr wrap="none" lIns="36576" tIns="18288" rIns="36576" bIns="18288">
+          <a:bodyPr wrap="square" lIns="36576" tIns="18288" rIns="36576" bIns="18288">
             <a:spAutoFit/>
           </a:bodyPr>
           <a:lstStyle/>
@@ -8539,8 +8539,19 @@
               </a:defRPr>
             </a:pPr>
             <a:r>
-              <a:t>At 32 KB, page-count cost is mostly amortized.</a:t>
-            </a:r>
+              <a:rPr lang="en-US" sz="840" dirty="0"/>
+              <a:t>At 32 KB, page-count cost is mostly amortized. Key takeaway is that 32 KB is the best balance, since below it repeated paging dominates, and above it fixed costs and tail latency dominate.</a:t>
+            </a:r>
+          </a:p>
+          <a:p>
+            <a:pPr algn="ctr">
+              <a:defRPr sz="840" b="1">
+                <a:solidFill>
+                  <a:srgbClr val="FACC15"/>
+                </a:solidFill>
+              </a:defRPr>
+            </a:pPr>
+            <a:endParaRPr dirty="0"/>
           </a:p>
         </p:txBody>
       </p:sp>

</xml_diff>